<commit_message>
Revise harness deck opener
</commit_message>
<xml_diff>
--- a/presentations/harness-engineering-principles-demo.pptx
+++ b/presentations/harness-engineering-principles-demo.pptx
@@ -2,26 +2,26 @@
 <file path=ppt/presentation.xml><?xml version="1.0" encoding="utf-8"?>
 <p:presentation xmlns:p="http://schemas.openxmlformats.org/presentationml/2006/main">
   <p:sldMasterIdLst>
-    <p:sldMasterId xmlns:r="http://schemas.openxmlformats.org/officeDocument/2006/relationships" id="2147483648" r:id="R7f6a984eb6f74a40"/>
+    <p:sldMasterId xmlns:r="http://schemas.openxmlformats.org/officeDocument/2006/relationships" id="2147483648" r:id="R540b50ff0a6c4c31"/>
   </p:sldMasterIdLst>
   <p:notesMasterIdLst>
-    <p:notesMasterId xmlns:r="http://schemas.openxmlformats.org/officeDocument/2006/relationships" r:id="R479545d2893242e7"/>
+    <p:notesMasterId xmlns:r="http://schemas.openxmlformats.org/officeDocument/2006/relationships" r:id="R1600068b2b69495e"/>
   </p:notesMasterIdLst>
   <p:sldIdLst>
-    <p:sldId xmlns:r="http://schemas.openxmlformats.org/officeDocument/2006/relationships" id="256" r:id="Rd39cc2a1340d4c5e"/>
-    <p:sldId xmlns:r="http://schemas.openxmlformats.org/officeDocument/2006/relationships" id="257" r:id="R4173afaef92f420f"/>
-    <p:sldId xmlns:r="http://schemas.openxmlformats.org/officeDocument/2006/relationships" id="258" r:id="R0dea076d14ec461e"/>
-    <p:sldId xmlns:r="http://schemas.openxmlformats.org/officeDocument/2006/relationships" id="259" r:id="Re4959fbeffb44a93"/>
-    <p:sldId xmlns:r="http://schemas.openxmlformats.org/officeDocument/2006/relationships" id="260" r:id="Rb04945fd4c4b46db"/>
-    <p:sldId xmlns:r="http://schemas.openxmlformats.org/officeDocument/2006/relationships" id="261" r:id="Rcb90ccfefadc413a"/>
-    <p:sldId xmlns:r="http://schemas.openxmlformats.org/officeDocument/2006/relationships" id="262" r:id="R84572ff8001e4791"/>
-    <p:sldId xmlns:r="http://schemas.openxmlformats.org/officeDocument/2006/relationships" id="263" r:id="R0dde506528c7403a"/>
-    <p:sldId xmlns:r="http://schemas.openxmlformats.org/officeDocument/2006/relationships" id="264" r:id="R968b05d94bc14e9e"/>
-    <p:sldId xmlns:r="http://schemas.openxmlformats.org/officeDocument/2006/relationships" id="265" r:id="R80c6e7394cf447c8"/>
-    <p:sldId xmlns:r="http://schemas.openxmlformats.org/officeDocument/2006/relationships" id="266" r:id="R7fd5c9a2f99946d6"/>
-    <p:sldId xmlns:r="http://schemas.openxmlformats.org/officeDocument/2006/relationships" id="267" r:id="R6b02afb39d8a499e"/>
-    <p:sldId xmlns:r="http://schemas.openxmlformats.org/officeDocument/2006/relationships" id="268" r:id="R470875b0d4ff4ad9"/>
-    <p:sldId xmlns:r="http://schemas.openxmlformats.org/officeDocument/2006/relationships" id="269" r:id="R3bedf35d57344cba"/>
+    <p:sldId xmlns:r="http://schemas.openxmlformats.org/officeDocument/2006/relationships" id="256" r:id="Rfb70ee02793c4ec7"/>
+    <p:sldId xmlns:r="http://schemas.openxmlformats.org/officeDocument/2006/relationships" id="257" r:id="R3674bf842a3a477d"/>
+    <p:sldId xmlns:r="http://schemas.openxmlformats.org/officeDocument/2006/relationships" id="258" r:id="Rc2d350bec8ba4c2a"/>
+    <p:sldId xmlns:r="http://schemas.openxmlformats.org/officeDocument/2006/relationships" id="259" r:id="R108912014e68470b"/>
+    <p:sldId xmlns:r="http://schemas.openxmlformats.org/officeDocument/2006/relationships" id="260" r:id="R4e3ded8d24bc4a3d"/>
+    <p:sldId xmlns:r="http://schemas.openxmlformats.org/officeDocument/2006/relationships" id="261" r:id="R093dc570ee864c33"/>
+    <p:sldId xmlns:r="http://schemas.openxmlformats.org/officeDocument/2006/relationships" id="262" r:id="R0c785990050346a8"/>
+    <p:sldId xmlns:r="http://schemas.openxmlformats.org/officeDocument/2006/relationships" id="263" r:id="R6c94f5538d0e4788"/>
+    <p:sldId xmlns:r="http://schemas.openxmlformats.org/officeDocument/2006/relationships" id="264" r:id="R48546a2b44a34abd"/>
+    <p:sldId xmlns:r="http://schemas.openxmlformats.org/officeDocument/2006/relationships" id="265" r:id="Rddf340b10422409c"/>
+    <p:sldId xmlns:r="http://schemas.openxmlformats.org/officeDocument/2006/relationships" id="266" r:id="R5a161ac275d04c33"/>
+    <p:sldId xmlns:r="http://schemas.openxmlformats.org/officeDocument/2006/relationships" id="267" r:id="R9fa65c44081b41bd"/>
+    <p:sldId xmlns:r="http://schemas.openxmlformats.org/officeDocument/2006/relationships" id="268" r:id="Rf938a4b60fb7448a"/>
+    <p:sldId xmlns:r="http://schemas.openxmlformats.org/officeDocument/2006/relationships" id="269" r:id="R2d908ad0572c4d74"/>
   </p:sldIdLst>
   <p:sldSz cx="12192000" cy="6858000"/>
   <p:notesSz cx="6858000" cy="9144000"/>
@@ -455,7 +455,12 @@
           <a:lstStyle xmlns:a="http://schemas.openxmlformats.org/drawingml/2006/main"/>
           <a:p xmlns:a="http://schemas.openxmlformats.org/drawingml/2006/main">
             <a:r>
-              <a:t>Use this as the opener before Colab. It sets the learning job.</a:t>
+              <a:t>Opening point: a model is only one component of a production AI system. The harness is the engineering around it: context guides, tools, memory, sensors, safety gates, observability, and repair loops.</a:t>
+            </a:r>
+          </a:p>
+          <a:p xmlns:a="http://schemas.openxmlformats.org/drawingml/2006/main">
+            <a:r>
+              <a:t>Use the game-editor example as the mental picture: same prompt and same model, but the supported run had a planner, generator, evaluator architecture and produced a usable result.</a:t>
             </a:r>
           </a:p>
           <a:p xmlns:a="http://schemas.openxmlformats.org/drawingml/2006/main">
@@ -465,7 +470,17 @@
           </a:p>
           <a:p xmlns:a="http://schemas.openxmlformats.org/drawingml/2006/main">
             <a:r>
-              <a:t>Fowler: https://martinfowler.com/articles/harness-engineering.html</a:t>
+              <a:t>User-provided course excerpt in the Codex task: Anthropic controlled experiment snippet with Opus 4.5 game-editor example; used as supplied by user, not independently verified in this edit.</a:t>
+            </a:r>
+          </a:p>
+          <a:p xmlns:a="http://schemas.openxmlformats.org/drawingml/2006/main">
+            <a:r>
+              <a:t>User-provided reference image in the Codex task: model + harness + agent diagram; recreated as editable PowerPoint shapes rather than copied as an image.</a:t>
+            </a:r>
+          </a:p>
+          <a:p xmlns:a="http://schemas.openxmlformats.org/drawingml/2006/main">
+            <a:r>
+              <a:t>Martin Fowler, Harness Engineering article: https://martinfowler.com/articles/harness-engineering.html</a:t>
             </a:r>
           </a:p>
         </p:txBody>
@@ -1568,7 +1583,7 @@
   </p:cSld>
   <p:clrMap bg1="lt1" tx1="dk1" bg2="lt2" tx2="dk2" accent1="accent1" accent2="accent2" accent3="accent3" accent4="accent4" accent5="accent5" accent6="accent6" hlink="hlink" folHlink="folHlink"/>
   <p:sldLayoutIdLst>
-    <p:sldLayoutId xmlns:r="http://schemas.openxmlformats.org/officeDocument/2006/relationships" id="2147483649" r:id="R259aa2547d5c4f2e"/>
+    <p:sldLayoutId xmlns:r="http://schemas.openxmlformats.org/officeDocument/2006/relationships" id="2147483649" r:id="Rdfbe993324bc4d47"/>
   </p:sldLayoutIdLst>
   <p:txStyles>
     <p:titleStyle>
@@ -2116,47 +2131,47 @@
       </p:grpSpPr>
       <p:sp>
         <p:nvSpPr>
-          <p:cNvPr id="8" name="eyebrow">
-            <a:extLst xmlns:a="http://schemas.openxmlformats.org/drawingml/2006/main">
-              <a:ext uri="{FF2B5EF4-FFF2-40B4-BE49-F238E27FC236}">
-                <a16:creationId xmlns:a16="http://schemas.microsoft.com/office/drawing/2014/main" id="{54989A38-569B-430D-B4ED-D48706AB5A50}"/>
-              </a:ext>
-            </a:extLst>
-          </p:cNvPr>
-          <p:cNvSpPr>
-            <a:spLocks xmlns:a="http://schemas.openxmlformats.org/drawingml/2006/main" noGrp="1"/>
-          </p:cNvSpPr>
-          <p:nvPr/>
-        </p:nvSpPr>
-        <p:spPr>
-          <a:xfrm xmlns:a="http://schemas.openxmlformats.org/drawingml/2006/main">
-            <a:off x="685800" y="666750"/>
-            <a:ext cx="4953000" cy="247650"/>
-          </a:xfrm>
-          <a:prstGeom xmlns:a="http://schemas.openxmlformats.org/drawingml/2006/main" prst="rect">
-            <a:avLst/>
-          </a:prstGeom>
-          <a:noFill xmlns:a="http://schemas.openxmlformats.org/drawingml/2006/main"/>
-          <a:ln xmlns:a="http://schemas.openxmlformats.org/drawingml/2006/main" w="0">
-            <a:noFill/>
-            <a:prstDash val="solid"/>
-          </a:ln>
-        </p:spPr>
-        <p:txBody>
-          <a:bodyPr xmlns:a="http://schemas.openxmlformats.org/drawingml/2006/main"/>
-          <a:lstStyle xmlns:a="http://schemas.openxmlformats.org/drawingml/2006/main"/>
-          <a:p xmlns:a="http://schemas.openxmlformats.org/drawingml/2006/main">
-            <a:pPr algn="l">
+          <p:cNvPr id="20" name="eyebrow">
+            <a:extLst xmlns:a="http://schemas.openxmlformats.org/drawingml/2006/main">
+              <a:ext uri="{FF2B5EF4-FFF2-40B4-BE49-F238E27FC236}">
+                <a16:creationId xmlns:a16="http://schemas.microsoft.com/office/drawing/2014/main" id="{95B9CB0B-634F-40D7-AFB1-4E2BCDFAADE1}"/>
+              </a:ext>
+            </a:extLst>
+          </p:cNvPr>
+          <p:cNvSpPr>
+            <a:spLocks xmlns:a="http://schemas.openxmlformats.org/drawingml/2006/main" noGrp="1"/>
+          </p:cNvSpPr>
+          <p:nvPr/>
+        </p:nvSpPr>
+        <p:spPr>
+          <a:xfrm xmlns:a="http://schemas.openxmlformats.org/drawingml/2006/main">
+            <a:off x="685800" y="495300"/>
+            <a:ext cx="3429000" cy="247650"/>
+          </a:xfrm>
+          <a:prstGeom xmlns:a="http://schemas.openxmlformats.org/drawingml/2006/main" prst="rect">
+            <a:avLst/>
+          </a:prstGeom>
+          <a:noFill xmlns:a="http://schemas.openxmlformats.org/drawingml/2006/main"/>
+          <a:ln xmlns:a="http://schemas.openxmlformats.org/drawingml/2006/main" w="0">
+            <a:noFill/>
+            <a:prstDash val="solid"/>
+          </a:ln>
+        </p:spPr>
+        <p:txBody>
+          <a:bodyPr xmlns:a="http://schemas.openxmlformats.org/drawingml/2006/main"/>
+          <a:lstStyle xmlns:a="http://schemas.openxmlformats.org/drawingml/2006/main"/>
+          <a:p xmlns:a="http://schemas.openxmlformats.org/drawingml/2006/main">
+            <a:pPr>
               <a:defRPr sz="1050" b="1">
                 <a:solidFill>
-                  <a:srgbClr val="6B7280"/>
+                  <a:srgbClr val="62748E"/>
                 </a:solidFill>
               </a:defRPr>
             </a:pPr>
             <a:r>
               <a:rPr sz="1050" b="1">
                 <a:solidFill>
-                  <a:srgbClr val="6B7280"/>
+                  <a:srgbClr val="62748E"/>
                 </a:solidFill>
               </a:rPr>
               <a:t>MANAGEMENT LEARNING DECK</a:t>
@@ -2169,47 +2184,47 @@
           <p:cNvPr id="2" name="title">
             <a:extLst xmlns:a="http://schemas.openxmlformats.org/drawingml/2006/main">
               <a:ext uri="{FF2B5EF4-FFF2-40B4-BE49-F238E27FC236}">
-                <a16:creationId xmlns:a16="http://schemas.microsoft.com/office/drawing/2014/main" id="{0840BA73-4F36-467C-8BA8-417F8E7E5CE4}"/>
-              </a:ext>
-            </a:extLst>
-          </p:cNvPr>
-          <p:cNvSpPr>
-            <a:spLocks xmlns:a="http://schemas.openxmlformats.org/drawingml/2006/main" noGrp="1"/>
-          </p:cNvSpPr>
-          <p:nvPr/>
-        </p:nvSpPr>
-        <p:spPr>
-          <a:xfrm xmlns:a="http://schemas.openxmlformats.org/drawingml/2006/main">
-            <a:off x="685800" y="1257300"/>
-            <a:ext cx="9525000" cy="1219200"/>
-          </a:xfrm>
-          <a:prstGeom xmlns:a="http://schemas.openxmlformats.org/drawingml/2006/main" prst="rect">
-            <a:avLst/>
-          </a:prstGeom>
-          <a:noFill xmlns:a="http://schemas.openxmlformats.org/drawingml/2006/main"/>
-          <a:ln xmlns:a="http://schemas.openxmlformats.org/drawingml/2006/main" w="0">
-            <a:noFill/>
-            <a:prstDash val="solid"/>
-          </a:ln>
-        </p:spPr>
-        <p:txBody>
-          <a:bodyPr xmlns:a="http://schemas.openxmlformats.org/drawingml/2006/main"/>
-          <a:lstStyle xmlns:a="http://schemas.openxmlformats.org/drawingml/2006/main"/>
-          <a:p xmlns:a="http://schemas.openxmlformats.org/drawingml/2006/main">
-            <a:pPr algn="l">
-              <a:defRPr sz="3900" b="1">
-                <a:solidFill>
-                  <a:srgbClr val="111827"/>
-                </a:solidFill>
-              </a:defRPr>
-            </a:pPr>
-            <a:r>
-              <a:rPr sz="3900" b="1">
-                <a:solidFill>
-                  <a:srgbClr val="111827"/>
-                </a:solidFill>
-              </a:rPr>
-              <a:t>Harness engineering is how we make AI workflows governable</a:t>
+                <a16:creationId xmlns:a16="http://schemas.microsoft.com/office/drawing/2014/main" id="{B29B84CB-57E0-4CD9-8652-8C67C5A10196}"/>
+              </a:ext>
+            </a:extLst>
+          </p:cNvPr>
+          <p:cNvSpPr>
+            <a:spLocks xmlns:a="http://schemas.openxmlformats.org/drawingml/2006/main" noGrp="1"/>
+          </p:cNvSpPr>
+          <p:nvPr/>
+        </p:nvSpPr>
+        <p:spPr>
+          <a:xfrm xmlns:a="http://schemas.openxmlformats.org/drawingml/2006/main">
+            <a:off x="685800" y="857250"/>
+            <a:ext cx="8096250" cy="1181100"/>
+          </a:xfrm>
+          <a:prstGeom xmlns:a="http://schemas.openxmlformats.org/drawingml/2006/main" prst="rect">
+            <a:avLst/>
+          </a:prstGeom>
+          <a:noFill xmlns:a="http://schemas.openxmlformats.org/drawingml/2006/main"/>
+          <a:ln xmlns:a="http://schemas.openxmlformats.org/drawingml/2006/main" w="0">
+            <a:noFill/>
+            <a:prstDash val="solid"/>
+          </a:ln>
+        </p:spPr>
+        <p:txBody>
+          <a:bodyPr xmlns:a="http://schemas.openxmlformats.org/drawingml/2006/main"/>
+          <a:lstStyle xmlns:a="http://schemas.openxmlformats.org/drawingml/2006/main"/>
+          <a:p xmlns:a="http://schemas.openxmlformats.org/drawingml/2006/main">
+            <a:pPr>
+              <a:defRPr sz="3750" b="1">
+                <a:solidFill>
+                  <a:srgbClr val="020618"/>
+                </a:solidFill>
+              </a:defRPr>
+            </a:pPr>
+            <a:r>
+              <a:rPr sz="3750" b="1">
+                <a:solidFill>
+                  <a:srgbClr val="020618"/>
+                </a:solidFill>
+              </a:rPr>
+              <a:t>Harness engineering is the system around the model</a:t>
             </a:r>
           </a:p>
         </p:txBody>
@@ -2219,79 +2234,387 @@
           <p:cNvPr id="3" name="subtitle">
             <a:extLst xmlns:a="http://schemas.openxmlformats.org/drawingml/2006/main">
               <a:ext uri="{FF2B5EF4-FFF2-40B4-BE49-F238E27FC236}">
-                <a16:creationId xmlns:a16="http://schemas.microsoft.com/office/drawing/2014/main" id="{30E659B7-D08D-49C5-96E5-51C205E81A39}"/>
-              </a:ext>
-            </a:extLst>
-          </p:cNvPr>
-          <p:cNvSpPr>
-            <a:spLocks xmlns:a="http://schemas.openxmlformats.org/drawingml/2006/main" noGrp="1"/>
-          </p:cNvSpPr>
-          <p:nvPr/>
-        </p:nvSpPr>
-        <p:spPr>
-          <a:xfrm xmlns:a="http://schemas.openxmlformats.org/drawingml/2006/main">
-            <a:off x="685800" y="2724150"/>
-            <a:ext cx="8572500" cy="723900"/>
-          </a:xfrm>
-          <a:prstGeom xmlns:a="http://schemas.openxmlformats.org/drawingml/2006/main" prst="rect">
-            <a:avLst/>
-          </a:prstGeom>
-          <a:noFill xmlns:a="http://schemas.openxmlformats.org/drawingml/2006/main"/>
-          <a:ln xmlns:a="http://schemas.openxmlformats.org/drawingml/2006/main" w="0">
-            <a:noFill/>
-            <a:prstDash val="solid"/>
-          </a:ln>
-        </p:spPr>
-        <p:txBody>
-          <a:bodyPr xmlns:a="http://schemas.openxmlformats.org/drawingml/2006/main"/>
-          <a:lstStyle xmlns:a="http://schemas.openxmlformats.org/drawingml/2006/main"/>
-          <a:p xmlns:a="http://schemas.openxmlformats.org/drawingml/2006/main">
-            <a:pPr algn="l">
-              <a:defRPr sz="1800" b="0">
-                <a:solidFill>
-                  <a:srgbClr val="4B5563"/>
-                </a:solidFill>
-              </a:defRPr>
-            </a:pPr>
-            <a:r>
-              <a:rPr sz="1800" b="0">
-                <a:solidFill>
-                  <a:srgbClr val="4B5563"/>
-                </a:solidFill>
-              </a:rPr>
-              <a:t>The demo hypothesis: a medium model in a strong harness can outperform a strong model in a weak or missing harness.</a:t>
-            </a:r>
-          </a:p>
-        </p:txBody>
-      </p:sp>
-      <p:sp>
-        <p:nvSpPr>
-          <p:cNvPr id="4" name="promise">
-            <a:extLst xmlns:a="http://schemas.openxmlformats.org/drawingml/2006/main">
-              <a:ext uri="{FF2B5EF4-FFF2-40B4-BE49-F238E27FC236}">
-                <a16:creationId xmlns:a16="http://schemas.microsoft.com/office/drawing/2014/main" id="{E597D0B1-C910-47AD-AA3F-E9CB6A7514DD}"/>
-              </a:ext>
-            </a:extLst>
-          </p:cNvPr>
-          <p:cNvSpPr>
-            <a:spLocks xmlns:a="http://schemas.openxmlformats.org/drawingml/2006/main" noGrp="1"/>
-          </p:cNvSpPr>
-          <p:nvPr/>
-        </p:nvSpPr>
-        <p:spPr>
-          <a:xfrm xmlns:a="http://schemas.openxmlformats.org/drawingml/2006/main">
-            <a:off x="685800" y="4495800"/>
-            <a:ext cx="7810500" cy="838200"/>
-          </a:xfrm>
-          <a:prstGeom xmlns:a="http://schemas.openxmlformats.org/drawingml/2006/main" prst="rect">
-            <a:avLst/>
+                <a16:creationId xmlns:a16="http://schemas.microsoft.com/office/drawing/2014/main" id="{568915E1-425B-4590-9A33-288606849B50}"/>
+              </a:ext>
+            </a:extLst>
+          </p:cNvPr>
+          <p:cNvSpPr>
+            <a:spLocks xmlns:a="http://schemas.openxmlformats.org/drawingml/2006/main" noGrp="1"/>
+          </p:cNvSpPr>
+          <p:nvPr/>
+        </p:nvSpPr>
+        <p:spPr>
+          <a:xfrm xmlns:a="http://schemas.openxmlformats.org/drawingml/2006/main">
+            <a:off x="685800" y="2076450"/>
+            <a:ext cx="7810500" cy="685800"/>
+          </a:xfrm>
+          <a:prstGeom xmlns:a="http://schemas.openxmlformats.org/drawingml/2006/main" prst="rect">
+            <a:avLst/>
+          </a:prstGeom>
+          <a:noFill xmlns:a="http://schemas.openxmlformats.org/drawingml/2006/main"/>
+          <a:ln xmlns:a="http://schemas.openxmlformats.org/drawingml/2006/main" w="0">
+            <a:noFill/>
+            <a:prstDash val="solid"/>
+          </a:ln>
+        </p:spPr>
+        <p:txBody>
+          <a:bodyPr xmlns:a="http://schemas.openxmlformats.org/drawingml/2006/main"/>
+          <a:lstStyle xmlns:a="http://schemas.openxmlformats.org/drawingml/2006/main"/>
+          <a:p xmlns:a="http://schemas.openxmlformats.org/drawingml/2006/main">
+            <a:pPr>
+              <a:defRPr sz="1425">
+                <a:solidFill>
+                  <a:srgbClr val="45556C"/>
+                </a:solidFill>
+              </a:defRPr>
+            </a:pPr>
+            <a:r>
+              <a:rPr sz="1425">
+                <a:solidFill>
+                  <a:srgbClr val="45556C"/>
+                </a:solidFill>
+              </a:rPr>
+              <a:t>The model supplies reasoning. The harness supplies guides, tools, memory, sensors, safety gates, and repair loops that turn reasoning into a governed workflow.</a:t>
+            </a:r>
+          </a:p>
+        </p:txBody>
+      </p:sp>
+      <p:sp>
+        <p:nvSpPr>
+          <p:cNvPr id="4" name="example-heading">
+            <a:extLst xmlns:a="http://schemas.openxmlformats.org/drawingml/2006/main">
+              <a:ext uri="{FF2B5EF4-FFF2-40B4-BE49-F238E27FC236}">
+                <a16:creationId xmlns:a16="http://schemas.microsoft.com/office/drawing/2014/main" id="{C97F5CA1-09F5-4A98-BDC3-5D7A9D23AB38}"/>
+              </a:ext>
+            </a:extLst>
+          </p:cNvPr>
+          <p:cNvSpPr>
+            <a:spLocks xmlns:a="http://schemas.openxmlformats.org/drawingml/2006/main" noGrp="1"/>
+          </p:cNvSpPr>
+          <p:nvPr/>
+        </p:nvSpPr>
+        <p:spPr>
+          <a:xfrm xmlns:a="http://schemas.openxmlformats.org/drawingml/2006/main">
+            <a:off x="685800" y="2895600"/>
+            <a:ext cx="4000500" cy="342900"/>
+          </a:xfrm>
+          <a:prstGeom xmlns:a="http://schemas.openxmlformats.org/drawingml/2006/main" prst="rect">
+            <a:avLst/>
+          </a:prstGeom>
+          <a:noFill xmlns:a="http://schemas.openxmlformats.org/drawingml/2006/main"/>
+          <a:ln xmlns:a="http://schemas.openxmlformats.org/drawingml/2006/main" w="0">
+            <a:noFill/>
+            <a:prstDash val="solid"/>
+          </a:ln>
+        </p:spPr>
+        <p:txBody>
+          <a:bodyPr xmlns:a="http://schemas.openxmlformats.org/drawingml/2006/main"/>
+          <a:lstStyle xmlns:a="http://schemas.openxmlformats.org/drawingml/2006/main"/>
+          <a:p xmlns:a="http://schemas.openxmlformats.org/drawingml/2006/main">
+            <a:pPr>
+              <a:defRPr sz="1875" b="1">
+                <a:solidFill>
+                  <a:srgbClr val="0F172B"/>
+                </a:solidFill>
+              </a:defRPr>
+            </a:pPr>
+            <a:r>
+              <a:rPr sz="1875" b="1">
+                <a:solidFill>
+                  <a:srgbClr val="0F172B"/>
+                </a:solidFill>
+              </a:rPr>
+              <a:t>Same model, different tack</a:t>
+            </a:r>
+          </a:p>
+        </p:txBody>
+      </p:sp>
+      <p:sp>
+        <p:nvSpPr>
+          <p:cNvPr id="5" name="bare-run">
+            <a:extLst xmlns:a="http://schemas.openxmlformats.org/drawingml/2006/main">
+              <a:ext uri="{FF2B5EF4-FFF2-40B4-BE49-F238E27FC236}">
+                <a16:creationId xmlns:a16="http://schemas.microsoft.com/office/drawing/2014/main" id="{EDD61196-CBCD-4DA6-B7AF-475E5F5E4475}"/>
+              </a:ext>
+            </a:extLst>
+          </p:cNvPr>
+          <p:cNvSpPr>
+            <a:spLocks xmlns:a="http://schemas.openxmlformats.org/drawingml/2006/main" noGrp="1"/>
+          </p:cNvSpPr>
+          <p:nvPr/>
+        </p:nvSpPr>
+        <p:spPr>
+          <a:xfrm xmlns:a="http://schemas.openxmlformats.org/drawingml/2006/main">
+            <a:off x="685800" y="3390900"/>
+            <a:ext cx="2381250" cy="1257300"/>
+          </a:xfrm>
+          <a:prstGeom xmlns:a="http://schemas.openxmlformats.org/drawingml/2006/main" prst="roundRect">
+            <a:avLst>
+              <a:gd name="adj" fmla="val 7576"/>
+            </a:avLst>
           </a:prstGeom>
           <a:solidFill xmlns:a="http://schemas.openxmlformats.org/drawingml/2006/main">
-            <a:srgbClr val="EAF6FF"/>
+            <a:srgbClr val="FFF1F2"/>
+          </a:solidFill>
+          <a:ln xmlns:a="http://schemas.openxmlformats.org/drawingml/2006/main" w="13335">
+            <a:solidFill>
+              <a:srgbClr val="FFCCD3"/>
+            </a:solidFill>
+            <a:prstDash val="solid"/>
+          </a:ln>
+        </p:spPr>
+        <p:txBody>
+          <a:bodyPr xmlns:a="http://schemas.openxmlformats.org/drawingml/2006/main"/>
+          <a:lstStyle xmlns:a="http://schemas.openxmlformats.org/drawingml/2006/main"/>
+          <a:p xmlns:a="http://schemas.openxmlformats.org/drawingml/2006/main">
+            <a:pPr algn="ctr">
+              <a:defRPr sz="1500" b="1">
+                <a:solidFill>
+                  <a:srgbClr val="8B0836"/>
+                </a:solidFill>
+              </a:defRPr>
+            </a:pPr>
+            <a:r>
+              <a:rPr sz="1500" b="1">
+                <a:solidFill>
+                  <a:srgbClr val="8B0836"/>
+                </a:solidFill>
+              </a:rPr>
+              <a:t>Bare run</a:t>
+            </a:r>
+          </a:p>
+          <a:p xmlns:a="http://schemas.openxmlformats.org/drawingml/2006/main">
+            <a:pPr algn="ctr">
+              <a:defRPr sz="1500" b="1">
+                <a:solidFill>
+                  <a:srgbClr val="8B0836"/>
+                </a:solidFill>
+              </a:defRPr>
+            </a:pPr>
+            <a:r>
+              <a:rPr sz="1500" b="1">
+                <a:solidFill>
+                  <a:srgbClr val="8B0836"/>
+                </a:solidFill>
+              </a:rPr>
+              <a:t>20 min / $9</a:t>
+            </a:r>
+          </a:p>
+          <a:p xmlns:a="http://schemas.openxmlformats.org/drawingml/2006/main">
+            <a:pPr algn="ctr">
+              <a:defRPr sz="1500" b="1">
+                <a:solidFill>
+                  <a:srgbClr val="8B0836"/>
+                </a:solidFill>
+              </a:defRPr>
+            </a:pPr>
+            <a:r>
+              <a:rPr sz="1500" b="1">
+                <a:solidFill>
+                  <a:srgbClr val="8B0836"/>
+                </a:solidFill>
+              </a:rPr>
+              <a:t>Core features failed</a:t>
+            </a:r>
+          </a:p>
+        </p:txBody>
+      </p:sp>
+      <p:sp>
+        <p:nvSpPr>
+          <p:cNvPr id="6" name="full-harness-run">
+            <a:extLst xmlns:a="http://schemas.openxmlformats.org/drawingml/2006/main">
+              <a:ext uri="{FF2B5EF4-FFF2-40B4-BE49-F238E27FC236}">
+                <a16:creationId xmlns:a16="http://schemas.microsoft.com/office/drawing/2014/main" id="{B02BE936-FB70-42B8-9798-2E56EFA2C438}"/>
+              </a:ext>
+            </a:extLst>
+          </p:cNvPr>
+          <p:cNvSpPr>
+            <a:spLocks xmlns:a="http://schemas.openxmlformats.org/drawingml/2006/main" noGrp="1"/>
+          </p:cNvSpPr>
+          <p:nvPr/>
+        </p:nvSpPr>
+        <p:spPr>
+          <a:xfrm xmlns:a="http://schemas.openxmlformats.org/drawingml/2006/main">
+            <a:off x="3371850" y="3390900"/>
+            <a:ext cx="3219450" cy="1257300"/>
+          </a:xfrm>
+          <a:prstGeom xmlns:a="http://schemas.openxmlformats.org/drawingml/2006/main" prst="roundRect">
+            <a:avLst>
+              <a:gd name="adj" fmla="val 7576"/>
+            </a:avLst>
+          </a:prstGeom>
+          <a:solidFill xmlns:a="http://schemas.openxmlformats.org/drawingml/2006/main">
+            <a:srgbClr val="ECFDF5"/>
+          </a:solidFill>
+          <a:ln xmlns:a="http://schemas.openxmlformats.org/drawingml/2006/main" w="13335">
+            <a:solidFill>
+              <a:srgbClr val="A4F4CF"/>
+            </a:solidFill>
+            <a:prstDash val="solid"/>
+          </a:ln>
+        </p:spPr>
+        <p:txBody>
+          <a:bodyPr xmlns:a="http://schemas.openxmlformats.org/drawingml/2006/main"/>
+          <a:lstStyle xmlns:a="http://schemas.openxmlformats.org/drawingml/2006/main"/>
+          <a:p xmlns:a="http://schemas.openxmlformats.org/drawingml/2006/main">
+            <a:pPr algn="ctr">
+              <a:defRPr sz="1425" b="1">
+                <a:solidFill>
+                  <a:srgbClr val="004F3B"/>
+                </a:solidFill>
+              </a:defRPr>
+            </a:pPr>
+            <a:r>
+              <a:rPr sz="1425" b="1">
+                <a:solidFill>
+                  <a:srgbClr val="004F3B"/>
+                </a:solidFill>
+              </a:rPr>
+              <a:t>Full harness</a:t>
+            </a:r>
+          </a:p>
+          <a:p xmlns:a="http://schemas.openxmlformats.org/drawingml/2006/main">
+            <a:pPr algn="ctr">
+              <a:defRPr sz="1425" b="1">
+                <a:solidFill>
+                  <a:srgbClr val="004F3B"/>
+                </a:solidFill>
+              </a:defRPr>
+            </a:pPr>
+            <a:r>
+              <a:rPr sz="1425" b="1">
+                <a:solidFill>
+                  <a:srgbClr val="004F3B"/>
+                </a:solidFill>
+              </a:rPr>
+              <a:t>Planner + generator + evaluator</a:t>
+            </a:r>
+          </a:p>
+          <a:p xmlns:a="http://schemas.openxmlformats.org/drawingml/2006/main">
+            <a:pPr algn="ctr">
+              <a:defRPr sz="1425" b="1">
+                <a:solidFill>
+                  <a:srgbClr val="004F3B"/>
+                </a:solidFill>
+              </a:defRPr>
+            </a:pPr>
+            <a:r>
+              <a:rPr sz="1425" b="1">
+                <a:solidFill>
+                  <a:srgbClr val="004F3B"/>
+                </a:solidFill>
+              </a:rPr>
+              <a:t>6 hr / $200 / playable</a:t>
+            </a:r>
+          </a:p>
+        </p:txBody>
+      </p:sp>
+      <p:cxnSp>
+        <p:nvCxnSpPr>
+          <p:cNvPr id="26" name=""/>
+          <p:cNvCxnSpPr>
+            <a:stCxn xmlns:a="http://schemas.openxmlformats.org/drawingml/2006/main" id="5" idx="3"/>
+            <a:endCxn xmlns:a="http://schemas.openxmlformats.org/drawingml/2006/main" id="6" idx="1"/>
+          </p:cNvCxnSpPr>
+          <p:nvPr/>
+        </p:nvCxnSpPr>
+        <p:spPr>
+          <a:xfrm xmlns:a="http://schemas.openxmlformats.org/drawingml/2006/main">
+            <a:off x="3067050" y="4019550"/>
+            <a:ext cx="304800" cy="0"/>
+          </a:xfrm>
+          <a:prstGeom xmlns:a="http://schemas.openxmlformats.org/drawingml/2006/main" prst="straightConnector1">
+            <a:avLst/>
+          </a:prstGeom>
+          <a:ln xmlns:a="http://schemas.openxmlformats.org/drawingml/2006/main" w="19050">
+            <a:solidFill>
+              <a:srgbClr val="90A1B9"/>
+            </a:solidFill>
+            <a:prstDash val="solid"/>
+            <a:tailEnd type="arrow" w="med" len="med"/>
+          </a:ln>
+        </p:spPr>
+      </p:cxnSp>
+      <p:sp>
+        <p:nvSpPr>
+          <p:cNvPr id="8" name="example-note">
+            <a:extLst xmlns:a="http://schemas.openxmlformats.org/drawingml/2006/main">
+              <a:ext uri="{FF2B5EF4-FFF2-40B4-BE49-F238E27FC236}">
+                <a16:creationId xmlns:a16="http://schemas.microsoft.com/office/drawing/2014/main" id="{F53D7D00-AE4A-46EF-A53D-7D687980DD28}"/>
+              </a:ext>
+            </a:extLst>
+          </p:cNvPr>
+          <p:cNvSpPr>
+            <a:spLocks xmlns:a="http://schemas.openxmlformats.org/drawingml/2006/main" noGrp="1"/>
+          </p:cNvSpPr>
+          <p:nvPr/>
+        </p:nvSpPr>
+        <p:spPr>
+          <a:xfrm xmlns:a="http://schemas.openxmlformats.org/drawingml/2006/main">
+            <a:off x="685800" y="4857750"/>
+            <a:ext cx="5905500" cy="514350"/>
+          </a:xfrm>
+          <a:prstGeom xmlns:a="http://schemas.openxmlformats.org/drawingml/2006/main" prst="rect">
+            <a:avLst/>
+          </a:prstGeom>
+          <a:noFill xmlns:a="http://schemas.openxmlformats.org/drawingml/2006/main"/>
+          <a:ln xmlns:a="http://schemas.openxmlformats.org/drawingml/2006/main" w="0">
+            <a:noFill/>
+            <a:prstDash val="solid"/>
+          </a:ln>
+        </p:spPr>
+        <p:txBody>
+          <a:bodyPr xmlns:a="http://schemas.openxmlformats.org/drawingml/2006/main"/>
+          <a:lstStyle xmlns:a="http://schemas.openxmlformats.org/drawingml/2006/main"/>
+          <a:p xmlns:a="http://schemas.openxmlformats.org/drawingml/2006/main">
+            <a:pPr>
+              <a:defRPr sz="1500" b="1">
+                <a:solidFill>
+                  <a:srgbClr val="1D293D"/>
+                </a:solidFill>
+              </a:defRPr>
+            </a:pPr>
+            <a:r>
+              <a:rPr sz="1500" b="1">
+                <a:solidFill>
+                  <a:srgbClr val="1D293D"/>
+                </a:solidFill>
+              </a:rPr>
+              <a:t>What changed was not the model weights. It was the engineering infrastructure around the model.</a:t>
+            </a:r>
+          </a:p>
+        </p:txBody>
+      </p:sp>
+      <p:sp>
+        <p:nvSpPr>
+          <p:cNvPr id="9" name="diagram-frame">
+            <a:extLst xmlns:a="http://schemas.openxmlformats.org/drawingml/2006/main">
+              <a:ext uri="{FF2B5EF4-FFF2-40B4-BE49-F238E27FC236}">
+                <a16:creationId xmlns:a16="http://schemas.microsoft.com/office/drawing/2014/main" id="{FD2E1E68-E937-49C8-A796-D34F05FF64BC}"/>
+              </a:ext>
+            </a:extLst>
+          </p:cNvPr>
+          <p:cNvSpPr>
+            <a:spLocks xmlns:a="http://schemas.openxmlformats.org/drawingml/2006/main" noGrp="1"/>
+          </p:cNvSpPr>
+          <p:nvPr/>
+        </p:nvSpPr>
+        <p:spPr>
+          <a:xfrm xmlns:a="http://schemas.openxmlformats.org/drawingml/2006/main">
+            <a:off x="7067550" y="2819400"/>
+            <a:ext cx="4438650" cy="2724150"/>
+          </a:xfrm>
+          <a:prstGeom xmlns:a="http://schemas.openxmlformats.org/drawingml/2006/main" prst="roundRect">
+            <a:avLst>
+              <a:gd name="adj" fmla="val 4895"/>
+            </a:avLst>
+          </a:prstGeom>
+          <a:solidFill xmlns:a="http://schemas.openxmlformats.org/drawingml/2006/main">
+            <a:srgbClr val="F8FAFC"/>
           </a:solidFill>
           <a:ln xmlns:a="http://schemas.openxmlformats.org/drawingml/2006/main" w="9525">
             <a:solidFill>
-              <a:srgbClr val="93C5FD"/>
+              <a:srgbClr val="E2E8F0"/>
             </a:solidFill>
             <a:prstDash val="solid"/>
           </a:ln>
@@ -2299,97 +2622,466 @@
       </p:sp>
       <p:sp>
         <p:nvSpPr>
-          <p:cNvPr id="5" name="promise-text">
-            <a:extLst xmlns:a="http://schemas.openxmlformats.org/drawingml/2006/main">
-              <a:ext uri="{FF2B5EF4-FFF2-40B4-BE49-F238E27FC236}">
-                <a16:creationId xmlns:a16="http://schemas.microsoft.com/office/drawing/2014/main" id="{74906FED-BD78-4510-B26C-D3D2798CBC88}"/>
-              </a:ext>
-            </a:extLst>
-          </p:cNvPr>
-          <p:cNvSpPr>
-            <a:spLocks xmlns:a="http://schemas.openxmlformats.org/drawingml/2006/main" noGrp="1"/>
-          </p:cNvSpPr>
-          <p:nvPr/>
-        </p:nvSpPr>
-        <p:spPr>
-          <a:xfrm xmlns:a="http://schemas.openxmlformats.org/drawingml/2006/main">
-            <a:off x="933450" y="4686300"/>
-            <a:ext cx="7239000" cy="400050"/>
-          </a:xfrm>
-          <a:prstGeom xmlns:a="http://schemas.openxmlformats.org/drawingml/2006/main" prst="rect">
-            <a:avLst/>
-          </a:prstGeom>
-          <a:noFill xmlns:a="http://schemas.openxmlformats.org/drawingml/2006/main"/>
-          <a:ln xmlns:a="http://schemas.openxmlformats.org/drawingml/2006/main" w="0">
-            <a:noFill/>
-            <a:prstDash val="solid"/>
-          </a:ln>
-        </p:spPr>
-        <p:txBody>
-          <a:bodyPr xmlns:a="http://schemas.openxmlformats.org/drawingml/2006/main"/>
-          <a:lstStyle xmlns:a="http://schemas.openxmlformats.org/drawingml/2006/main"/>
-          <a:p xmlns:a="http://schemas.openxmlformats.org/drawingml/2006/main">
-            <a:pPr algn="l">
-              <a:defRPr sz="1875" b="1">
-                <a:solidFill>
-                  <a:srgbClr val="111827"/>
-                </a:solidFill>
-              </a:defRPr>
-            </a:pPr>
-            <a:r>
-              <a:rPr sz="1875" b="1">
-                <a:solidFill>
-                  <a:srgbClr val="111827"/>
-                </a:solidFill>
-              </a:rPr>
-              <a:t>This deck teaches the principles first, then maps each one to our code and Colab demo.</a:t>
-            </a:r>
-          </a:p>
-        </p:txBody>
-      </p:sp>
-      <p:sp>
-        <p:nvSpPr>
-          <p:cNvPr id="6" name="footer-left">
-            <a:extLst xmlns:a="http://schemas.openxmlformats.org/drawingml/2006/main">
-              <a:ext uri="{FF2B5EF4-FFF2-40B4-BE49-F238E27FC236}">
-                <a16:creationId xmlns:a16="http://schemas.microsoft.com/office/drawing/2014/main" id="{372B7699-599C-4B25-A069-DA67000A89E5}"/>
-              </a:ext>
-            </a:extLst>
-          </p:cNvPr>
-          <p:cNvSpPr>
-            <a:spLocks xmlns:a="http://schemas.openxmlformats.org/drawingml/2006/main" noGrp="1"/>
-          </p:cNvSpPr>
-          <p:nvPr/>
-        </p:nvSpPr>
-        <p:spPr>
-          <a:xfrm xmlns:a="http://schemas.openxmlformats.org/drawingml/2006/main">
-            <a:off x="685800" y="6457950"/>
-            <a:ext cx="4000500" cy="190500"/>
-          </a:xfrm>
-          <a:prstGeom xmlns:a="http://schemas.openxmlformats.org/drawingml/2006/main" prst="rect">
-            <a:avLst/>
-          </a:prstGeom>
-          <a:noFill xmlns:a="http://schemas.openxmlformats.org/drawingml/2006/main"/>
-          <a:ln xmlns:a="http://schemas.openxmlformats.org/drawingml/2006/main" w="0">
-            <a:noFill/>
-            <a:prstDash val="solid"/>
-          </a:ln>
-        </p:spPr>
-        <p:txBody>
-          <a:bodyPr xmlns:a="http://schemas.openxmlformats.org/drawingml/2006/main"/>
-          <a:lstStyle xmlns:a="http://schemas.openxmlformats.org/drawingml/2006/main"/>
-          <a:p xmlns:a="http://schemas.openxmlformats.org/drawingml/2006/main">
-            <a:pPr algn="l">
-              <a:defRPr sz="825" b="0">
-                <a:solidFill>
-                  <a:srgbClr val="6B7280"/>
-                </a:solidFill>
-              </a:defRPr>
-            </a:pPr>
-            <a:r>
-              <a:rPr sz="825" b="0">
-                <a:solidFill>
-                  <a:srgbClr val="6B7280"/>
+          <p:cNvPr id="10" name="diagram-title">
+            <a:extLst xmlns:a="http://schemas.openxmlformats.org/drawingml/2006/main">
+              <a:ext uri="{FF2B5EF4-FFF2-40B4-BE49-F238E27FC236}">
+                <a16:creationId xmlns:a16="http://schemas.microsoft.com/office/drawing/2014/main" id="{051D4549-3245-461D-AC25-28B62ECAD137}"/>
+              </a:ext>
+            </a:extLst>
+          </p:cNvPr>
+          <p:cNvSpPr>
+            <a:spLocks xmlns:a="http://schemas.openxmlformats.org/drawingml/2006/main" noGrp="1"/>
+          </p:cNvSpPr>
+          <p:nvPr/>
+        </p:nvSpPr>
+        <p:spPr>
+          <a:xfrm xmlns:a="http://schemas.openxmlformats.org/drawingml/2006/main">
+            <a:off x="7296150" y="2990850"/>
+            <a:ext cx="2857500" cy="285750"/>
+          </a:xfrm>
+          <a:prstGeom xmlns:a="http://schemas.openxmlformats.org/drawingml/2006/main" prst="rect">
+            <a:avLst/>
+          </a:prstGeom>
+          <a:noFill xmlns:a="http://schemas.openxmlformats.org/drawingml/2006/main"/>
+          <a:ln xmlns:a="http://schemas.openxmlformats.org/drawingml/2006/main" w="0">
+            <a:noFill/>
+            <a:prstDash val="solid"/>
+          </a:ln>
+        </p:spPr>
+        <p:txBody>
+          <a:bodyPr xmlns:a="http://schemas.openxmlformats.org/drawingml/2006/main"/>
+          <a:lstStyle xmlns:a="http://schemas.openxmlformats.org/drawingml/2006/main"/>
+          <a:p xmlns:a="http://schemas.openxmlformats.org/drawingml/2006/main">
+            <a:pPr>
+              <a:defRPr sz="1650" b="1">
+                <a:solidFill>
+                  <a:srgbClr val="0F172B"/>
+                </a:solidFill>
+              </a:defRPr>
+            </a:pPr>
+            <a:r>
+              <a:rPr sz="1650" b="1">
+                <a:solidFill>
+                  <a:srgbClr val="0F172B"/>
+                </a:solidFill>
+              </a:rPr>
+              <a:t>What constitutes a harness</a:t>
+            </a:r>
+          </a:p>
+        </p:txBody>
+      </p:sp>
+      <p:sp>
+        <p:nvSpPr>
+          <p:cNvPr id="11" name="diagram-model">
+            <a:extLst xmlns:a="http://schemas.openxmlformats.org/drawingml/2006/main">
+              <a:ext uri="{FF2B5EF4-FFF2-40B4-BE49-F238E27FC236}">
+                <a16:creationId xmlns:a16="http://schemas.microsoft.com/office/drawing/2014/main" id="{D7DB0B95-BE14-44D9-8840-B8EF0D0FE62A}"/>
+              </a:ext>
+            </a:extLst>
+          </p:cNvPr>
+          <p:cNvSpPr>
+            <a:spLocks xmlns:a="http://schemas.openxmlformats.org/drawingml/2006/main" noGrp="1"/>
+          </p:cNvSpPr>
+          <p:nvPr/>
+        </p:nvSpPr>
+        <p:spPr>
+          <a:xfrm xmlns:a="http://schemas.openxmlformats.org/drawingml/2006/main">
+            <a:off x="7372350" y="3543300"/>
+            <a:ext cx="1104900" cy="742950"/>
+          </a:xfrm>
+          <a:prstGeom xmlns:a="http://schemas.openxmlformats.org/drawingml/2006/main" prst="roundRect">
+            <a:avLst>
+              <a:gd name="adj" fmla="val 15385"/>
+            </a:avLst>
+          </a:prstGeom>
+          <a:solidFill xmlns:a="http://schemas.openxmlformats.org/drawingml/2006/main">
+            <a:srgbClr val="F5F3FF"/>
+          </a:solidFill>
+          <a:ln xmlns:a="http://schemas.openxmlformats.org/drawingml/2006/main" w="13335">
+            <a:solidFill>
+              <a:srgbClr val="DDD6FF"/>
+            </a:solidFill>
+            <a:prstDash val="solid"/>
+          </a:ln>
+        </p:spPr>
+        <p:txBody>
+          <a:bodyPr xmlns:a="http://schemas.openxmlformats.org/drawingml/2006/main"/>
+          <a:lstStyle xmlns:a="http://schemas.openxmlformats.org/drawingml/2006/main"/>
+          <a:p xmlns:a="http://schemas.openxmlformats.org/drawingml/2006/main">
+            <a:pPr algn="ctr">
+              <a:defRPr sz="1050" b="1">
+                <a:solidFill>
+                  <a:srgbClr val="4D179A"/>
+                </a:solidFill>
+              </a:defRPr>
+            </a:pPr>
+            <a:r>
+              <a:rPr sz="1050" b="1">
+                <a:solidFill>
+                  <a:srgbClr val="4D179A"/>
+                </a:solidFill>
+              </a:rPr>
+              <a:t>MODEL</a:t>
+            </a:r>
+          </a:p>
+          <a:p xmlns:a="http://schemas.openxmlformats.org/drawingml/2006/main">
+            <a:pPr algn="ctr">
+              <a:defRPr sz="1050" b="1">
+                <a:solidFill>
+                  <a:srgbClr val="4D179A"/>
+                </a:solidFill>
+              </a:defRPr>
+            </a:pPr>
+            <a:r>
+              <a:rPr sz="1050" b="1">
+                <a:solidFill>
+                  <a:srgbClr val="4D179A"/>
+                </a:solidFill>
+              </a:rPr>
+              <a:t>LLM reasoning engine</a:t>
+            </a:r>
+          </a:p>
+        </p:txBody>
+      </p:sp>
+      <p:sp>
+        <p:nvSpPr>
+          <p:cNvPr id="12" name="diagram-harness">
+            <a:extLst xmlns:a="http://schemas.openxmlformats.org/drawingml/2006/main">
+              <a:ext uri="{FF2B5EF4-FFF2-40B4-BE49-F238E27FC236}">
+                <a16:creationId xmlns:a16="http://schemas.microsoft.com/office/drawing/2014/main" id="{89345492-FE85-4D25-A2D6-E23669167F90}"/>
+              </a:ext>
+            </a:extLst>
+          </p:cNvPr>
+          <p:cNvSpPr>
+            <a:spLocks xmlns:a="http://schemas.openxmlformats.org/drawingml/2006/main" noGrp="1"/>
+          </p:cNvSpPr>
+          <p:nvPr/>
+        </p:nvSpPr>
+        <p:spPr>
+          <a:xfrm xmlns:a="http://schemas.openxmlformats.org/drawingml/2006/main">
+            <a:off x="8858250" y="3390900"/>
+            <a:ext cx="2286000" cy="1047750"/>
+          </a:xfrm>
+          <a:prstGeom xmlns:a="http://schemas.openxmlformats.org/drawingml/2006/main" prst="roundRect">
+            <a:avLst>
+              <a:gd name="adj" fmla="val 10909"/>
+            </a:avLst>
+          </a:prstGeom>
+          <a:solidFill xmlns:a="http://schemas.openxmlformats.org/drawingml/2006/main">
+            <a:srgbClr val="EFF6FF"/>
+          </a:solidFill>
+          <a:ln xmlns:a="http://schemas.openxmlformats.org/drawingml/2006/main" w="13335">
+            <a:solidFill>
+              <a:srgbClr val="BEDBFF"/>
+            </a:solidFill>
+            <a:prstDash val="solid"/>
+          </a:ln>
+        </p:spPr>
+        <p:txBody>
+          <a:bodyPr xmlns:a="http://schemas.openxmlformats.org/drawingml/2006/main"/>
+          <a:lstStyle xmlns:a="http://schemas.openxmlformats.org/drawingml/2006/main"/>
+          <a:p xmlns:a="http://schemas.openxmlformats.org/drawingml/2006/main">
+            <a:pPr algn="ctr">
+              <a:defRPr sz="1050" b="1">
+                <a:solidFill>
+                  <a:srgbClr val="1C398E"/>
+                </a:solidFill>
+              </a:defRPr>
+            </a:pPr>
+            <a:r>
+              <a:rPr sz="1050" b="1">
+                <a:solidFill>
+                  <a:srgbClr val="1C398E"/>
+                </a:solidFill>
+              </a:rPr>
+              <a:t>HARNESS</a:t>
+            </a:r>
+          </a:p>
+          <a:p xmlns:a="http://schemas.openxmlformats.org/drawingml/2006/main">
+            <a:pPr algn="ctr">
+              <a:defRPr sz="1050" b="1">
+                <a:solidFill>
+                  <a:srgbClr val="1C398E"/>
+                </a:solidFill>
+              </a:defRPr>
+            </a:pPr>
+            <a:r>
+              <a:rPr sz="1050" b="1">
+                <a:solidFill>
+                  <a:srgbClr val="1C398E"/>
+                </a:solidFill>
+              </a:rPr>
+              <a:t>Guides • Tools • Memory</a:t>
+            </a:r>
+          </a:p>
+          <a:p xmlns:a="http://schemas.openxmlformats.org/drawingml/2006/main">
+            <a:pPr algn="ctr">
+              <a:defRPr sz="1050" b="1">
+                <a:solidFill>
+                  <a:srgbClr val="1C398E"/>
+                </a:solidFill>
+              </a:defRPr>
+            </a:pPr>
+            <a:r>
+              <a:rPr sz="1050" b="1">
+                <a:solidFill>
+                  <a:srgbClr val="1C398E"/>
+                </a:solidFill>
+              </a:rPr>
+              <a:t>Sensors • Safety • Repair</a:t>
+            </a:r>
+          </a:p>
+        </p:txBody>
+      </p:sp>
+      <p:sp>
+        <p:nvSpPr>
+          <p:cNvPr id="13" name="diagram-agent">
+            <a:extLst xmlns:a="http://schemas.openxmlformats.org/drawingml/2006/main">
+              <a:ext uri="{FF2B5EF4-FFF2-40B4-BE49-F238E27FC236}">
+                <a16:creationId xmlns:a16="http://schemas.microsoft.com/office/drawing/2014/main" id="{40674F3F-5CED-4D85-B0E2-968B83D45934}"/>
+              </a:ext>
+            </a:extLst>
+          </p:cNvPr>
+          <p:cNvSpPr>
+            <a:spLocks xmlns:a="http://schemas.openxmlformats.org/drawingml/2006/main" noGrp="1"/>
+          </p:cNvSpPr>
+          <p:nvPr/>
+        </p:nvSpPr>
+        <p:spPr>
+          <a:xfrm xmlns:a="http://schemas.openxmlformats.org/drawingml/2006/main">
+            <a:off x="8172450" y="4762500"/>
+            <a:ext cx="2343150" cy="552450"/>
+          </a:xfrm>
+          <a:prstGeom xmlns:a="http://schemas.openxmlformats.org/drawingml/2006/main" prst="roundRect">
+            <a:avLst>
+              <a:gd name="adj" fmla="val 20690"/>
+            </a:avLst>
+          </a:prstGeom>
+          <a:solidFill xmlns:a="http://schemas.openxmlformats.org/drawingml/2006/main">
+            <a:srgbClr val="ECFDF5"/>
+          </a:solidFill>
+          <a:ln xmlns:a="http://schemas.openxmlformats.org/drawingml/2006/main" w="13335">
+            <a:solidFill>
+              <a:srgbClr val="A4F4CF"/>
+            </a:solidFill>
+            <a:prstDash val="solid"/>
+          </a:ln>
+        </p:spPr>
+        <p:txBody>
+          <a:bodyPr xmlns:a="http://schemas.openxmlformats.org/drawingml/2006/main"/>
+          <a:lstStyle xmlns:a="http://schemas.openxmlformats.org/drawingml/2006/main"/>
+          <a:p xmlns:a="http://schemas.openxmlformats.org/drawingml/2006/main">
+            <a:pPr algn="ctr">
+              <a:defRPr sz="1125" b="1">
+                <a:solidFill>
+                  <a:srgbClr val="004F3B"/>
+                </a:solidFill>
+              </a:defRPr>
+            </a:pPr>
+            <a:r>
+              <a:rPr sz="1125" b="1">
+                <a:solidFill>
+                  <a:srgbClr val="004F3B"/>
+                </a:solidFill>
+              </a:rPr>
+              <a:t>AGENTIC WORKFLOW</a:t>
+            </a:r>
+          </a:p>
+          <a:p xmlns:a="http://schemas.openxmlformats.org/drawingml/2006/main">
+            <a:pPr algn="ctr">
+              <a:defRPr sz="1125" b="1">
+                <a:solidFill>
+                  <a:srgbClr val="004F3B"/>
+                </a:solidFill>
+              </a:defRPr>
+            </a:pPr>
+            <a:r>
+              <a:rPr sz="1125" b="1">
+                <a:solidFill>
+                  <a:srgbClr val="004F3B"/>
+                </a:solidFill>
+              </a:rPr>
+              <a:t>Perceive → decide → act → learn</a:t>
+            </a:r>
+          </a:p>
+        </p:txBody>
+      </p:sp>
+      <p:cxnSp>
+        <p:nvCxnSpPr>
+          <p:cNvPr id="33" name=""/>
+          <p:cNvCxnSpPr>
+            <a:stCxn xmlns:a="http://schemas.openxmlformats.org/drawingml/2006/main" id="11" idx="3"/>
+            <a:endCxn xmlns:a="http://schemas.openxmlformats.org/drawingml/2006/main" id="12" idx="1"/>
+          </p:cNvCxnSpPr>
+          <p:nvPr/>
+        </p:nvCxnSpPr>
+        <p:spPr>
+          <a:xfrm xmlns:a="http://schemas.openxmlformats.org/drawingml/2006/main">
+            <a:off x="8477250" y="3914775"/>
+            <a:ext cx="381000" cy="0"/>
+          </a:xfrm>
+          <a:prstGeom xmlns:a="http://schemas.openxmlformats.org/drawingml/2006/main" prst="straightConnector1">
+            <a:avLst/>
+          </a:prstGeom>
+          <a:ln xmlns:a="http://schemas.openxmlformats.org/drawingml/2006/main" w="19050">
+            <a:solidFill>
+              <a:srgbClr val="62748E"/>
+            </a:solidFill>
+            <a:prstDash val="solid"/>
+            <a:tailEnd type="arrow" w="med" len="med"/>
+          </a:ln>
+        </p:spPr>
+      </p:cxnSp>
+      <p:cxnSp>
+        <p:nvCxnSpPr>
+          <p:cNvPr id="34" name=""/>
+          <p:cNvCxnSpPr>
+            <a:stCxn xmlns:a="http://schemas.openxmlformats.org/drawingml/2006/main" id="12" idx="2"/>
+            <a:endCxn xmlns:a="http://schemas.openxmlformats.org/drawingml/2006/main" id="13" idx="0"/>
+          </p:cNvCxnSpPr>
+          <p:nvPr/>
+        </p:nvCxnSpPr>
+        <p:spPr>
+          <a:xfrm xmlns:a="http://schemas.openxmlformats.org/drawingml/2006/main" flipH="1">
+            <a:off x="9344025" y="4438650"/>
+            <a:ext cx="657225" cy="323850"/>
+          </a:xfrm>
+          <a:prstGeom xmlns:a="http://schemas.openxmlformats.org/drawingml/2006/main" prst="bentConnector4">
+            <a:avLst>
+              <a:gd name="adj1" fmla="val 0"/>
+              <a:gd name="adj2" fmla="val 50000"/>
+            </a:avLst>
+          </a:prstGeom>
+          <a:ln xmlns:a="http://schemas.openxmlformats.org/drawingml/2006/main" w="19050">
+            <a:solidFill>
+              <a:srgbClr val="62748E"/>
+            </a:solidFill>
+            <a:prstDash val="solid"/>
+            <a:tailEnd type="arrow" w="med" len="med"/>
+          </a:ln>
+        </p:spPr>
+      </p:cxnSp>
+      <p:cxnSp>
+        <p:nvCxnSpPr>
+          <p:cNvPr id="35" name=""/>
+          <p:cNvCxnSpPr>
+            <a:stCxn xmlns:a="http://schemas.openxmlformats.org/drawingml/2006/main" id="11" idx="2"/>
+            <a:endCxn xmlns:a="http://schemas.openxmlformats.org/drawingml/2006/main" id="13" idx="1"/>
+          </p:cNvCxnSpPr>
+          <p:nvPr/>
+        </p:nvCxnSpPr>
+        <p:spPr>
+          <a:xfrm xmlns:a="http://schemas.openxmlformats.org/drawingml/2006/main">
+            <a:off x="7924800" y="4286250"/>
+            <a:ext cx="247650" cy="752475"/>
+          </a:xfrm>
+          <a:prstGeom xmlns:a="http://schemas.openxmlformats.org/drawingml/2006/main" prst="bentConnector3">
+            <a:avLst>
+              <a:gd name="adj1" fmla="val 0"/>
+            </a:avLst>
+          </a:prstGeom>
+          <a:ln xmlns:a="http://schemas.openxmlformats.org/drawingml/2006/main" w="14288">
+            <a:solidFill>
+              <a:srgbClr val="90A1B9"/>
+            </a:solidFill>
+            <a:prstDash val="dash"/>
+            <a:tailEnd type="arrow" w="sm" len="sm"/>
+          </a:ln>
+        </p:spPr>
+      </p:cxnSp>
+      <p:sp>
+        <p:nvSpPr>
+          <p:cNvPr id="17" name="bottom-callout">
+            <a:extLst xmlns:a="http://schemas.openxmlformats.org/drawingml/2006/main">
+              <a:ext uri="{FF2B5EF4-FFF2-40B4-BE49-F238E27FC236}">
+                <a16:creationId xmlns:a16="http://schemas.microsoft.com/office/drawing/2014/main" id="{3C45EFB3-E18C-4B2C-B7AC-BBD132EB335F}"/>
+              </a:ext>
+            </a:extLst>
+          </p:cNvPr>
+          <p:cNvSpPr>
+            <a:spLocks xmlns:a="http://schemas.openxmlformats.org/drawingml/2006/main" noGrp="1"/>
+          </p:cNvSpPr>
+          <p:nvPr/>
+        </p:nvSpPr>
+        <p:spPr>
+          <a:xfrm xmlns:a="http://schemas.openxmlformats.org/drawingml/2006/main">
+            <a:off x="685800" y="5772150"/>
+            <a:ext cx="9810750" cy="419100"/>
+          </a:xfrm>
+          <a:prstGeom xmlns:a="http://schemas.openxmlformats.org/drawingml/2006/main" prst="rect">
+            <a:avLst/>
+          </a:prstGeom>
+          <a:noFill xmlns:a="http://schemas.openxmlformats.org/drawingml/2006/main"/>
+          <a:ln xmlns:a="http://schemas.openxmlformats.org/drawingml/2006/main" w="0">
+            <a:noFill/>
+            <a:prstDash val="solid"/>
+          </a:ln>
+        </p:spPr>
+        <p:txBody>
+          <a:bodyPr xmlns:a="http://schemas.openxmlformats.org/drawingml/2006/main"/>
+          <a:lstStyle xmlns:a="http://schemas.openxmlformats.org/drawingml/2006/main"/>
+          <a:p xmlns:a="http://schemas.openxmlformats.org/drawingml/2006/main">
+            <a:pPr>
+              <a:defRPr sz="1650" b="1">
+                <a:solidFill>
+                  <a:srgbClr val="020618"/>
+                </a:solidFill>
+              </a:defRPr>
+            </a:pPr>
+            <a:r>
+              <a:rPr sz="1650" b="1">
+                <a:solidFill>
+                  <a:srgbClr val="020618"/>
+                </a:solidFill>
+              </a:rPr>
+              <a:t>Demo hypothesis: a medium model in a strong harness can beat a stronger model in a weak or missing harness.</a:t>
+            </a:r>
+          </a:p>
+        </p:txBody>
+      </p:sp>
+      <p:sp>
+        <p:nvSpPr>
+          <p:cNvPr id="18" name="footer">
+            <a:extLst xmlns:a="http://schemas.openxmlformats.org/drawingml/2006/main">
+              <a:ext uri="{FF2B5EF4-FFF2-40B4-BE49-F238E27FC236}">
+                <a16:creationId xmlns:a16="http://schemas.microsoft.com/office/drawing/2014/main" id="{0AF5A810-BBE3-4659-9DBB-B8BAE4DF2C0B}"/>
+              </a:ext>
+            </a:extLst>
+          </p:cNvPr>
+          <p:cNvSpPr>
+            <a:spLocks xmlns:a="http://schemas.openxmlformats.org/drawingml/2006/main" noGrp="1"/>
+          </p:cNvSpPr>
+          <p:nvPr/>
+        </p:nvSpPr>
+        <p:spPr>
+          <a:xfrm xmlns:a="http://schemas.openxmlformats.org/drawingml/2006/main">
+            <a:off x="781050" y="6534150"/>
+            <a:ext cx="3048000" cy="171450"/>
+          </a:xfrm>
+          <a:prstGeom xmlns:a="http://schemas.openxmlformats.org/drawingml/2006/main" prst="rect">
+            <a:avLst/>
+          </a:prstGeom>
+          <a:noFill xmlns:a="http://schemas.openxmlformats.org/drawingml/2006/main"/>
+          <a:ln xmlns:a="http://schemas.openxmlformats.org/drawingml/2006/main" w="0">
+            <a:noFill/>
+            <a:prstDash val="solid"/>
+          </a:ln>
+        </p:spPr>
+        <p:txBody>
+          <a:bodyPr xmlns:a="http://schemas.openxmlformats.org/drawingml/2006/main"/>
+          <a:lstStyle xmlns:a="http://schemas.openxmlformats.org/drawingml/2006/main"/>
+          <a:p xmlns:a="http://schemas.openxmlformats.org/drawingml/2006/main">
+            <a:pPr>
+              <a:defRPr sz="825">
+                <a:solidFill>
+                  <a:srgbClr val="62748E"/>
+                </a:solidFill>
+              </a:defRPr>
+            </a:pPr>
+            <a:r>
+              <a:rPr sz="825">
+                <a:solidFill>
+                  <a:srgbClr val="62748E"/>
                 </a:solidFill>
               </a:rPr>
               <a:t>Ollama Harness Engineering Demo</a:t>
@@ -2399,22 +3091,22 @@
       </p:sp>
       <p:sp>
         <p:nvSpPr>
-          <p:cNvPr id="7" name="footer-num">
-            <a:extLst xmlns:a="http://schemas.openxmlformats.org/drawingml/2006/main">
-              <a:ext uri="{FF2B5EF4-FFF2-40B4-BE49-F238E27FC236}">
-                <a16:creationId xmlns:a16="http://schemas.microsoft.com/office/drawing/2014/main" id="{2C80EC5B-41D8-4C5B-9417-E44662DC1624}"/>
-              </a:ext>
-            </a:extLst>
-          </p:cNvPr>
-          <p:cNvSpPr>
-            <a:spLocks xmlns:a="http://schemas.openxmlformats.org/drawingml/2006/main" noGrp="1"/>
-          </p:cNvSpPr>
-          <p:nvPr/>
-        </p:nvSpPr>
-        <p:spPr>
-          <a:xfrm xmlns:a="http://schemas.openxmlformats.org/drawingml/2006/main">
-            <a:off x="11125200" y="6457950"/>
-            <a:ext cx="381000" cy="190500"/>
+          <p:cNvPr id="19" name="page-number">
+            <a:extLst xmlns:a="http://schemas.openxmlformats.org/drawingml/2006/main">
+              <a:ext uri="{FF2B5EF4-FFF2-40B4-BE49-F238E27FC236}">
+                <a16:creationId xmlns:a16="http://schemas.microsoft.com/office/drawing/2014/main" id="{866F437F-6965-41FB-A054-73CDB74B1B00}"/>
+              </a:ext>
+            </a:extLst>
+          </p:cNvPr>
+          <p:cNvSpPr>
+            <a:spLocks xmlns:a="http://schemas.openxmlformats.org/drawingml/2006/main" noGrp="1"/>
+          </p:cNvSpPr>
+          <p:nvPr/>
+        </p:nvSpPr>
+        <p:spPr>
+          <a:xfrm xmlns:a="http://schemas.openxmlformats.org/drawingml/2006/main">
+            <a:off x="11353800" y="6534150"/>
+            <a:ext cx="190500" cy="171450"/>
           </a:xfrm>
           <a:prstGeom xmlns:a="http://schemas.openxmlformats.org/drawingml/2006/main" prst="rect">
             <a:avLst/>
@@ -2430,16 +3122,16 @@
           <a:lstStyle xmlns:a="http://schemas.openxmlformats.org/drawingml/2006/main"/>
           <a:p xmlns:a="http://schemas.openxmlformats.org/drawingml/2006/main">
             <a:pPr algn="r">
-              <a:defRPr sz="825" b="0">
-                <a:solidFill>
-                  <a:srgbClr val="6B7280"/>
-                </a:solidFill>
-              </a:defRPr>
-            </a:pPr>
-            <a:r>
-              <a:rPr sz="825" b="0">
-                <a:solidFill>
-                  <a:srgbClr val="6B7280"/>
+              <a:defRPr sz="825">
+                <a:solidFill>
+                  <a:srgbClr val="62748E"/>
+                </a:solidFill>
+              </a:defRPr>
+            </a:pPr>
+            <a:r>
+              <a:rPr sz="825">
+                <a:solidFill>
+                  <a:srgbClr val="62748E"/>
                 </a:solidFill>
               </a:rPr>
               <a:t>1</a:t>
@@ -2509,6 +3201,7 @@
           <a:lstStyle xmlns:a="http://schemas.openxmlformats.org/drawingml/2006/main"/>
           <a:p xmlns:a="http://schemas.openxmlformats.org/drawingml/2006/main">
             <a:pPr algn="l">
+              <a:buNone/>
               <a:defRPr sz="975" b="1">
                 <a:solidFill>
                   <a:srgbClr val="6B7280"/>
@@ -2559,6 +3252,7 @@
           <a:lstStyle xmlns:a="http://schemas.openxmlformats.org/drawingml/2006/main"/>
           <a:p xmlns:a="http://schemas.openxmlformats.org/drawingml/2006/main">
             <a:pPr algn="l">
+              <a:buNone/>
               <a:defRPr sz="2850" b="1">
                 <a:solidFill>
                   <a:srgbClr val="111827"/>
@@ -2642,6 +3336,7 @@
           <a:lstStyle xmlns:a="http://schemas.openxmlformats.org/drawingml/2006/main"/>
           <a:p xmlns:a="http://schemas.openxmlformats.org/drawingml/2006/main">
             <a:pPr algn="l">
+              <a:buNone/>
               <a:defRPr sz="1350" b="1">
                 <a:solidFill>
                   <a:srgbClr val="6B7280"/>
@@ -2692,6 +3387,7 @@
           <a:lstStyle xmlns:a="http://schemas.openxmlformats.org/drawingml/2006/main"/>
           <a:p xmlns:a="http://schemas.openxmlformats.org/drawingml/2006/main">
             <a:pPr algn="l">
+              <a:buNone/>
               <a:defRPr sz="2100" b="1">
                 <a:solidFill>
                   <a:srgbClr val="111827"/>
@@ -2775,6 +3471,7 @@
           <a:lstStyle xmlns:a="http://schemas.openxmlformats.org/drawingml/2006/main"/>
           <a:p xmlns:a="http://schemas.openxmlformats.org/drawingml/2006/main">
             <a:pPr algn="l">
+              <a:buNone/>
               <a:defRPr sz="1500" b="1">
                 <a:solidFill>
                   <a:srgbClr val="111827"/>
@@ -2825,6 +3522,7 @@
           <a:lstStyle xmlns:a="http://schemas.openxmlformats.org/drawingml/2006/main"/>
           <a:p xmlns:a="http://schemas.openxmlformats.org/drawingml/2006/main">
             <a:pPr algn="l">
+              <a:buNone/>
               <a:defRPr sz="1275" b="0">
                 <a:solidFill>
                   <a:srgbClr val="4B5563"/>
@@ -2908,6 +3606,7 @@
           <a:lstStyle xmlns:a="http://schemas.openxmlformats.org/drawingml/2006/main"/>
           <a:p xmlns:a="http://schemas.openxmlformats.org/drawingml/2006/main">
             <a:pPr algn="l">
+              <a:buNone/>
               <a:defRPr sz="1500" b="1">
                 <a:solidFill>
                   <a:srgbClr val="111827"/>
@@ -2958,6 +3657,7 @@
           <a:lstStyle xmlns:a="http://schemas.openxmlformats.org/drawingml/2006/main"/>
           <a:p xmlns:a="http://schemas.openxmlformats.org/drawingml/2006/main">
             <a:pPr algn="l">
+              <a:buNone/>
               <a:defRPr sz="1275" b="0">
                 <a:solidFill>
                   <a:srgbClr val="4B5563"/>
@@ -3041,6 +3741,7 @@
           <a:lstStyle xmlns:a="http://schemas.openxmlformats.org/drawingml/2006/main"/>
           <a:p xmlns:a="http://schemas.openxmlformats.org/drawingml/2006/main">
             <a:pPr algn="l">
+              <a:buNone/>
               <a:defRPr sz="1500" b="1">
                 <a:solidFill>
                   <a:srgbClr val="111827"/>
@@ -3091,6 +3792,7 @@
           <a:lstStyle xmlns:a="http://schemas.openxmlformats.org/drawingml/2006/main"/>
           <a:p xmlns:a="http://schemas.openxmlformats.org/drawingml/2006/main">
             <a:pPr algn="l">
+              <a:buNone/>
               <a:defRPr sz="1275" b="0">
                 <a:solidFill>
                   <a:srgbClr val="4B5563"/>
@@ -3141,6 +3843,7 @@
           <a:lstStyle xmlns:a="http://schemas.openxmlformats.org/drawingml/2006/main"/>
           <a:p xmlns:a="http://schemas.openxmlformats.org/drawingml/2006/main">
             <a:pPr algn="ctr">
+              <a:buNone/>
               <a:defRPr sz="1800" b="1">
                 <a:solidFill>
                   <a:srgbClr val="111827"/>
@@ -3191,6 +3894,7 @@
           <a:lstStyle xmlns:a="http://schemas.openxmlformats.org/drawingml/2006/main"/>
           <a:p xmlns:a="http://schemas.openxmlformats.org/drawingml/2006/main">
             <a:pPr algn="l">
+              <a:buNone/>
               <a:defRPr sz="825" b="0">
                 <a:solidFill>
                   <a:srgbClr val="6B7280"/>
@@ -3241,6 +3945,7 @@
           <a:lstStyle xmlns:a="http://schemas.openxmlformats.org/drawingml/2006/main"/>
           <a:p xmlns:a="http://schemas.openxmlformats.org/drawingml/2006/main">
             <a:pPr algn="r">
+              <a:buNone/>
               <a:defRPr sz="825" b="0">
                 <a:solidFill>
                   <a:srgbClr val="6B7280"/>
@@ -3320,6 +4025,7 @@
           <a:lstStyle xmlns:a="http://schemas.openxmlformats.org/drawingml/2006/main"/>
           <a:p xmlns:a="http://schemas.openxmlformats.org/drawingml/2006/main">
             <a:pPr algn="l">
+              <a:buNone/>
               <a:defRPr sz="975" b="1">
                 <a:solidFill>
                   <a:srgbClr val="6B7280"/>
@@ -3370,6 +4076,7 @@
           <a:lstStyle xmlns:a="http://schemas.openxmlformats.org/drawingml/2006/main"/>
           <a:p xmlns:a="http://schemas.openxmlformats.org/drawingml/2006/main">
             <a:pPr algn="l">
+              <a:buNone/>
               <a:defRPr sz="2850" b="1">
                 <a:solidFill>
                   <a:srgbClr val="111827"/>
@@ -3453,6 +4160,7 @@
           <a:lstStyle xmlns:a="http://schemas.openxmlformats.org/drawingml/2006/main"/>
           <a:p xmlns:a="http://schemas.openxmlformats.org/drawingml/2006/main">
             <a:pPr algn="l">
+              <a:buNone/>
               <a:defRPr sz="1350" b="1">
                 <a:solidFill>
                   <a:srgbClr val="6B7280"/>
@@ -3503,6 +4211,7 @@
           <a:lstStyle xmlns:a="http://schemas.openxmlformats.org/drawingml/2006/main"/>
           <a:p xmlns:a="http://schemas.openxmlformats.org/drawingml/2006/main">
             <a:pPr algn="l">
+              <a:buNone/>
               <a:defRPr sz="2100" b="1">
                 <a:solidFill>
                   <a:srgbClr val="111827"/>
@@ -3586,6 +4295,7 @@
           <a:lstStyle xmlns:a="http://schemas.openxmlformats.org/drawingml/2006/main"/>
           <a:p xmlns:a="http://schemas.openxmlformats.org/drawingml/2006/main">
             <a:pPr algn="l">
+              <a:buNone/>
               <a:defRPr sz="1500" b="1">
                 <a:solidFill>
                   <a:srgbClr val="111827"/>
@@ -3636,6 +4346,7 @@
           <a:lstStyle xmlns:a="http://schemas.openxmlformats.org/drawingml/2006/main"/>
           <a:p xmlns:a="http://schemas.openxmlformats.org/drawingml/2006/main">
             <a:pPr algn="l">
+              <a:buNone/>
               <a:defRPr sz="1275" b="0">
                 <a:solidFill>
                   <a:srgbClr val="4B5563"/>
@@ -3719,6 +4430,7 @@
           <a:lstStyle xmlns:a="http://schemas.openxmlformats.org/drawingml/2006/main"/>
           <a:p xmlns:a="http://schemas.openxmlformats.org/drawingml/2006/main">
             <a:pPr algn="l">
+              <a:buNone/>
               <a:defRPr sz="1500" b="1">
                 <a:solidFill>
                   <a:srgbClr val="111827"/>
@@ -3769,6 +4481,7 @@
           <a:lstStyle xmlns:a="http://schemas.openxmlformats.org/drawingml/2006/main"/>
           <a:p xmlns:a="http://schemas.openxmlformats.org/drawingml/2006/main">
             <a:pPr algn="l">
+              <a:buNone/>
               <a:defRPr sz="1275" b="0">
                 <a:solidFill>
                   <a:srgbClr val="4B5563"/>
@@ -3852,6 +4565,7 @@
           <a:lstStyle xmlns:a="http://schemas.openxmlformats.org/drawingml/2006/main"/>
           <a:p xmlns:a="http://schemas.openxmlformats.org/drawingml/2006/main">
             <a:pPr algn="l">
+              <a:buNone/>
               <a:defRPr sz="1500" b="1">
                 <a:solidFill>
                   <a:srgbClr val="111827"/>
@@ -3902,6 +4616,7 @@
           <a:lstStyle xmlns:a="http://schemas.openxmlformats.org/drawingml/2006/main"/>
           <a:p xmlns:a="http://schemas.openxmlformats.org/drawingml/2006/main">
             <a:pPr algn="l">
+              <a:buNone/>
               <a:defRPr sz="1275" b="0">
                 <a:solidFill>
                   <a:srgbClr val="4B5563"/>
@@ -3952,6 +4667,7 @@
           <a:lstStyle xmlns:a="http://schemas.openxmlformats.org/drawingml/2006/main"/>
           <a:p xmlns:a="http://schemas.openxmlformats.org/drawingml/2006/main">
             <a:pPr algn="ctr">
+              <a:buNone/>
               <a:defRPr sz="1800" b="1">
                 <a:solidFill>
                   <a:srgbClr val="111827"/>
@@ -4002,6 +4718,7 @@
           <a:lstStyle xmlns:a="http://schemas.openxmlformats.org/drawingml/2006/main"/>
           <a:p xmlns:a="http://schemas.openxmlformats.org/drawingml/2006/main">
             <a:pPr algn="l">
+              <a:buNone/>
               <a:defRPr sz="825" b="0">
                 <a:solidFill>
                   <a:srgbClr val="6B7280"/>
@@ -4052,6 +4769,7 @@
           <a:lstStyle xmlns:a="http://schemas.openxmlformats.org/drawingml/2006/main"/>
           <a:p xmlns:a="http://schemas.openxmlformats.org/drawingml/2006/main">
             <a:pPr algn="r">
+              <a:buNone/>
               <a:defRPr sz="825" b="0">
                 <a:solidFill>
                   <a:srgbClr val="6B7280"/>
@@ -4131,6 +4849,7 @@
           <a:lstStyle xmlns:a="http://schemas.openxmlformats.org/drawingml/2006/main"/>
           <a:p xmlns:a="http://schemas.openxmlformats.org/drawingml/2006/main">
             <a:pPr algn="l">
+              <a:buNone/>
               <a:defRPr sz="975" b="1">
                 <a:solidFill>
                   <a:srgbClr val="6B7280"/>
@@ -4181,6 +4900,7 @@
           <a:lstStyle xmlns:a="http://schemas.openxmlformats.org/drawingml/2006/main"/>
           <a:p xmlns:a="http://schemas.openxmlformats.org/drawingml/2006/main">
             <a:pPr algn="l">
+              <a:buNone/>
               <a:defRPr sz="2850" b="1">
                 <a:solidFill>
                   <a:srgbClr val="111827"/>
@@ -4297,6 +5017,7 @@
           <a:lstStyle xmlns:a="http://schemas.openxmlformats.org/drawingml/2006/main"/>
           <a:p xmlns:a="http://schemas.openxmlformats.org/drawingml/2006/main">
             <a:pPr algn="l">
+              <a:buNone/>
               <a:defRPr sz="1350" b="1">
                 <a:solidFill>
                   <a:srgbClr val="111827"/>
@@ -4347,6 +5068,7 @@
           <a:lstStyle xmlns:a="http://schemas.openxmlformats.org/drawingml/2006/main"/>
           <a:p xmlns:a="http://schemas.openxmlformats.org/drawingml/2006/main">
             <a:pPr algn="l">
+              <a:buNone/>
               <a:defRPr sz="1275" b="0">
                 <a:solidFill>
                   <a:srgbClr val="4B5563"/>
@@ -4397,6 +5119,7 @@
           <a:lstStyle xmlns:a="http://schemas.openxmlformats.org/drawingml/2006/main"/>
           <a:p xmlns:a="http://schemas.openxmlformats.org/drawingml/2006/main">
             <a:pPr algn="l">
+              <a:buNone/>
               <a:defRPr sz="1275" b="1">
                 <a:solidFill>
                   <a:srgbClr val="2563EB"/>
@@ -4480,6 +5203,7 @@
           <a:lstStyle xmlns:a="http://schemas.openxmlformats.org/drawingml/2006/main"/>
           <a:p xmlns:a="http://schemas.openxmlformats.org/drawingml/2006/main">
             <a:pPr algn="l">
+              <a:buNone/>
               <a:defRPr sz="1350" b="1">
                 <a:solidFill>
                   <a:srgbClr val="111827"/>
@@ -4530,6 +5254,7 @@
           <a:lstStyle xmlns:a="http://schemas.openxmlformats.org/drawingml/2006/main"/>
           <a:p xmlns:a="http://schemas.openxmlformats.org/drawingml/2006/main">
             <a:pPr algn="l">
+              <a:buNone/>
               <a:defRPr sz="1275" b="0">
                 <a:solidFill>
                   <a:srgbClr val="4B5563"/>
@@ -4580,6 +5305,7 @@
           <a:lstStyle xmlns:a="http://schemas.openxmlformats.org/drawingml/2006/main"/>
           <a:p xmlns:a="http://schemas.openxmlformats.org/drawingml/2006/main">
             <a:pPr algn="l">
+              <a:buNone/>
               <a:defRPr sz="1275" b="1">
                 <a:solidFill>
                   <a:srgbClr val="2563EB"/>
@@ -4663,6 +5389,7 @@
           <a:lstStyle xmlns:a="http://schemas.openxmlformats.org/drawingml/2006/main"/>
           <a:p xmlns:a="http://schemas.openxmlformats.org/drawingml/2006/main">
             <a:pPr algn="l">
+              <a:buNone/>
               <a:defRPr sz="1350" b="1">
                 <a:solidFill>
                   <a:srgbClr val="111827"/>
@@ -4713,6 +5440,7 @@
           <a:lstStyle xmlns:a="http://schemas.openxmlformats.org/drawingml/2006/main"/>
           <a:p xmlns:a="http://schemas.openxmlformats.org/drawingml/2006/main">
             <a:pPr algn="l">
+              <a:buNone/>
               <a:defRPr sz="1275" b="0">
                 <a:solidFill>
                   <a:srgbClr val="4B5563"/>
@@ -4763,6 +5491,7 @@
           <a:lstStyle xmlns:a="http://schemas.openxmlformats.org/drawingml/2006/main"/>
           <a:p xmlns:a="http://schemas.openxmlformats.org/drawingml/2006/main">
             <a:pPr algn="l">
+              <a:buNone/>
               <a:defRPr sz="1275" b="1">
                 <a:solidFill>
                   <a:srgbClr val="2563EB"/>
@@ -4846,6 +5575,7 @@
           <a:lstStyle xmlns:a="http://schemas.openxmlformats.org/drawingml/2006/main"/>
           <a:p xmlns:a="http://schemas.openxmlformats.org/drawingml/2006/main">
             <a:pPr algn="l">
+              <a:buNone/>
               <a:defRPr sz="1350" b="1">
                 <a:solidFill>
                   <a:srgbClr val="111827"/>
@@ -4896,6 +5626,7 @@
           <a:lstStyle xmlns:a="http://schemas.openxmlformats.org/drawingml/2006/main"/>
           <a:p xmlns:a="http://schemas.openxmlformats.org/drawingml/2006/main">
             <a:pPr algn="l">
+              <a:buNone/>
               <a:defRPr sz="1275" b="0">
                 <a:solidFill>
                   <a:srgbClr val="4B5563"/>
@@ -4946,6 +5677,7 @@
           <a:lstStyle xmlns:a="http://schemas.openxmlformats.org/drawingml/2006/main"/>
           <a:p xmlns:a="http://schemas.openxmlformats.org/drawingml/2006/main">
             <a:pPr algn="l">
+              <a:buNone/>
               <a:defRPr sz="1275" b="1">
                 <a:solidFill>
                   <a:srgbClr val="2563EB"/>
@@ -5029,6 +5761,7 @@
           <a:lstStyle xmlns:a="http://schemas.openxmlformats.org/drawingml/2006/main"/>
           <a:p xmlns:a="http://schemas.openxmlformats.org/drawingml/2006/main">
             <a:pPr algn="l">
+              <a:buNone/>
               <a:defRPr sz="1350" b="1">
                 <a:solidFill>
                   <a:srgbClr val="111827"/>
@@ -5079,6 +5812,7 @@
           <a:lstStyle xmlns:a="http://schemas.openxmlformats.org/drawingml/2006/main"/>
           <a:p xmlns:a="http://schemas.openxmlformats.org/drawingml/2006/main">
             <a:pPr algn="l">
+              <a:buNone/>
               <a:defRPr sz="1275" b="0">
                 <a:solidFill>
                   <a:srgbClr val="4B5563"/>
@@ -5129,6 +5863,7 @@
           <a:lstStyle xmlns:a="http://schemas.openxmlformats.org/drawingml/2006/main"/>
           <a:p xmlns:a="http://schemas.openxmlformats.org/drawingml/2006/main">
             <a:pPr algn="l">
+              <a:buNone/>
               <a:defRPr sz="1275" b="1">
                 <a:solidFill>
                   <a:srgbClr val="2563EB"/>
@@ -5179,6 +5914,7 @@
           <a:lstStyle xmlns:a="http://schemas.openxmlformats.org/drawingml/2006/main"/>
           <a:p xmlns:a="http://schemas.openxmlformats.org/drawingml/2006/main">
             <a:pPr algn="ctr">
+              <a:buNone/>
               <a:defRPr sz="1875" b="1">
                 <a:solidFill>
                   <a:srgbClr val="111827"/>
@@ -5229,6 +5965,7 @@
           <a:lstStyle xmlns:a="http://schemas.openxmlformats.org/drawingml/2006/main"/>
           <a:p xmlns:a="http://schemas.openxmlformats.org/drawingml/2006/main">
             <a:pPr algn="l">
+              <a:buNone/>
               <a:defRPr sz="825" b="0">
                 <a:solidFill>
                   <a:srgbClr val="6B7280"/>
@@ -5279,6 +6016,7 @@
           <a:lstStyle xmlns:a="http://schemas.openxmlformats.org/drawingml/2006/main"/>
           <a:p xmlns:a="http://schemas.openxmlformats.org/drawingml/2006/main">
             <a:pPr algn="r">
+              <a:buNone/>
               <a:defRPr sz="825" b="0">
                 <a:solidFill>
                   <a:srgbClr val="6B7280"/>
@@ -5358,6 +6096,7 @@
           <a:lstStyle xmlns:a="http://schemas.openxmlformats.org/drawingml/2006/main"/>
           <a:p xmlns:a="http://schemas.openxmlformats.org/drawingml/2006/main">
             <a:pPr algn="l">
+              <a:buNone/>
               <a:defRPr sz="975" b="1">
                 <a:solidFill>
                   <a:srgbClr val="6B7280"/>
@@ -5408,6 +6147,7 @@
           <a:lstStyle xmlns:a="http://schemas.openxmlformats.org/drawingml/2006/main"/>
           <a:p xmlns:a="http://schemas.openxmlformats.org/drawingml/2006/main">
             <a:pPr algn="l">
+              <a:buNone/>
               <a:defRPr sz="2850" b="1">
                 <a:solidFill>
                   <a:srgbClr val="111827"/>
@@ -5524,6 +6264,7 @@
           <a:lstStyle xmlns:a="http://schemas.openxmlformats.org/drawingml/2006/main"/>
           <a:p xmlns:a="http://schemas.openxmlformats.org/drawingml/2006/main">
             <a:pPr algn="l">
+              <a:buNone/>
               <a:defRPr sz="1500" b="1">
                 <a:solidFill>
                   <a:srgbClr val="111827"/>
@@ -5574,6 +6315,7 @@
           <a:lstStyle xmlns:a="http://schemas.openxmlformats.org/drawingml/2006/main"/>
           <a:p xmlns:a="http://schemas.openxmlformats.org/drawingml/2006/main">
             <a:pPr algn="l">
+              <a:buNone/>
               <a:defRPr sz="1200" b="0">
                 <a:solidFill>
                   <a:srgbClr val="4B5563"/>
@@ -5657,6 +6399,7 @@
           <a:lstStyle xmlns:a="http://schemas.openxmlformats.org/drawingml/2006/main"/>
           <a:p xmlns:a="http://schemas.openxmlformats.org/drawingml/2006/main">
             <a:pPr algn="l">
+              <a:buNone/>
               <a:defRPr sz="1500" b="1">
                 <a:solidFill>
                   <a:srgbClr val="111827"/>
@@ -5707,6 +6450,7 @@
           <a:lstStyle xmlns:a="http://schemas.openxmlformats.org/drawingml/2006/main"/>
           <a:p xmlns:a="http://schemas.openxmlformats.org/drawingml/2006/main">
             <a:pPr algn="l">
+              <a:buNone/>
               <a:defRPr sz="1200" b="0">
                 <a:solidFill>
                   <a:srgbClr val="4B5563"/>
@@ -5790,6 +6534,7 @@
           <a:lstStyle xmlns:a="http://schemas.openxmlformats.org/drawingml/2006/main"/>
           <a:p xmlns:a="http://schemas.openxmlformats.org/drawingml/2006/main">
             <a:pPr algn="l">
+              <a:buNone/>
               <a:defRPr sz="1500" b="1">
                 <a:solidFill>
                   <a:srgbClr val="111827"/>
@@ -5840,6 +6585,7 @@
           <a:lstStyle xmlns:a="http://schemas.openxmlformats.org/drawingml/2006/main"/>
           <a:p xmlns:a="http://schemas.openxmlformats.org/drawingml/2006/main">
             <a:pPr algn="l">
+              <a:buNone/>
               <a:defRPr sz="1200" b="0">
                 <a:solidFill>
                   <a:srgbClr val="4B5563"/>
@@ -5923,6 +6669,7 @@
           <a:lstStyle xmlns:a="http://schemas.openxmlformats.org/drawingml/2006/main"/>
           <a:p xmlns:a="http://schemas.openxmlformats.org/drawingml/2006/main">
             <a:pPr algn="l">
+              <a:buNone/>
               <a:defRPr sz="1500" b="1">
                 <a:solidFill>
                   <a:srgbClr val="111827"/>
@@ -5973,6 +6720,7 @@
           <a:lstStyle xmlns:a="http://schemas.openxmlformats.org/drawingml/2006/main"/>
           <a:p xmlns:a="http://schemas.openxmlformats.org/drawingml/2006/main">
             <a:pPr algn="l">
+              <a:buNone/>
               <a:defRPr sz="1200" b="0">
                 <a:solidFill>
                   <a:srgbClr val="4B5563"/>
@@ -6023,6 +6771,7 @@
           <a:lstStyle xmlns:a="http://schemas.openxmlformats.org/drawingml/2006/main"/>
           <a:p xmlns:a="http://schemas.openxmlformats.org/drawingml/2006/main">
             <a:pPr algn="ctr">
+              <a:buNone/>
               <a:defRPr sz="1725" b="1">
                 <a:solidFill>
                   <a:srgbClr val="111827"/>
@@ -6073,6 +6822,7 @@
           <a:lstStyle xmlns:a="http://schemas.openxmlformats.org/drawingml/2006/main"/>
           <a:p xmlns:a="http://schemas.openxmlformats.org/drawingml/2006/main">
             <a:pPr algn="l">
+              <a:buNone/>
               <a:defRPr sz="825" b="0">
                 <a:solidFill>
                   <a:srgbClr val="6B7280"/>
@@ -6123,6 +6873,7 @@
           <a:lstStyle xmlns:a="http://schemas.openxmlformats.org/drawingml/2006/main"/>
           <a:p xmlns:a="http://schemas.openxmlformats.org/drawingml/2006/main">
             <a:pPr algn="r">
+              <a:buNone/>
               <a:defRPr sz="825" b="0">
                 <a:solidFill>
                   <a:srgbClr val="6B7280"/>
@@ -6202,6 +6953,7 @@
           <a:lstStyle xmlns:a="http://schemas.openxmlformats.org/drawingml/2006/main"/>
           <a:p xmlns:a="http://schemas.openxmlformats.org/drawingml/2006/main">
             <a:pPr algn="l">
+              <a:buNone/>
               <a:defRPr sz="975" b="1">
                 <a:solidFill>
                   <a:srgbClr val="6B7280"/>
@@ -6252,6 +7004,7 @@
           <a:lstStyle xmlns:a="http://schemas.openxmlformats.org/drawingml/2006/main"/>
           <a:p xmlns:a="http://schemas.openxmlformats.org/drawingml/2006/main">
             <a:pPr algn="l">
+              <a:buNone/>
               <a:defRPr sz="2850" b="1">
                 <a:solidFill>
                   <a:srgbClr val="111827"/>
@@ -6368,6 +7121,7 @@
           <a:lstStyle xmlns:a="http://schemas.openxmlformats.org/drawingml/2006/main"/>
           <a:p xmlns:a="http://schemas.openxmlformats.org/drawingml/2006/main">
             <a:pPr algn="l">
+              <a:buNone/>
               <a:defRPr sz="1575" b="1">
                 <a:solidFill>
                   <a:srgbClr val="111827"/>
@@ -6418,6 +7172,7 @@
           <a:lstStyle xmlns:a="http://schemas.openxmlformats.org/drawingml/2006/main"/>
           <a:p xmlns:a="http://schemas.openxmlformats.org/drawingml/2006/main">
             <a:pPr algn="l">
+              <a:buNone/>
               <a:defRPr sz="1200" b="0">
                 <a:solidFill>
                   <a:srgbClr val="4B5563"/>
@@ -6501,6 +7256,7 @@
           <a:lstStyle xmlns:a="http://schemas.openxmlformats.org/drawingml/2006/main"/>
           <a:p xmlns:a="http://schemas.openxmlformats.org/drawingml/2006/main">
             <a:pPr algn="l">
+              <a:buNone/>
               <a:defRPr sz="1575" b="1">
                 <a:solidFill>
                   <a:srgbClr val="111827"/>
@@ -6551,6 +7307,7 @@
           <a:lstStyle xmlns:a="http://schemas.openxmlformats.org/drawingml/2006/main"/>
           <a:p xmlns:a="http://schemas.openxmlformats.org/drawingml/2006/main">
             <a:pPr algn="l">
+              <a:buNone/>
               <a:defRPr sz="1200" b="0">
                 <a:solidFill>
                   <a:srgbClr val="4B5563"/>
@@ -6634,6 +7391,7 @@
           <a:lstStyle xmlns:a="http://schemas.openxmlformats.org/drawingml/2006/main"/>
           <a:p xmlns:a="http://schemas.openxmlformats.org/drawingml/2006/main">
             <a:pPr algn="l">
+              <a:buNone/>
               <a:defRPr sz="1575" b="1">
                 <a:solidFill>
                   <a:srgbClr val="111827"/>
@@ -6684,6 +7442,7 @@
           <a:lstStyle xmlns:a="http://schemas.openxmlformats.org/drawingml/2006/main"/>
           <a:p xmlns:a="http://schemas.openxmlformats.org/drawingml/2006/main">
             <a:pPr algn="l">
+              <a:buNone/>
               <a:defRPr sz="1200" b="0">
                 <a:solidFill>
                   <a:srgbClr val="4B5563"/>
@@ -6767,6 +7526,7 @@
           <a:lstStyle xmlns:a="http://schemas.openxmlformats.org/drawingml/2006/main"/>
           <a:p xmlns:a="http://schemas.openxmlformats.org/drawingml/2006/main">
             <a:pPr algn="l">
+              <a:buNone/>
               <a:defRPr sz="1575" b="1">
                 <a:solidFill>
                   <a:srgbClr val="111827"/>
@@ -6817,6 +7577,7 @@
           <a:lstStyle xmlns:a="http://schemas.openxmlformats.org/drawingml/2006/main"/>
           <a:p xmlns:a="http://schemas.openxmlformats.org/drawingml/2006/main">
             <a:pPr algn="l">
+              <a:buNone/>
               <a:defRPr sz="1200" b="0">
                 <a:solidFill>
                   <a:srgbClr val="4B5563"/>
@@ -6867,6 +7628,7 @@
           <a:lstStyle xmlns:a="http://schemas.openxmlformats.org/drawingml/2006/main"/>
           <a:p xmlns:a="http://schemas.openxmlformats.org/drawingml/2006/main">
             <a:pPr algn="ctr">
+              <a:buNone/>
               <a:defRPr sz="2100" b="1">
                 <a:solidFill>
                   <a:srgbClr val="111827"/>
@@ -6917,6 +7679,7 @@
           <a:lstStyle xmlns:a="http://schemas.openxmlformats.org/drawingml/2006/main"/>
           <a:p xmlns:a="http://schemas.openxmlformats.org/drawingml/2006/main">
             <a:pPr algn="l">
+              <a:buNone/>
               <a:defRPr sz="825" b="0">
                 <a:solidFill>
                   <a:srgbClr val="6B7280"/>
@@ -6967,6 +7730,7 @@
           <a:lstStyle xmlns:a="http://schemas.openxmlformats.org/drawingml/2006/main"/>
           <a:p xmlns:a="http://schemas.openxmlformats.org/drawingml/2006/main">
             <a:pPr algn="r">
+              <a:buNone/>
               <a:defRPr sz="825" b="0">
                 <a:solidFill>
                   <a:srgbClr val="6B7280"/>
@@ -7046,6 +7810,7 @@
           <a:lstStyle xmlns:a="http://schemas.openxmlformats.org/drawingml/2006/main"/>
           <a:p xmlns:a="http://schemas.openxmlformats.org/drawingml/2006/main">
             <a:pPr algn="l">
+              <a:buNone/>
               <a:defRPr sz="975" b="1">
                 <a:solidFill>
                   <a:srgbClr val="6B7280"/>
@@ -7096,6 +7861,7 @@
           <a:lstStyle xmlns:a="http://schemas.openxmlformats.org/drawingml/2006/main"/>
           <a:p xmlns:a="http://schemas.openxmlformats.org/drawingml/2006/main">
             <a:pPr algn="l">
+              <a:buNone/>
               <a:defRPr sz="2850" b="1">
                 <a:solidFill>
                   <a:srgbClr val="111827"/>
@@ -7212,6 +7978,7 @@
           <a:lstStyle xmlns:a="http://schemas.openxmlformats.org/drawingml/2006/main"/>
           <a:p xmlns:a="http://schemas.openxmlformats.org/drawingml/2006/main">
             <a:pPr algn="l">
+              <a:buNone/>
               <a:defRPr sz="1425" b="1">
                 <a:solidFill>
                   <a:srgbClr val="111827"/>
@@ -7262,6 +8029,7 @@
           <a:lstStyle xmlns:a="http://schemas.openxmlformats.org/drawingml/2006/main"/>
           <a:p xmlns:a="http://schemas.openxmlformats.org/drawingml/2006/main">
             <a:pPr algn="l">
+              <a:buNone/>
               <a:defRPr sz="1125" b="0">
                 <a:solidFill>
                   <a:srgbClr val="4B5563"/>
@@ -7345,6 +8113,7 @@
           <a:lstStyle xmlns:a="http://schemas.openxmlformats.org/drawingml/2006/main"/>
           <a:p xmlns:a="http://schemas.openxmlformats.org/drawingml/2006/main">
             <a:pPr algn="l">
+              <a:buNone/>
               <a:defRPr sz="1425" b="1">
                 <a:solidFill>
                   <a:srgbClr val="111827"/>
@@ -7395,6 +8164,7 @@
           <a:lstStyle xmlns:a="http://schemas.openxmlformats.org/drawingml/2006/main"/>
           <a:p xmlns:a="http://schemas.openxmlformats.org/drawingml/2006/main">
             <a:pPr algn="l">
+              <a:buNone/>
               <a:defRPr sz="1125" b="0">
                 <a:solidFill>
                   <a:srgbClr val="4B5563"/>
@@ -7478,6 +8248,7 @@
           <a:lstStyle xmlns:a="http://schemas.openxmlformats.org/drawingml/2006/main"/>
           <a:p xmlns:a="http://schemas.openxmlformats.org/drawingml/2006/main">
             <a:pPr algn="l">
+              <a:buNone/>
               <a:defRPr sz="1425" b="1">
                 <a:solidFill>
                   <a:srgbClr val="111827"/>
@@ -7528,6 +8299,7 @@
           <a:lstStyle xmlns:a="http://schemas.openxmlformats.org/drawingml/2006/main"/>
           <a:p xmlns:a="http://schemas.openxmlformats.org/drawingml/2006/main">
             <a:pPr algn="l">
+              <a:buNone/>
               <a:defRPr sz="1125" b="0">
                 <a:solidFill>
                   <a:srgbClr val="4B5563"/>
@@ -7611,6 +8383,7 @@
           <a:lstStyle xmlns:a="http://schemas.openxmlformats.org/drawingml/2006/main"/>
           <a:p xmlns:a="http://schemas.openxmlformats.org/drawingml/2006/main">
             <a:pPr algn="l">
+              <a:buNone/>
               <a:defRPr sz="1425" b="1">
                 <a:solidFill>
                   <a:srgbClr val="111827"/>
@@ -7661,6 +8434,7 @@
           <a:lstStyle xmlns:a="http://schemas.openxmlformats.org/drawingml/2006/main"/>
           <a:p xmlns:a="http://schemas.openxmlformats.org/drawingml/2006/main">
             <a:pPr algn="l">
+              <a:buNone/>
               <a:defRPr sz="1125" b="0">
                 <a:solidFill>
                   <a:srgbClr val="4B5563"/>
@@ -7744,6 +8518,7 @@
           <a:lstStyle xmlns:a="http://schemas.openxmlformats.org/drawingml/2006/main"/>
           <a:p xmlns:a="http://schemas.openxmlformats.org/drawingml/2006/main">
             <a:pPr algn="l">
+              <a:buNone/>
               <a:defRPr sz="1425" b="1">
                 <a:solidFill>
                   <a:srgbClr val="111827"/>
@@ -7794,6 +8569,7 @@
           <a:lstStyle xmlns:a="http://schemas.openxmlformats.org/drawingml/2006/main"/>
           <a:p xmlns:a="http://schemas.openxmlformats.org/drawingml/2006/main">
             <a:pPr algn="l">
+              <a:buNone/>
               <a:defRPr sz="1125" b="0">
                 <a:solidFill>
                   <a:srgbClr val="4B5563"/>
@@ -7877,6 +8653,7 @@
           <a:lstStyle xmlns:a="http://schemas.openxmlformats.org/drawingml/2006/main"/>
           <a:p xmlns:a="http://schemas.openxmlformats.org/drawingml/2006/main">
             <a:pPr algn="l">
+              <a:buNone/>
               <a:defRPr sz="1425" b="1">
                 <a:solidFill>
                   <a:srgbClr val="111827"/>
@@ -7927,6 +8704,7 @@
           <a:lstStyle xmlns:a="http://schemas.openxmlformats.org/drawingml/2006/main"/>
           <a:p xmlns:a="http://schemas.openxmlformats.org/drawingml/2006/main">
             <a:pPr algn="l">
+              <a:buNone/>
               <a:defRPr sz="1125" b="0">
                 <a:solidFill>
                   <a:srgbClr val="4B5563"/>
@@ -8010,6 +8788,7 @@
           <a:lstStyle xmlns:a="http://schemas.openxmlformats.org/drawingml/2006/main"/>
           <a:p xmlns:a="http://schemas.openxmlformats.org/drawingml/2006/main">
             <a:pPr algn="l">
+              <a:buNone/>
               <a:defRPr sz="1425" b="1">
                 <a:solidFill>
                   <a:srgbClr val="111827"/>
@@ -8060,6 +8839,7 @@
           <a:lstStyle xmlns:a="http://schemas.openxmlformats.org/drawingml/2006/main"/>
           <a:p xmlns:a="http://schemas.openxmlformats.org/drawingml/2006/main">
             <a:pPr algn="l">
+              <a:buNone/>
               <a:defRPr sz="1125" b="0">
                 <a:solidFill>
                   <a:srgbClr val="4B5563"/>
@@ -8143,6 +8923,7 @@
           <a:lstStyle xmlns:a="http://schemas.openxmlformats.org/drawingml/2006/main"/>
           <a:p xmlns:a="http://schemas.openxmlformats.org/drawingml/2006/main">
             <a:pPr algn="l">
+              <a:buNone/>
               <a:defRPr sz="1425" b="1">
                 <a:solidFill>
                   <a:srgbClr val="111827"/>
@@ -8193,6 +8974,7 @@
           <a:lstStyle xmlns:a="http://schemas.openxmlformats.org/drawingml/2006/main"/>
           <a:p xmlns:a="http://schemas.openxmlformats.org/drawingml/2006/main">
             <a:pPr algn="l">
+              <a:buNone/>
               <a:defRPr sz="1125" b="0">
                 <a:solidFill>
                   <a:srgbClr val="4B5563"/>
@@ -8276,6 +9058,7 @@
           <a:lstStyle xmlns:a="http://schemas.openxmlformats.org/drawingml/2006/main"/>
           <a:p xmlns:a="http://schemas.openxmlformats.org/drawingml/2006/main">
             <a:pPr algn="l">
+              <a:buNone/>
               <a:defRPr sz="1425" b="1">
                 <a:solidFill>
                   <a:srgbClr val="111827"/>
@@ -8326,6 +9109,7 @@
           <a:lstStyle xmlns:a="http://schemas.openxmlformats.org/drawingml/2006/main"/>
           <a:p xmlns:a="http://schemas.openxmlformats.org/drawingml/2006/main">
             <a:pPr algn="l">
+              <a:buNone/>
               <a:defRPr sz="1125" b="0">
                 <a:solidFill>
                   <a:srgbClr val="4B5563"/>
@@ -8376,6 +9160,7 @@
           <a:lstStyle xmlns:a="http://schemas.openxmlformats.org/drawingml/2006/main"/>
           <a:p xmlns:a="http://schemas.openxmlformats.org/drawingml/2006/main">
             <a:pPr algn="ctr">
+              <a:buNone/>
               <a:defRPr sz="1800" b="1">
                 <a:solidFill>
                   <a:srgbClr val="111827"/>
@@ -8426,6 +9211,7 @@
           <a:lstStyle xmlns:a="http://schemas.openxmlformats.org/drawingml/2006/main"/>
           <a:p xmlns:a="http://schemas.openxmlformats.org/drawingml/2006/main">
             <a:pPr algn="l">
+              <a:buNone/>
               <a:defRPr sz="825" b="0">
                 <a:solidFill>
                   <a:srgbClr val="6B7280"/>
@@ -8476,6 +9262,7 @@
           <a:lstStyle xmlns:a="http://schemas.openxmlformats.org/drawingml/2006/main"/>
           <a:p xmlns:a="http://schemas.openxmlformats.org/drawingml/2006/main">
             <a:pPr algn="r">
+              <a:buNone/>
               <a:defRPr sz="825" b="0">
                 <a:solidFill>
                   <a:srgbClr val="6B7280"/>
@@ -8555,6 +9342,7 @@
           <a:lstStyle xmlns:a="http://schemas.openxmlformats.org/drawingml/2006/main"/>
           <a:p xmlns:a="http://schemas.openxmlformats.org/drawingml/2006/main">
             <a:pPr algn="l">
+              <a:buNone/>
               <a:defRPr sz="975" b="1">
                 <a:solidFill>
                   <a:srgbClr val="6B7280"/>
@@ -8605,6 +9393,7 @@
           <a:lstStyle xmlns:a="http://schemas.openxmlformats.org/drawingml/2006/main"/>
           <a:p xmlns:a="http://schemas.openxmlformats.org/drawingml/2006/main">
             <a:pPr algn="l">
+              <a:buNone/>
               <a:defRPr sz="2850" b="1">
                 <a:solidFill>
                   <a:srgbClr val="111827"/>
@@ -8688,6 +9477,7 @@
           <a:lstStyle xmlns:a="http://schemas.openxmlformats.org/drawingml/2006/main"/>
           <a:p xmlns:a="http://schemas.openxmlformats.org/drawingml/2006/main">
             <a:pPr algn="l">
+              <a:buNone/>
               <a:defRPr sz="1350" b="1">
                 <a:solidFill>
                   <a:srgbClr val="6B7280"/>
@@ -8738,6 +9528,7 @@
           <a:lstStyle xmlns:a="http://schemas.openxmlformats.org/drawingml/2006/main"/>
           <a:p xmlns:a="http://schemas.openxmlformats.org/drawingml/2006/main">
             <a:pPr algn="l">
+              <a:buNone/>
               <a:defRPr sz="2100" b="1">
                 <a:solidFill>
                   <a:srgbClr val="111827"/>
@@ -8821,6 +9612,7 @@
           <a:lstStyle xmlns:a="http://schemas.openxmlformats.org/drawingml/2006/main"/>
           <a:p xmlns:a="http://schemas.openxmlformats.org/drawingml/2006/main">
             <a:pPr algn="l">
+              <a:buNone/>
               <a:defRPr sz="1500" b="1">
                 <a:solidFill>
                   <a:srgbClr val="111827"/>
@@ -8871,6 +9663,7 @@
           <a:lstStyle xmlns:a="http://schemas.openxmlformats.org/drawingml/2006/main"/>
           <a:p xmlns:a="http://schemas.openxmlformats.org/drawingml/2006/main">
             <a:pPr algn="l">
+              <a:buNone/>
               <a:defRPr sz="1275" b="0">
                 <a:solidFill>
                   <a:srgbClr val="4B5563"/>
@@ -8954,6 +9747,7 @@
           <a:lstStyle xmlns:a="http://schemas.openxmlformats.org/drawingml/2006/main"/>
           <a:p xmlns:a="http://schemas.openxmlformats.org/drawingml/2006/main">
             <a:pPr algn="l">
+              <a:buNone/>
               <a:defRPr sz="1500" b="1">
                 <a:solidFill>
                   <a:srgbClr val="111827"/>
@@ -9004,6 +9798,7 @@
           <a:lstStyle xmlns:a="http://schemas.openxmlformats.org/drawingml/2006/main"/>
           <a:p xmlns:a="http://schemas.openxmlformats.org/drawingml/2006/main">
             <a:pPr algn="l">
+              <a:buNone/>
               <a:defRPr sz="1275" b="0">
                 <a:solidFill>
                   <a:srgbClr val="4B5563"/>
@@ -9087,6 +9882,7 @@
           <a:lstStyle xmlns:a="http://schemas.openxmlformats.org/drawingml/2006/main"/>
           <a:p xmlns:a="http://schemas.openxmlformats.org/drawingml/2006/main">
             <a:pPr algn="l">
+              <a:buNone/>
               <a:defRPr sz="1500" b="1">
                 <a:solidFill>
                   <a:srgbClr val="111827"/>
@@ -9137,6 +9933,7 @@
           <a:lstStyle xmlns:a="http://schemas.openxmlformats.org/drawingml/2006/main"/>
           <a:p xmlns:a="http://schemas.openxmlformats.org/drawingml/2006/main">
             <a:pPr algn="l">
+              <a:buNone/>
               <a:defRPr sz="1275" b="0">
                 <a:solidFill>
                   <a:srgbClr val="4B5563"/>
@@ -9187,6 +9984,7 @@
           <a:lstStyle xmlns:a="http://schemas.openxmlformats.org/drawingml/2006/main"/>
           <a:p xmlns:a="http://schemas.openxmlformats.org/drawingml/2006/main">
             <a:pPr algn="ctr">
+              <a:buNone/>
               <a:defRPr sz="1800" b="1">
                 <a:solidFill>
                   <a:srgbClr val="111827"/>
@@ -9237,6 +10035,7 @@
           <a:lstStyle xmlns:a="http://schemas.openxmlformats.org/drawingml/2006/main"/>
           <a:p xmlns:a="http://schemas.openxmlformats.org/drawingml/2006/main">
             <a:pPr algn="l">
+              <a:buNone/>
               <a:defRPr sz="825" b="0">
                 <a:solidFill>
                   <a:srgbClr val="6B7280"/>
@@ -9287,6 +10086,7 @@
           <a:lstStyle xmlns:a="http://schemas.openxmlformats.org/drawingml/2006/main"/>
           <a:p xmlns:a="http://schemas.openxmlformats.org/drawingml/2006/main">
             <a:pPr algn="r">
+              <a:buNone/>
               <a:defRPr sz="825" b="0">
                 <a:solidFill>
                   <a:srgbClr val="6B7280"/>
@@ -9366,6 +10166,7 @@
           <a:lstStyle xmlns:a="http://schemas.openxmlformats.org/drawingml/2006/main"/>
           <a:p xmlns:a="http://schemas.openxmlformats.org/drawingml/2006/main">
             <a:pPr algn="l">
+              <a:buNone/>
               <a:defRPr sz="975" b="1">
                 <a:solidFill>
                   <a:srgbClr val="6B7280"/>
@@ -9416,6 +10217,7 @@
           <a:lstStyle xmlns:a="http://schemas.openxmlformats.org/drawingml/2006/main"/>
           <a:p xmlns:a="http://schemas.openxmlformats.org/drawingml/2006/main">
             <a:pPr algn="l">
+              <a:buNone/>
               <a:defRPr sz="2850" b="1">
                 <a:solidFill>
                   <a:srgbClr val="111827"/>
@@ -9499,6 +10301,7 @@
           <a:lstStyle xmlns:a="http://schemas.openxmlformats.org/drawingml/2006/main"/>
           <a:p xmlns:a="http://schemas.openxmlformats.org/drawingml/2006/main">
             <a:pPr algn="l">
+              <a:buNone/>
               <a:defRPr sz="1350" b="1">
                 <a:solidFill>
                   <a:srgbClr val="6B7280"/>
@@ -9549,6 +10352,7 @@
           <a:lstStyle xmlns:a="http://schemas.openxmlformats.org/drawingml/2006/main"/>
           <a:p xmlns:a="http://schemas.openxmlformats.org/drawingml/2006/main">
             <a:pPr algn="l">
+              <a:buNone/>
               <a:defRPr sz="2100" b="1">
                 <a:solidFill>
                   <a:srgbClr val="111827"/>
@@ -9632,6 +10436,7 @@
           <a:lstStyle xmlns:a="http://schemas.openxmlformats.org/drawingml/2006/main"/>
           <a:p xmlns:a="http://schemas.openxmlformats.org/drawingml/2006/main">
             <a:pPr algn="l">
+              <a:buNone/>
               <a:defRPr sz="1500" b="1">
                 <a:solidFill>
                   <a:srgbClr val="111827"/>
@@ -9682,6 +10487,7 @@
           <a:lstStyle xmlns:a="http://schemas.openxmlformats.org/drawingml/2006/main"/>
           <a:p xmlns:a="http://schemas.openxmlformats.org/drawingml/2006/main">
             <a:pPr algn="l">
+              <a:buNone/>
               <a:defRPr sz="1275" b="0">
                 <a:solidFill>
                   <a:srgbClr val="4B5563"/>
@@ -9765,6 +10571,7 @@
           <a:lstStyle xmlns:a="http://schemas.openxmlformats.org/drawingml/2006/main"/>
           <a:p xmlns:a="http://schemas.openxmlformats.org/drawingml/2006/main">
             <a:pPr algn="l">
+              <a:buNone/>
               <a:defRPr sz="1500" b="1">
                 <a:solidFill>
                   <a:srgbClr val="111827"/>
@@ -9815,6 +10622,7 @@
           <a:lstStyle xmlns:a="http://schemas.openxmlformats.org/drawingml/2006/main"/>
           <a:p xmlns:a="http://schemas.openxmlformats.org/drawingml/2006/main">
             <a:pPr algn="l">
+              <a:buNone/>
               <a:defRPr sz="1275" b="0">
                 <a:solidFill>
                   <a:srgbClr val="4B5563"/>
@@ -9898,6 +10706,7 @@
           <a:lstStyle xmlns:a="http://schemas.openxmlformats.org/drawingml/2006/main"/>
           <a:p xmlns:a="http://schemas.openxmlformats.org/drawingml/2006/main">
             <a:pPr algn="l">
+              <a:buNone/>
               <a:defRPr sz="1500" b="1">
                 <a:solidFill>
                   <a:srgbClr val="111827"/>
@@ -9948,6 +10757,7 @@
           <a:lstStyle xmlns:a="http://schemas.openxmlformats.org/drawingml/2006/main"/>
           <a:p xmlns:a="http://schemas.openxmlformats.org/drawingml/2006/main">
             <a:pPr algn="l">
+              <a:buNone/>
               <a:defRPr sz="1275" b="0">
                 <a:solidFill>
                   <a:srgbClr val="4B5563"/>
@@ -9998,6 +10808,7 @@
           <a:lstStyle xmlns:a="http://schemas.openxmlformats.org/drawingml/2006/main"/>
           <a:p xmlns:a="http://schemas.openxmlformats.org/drawingml/2006/main">
             <a:pPr algn="ctr">
+              <a:buNone/>
               <a:defRPr sz="1800" b="1">
                 <a:solidFill>
                   <a:srgbClr val="111827"/>
@@ -10048,6 +10859,7 @@
           <a:lstStyle xmlns:a="http://schemas.openxmlformats.org/drawingml/2006/main"/>
           <a:p xmlns:a="http://schemas.openxmlformats.org/drawingml/2006/main">
             <a:pPr algn="l">
+              <a:buNone/>
               <a:defRPr sz="825" b="0">
                 <a:solidFill>
                   <a:srgbClr val="6B7280"/>
@@ -10098,6 +10910,7 @@
           <a:lstStyle xmlns:a="http://schemas.openxmlformats.org/drawingml/2006/main"/>
           <a:p xmlns:a="http://schemas.openxmlformats.org/drawingml/2006/main">
             <a:pPr algn="r">
+              <a:buNone/>
               <a:defRPr sz="825" b="0">
                 <a:solidFill>
                   <a:srgbClr val="6B7280"/>
@@ -10177,6 +10990,7 @@
           <a:lstStyle xmlns:a="http://schemas.openxmlformats.org/drawingml/2006/main"/>
           <a:p xmlns:a="http://schemas.openxmlformats.org/drawingml/2006/main">
             <a:pPr algn="l">
+              <a:buNone/>
               <a:defRPr sz="975" b="1">
                 <a:solidFill>
                   <a:srgbClr val="6B7280"/>
@@ -10227,6 +11041,7 @@
           <a:lstStyle xmlns:a="http://schemas.openxmlformats.org/drawingml/2006/main"/>
           <a:p xmlns:a="http://schemas.openxmlformats.org/drawingml/2006/main">
             <a:pPr algn="l">
+              <a:buNone/>
               <a:defRPr sz="2850" b="1">
                 <a:solidFill>
                   <a:srgbClr val="111827"/>
@@ -10310,6 +11125,7 @@
           <a:lstStyle xmlns:a="http://schemas.openxmlformats.org/drawingml/2006/main"/>
           <a:p xmlns:a="http://schemas.openxmlformats.org/drawingml/2006/main">
             <a:pPr algn="l">
+              <a:buNone/>
               <a:defRPr sz="1350" b="1">
                 <a:solidFill>
                   <a:srgbClr val="6B7280"/>
@@ -10360,6 +11176,7 @@
           <a:lstStyle xmlns:a="http://schemas.openxmlformats.org/drawingml/2006/main"/>
           <a:p xmlns:a="http://schemas.openxmlformats.org/drawingml/2006/main">
             <a:pPr algn="l">
+              <a:buNone/>
               <a:defRPr sz="2100" b="1">
                 <a:solidFill>
                   <a:srgbClr val="111827"/>
@@ -10443,6 +11260,7 @@
           <a:lstStyle xmlns:a="http://schemas.openxmlformats.org/drawingml/2006/main"/>
           <a:p xmlns:a="http://schemas.openxmlformats.org/drawingml/2006/main">
             <a:pPr algn="l">
+              <a:buNone/>
               <a:defRPr sz="1500" b="1">
                 <a:solidFill>
                   <a:srgbClr val="111827"/>
@@ -10493,6 +11311,7 @@
           <a:lstStyle xmlns:a="http://schemas.openxmlformats.org/drawingml/2006/main"/>
           <a:p xmlns:a="http://schemas.openxmlformats.org/drawingml/2006/main">
             <a:pPr algn="l">
+              <a:buNone/>
               <a:defRPr sz="1275" b="0">
                 <a:solidFill>
                   <a:srgbClr val="4B5563"/>
@@ -10576,6 +11395,7 @@
           <a:lstStyle xmlns:a="http://schemas.openxmlformats.org/drawingml/2006/main"/>
           <a:p xmlns:a="http://schemas.openxmlformats.org/drawingml/2006/main">
             <a:pPr algn="l">
+              <a:buNone/>
               <a:defRPr sz="1500" b="1">
                 <a:solidFill>
                   <a:srgbClr val="111827"/>
@@ -10626,6 +11446,7 @@
           <a:lstStyle xmlns:a="http://schemas.openxmlformats.org/drawingml/2006/main"/>
           <a:p xmlns:a="http://schemas.openxmlformats.org/drawingml/2006/main">
             <a:pPr algn="l">
+              <a:buNone/>
               <a:defRPr sz="1275" b="0">
                 <a:solidFill>
                   <a:srgbClr val="4B5563"/>
@@ -10709,6 +11530,7 @@
           <a:lstStyle xmlns:a="http://schemas.openxmlformats.org/drawingml/2006/main"/>
           <a:p xmlns:a="http://schemas.openxmlformats.org/drawingml/2006/main">
             <a:pPr algn="l">
+              <a:buNone/>
               <a:defRPr sz="1500" b="1">
                 <a:solidFill>
                   <a:srgbClr val="111827"/>
@@ -10759,6 +11581,7 @@
           <a:lstStyle xmlns:a="http://schemas.openxmlformats.org/drawingml/2006/main"/>
           <a:p xmlns:a="http://schemas.openxmlformats.org/drawingml/2006/main">
             <a:pPr algn="l">
+              <a:buNone/>
               <a:defRPr sz="1275" b="0">
                 <a:solidFill>
                   <a:srgbClr val="4B5563"/>
@@ -10809,6 +11632,7 @@
           <a:lstStyle xmlns:a="http://schemas.openxmlformats.org/drawingml/2006/main"/>
           <a:p xmlns:a="http://schemas.openxmlformats.org/drawingml/2006/main">
             <a:pPr algn="ctr">
+              <a:buNone/>
               <a:defRPr sz="1800" b="1">
                 <a:solidFill>
                   <a:srgbClr val="111827"/>
@@ -10859,6 +11683,7 @@
           <a:lstStyle xmlns:a="http://schemas.openxmlformats.org/drawingml/2006/main"/>
           <a:p xmlns:a="http://schemas.openxmlformats.org/drawingml/2006/main">
             <a:pPr algn="l">
+              <a:buNone/>
               <a:defRPr sz="825" b="0">
                 <a:solidFill>
                   <a:srgbClr val="6B7280"/>
@@ -10909,6 +11734,7 @@
           <a:lstStyle xmlns:a="http://schemas.openxmlformats.org/drawingml/2006/main"/>
           <a:p xmlns:a="http://schemas.openxmlformats.org/drawingml/2006/main">
             <a:pPr algn="r">
+              <a:buNone/>
               <a:defRPr sz="825" b="0">
                 <a:solidFill>
                   <a:srgbClr val="6B7280"/>
@@ -10988,6 +11814,7 @@
           <a:lstStyle xmlns:a="http://schemas.openxmlformats.org/drawingml/2006/main"/>
           <a:p xmlns:a="http://schemas.openxmlformats.org/drawingml/2006/main">
             <a:pPr algn="l">
+              <a:buNone/>
               <a:defRPr sz="975" b="1">
                 <a:solidFill>
                   <a:srgbClr val="6B7280"/>
@@ -11038,6 +11865,7 @@
           <a:lstStyle xmlns:a="http://schemas.openxmlformats.org/drawingml/2006/main"/>
           <a:p xmlns:a="http://schemas.openxmlformats.org/drawingml/2006/main">
             <a:pPr algn="l">
+              <a:buNone/>
               <a:defRPr sz="2850" b="1">
                 <a:solidFill>
                   <a:srgbClr val="111827"/>
@@ -11121,6 +11949,7 @@
           <a:lstStyle xmlns:a="http://schemas.openxmlformats.org/drawingml/2006/main"/>
           <a:p xmlns:a="http://schemas.openxmlformats.org/drawingml/2006/main">
             <a:pPr algn="l">
+              <a:buNone/>
               <a:defRPr sz="1350" b="1">
                 <a:solidFill>
                   <a:srgbClr val="6B7280"/>
@@ -11171,6 +12000,7 @@
           <a:lstStyle xmlns:a="http://schemas.openxmlformats.org/drawingml/2006/main"/>
           <a:p xmlns:a="http://schemas.openxmlformats.org/drawingml/2006/main">
             <a:pPr algn="l">
+              <a:buNone/>
               <a:defRPr sz="2100" b="1">
                 <a:solidFill>
                   <a:srgbClr val="111827"/>
@@ -11254,6 +12084,7 @@
           <a:lstStyle xmlns:a="http://schemas.openxmlformats.org/drawingml/2006/main"/>
           <a:p xmlns:a="http://schemas.openxmlformats.org/drawingml/2006/main">
             <a:pPr algn="l">
+              <a:buNone/>
               <a:defRPr sz="1500" b="1">
                 <a:solidFill>
                   <a:srgbClr val="111827"/>
@@ -11304,6 +12135,7 @@
           <a:lstStyle xmlns:a="http://schemas.openxmlformats.org/drawingml/2006/main"/>
           <a:p xmlns:a="http://schemas.openxmlformats.org/drawingml/2006/main">
             <a:pPr algn="l">
+              <a:buNone/>
               <a:defRPr sz="1275" b="0">
                 <a:solidFill>
                   <a:srgbClr val="4B5563"/>
@@ -11387,6 +12219,7 @@
           <a:lstStyle xmlns:a="http://schemas.openxmlformats.org/drawingml/2006/main"/>
           <a:p xmlns:a="http://schemas.openxmlformats.org/drawingml/2006/main">
             <a:pPr algn="l">
+              <a:buNone/>
               <a:defRPr sz="1500" b="1">
                 <a:solidFill>
                   <a:srgbClr val="111827"/>
@@ -11437,6 +12270,7 @@
           <a:lstStyle xmlns:a="http://schemas.openxmlformats.org/drawingml/2006/main"/>
           <a:p xmlns:a="http://schemas.openxmlformats.org/drawingml/2006/main">
             <a:pPr algn="l">
+              <a:buNone/>
               <a:defRPr sz="1275" b="0">
                 <a:solidFill>
                   <a:srgbClr val="4B5563"/>
@@ -11520,6 +12354,7 @@
           <a:lstStyle xmlns:a="http://schemas.openxmlformats.org/drawingml/2006/main"/>
           <a:p xmlns:a="http://schemas.openxmlformats.org/drawingml/2006/main">
             <a:pPr algn="l">
+              <a:buNone/>
               <a:defRPr sz="1500" b="1">
                 <a:solidFill>
                   <a:srgbClr val="111827"/>
@@ -11570,6 +12405,7 @@
           <a:lstStyle xmlns:a="http://schemas.openxmlformats.org/drawingml/2006/main"/>
           <a:p xmlns:a="http://schemas.openxmlformats.org/drawingml/2006/main">
             <a:pPr algn="l">
+              <a:buNone/>
               <a:defRPr sz="1275" b="0">
                 <a:solidFill>
                   <a:srgbClr val="4B5563"/>
@@ -11620,6 +12456,7 @@
           <a:lstStyle xmlns:a="http://schemas.openxmlformats.org/drawingml/2006/main"/>
           <a:p xmlns:a="http://schemas.openxmlformats.org/drawingml/2006/main">
             <a:pPr algn="ctr">
+              <a:buNone/>
               <a:defRPr sz="1800" b="1">
                 <a:solidFill>
                   <a:srgbClr val="111827"/>
@@ -11670,6 +12507,7 @@
           <a:lstStyle xmlns:a="http://schemas.openxmlformats.org/drawingml/2006/main"/>
           <a:p xmlns:a="http://schemas.openxmlformats.org/drawingml/2006/main">
             <a:pPr algn="l">
+              <a:buNone/>
               <a:defRPr sz="825" b="0">
                 <a:solidFill>
                   <a:srgbClr val="6B7280"/>
@@ -11720,6 +12558,7 @@
           <a:lstStyle xmlns:a="http://schemas.openxmlformats.org/drawingml/2006/main"/>
           <a:p xmlns:a="http://schemas.openxmlformats.org/drawingml/2006/main">
             <a:pPr algn="r">
+              <a:buNone/>
               <a:defRPr sz="825" b="0">
                 <a:solidFill>
                   <a:srgbClr val="6B7280"/>
@@ -11799,6 +12638,7 @@
           <a:lstStyle xmlns:a="http://schemas.openxmlformats.org/drawingml/2006/main"/>
           <a:p xmlns:a="http://schemas.openxmlformats.org/drawingml/2006/main">
             <a:pPr algn="l">
+              <a:buNone/>
               <a:defRPr sz="975" b="1">
                 <a:solidFill>
                   <a:srgbClr val="6B7280"/>
@@ -11849,6 +12689,7 @@
           <a:lstStyle xmlns:a="http://schemas.openxmlformats.org/drawingml/2006/main"/>
           <a:p xmlns:a="http://schemas.openxmlformats.org/drawingml/2006/main">
             <a:pPr algn="l">
+              <a:buNone/>
               <a:defRPr sz="2850" b="1">
                 <a:solidFill>
                   <a:srgbClr val="111827"/>
@@ -11965,6 +12806,7 @@
           <a:lstStyle xmlns:a="http://schemas.openxmlformats.org/drawingml/2006/main"/>
           <a:p xmlns:a="http://schemas.openxmlformats.org/drawingml/2006/main">
             <a:pPr algn="ctr">
+              <a:buNone/>
               <a:defRPr sz="1575" b="1">
                 <a:solidFill>
                   <a:srgbClr val="111827"/>
@@ -12015,6 +12857,7 @@
           <a:lstStyle xmlns:a="http://schemas.openxmlformats.org/drawingml/2006/main"/>
           <a:p xmlns:a="http://schemas.openxmlformats.org/drawingml/2006/main">
             <a:pPr algn="ctr">
+              <a:buNone/>
               <a:defRPr sz="1200" b="0">
                 <a:solidFill>
                   <a:srgbClr val="4B5563"/>
@@ -12131,6 +12974,7 @@
           <a:lstStyle xmlns:a="http://schemas.openxmlformats.org/drawingml/2006/main"/>
           <a:p xmlns:a="http://schemas.openxmlformats.org/drawingml/2006/main">
             <a:pPr algn="ctr">
+              <a:buNone/>
               <a:defRPr sz="1575" b="1">
                 <a:solidFill>
                   <a:srgbClr val="111827"/>
@@ -12181,6 +13025,7 @@
           <a:lstStyle xmlns:a="http://schemas.openxmlformats.org/drawingml/2006/main"/>
           <a:p xmlns:a="http://schemas.openxmlformats.org/drawingml/2006/main">
             <a:pPr algn="ctr">
+              <a:buNone/>
               <a:defRPr sz="1200" b="0">
                 <a:solidFill>
                   <a:srgbClr val="4B5563"/>
@@ -12297,6 +13142,7 @@
           <a:lstStyle xmlns:a="http://schemas.openxmlformats.org/drawingml/2006/main"/>
           <a:p xmlns:a="http://schemas.openxmlformats.org/drawingml/2006/main">
             <a:pPr algn="ctr">
+              <a:buNone/>
               <a:defRPr sz="1575" b="1">
                 <a:solidFill>
                   <a:srgbClr val="111827"/>
@@ -12347,6 +13193,7 @@
           <a:lstStyle xmlns:a="http://schemas.openxmlformats.org/drawingml/2006/main"/>
           <a:p xmlns:a="http://schemas.openxmlformats.org/drawingml/2006/main">
             <a:pPr algn="ctr">
+              <a:buNone/>
               <a:defRPr sz="1200" b="0">
                 <a:solidFill>
                   <a:srgbClr val="4B5563"/>
@@ -12463,6 +13310,7 @@
           <a:lstStyle xmlns:a="http://schemas.openxmlformats.org/drawingml/2006/main"/>
           <a:p xmlns:a="http://schemas.openxmlformats.org/drawingml/2006/main">
             <a:pPr algn="ctr">
+              <a:buNone/>
               <a:defRPr sz="1575" b="1">
                 <a:solidFill>
                   <a:srgbClr val="111827"/>
@@ -12513,6 +13361,7 @@
           <a:lstStyle xmlns:a="http://schemas.openxmlformats.org/drawingml/2006/main"/>
           <a:p xmlns:a="http://schemas.openxmlformats.org/drawingml/2006/main">
             <a:pPr algn="ctr">
+              <a:buNone/>
               <a:defRPr sz="1200" b="0">
                 <a:solidFill>
                   <a:srgbClr val="4B5563"/>
@@ -12596,6 +13445,7 @@
           <a:lstStyle xmlns:a="http://schemas.openxmlformats.org/drawingml/2006/main"/>
           <a:p xmlns:a="http://schemas.openxmlformats.org/drawingml/2006/main">
             <a:pPr algn="ctr">
+              <a:buNone/>
               <a:defRPr sz="1650" b="1">
                 <a:solidFill>
                   <a:srgbClr val="111827"/>
@@ -12646,6 +13496,7 @@
           <a:lstStyle xmlns:a="http://schemas.openxmlformats.org/drawingml/2006/main"/>
           <a:p xmlns:a="http://schemas.openxmlformats.org/drawingml/2006/main">
             <a:pPr algn="ctr">
+              <a:buNone/>
               <a:defRPr sz="1800" b="1">
                 <a:solidFill>
                   <a:srgbClr val="111827"/>
@@ -12696,6 +13547,7 @@
           <a:lstStyle xmlns:a="http://schemas.openxmlformats.org/drawingml/2006/main"/>
           <a:p xmlns:a="http://schemas.openxmlformats.org/drawingml/2006/main">
             <a:pPr algn="l">
+              <a:buNone/>
               <a:defRPr sz="825" b="0">
                 <a:solidFill>
                   <a:srgbClr val="6B7280"/>
@@ -12746,6 +13598,7 @@
           <a:lstStyle xmlns:a="http://schemas.openxmlformats.org/drawingml/2006/main"/>
           <a:p xmlns:a="http://schemas.openxmlformats.org/drawingml/2006/main">
             <a:pPr algn="r">
+              <a:buNone/>
               <a:defRPr sz="825" b="0">
                 <a:solidFill>
                   <a:srgbClr val="6B7280"/>
@@ -12825,6 +13678,7 @@
           <a:lstStyle xmlns:a="http://schemas.openxmlformats.org/drawingml/2006/main"/>
           <a:p xmlns:a="http://schemas.openxmlformats.org/drawingml/2006/main">
             <a:pPr algn="l">
+              <a:buNone/>
               <a:defRPr sz="975" b="1">
                 <a:solidFill>
                   <a:srgbClr val="6B7280"/>
@@ -12875,6 +13729,7 @@
           <a:lstStyle xmlns:a="http://schemas.openxmlformats.org/drawingml/2006/main"/>
           <a:p xmlns:a="http://schemas.openxmlformats.org/drawingml/2006/main">
             <a:pPr algn="l">
+              <a:buNone/>
               <a:defRPr sz="2850" b="1">
                 <a:solidFill>
                   <a:srgbClr val="111827"/>
@@ -12958,6 +13813,7 @@
           <a:lstStyle xmlns:a="http://schemas.openxmlformats.org/drawingml/2006/main"/>
           <a:p xmlns:a="http://schemas.openxmlformats.org/drawingml/2006/main">
             <a:pPr algn="l">
+              <a:buNone/>
               <a:defRPr sz="1350" b="1">
                 <a:solidFill>
                   <a:srgbClr val="6B7280"/>
@@ -13008,6 +13864,7 @@
           <a:lstStyle xmlns:a="http://schemas.openxmlformats.org/drawingml/2006/main"/>
           <a:p xmlns:a="http://schemas.openxmlformats.org/drawingml/2006/main">
             <a:pPr algn="l">
+              <a:buNone/>
               <a:defRPr sz="2100" b="1">
                 <a:solidFill>
                   <a:srgbClr val="111827"/>
@@ -13091,6 +13948,7 @@
           <a:lstStyle xmlns:a="http://schemas.openxmlformats.org/drawingml/2006/main"/>
           <a:p xmlns:a="http://schemas.openxmlformats.org/drawingml/2006/main">
             <a:pPr algn="l">
+              <a:buNone/>
               <a:defRPr sz="1500" b="1">
                 <a:solidFill>
                   <a:srgbClr val="111827"/>
@@ -13141,6 +13999,7 @@
           <a:lstStyle xmlns:a="http://schemas.openxmlformats.org/drawingml/2006/main"/>
           <a:p xmlns:a="http://schemas.openxmlformats.org/drawingml/2006/main">
             <a:pPr algn="l">
+              <a:buNone/>
               <a:defRPr sz="1275" b="0">
                 <a:solidFill>
                   <a:srgbClr val="4B5563"/>
@@ -13224,6 +14083,7 @@
           <a:lstStyle xmlns:a="http://schemas.openxmlformats.org/drawingml/2006/main"/>
           <a:p xmlns:a="http://schemas.openxmlformats.org/drawingml/2006/main">
             <a:pPr algn="l">
+              <a:buNone/>
               <a:defRPr sz="1500" b="1">
                 <a:solidFill>
                   <a:srgbClr val="111827"/>
@@ -13274,6 +14134,7 @@
           <a:lstStyle xmlns:a="http://schemas.openxmlformats.org/drawingml/2006/main"/>
           <a:p xmlns:a="http://schemas.openxmlformats.org/drawingml/2006/main">
             <a:pPr algn="l">
+              <a:buNone/>
               <a:defRPr sz="1275" b="0">
                 <a:solidFill>
                   <a:srgbClr val="4B5563"/>
@@ -13357,6 +14218,7 @@
           <a:lstStyle xmlns:a="http://schemas.openxmlformats.org/drawingml/2006/main"/>
           <a:p xmlns:a="http://schemas.openxmlformats.org/drawingml/2006/main">
             <a:pPr algn="l">
+              <a:buNone/>
               <a:defRPr sz="1500" b="1">
                 <a:solidFill>
                   <a:srgbClr val="111827"/>
@@ -13407,6 +14269,7 @@
           <a:lstStyle xmlns:a="http://schemas.openxmlformats.org/drawingml/2006/main"/>
           <a:p xmlns:a="http://schemas.openxmlformats.org/drawingml/2006/main">
             <a:pPr algn="l">
+              <a:buNone/>
               <a:defRPr sz="1275" b="0">
                 <a:solidFill>
                   <a:srgbClr val="4B5563"/>
@@ -13457,6 +14320,7 @@
           <a:lstStyle xmlns:a="http://schemas.openxmlformats.org/drawingml/2006/main"/>
           <a:p xmlns:a="http://schemas.openxmlformats.org/drawingml/2006/main">
             <a:pPr algn="ctr">
+              <a:buNone/>
               <a:defRPr sz="1800" b="1">
                 <a:solidFill>
                   <a:srgbClr val="111827"/>
@@ -13507,6 +14371,7 @@
           <a:lstStyle xmlns:a="http://schemas.openxmlformats.org/drawingml/2006/main"/>
           <a:p xmlns:a="http://schemas.openxmlformats.org/drawingml/2006/main">
             <a:pPr algn="l">
+              <a:buNone/>
               <a:defRPr sz="825" b="0">
                 <a:solidFill>
                   <a:srgbClr val="6B7280"/>
@@ -13557,6 +14422,7 @@
           <a:lstStyle xmlns:a="http://schemas.openxmlformats.org/drawingml/2006/main"/>
           <a:p xmlns:a="http://schemas.openxmlformats.org/drawingml/2006/main">
             <a:pPr algn="r">
+              <a:buNone/>
               <a:defRPr sz="825" b="0">
                 <a:solidFill>
                   <a:srgbClr val="6B7280"/>
@@ -13636,6 +14502,7 @@
           <a:lstStyle xmlns:a="http://schemas.openxmlformats.org/drawingml/2006/main"/>
           <a:p xmlns:a="http://schemas.openxmlformats.org/drawingml/2006/main">
             <a:pPr algn="l">
+              <a:buNone/>
               <a:defRPr sz="975" b="1">
                 <a:solidFill>
                   <a:srgbClr val="6B7280"/>
@@ -13686,6 +14553,7 @@
           <a:lstStyle xmlns:a="http://schemas.openxmlformats.org/drawingml/2006/main"/>
           <a:p xmlns:a="http://schemas.openxmlformats.org/drawingml/2006/main">
             <a:pPr algn="l">
+              <a:buNone/>
               <a:defRPr sz="2850" b="1">
                 <a:solidFill>
                   <a:srgbClr val="111827"/>
@@ -13769,6 +14637,7 @@
           <a:lstStyle xmlns:a="http://schemas.openxmlformats.org/drawingml/2006/main"/>
           <a:p xmlns:a="http://schemas.openxmlformats.org/drawingml/2006/main">
             <a:pPr algn="l">
+              <a:buNone/>
               <a:defRPr sz="1350" b="1">
                 <a:solidFill>
                   <a:srgbClr val="6B7280"/>
@@ -13819,6 +14688,7 @@
           <a:lstStyle xmlns:a="http://schemas.openxmlformats.org/drawingml/2006/main"/>
           <a:p xmlns:a="http://schemas.openxmlformats.org/drawingml/2006/main">
             <a:pPr algn="l">
+              <a:buNone/>
               <a:defRPr sz="2100" b="1">
                 <a:solidFill>
                   <a:srgbClr val="111827"/>
@@ -13902,6 +14772,7 @@
           <a:lstStyle xmlns:a="http://schemas.openxmlformats.org/drawingml/2006/main"/>
           <a:p xmlns:a="http://schemas.openxmlformats.org/drawingml/2006/main">
             <a:pPr algn="l">
+              <a:buNone/>
               <a:defRPr sz="1500" b="1">
                 <a:solidFill>
                   <a:srgbClr val="111827"/>
@@ -13952,6 +14823,7 @@
           <a:lstStyle xmlns:a="http://schemas.openxmlformats.org/drawingml/2006/main"/>
           <a:p xmlns:a="http://schemas.openxmlformats.org/drawingml/2006/main">
             <a:pPr algn="l">
+              <a:buNone/>
               <a:defRPr sz="1275" b="0">
                 <a:solidFill>
                   <a:srgbClr val="4B5563"/>
@@ -14035,6 +14907,7 @@
           <a:lstStyle xmlns:a="http://schemas.openxmlformats.org/drawingml/2006/main"/>
           <a:p xmlns:a="http://schemas.openxmlformats.org/drawingml/2006/main">
             <a:pPr algn="l">
+              <a:buNone/>
               <a:defRPr sz="1500" b="1">
                 <a:solidFill>
                   <a:srgbClr val="111827"/>
@@ -14085,6 +14958,7 @@
           <a:lstStyle xmlns:a="http://schemas.openxmlformats.org/drawingml/2006/main"/>
           <a:p xmlns:a="http://schemas.openxmlformats.org/drawingml/2006/main">
             <a:pPr algn="l">
+              <a:buNone/>
               <a:defRPr sz="1275" b="0">
                 <a:solidFill>
                   <a:srgbClr val="4B5563"/>
@@ -14168,6 +15042,7 @@
           <a:lstStyle xmlns:a="http://schemas.openxmlformats.org/drawingml/2006/main"/>
           <a:p xmlns:a="http://schemas.openxmlformats.org/drawingml/2006/main">
             <a:pPr algn="l">
+              <a:buNone/>
               <a:defRPr sz="1500" b="1">
                 <a:solidFill>
                   <a:srgbClr val="111827"/>
@@ -14218,6 +15093,7 @@
           <a:lstStyle xmlns:a="http://schemas.openxmlformats.org/drawingml/2006/main"/>
           <a:p xmlns:a="http://schemas.openxmlformats.org/drawingml/2006/main">
             <a:pPr algn="l">
+              <a:buNone/>
               <a:defRPr sz="1275" b="0">
                 <a:solidFill>
                   <a:srgbClr val="4B5563"/>
@@ -14268,6 +15144,7 @@
           <a:lstStyle xmlns:a="http://schemas.openxmlformats.org/drawingml/2006/main"/>
           <a:p xmlns:a="http://schemas.openxmlformats.org/drawingml/2006/main">
             <a:pPr algn="ctr">
+              <a:buNone/>
               <a:defRPr sz="1800" b="1">
                 <a:solidFill>
                   <a:srgbClr val="111827"/>
@@ -14318,6 +15195,7 @@
           <a:lstStyle xmlns:a="http://schemas.openxmlformats.org/drawingml/2006/main"/>
           <a:p xmlns:a="http://schemas.openxmlformats.org/drawingml/2006/main">
             <a:pPr algn="l">
+              <a:buNone/>
               <a:defRPr sz="825" b="0">
                 <a:solidFill>
                   <a:srgbClr val="6B7280"/>
@@ -14368,6 +15246,7 @@
           <a:lstStyle xmlns:a="http://schemas.openxmlformats.org/drawingml/2006/main"/>
           <a:p xmlns:a="http://schemas.openxmlformats.org/drawingml/2006/main">
             <a:pPr algn="r">
+              <a:buNone/>
               <a:defRPr sz="825" b="0">
                 <a:solidFill>
                   <a:srgbClr val="6B7280"/>

</xml_diff>

<commit_message>
Add production harness checklist slide
</commit_message>
<xml_diff>
--- a/presentations/harness-engineering-principles-demo.pptx
+++ b/presentations/harness-engineering-principles-demo.pptx
@@ -2,23 +2,24 @@
 <file path=ppt/presentation.xml><?xml version="1.0" encoding="utf-8"?>
 <p:presentation xmlns:p="http://schemas.openxmlformats.org/presentationml/2006/main">
   <p:sldMasterIdLst>
-    <p:sldMasterId xmlns:r="http://schemas.openxmlformats.org/officeDocument/2006/relationships" id="2147483648" r:id="Rb28509ca289a4b6f"/>
+    <p:sldMasterId xmlns:r="http://schemas.openxmlformats.org/officeDocument/2006/relationships" id="2147483648" r:id="R84b1d69a374348c7"/>
   </p:sldMasterIdLst>
   <p:notesMasterIdLst>
-    <p:notesMasterId xmlns:r="http://schemas.openxmlformats.org/officeDocument/2006/relationships" r:id="R5c2108c105ee4833"/>
+    <p:notesMasterId xmlns:r="http://schemas.openxmlformats.org/officeDocument/2006/relationships" r:id="R95747480da5f4136"/>
   </p:notesMasterIdLst>
   <p:sldIdLst>
-    <p:sldId xmlns:r="http://schemas.openxmlformats.org/officeDocument/2006/relationships" id="256" r:id="R03263ecb0e7b4588"/>
-    <p:sldId xmlns:r="http://schemas.openxmlformats.org/officeDocument/2006/relationships" id="257" r:id="Rc338e95ca3c04aa2"/>
-    <p:sldId xmlns:r="http://schemas.openxmlformats.org/officeDocument/2006/relationships" id="258" r:id="Rd7de76bf153e40c6"/>
-    <p:sldId xmlns:r="http://schemas.openxmlformats.org/officeDocument/2006/relationships" id="259" r:id="Rd23106b7e3854edc"/>
-    <p:sldId xmlns:r="http://schemas.openxmlformats.org/officeDocument/2006/relationships" id="260" r:id="R366170fed2b645b3"/>
-    <p:sldId xmlns:r="http://schemas.openxmlformats.org/officeDocument/2006/relationships" id="261" r:id="Rb7d0752ae02c4019"/>
-    <p:sldId xmlns:r="http://schemas.openxmlformats.org/officeDocument/2006/relationships" id="262" r:id="Rbf6babfa8e774416"/>
-    <p:sldId xmlns:r="http://schemas.openxmlformats.org/officeDocument/2006/relationships" id="263" r:id="R7afcdef7182440b1"/>
-    <p:sldId xmlns:r="http://schemas.openxmlformats.org/officeDocument/2006/relationships" id="264" r:id="R7208ca74b375411e"/>
-    <p:sldId xmlns:r="http://schemas.openxmlformats.org/officeDocument/2006/relationships" id="265" r:id="Re3bc91f8f2f24019"/>
-    <p:sldId xmlns:r="http://schemas.openxmlformats.org/officeDocument/2006/relationships" id="266" r:id="Rbbd1b31642504b72"/>
+    <p:sldId xmlns:r="http://schemas.openxmlformats.org/officeDocument/2006/relationships" id="256" r:id="Rcd4e3944d9ef475a"/>
+    <p:sldId xmlns:r="http://schemas.openxmlformats.org/officeDocument/2006/relationships" id="257" r:id="R612a234503f14f3f"/>
+    <p:sldId xmlns:r="http://schemas.openxmlformats.org/officeDocument/2006/relationships" id="258" r:id="Rfb2d4dd329b94b66"/>
+    <p:sldId xmlns:r="http://schemas.openxmlformats.org/officeDocument/2006/relationships" id="259" r:id="Rc7c9dbac6c5c4d2a"/>
+    <p:sldId xmlns:r="http://schemas.openxmlformats.org/officeDocument/2006/relationships" id="260" r:id="R89dec0b03ef34104"/>
+    <p:sldId xmlns:r="http://schemas.openxmlformats.org/officeDocument/2006/relationships" id="261" r:id="R12fa739939454536"/>
+    <p:sldId xmlns:r="http://schemas.openxmlformats.org/officeDocument/2006/relationships" id="262" r:id="R19acd7defdae425a"/>
+    <p:sldId xmlns:r="http://schemas.openxmlformats.org/officeDocument/2006/relationships" id="263" r:id="Rafb8b2c490fe4868"/>
+    <p:sldId xmlns:r="http://schemas.openxmlformats.org/officeDocument/2006/relationships" id="264" r:id="Rfc999b86680d4adb"/>
+    <p:sldId xmlns:r="http://schemas.openxmlformats.org/officeDocument/2006/relationships" id="265" r:id="Red2115ba255d4b96"/>
+    <p:sldId xmlns:r="http://schemas.openxmlformats.org/officeDocument/2006/relationships" id="266" r:id="R6d9de5c0e2a24399"/>
+    <p:sldId xmlns:r="http://schemas.openxmlformats.org/officeDocument/2006/relationships" id="267" r:id="Ra7782c26ca914996"/>
   </p:sldIdLst>
   <p:sldSz cx="12192000" cy="6858000"/>
   <p:notesSz cx="6858000" cy="9144000"/>
@@ -622,6 +623,101 @@
           </a:p>
           <a:p xmlns:a="http://schemas.openxmlformats.org/drawingml/2006/main">
             <a:r>
+              <a:t>OpenAI, A practical guide to building agents: recommends defining tools/instructions/orchestration, using evals before optimizing model cost/latency, applying layered guardrails, and planning human intervention for failure thresholds and high-risk actions. https://openai.com/business/guides-and-resources/a-practical-guide-to-building-ai-agents/</a:t>
+            </a:r>
+          </a:p>
+          <a:p xmlns:a="http://schemas.openxmlformats.org/drawingml/2006/main">
+            <a:r>
+              <a:t>OpenAI Agents SDK guardrails docs: input, output, and tool guardrails can run at workflow boundaries and around function-tool invocation. https://openai.github.io/openai-agents-js/guides/guardrails/</a:t>
+            </a:r>
+          </a:p>
+          <a:p xmlns:a="http://schemas.openxmlformats.org/drawingml/2006/main">
+            <a:r>
+              <a:t>Anthropic, Building effective agents: start with the simplest solution, use augmented LLM/workflow/agent patterns, and apply evaluator-optimizer or orchestrator-worker patterns when justified by complexity. https://www.anthropic.com/engineering/building-effective-agents</a:t>
+            </a:r>
+          </a:p>
+          <a:p xmlns:a="http://schemas.openxmlformats.org/drawingml/2006/main">
+            <a:r>
+              <a:t>Fowler, Harness engineering: combines feedforward guides, feedback sensors, steering loops, timing/keep-quality-left, and the role of the human. https://martinfowler.com/articles/harness-engineering.html</a:t>
+            </a:r>
+          </a:p>
+          <a:p xmlns:a="http://schemas.openxmlformats.org/drawingml/2006/main">
+            <a:r>
+              <a:t>OpenAI, Harness engineering: repository/system knowledge should be legible, versioned, enforceable, and continuously improved; agents need boundaries, verification, observability, and garbage collection. https://openai.com/index/harness-engineering/</a:t>
+            </a:r>
+          </a:p>
+        </p:txBody>
+      </p:sp>
+      <p:sp>
+        <p:nvSpPr>
+          <p:cNvPr id="4" name="Slide Number Placeholder 3"/>
+          <p:cNvSpPr>
+            <a:spLocks xmlns:a="http://schemas.openxmlformats.org/drawingml/2006/main" noGrp="1"/>
+          </p:cNvSpPr>
+          <p:nvPr>
+            <p:ph type="sldNum" idx="5"/>
+          </p:nvPr>
+        </p:nvSpPr>
+        <p:spPr/>
+        <p:txBody>
+          <a:bodyPr xmlns:a="http://schemas.openxmlformats.org/drawingml/2006/main"/>
+          <a:lstStyle xmlns:a="http://schemas.openxmlformats.org/drawingml/2006/main"/>
+          <a:p xmlns:a="http://schemas.openxmlformats.org/drawingml/2006/main"/>
+        </p:txBody>
+      </p:sp>
+    </p:spTree>
+  </p:cSld>
+  <p:clrMapOvr>
+    <a:masterClrMapping xmlns:a="http://schemas.openxmlformats.org/drawingml/2006/main"/>
+  </p:clrMapOvr>
+</p:notes>
+</file>
+
+<file path=ppt/notesSlides/notesSlide12.xml><?xml version="1.0" encoding="utf-8"?>
+<p:notes xmlns:p="http://schemas.openxmlformats.org/presentationml/2006/main">
+  <p:cSld>
+    <p:spTree>
+      <p:nvGrpSpPr>
+        <p:cNvPr id="1" name=""/>
+        <p:cNvGrpSpPr/>
+        <p:nvPr/>
+      </p:nvGrpSpPr>
+      <p:grpSpPr>
+        <a:xfrm xmlns:a="http://schemas.openxmlformats.org/drawingml/2006/main"/>
+      </p:grpSpPr>
+      <p:sp>
+        <p:nvSpPr>
+          <p:cNvPr id="2" name="Slide Image Placeholder 1"/>
+          <p:cNvSpPr>
+            <a:spLocks xmlns:a="http://schemas.openxmlformats.org/drawingml/2006/main" noGrp="1"/>
+          </p:cNvSpPr>
+          <p:nvPr>
+            <p:ph type="sldImg" idx="0"/>
+          </p:nvPr>
+        </p:nvSpPr>
+        <p:spPr/>
+      </p:sp>
+      <p:sp>
+        <p:nvSpPr>
+          <p:cNvPr id="3" name="Notes Placeholder 2"/>
+          <p:cNvSpPr>
+            <a:spLocks xmlns:a="http://schemas.openxmlformats.org/drawingml/2006/main" noGrp="1"/>
+          </p:cNvSpPr>
+          <p:nvPr>
+            <p:ph type="body" idx="1"/>
+          </p:nvPr>
+        </p:nvSpPr>
+        <p:spPr/>
+        <p:txBody>
+          <a:bodyPr xmlns:a="http://schemas.openxmlformats.org/drawingml/2006/main"/>
+          <a:lstStyle xmlns:a="http://schemas.openxmlformats.org/drawingml/2006/main"/>
+          <a:p xmlns:a="http://schemas.openxmlformats.org/drawingml/2006/main">
+            <a:r>
+              <a:t>[Sources]</a:t>
+            </a:r>
+          </a:p>
+          <a:p xmlns:a="http://schemas.openxmlformats.org/drawingml/2006/main">
+            <a:r>
               <a:t>Fowler is the primary reference for harness engineering. https://martinfowler.com/articles/harness-engineering.html</a:t>
             </a:r>
           </a:p>
@@ -1370,7 +1466,7 @@
   </p:cSld>
   <p:clrMap bg1="lt1" tx1="dk1" bg2="lt2" tx2="dk2" accent1="accent1" accent2="accent2" accent3="accent3" accent4="accent4" accent5="accent5" accent6="accent6" hlink="hlink" folHlink="folHlink"/>
   <p:sldLayoutIdLst>
-    <p:sldLayoutId xmlns:r="http://schemas.openxmlformats.org/officeDocument/2006/relationships" id="2147483649" r:id="Ra02ef25e56654bf1"/>
+    <p:sldLayoutId xmlns:r="http://schemas.openxmlformats.org/officeDocument/2006/relationships" id="2147483649" r:id="R4b19912fa6384ee1"/>
   </p:sldLayoutIdLst>
   <p:txStyles>
     <p:titleStyle>
@@ -1949,6 +2045,7 @@
           <a:lstStyle xmlns:a="http://schemas.openxmlformats.org/drawingml/2006/main"/>
           <a:p xmlns:a="http://schemas.openxmlformats.org/drawingml/2006/main">
             <a:pPr algn="l">
+              <a:buNone/>
               <a:defRPr sz="3750" b="1">
                 <a:solidFill>
                   <a:srgbClr val="0B0F19"/>
@@ -1999,6 +2096,7 @@
           <a:lstStyle xmlns:a="http://schemas.openxmlformats.org/drawingml/2006/main"/>
           <a:p xmlns:a="http://schemas.openxmlformats.org/drawingml/2006/main">
             <a:pPr algn="l">
+              <a:buNone/>
               <a:defRPr sz="1875" b="0">
                 <a:solidFill>
                   <a:srgbClr val="4B5563"/>
@@ -2082,6 +2180,7 @@
           <a:lstStyle xmlns:a="http://schemas.openxmlformats.org/drawingml/2006/main"/>
           <a:p xmlns:a="http://schemas.openxmlformats.org/drawingml/2006/main">
             <a:pPr algn="l">
+              <a:buNone/>
               <a:defRPr sz="1350" b="1">
                 <a:solidFill>
                   <a:srgbClr val="DC2626"/>
@@ -2132,6 +2231,7 @@
           <a:lstStyle xmlns:a="http://schemas.openxmlformats.org/drawingml/2006/main"/>
           <a:p xmlns:a="http://schemas.openxmlformats.org/drawingml/2006/main">
             <a:pPr algn="l">
+              <a:buNone/>
               <a:defRPr sz="1500" b="0">
                 <a:solidFill>
                   <a:srgbClr val="0B0F19"/>
@@ -2215,6 +2315,7 @@
           <a:lstStyle xmlns:a="http://schemas.openxmlformats.org/drawingml/2006/main"/>
           <a:p xmlns:a="http://schemas.openxmlformats.org/drawingml/2006/main">
             <a:pPr algn="l">
+              <a:buNone/>
               <a:defRPr sz="1350" b="1">
                 <a:solidFill>
                   <a:srgbClr val="DC2626"/>
@@ -2265,6 +2366,7 @@
           <a:lstStyle xmlns:a="http://schemas.openxmlformats.org/drawingml/2006/main"/>
           <a:p xmlns:a="http://schemas.openxmlformats.org/drawingml/2006/main">
             <a:pPr algn="l">
+              <a:buNone/>
               <a:defRPr sz="1500" b="0">
                 <a:solidFill>
                   <a:srgbClr val="0B0F19"/>
@@ -2348,6 +2450,7 @@
           <a:lstStyle xmlns:a="http://schemas.openxmlformats.org/drawingml/2006/main"/>
           <a:p xmlns:a="http://schemas.openxmlformats.org/drawingml/2006/main">
             <a:pPr algn="l">
+              <a:buNone/>
               <a:defRPr sz="1350" b="1">
                 <a:solidFill>
                   <a:srgbClr val="D97706"/>
@@ -2398,6 +2501,7 @@
           <a:lstStyle xmlns:a="http://schemas.openxmlformats.org/drawingml/2006/main"/>
           <a:p xmlns:a="http://schemas.openxmlformats.org/drawingml/2006/main">
             <a:pPr algn="l">
+              <a:buNone/>
               <a:defRPr sz="1500" b="0">
                 <a:solidFill>
                   <a:srgbClr val="0B0F19"/>
@@ -2481,6 +2585,7 @@
           <a:lstStyle xmlns:a="http://schemas.openxmlformats.org/drawingml/2006/main"/>
           <a:p xmlns:a="http://schemas.openxmlformats.org/drawingml/2006/main">
             <a:pPr algn="l">
+              <a:buNone/>
               <a:defRPr sz="1350" b="1">
                 <a:solidFill>
                   <a:srgbClr val="D97706"/>
@@ -2531,6 +2636,7 @@
           <a:lstStyle xmlns:a="http://schemas.openxmlformats.org/drawingml/2006/main"/>
           <a:p xmlns:a="http://schemas.openxmlformats.org/drawingml/2006/main">
             <a:pPr algn="l">
+              <a:buNone/>
               <a:defRPr sz="1500" b="0">
                 <a:solidFill>
                   <a:srgbClr val="0B0F19"/>
@@ -2614,6 +2720,7 @@
           <a:lstStyle xmlns:a="http://schemas.openxmlformats.org/drawingml/2006/main"/>
           <a:p xmlns:a="http://schemas.openxmlformats.org/drawingml/2006/main">
             <a:pPr algn="l">
+              <a:buNone/>
               <a:defRPr sz="1350" b="1">
                 <a:solidFill>
                   <a:srgbClr val="2563EB"/>
@@ -2664,6 +2771,7 @@
           <a:lstStyle xmlns:a="http://schemas.openxmlformats.org/drawingml/2006/main"/>
           <a:p xmlns:a="http://schemas.openxmlformats.org/drawingml/2006/main">
             <a:pPr algn="l">
+              <a:buNone/>
               <a:defRPr sz="1500" b="0">
                 <a:solidFill>
                   <a:srgbClr val="0B0F19"/>
@@ -2747,6 +2855,7 @@
           <a:lstStyle xmlns:a="http://schemas.openxmlformats.org/drawingml/2006/main"/>
           <a:p xmlns:a="http://schemas.openxmlformats.org/drawingml/2006/main">
             <a:pPr algn="l">
+              <a:buNone/>
               <a:defRPr sz="1350" b="1">
                 <a:solidFill>
                   <a:srgbClr val="2563EB"/>
@@ -2797,6 +2906,7 @@
           <a:lstStyle xmlns:a="http://schemas.openxmlformats.org/drawingml/2006/main"/>
           <a:p xmlns:a="http://schemas.openxmlformats.org/drawingml/2006/main">
             <a:pPr algn="l">
+              <a:buNone/>
               <a:defRPr sz="1500" b="0">
                 <a:solidFill>
                   <a:srgbClr val="0B0F19"/>
@@ -2876,6 +2986,7 @@
           <a:lstStyle xmlns:a="http://schemas.openxmlformats.org/drawingml/2006/main"/>
           <a:p xmlns:a="http://schemas.openxmlformats.org/drawingml/2006/main">
             <a:pPr algn="l">
+              <a:buNone/>
               <a:defRPr sz="975" b="1">
                 <a:solidFill>
                   <a:srgbClr val="2563EB"/>
@@ -2926,6 +3037,7 @@
           <a:lstStyle xmlns:a="http://schemas.openxmlformats.org/drawingml/2006/main"/>
           <a:p xmlns:a="http://schemas.openxmlformats.org/drawingml/2006/main">
             <a:pPr algn="l">
+              <a:buNone/>
               <a:defRPr sz="2925" b="1">
                 <a:solidFill>
                   <a:srgbClr val="0B0F19"/>
@@ -3009,6 +3121,7 @@
           <a:lstStyle xmlns:a="http://schemas.openxmlformats.org/drawingml/2006/main"/>
           <a:p xmlns:a="http://schemas.openxmlformats.org/drawingml/2006/main">
             <a:pPr algn="l">
+              <a:buNone/>
               <a:defRPr sz="2250" b="1">
                 <a:solidFill>
                   <a:srgbClr val="0B0F19"/>
@@ -3092,6 +3205,7 @@
           <a:lstStyle xmlns:a="http://schemas.openxmlformats.org/drawingml/2006/main"/>
           <a:p xmlns:a="http://schemas.openxmlformats.org/drawingml/2006/main">
             <a:pPr algn="l">
+              <a:buNone/>
               <a:defRPr sz="1575" b="0">
                 <a:solidFill>
                   <a:srgbClr val="0B0F19"/>
@@ -3175,6 +3289,7 @@
           <a:lstStyle xmlns:a="http://schemas.openxmlformats.org/drawingml/2006/main"/>
           <a:p xmlns:a="http://schemas.openxmlformats.org/drawingml/2006/main">
             <a:pPr algn="l">
+              <a:buNone/>
               <a:defRPr sz="1575" b="0">
                 <a:solidFill>
                   <a:srgbClr val="0B0F19"/>
@@ -3258,6 +3373,7 @@
           <a:lstStyle xmlns:a="http://schemas.openxmlformats.org/drawingml/2006/main"/>
           <a:p xmlns:a="http://schemas.openxmlformats.org/drawingml/2006/main">
             <a:pPr algn="l">
+              <a:buNone/>
               <a:defRPr sz="1575" b="0">
                 <a:solidFill>
                   <a:srgbClr val="0B0F19"/>
@@ -3341,6 +3457,7 @@
           <a:lstStyle xmlns:a="http://schemas.openxmlformats.org/drawingml/2006/main"/>
           <a:p xmlns:a="http://schemas.openxmlformats.org/drawingml/2006/main">
             <a:pPr algn="ctr">
+              <a:buNone/>
               <a:defRPr sz="1800" b="1">
                 <a:solidFill>
                   <a:srgbClr val="FFFFFF"/>
@@ -3389,10 +3506,10 @@
       </p:grpSpPr>
       <p:sp>
         <p:nvSpPr>
-          <p:cNvPr id="16" name="">
-            <a:extLst xmlns:a="http://schemas.openxmlformats.org/drawingml/2006/main">
-              <a:ext uri="{FF2B5EF4-FFF2-40B4-BE49-F238E27FC236}">
-                <a16:creationId xmlns:a16="http://schemas.microsoft.com/office/drawing/2014/main" id="{64B6A23A-0764-4156-A386-02028A6FA49F}"/>
+          <p:cNvPr id="52" name="">
+            <a:extLst xmlns:a="http://schemas.openxmlformats.org/drawingml/2006/main">
+              <a:ext uri="{FF2B5EF4-FFF2-40B4-BE49-F238E27FC236}">
+                <a16:creationId xmlns:a16="http://schemas.microsoft.com/office/drawing/2014/main" id="{96674E05-0D0D-40AB-B478-077112DF7955}"/>
               </a:ext>
             </a:extLst>
           </p:cNvPr>
@@ -3432,7 +3549,7 @@
                   <a:srgbClr val="2563EB"/>
                 </a:solidFill>
               </a:rPr>
-              <a:t>APPENDIX</a:t>
+              <a:t>PRODUCTION PLAYBOOK</a:t>
             </a:r>
           </a:p>
         </p:txBody>
@@ -3442,7 +3559,7 @@
           <p:cNvPr id="2" name="">
             <a:extLst xmlns:a="http://schemas.openxmlformats.org/drawingml/2006/main">
               <a:ext uri="{FF2B5EF4-FFF2-40B4-BE49-F238E27FC236}">
-                <a16:creationId xmlns:a16="http://schemas.microsoft.com/office/drawing/2014/main" id="{CEC93461-B644-4A51-989C-53BC07347260}"/>
+                <a16:creationId xmlns:a16="http://schemas.microsoft.com/office/drawing/2014/main" id="{3C7B23F4-7462-4FA7-B47A-7A57D8470D35}"/>
               </a:ext>
             </a:extLst>
           </p:cNvPr>
@@ -3454,7 +3571,7 @@
         <p:spPr>
           <a:xfrm xmlns:a="http://schemas.openxmlformats.org/drawingml/2006/main">
             <a:off x="609600" y="723900"/>
-            <a:ext cx="9715500" cy="552450"/>
+            <a:ext cx="9906000" cy="552450"/>
           </a:xfrm>
           <a:prstGeom xmlns:a="http://schemas.openxmlformats.org/drawingml/2006/main" prst="rect">
             <a:avLst/>
@@ -3482,7 +3599,7 @@
                   <a:srgbClr val="0B0F19"/>
                 </a:solidFill>
               </a:rPr>
-              <a:t>Appendix: harness, loop, and workflow are different lenses</a:t>
+              <a:t>What a production agentic harness includes</a:t>
             </a:r>
           </a:p>
         </p:txBody>
@@ -3492,7 +3609,7 @@
           <p:cNvPr id="3" name="">
             <a:extLst xmlns:a="http://schemas.openxmlformats.org/drawingml/2006/main">
               <a:ext uri="{FF2B5EF4-FFF2-40B4-BE49-F238E27FC236}">
-                <a16:creationId xmlns:a16="http://schemas.microsoft.com/office/drawing/2014/main" id="{B36B401A-A908-4235-8A92-06DC0C3FE5B3}"/>
+                <a16:creationId xmlns:a16="http://schemas.microsoft.com/office/drawing/2014/main" id="{9B3943D9-88E6-4950-919B-06A72583F8F1}"/>
               </a:ext>
             </a:extLst>
           </p:cNvPr>
@@ -3525,6 +3642,2247 @@
           <p:cNvPr id="4" name="">
             <a:extLst xmlns:a="http://schemas.openxmlformats.org/drawingml/2006/main">
               <a:ext uri="{FF2B5EF4-FFF2-40B4-BE49-F238E27FC236}">
+                <a16:creationId xmlns:a16="http://schemas.microsoft.com/office/drawing/2014/main" id="{E9F16D15-523F-4A9C-A0F8-401A61BED05E}"/>
+              </a:ext>
+            </a:extLst>
+          </p:cNvPr>
+          <p:cNvSpPr>
+            <a:spLocks xmlns:a="http://schemas.openxmlformats.org/drawingml/2006/main" noGrp="1"/>
+          </p:cNvSpPr>
+          <p:nvPr/>
+        </p:nvSpPr>
+        <p:spPr>
+          <a:xfrm xmlns:a="http://schemas.openxmlformats.org/drawingml/2006/main">
+            <a:off x="685800" y="1600200"/>
+            <a:ext cx="10191750" cy="400050"/>
+          </a:xfrm>
+          <a:prstGeom xmlns:a="http://schemas.openxmlformats.org/drawingml/2006/main" prst="rect">
+            <a:avLst/>
+          </a:prstGeom>
+          <a:noFill xmlns:a="http://schemas.openxmlformats.org/drawingml/2006/main"/>
+          <a:ln xmlns:a="http://schemas.openxmlformats.org/drawingml/2006/main" w="0">
+            <a:noFill/>
+            <a:prstDash val="solid"/>
+          </a:ln>
+        </p:spPr>
+        <p:txBody>
+          <a:bodyPr xmlns:a="http://schemas.openxmlformats.org/drawingml/2006/main"/>
+          <a:lstStyle xmlns:a="http://schemas.openxmlformats.org/drawingml/2006/main"/>
+          <a:p xmlns:a="http://schemas.openxmlformats.org/drawingml/2006/main">
+            <a:pPr algn="l">
+              <a:defRPr sz="1575" b="0">
+                <a:solidFill>
+                  <a:srgbClr val="4B5563"/>
+                </a:solidFill>
+              </a:defRPr>
+            </a:pPr>
+            <a:r>
+              <a:rPr sz="1575" b="0">
+                <a:solidFill>
+                  <a:srgbClr val="4B5563"/>
+                </a:solidFill>
+              </a:rPr>
+              <a:t>Use this as the build checklist after the demo: design the work, bound the autonomy, then add controls that make behavior measurable and recoverable.</a:t>
+            </a:r>
+          </a:p>
+        </p:txBody>
+      </p:sp>
+      <p:sp>
+        <p:nvSpPr>
+          <p:cNvPr id="5" name="">
+            <a:extLst xmlns:a="http://schemas.openxmlformats.org/drawingml/2006/main">
+              <a:ext uri="{FF2B5EF4-FFF2-40B4-BE49-F238E27FC236}">
+                <a16:creationId xmlns:a16="http://schemas.microsoft.com/office/drawing/2014/main" id="{6B8D84EB-B432-4DB1-A7B4-8E3B3645B553}"/>
+              </a:ext>
+            </a:extLst>
+          </p:cNvPr>
+          <p:cNvSpPr>
+            <a:spLocks xmlns:a="http://schemas.openxmlformats.org/drawingml/2006/main" noGrp="1"/>
+          </p:cNvSpPr>
+          <p:nvPr/>
+        </p:nvSpPr>
+        <p:spPr>
+          <a:xfrm xmlns:a="http://schemas.openxmlformats.org/drawingml/2006/main">
+            <a:off x="685800" y="2286000"/>
+            <a:ext cx="3286125" cy="914400"/>
+          </a:xfrm>
+          <a:prstGeom xmlns:a="http://schemas.openxmlformats.org/drawingml/2006/main" prst="rect">
+            <a:avLst/>
+          </a:prstGeom>
+          <a:solidFill xmlns:a="http://schemas.openxmlformats.org/drawingml/2006/main">
+            <a:srgbClr val="FFFFFF"/>
+          </a:solidFill>
+          <a:ln xmlns:a="http://schemas.openxmlformats.org/drawingml/2006/main" w="9525">
+            <a:solidFill>
+              <a:srgbClr val="CBD5E1"/>
+            </a:solidFill>
+            <a:prstDash val="solid"/>
+          </a:ln>
+        </p:spPr>
+      </p:sp>
+      <p:sp>
+        <p:nvSpPr>
+          <p:cNvPr id="6" name="">
+            <a:extLst xmlns:a="http://schemas.openxmlformats.org/drawingml/2006/main">
+              <a:ext uri="{FF2B5EF4-FFF2-40B4-BE49-F238E27FC236}">
+                <a16:creationId xmlns:a16="http://schemas.microsoft.com/office/drawing/2014/main" id="{0ACFADF2-6540-4EB4-ADA3-2196BECC6B7F}"/>
+              </a:ext>
+            </a:extLst>
+          </p:cNvPr>
+          <p:cNvSpPr>
+            <a:spLocks xmlns:a="http://schemas.openxmlformats.org/drawingml/2006/main" noGrp="1"/>
+          </p:cNvSpPr>
+          <p:nvPr/>
+        </p:nvSpPr>
+        <p:spPr>
+          <a:xfrm xmlns:a="http://schemas.openxmlformats.org/drawingml/2006/main">
+            <a:off x="838200" y="2543175"/>
+            <a:ext cx="323850" cy="323850"/>
+          </a:xfrm>
+          <a:prstGeom xmlns:a="http://schemas.openxmlformats.org/drawingml/2006/main" prst="rect">
+            <a:avLst/>
+          </a:prstGeom>
+          <a:solidFill xmlns:a="http://schemas.openxmlformats.org/drawingml/2006/main">
+            <a:srgbClr val="2563EB"/>
+          </a:solidFill>
+          <a:ln xmlns:a="http://schemas.openxmlformats.org/drawingml/2006/main" w="9525">
+            <a:solidFill>
+              <a:srgbClr val="2563EB"/>
+            </a:solidFill>
+            <a:prstDash val="solid"/>
+          </a:ln>
+        </p:spPr>
+      </p:sp>
+      <p:sp>
+        <p:nvSpPr>
+          <p:cNvPr id="7" name="">
+            <a:extLst xmlns:a="http://schemas.openxmlformats.org/drawingml/2006/main">
+              <a:ext uri="{FF2B5EF4-FFF2-40B4-BE49-F238E27FC236}">
+                <a16:creationId xmlns:a16="http://schemas.microsoft.com/office/drawing/2014/main" id="{430EF95C-E25B-49ED-AED0-6F490B0EBC91}"/>
+              </a:ext>
+            </a:extLst>
+          </p:cNvPr>
+          <p:cNvSpPr>
+            <a:spLocks xmlns:a="http://schemas.openxmlformats.org/drawingml/2006/main" noGrp="1"/>
+          </p:cNvSpPr>
+          <p:nvPr/>
+        </p:nvSpPr>
+        <p:spPr>
+          <a:xfrm xmlns:a="http://schemas.openxmlformats.org/drawingml/2006/main">
+            <a:off x="838200" y="2600325"/>
+            <a:ext cx="323850" cy="171450"/>
+          </a:xfrm>
+          <a:prstGeom xmlns:a="http://schemas.openxmlformats.org/drawingml/2006/main" prst="rect">
+            <a:avLst/>
+          </a:prstGeom>
+          <a:noFill xmlns:a="http://schemas.openxmlformats.org/drawingml/2006/main"/>
+          <a:ln xmlns:a="http://schemas.openxmlformats.org/drawingml/2006/main" w="0">
+            <a:noFill/>
+            <a:prstDash val="solid"/>
+          </a:ln>
+        </p:spPr>
+        <p:txBody>
+          <a:bodyPr xmlns:a="http://schemas.openxmlformats.org/drawingml/2006/main"/>
+          <a:lstStyle xmlns:a="http://schemas.openxmlformats.org/drawingml/2006/main"/>
+          <a:p xmlns:a="http://schemas.openxmlformats.org/drawingml/2006/main">
+            <a:pPr algn="ctr">
+              <a:defRPr sz="1275" b="1">
+                <a:solidFill>
+                  <a:srgbClr val="FFFFFF"/>
+                </a:solidFill>
+              </a:defRPr>
+            </a:pPr>
+            <a:r>
+              <a:rPr sz="1275" b="1">
+                <a:solidFill>
+                  <a:srgbClr val="FFFFFF"/>
+                </a:solidFill>
+              </a:rPr>
+              <a:t>1</a:t>
+            </a:r>
+          </a:p>
+        </p:txBody>
+      </p:sp>
+      <p:sp>
+        <p:nvSpPr>
+          <p:cNvPr id="8" name="">
+            <a:extLst xmlns:a="http://schemas.openxmlformats.org/drawingml/2006/main">
+              <a:ext uri="{FF2B5EF4-FFF2-40B4-BE49-F238E27FC236}">
+                <a16:creationId xmlns:a16="http://schemas.microsoft.com/office/drawing/2014/main" id="{3504AA46-9031-4586-9979-BA850B670F3A}"/>
+              </a:ext>
+            </a:extLst>
+          </p:cNvPr>
+          <p:cNvSpPr>
+            <a:spLocks xmlns:a="http://schemas.openxmlformats.org/drawingml/2006/main" noGrp="1"/>
+          </p:cNvSpPr>
+          <p:nvPr/>
+        </p:nvSpPr>
+        <p:spPr>
+          <a:xfrm xmlns:a="http://schemas.openxmlformats.org/drawingml/2006/main">
+            <a:off x="1314450" y="2438400"/>
+            <a:ext cx="2505075" cy="228600"/>
+          </a:xfrm>
+          <a:prstGeom xmlns:a="http://schemas.openxmlformats.org/drawingml/2006/main" prst="rect">
+            <a:avLst/>
+          </a:prstGeom>
+          <a:noFill xmlns:a="http://schemas.openxmlformats.org/drawingml/2006/main"/>
+          <a:ln xmlns:a="http://schemas.openxmlformats.org/drawingml/2006/main" w="0">
+            <a:noFill/>
+            <a:prstDash val="solid"/>
+          </a:ln>
+        </p:spPr>
+        <p:txBody>
+          <a:bodyPr xmlns:a="http://schemas.openxmlformats.org/drawingml/2006/main"/>
+          <a:lstStyle xmlns:a="http://schemas.openxmlformats.org/drawingml/2006/main"/>
+          <a:p xmlns:a="http://schemas.openxmlformats.org/drawingml/2006/main">
+            <a:pPr algn="l">
+              <a:defRPr sz="1350" b="1">
+                <a:solidFill>
+                  <a:srgbClr val="2563EB"/>
+                </a:solidFill>
+              </a:defRPr>
+            </a:pPr>
+            <a:r>
+              <a:rPr sz="1350" b="1">
+                <a:solidFill>
+                  <a:srgbClr val="2563EB"/>
+                </a:solidFill>
+              </a:rPr>
+              <a:t>Decompose the work</a:t>
+            </a:r>
+          </a:p>
+        </p:txBody>
+      </p:sp>
+      <p:sp>
+        <p:nvSpPr>
+          <p:cNvPr id="9" name="">
+            <a:extLst xmlns:a="http://schemas.openxmlformats.org/drawingml/2006/main">
+              <a:ext uri="{FF2B5EF4-FFF2-40B4-BE49-F238E27FC236}">
+                <a16:creationId xmlns:a16="http://schemas.microsoft.com/office/drawing/2014/main" id="{541653C7-DCDB-424E-B15E-5E917A7690AF}"/>
+              </a:ext>
+            </a:extLst>
+          </p:cNvPr>
+          <p:cNvSpPr>
+            <a:spLocks xmlns:a="http://schemas.openxmlformats.org/drawingml/2006/main" noGrp="1"/>
+          </p:cNvSpPr>
+          <p:nvPr/>
+        </p:nvSpPr>
+        <p:spPr>
+          <a:xfrm xmlns:a="http://schemas.openxmlformats.org/drawingml/2006/main">
+            <a:off x="1314450" y="2714625"/>
+            <a:ext cx="2505075" cy="400050"/>
+          </a:xfrm>
+          <a:prstGeom xmlns:a="http://schemas.openxmlformats.org/drawingml/2006/main" prst="rect">
+            <a:avLst/>
+          </a:prstGeom>
+          <a:noFill xmlns:a="http://schemas.openxmlformats.org/drawingml/2006/main"/>
+          <a:ln xmlns:a="http://schemas.openxmlformats.org/drawingml/2006/main" w="0">
+            <a:noFill/>
+            <a:prstDash val="solid"/>
+          </a:ln>
+        </p:spPr>
+        <p:txBody>
+          <a:bodyPr xmlns:a="http://schemas.openxmlformats.org/drawingml/2006/main"/>
+          <a:lstStyle xmlns:a="http://schemas.openxmlformats.org/drawingml/2006/main"/>
+          <a:p xmlns:a="http://schemas.openxmlformats.org/drawingml/2006/main">
+            <a:pPr algn="l">
+              <a:defRPr sz="1125" b="0">
+                <a:solidFill>
+                  <a:srgbClr val="4B5563"/>
+                </a:solidFill>
+              </a:defRPr>
+            </a:pPr>
+            <a:r>
+              <a:rPr sz="1125" b="0">
+                <a:solidFill>
+                  <a:srgbClr val="4B5563"/>
+                </a:solidFill>
+              </a:rPr>
+              <a:t>Stages, inputs, outputs, owners, and handoffs.</a:t>
+            </a:r>
+          </a:p>
+        </p:txBody>
+      </p:sp>
+      <p:sp>
+        <p:nvSpPr>
+          <p:cNvPr id="10" name="">
+            <a:extLst xmlns:a="http://schemas.openxmlformats.org/drawingml/2006/main">
+              <a:ext uri="{FF2B5EF4-FFF2-40B4-BE49-F238E27FC236}">
+                <a16:creationId xmlns:a16="http://schemas.microsoft.com/office/drawing/2014/main" id="{D72A2F25-FEFC-497C-A186-D6C63CCEB0FC}"/>
+              </a:ext>
+            </a:extLst>
+          </p:cNvPr>
+          <p:cNvSpPr>
+            <a:spLocks xmlns:a="http://schemas.openxmlformats.org/drawingml/2006/main" noGrp="1"/>
+          </p:cNvSpPr>
+          <p:nvPr/>
+        </p:nvSpPr>
+        <p:spPr>
+          <a:xfrm xmlns:a="http://schemas.openxmlformats.org/drawingml/2006/main">
+            <a:off x="4295775" y="2286000"/>
+            <a:ext cx="3286125" cy="914400"/>
+          </a:xfrm>
+          <a:prstGeom xmlns:a="http://schemas.openxmlformats.org/drawingml/2006/main" prst="rect">
+            <a:avLst/>
+          </a:prstGeom>
+          <a:solidFill xmlns:a="http://schemas.openxmlformats.org/drawingml/2006/main">
+            <a:srgbClr val="FFFFFF"/>
+          </a:solidFill>
+          <a:ln xmlns:a="http://schemas.openxmlformats.org/drawingml/2006/main" w="9525">
+            <a:solidFill>
+              <a:srgbClr val="CBD5E1"/>
+            </a:solidFill>
+            <a:prstDash val="solid"/>
+          </a:ln>
+        </p:spPr>
+      </p:sp>
+      <p:sp>
+        <p:nvSpPr>
+          <p:cNvPr id="11" name="">
+            <a:extLst xmlns:a="http://schemas.openxmlformats.org/drawingml/2006/main">
+              <a:ext uri="{FF2B5EF4-FFF2-40B4-BE49-F238E27FC236}">
+                <a16:creationId xmlns:a16="http://schemas.microsoft.com/office/drawing/2014/main" id="{E6591B10-64B4-4402-A674-DC6A4096464A}"/>
+              </a:ext>
+            </a:extLst>
+          </p:cNvPr>
+          <p:cNvSpPr>
+            <a:spLocks xmlns:a="http://schemas.openxmlformats.org/drawingml/2006/main" noGrp="1"/>
+          </p:cNvSpPr>
+          <p:nvPr/>
+        </p:nvSpPr>
+        <p:spPr>
+          <a:xfrm xmlns:a="http://schemas.openxmlformats.org/drawingml/2006/main">
+            <a:off x="4448175" y="2543175"/>
+            <a:ext cx="323850" cy="323850"/>
+          </a:xfrm>
+          <a:prstGeom xmlns:a="http://schemas.openxmlformats.org/drawingml/2006/main" prst="rect">
+            <a:avLst/>
+          </a:prstGeom>
+          <a:solidFill xmlns:a="http://schemas.openxmlformats.org/drawingml/2006/main">
+            <a:srgbClr val="DC2626"/>
+          </a:solidFill>
+          <a:ln xmlns:a="http://schemas.openxmlformats.org/drawingml/2006/main" w="9525">
+            <a:solidFill>
+              <a:srgbClr val="DC2626"/>
+            </a:solidFill>
+            <a:prstDash val="solid"/>
+          </a:ln>
+        </p:spPr>
+      </p:sp>
+      <p:sp>
+        <p:nvSpPr>
+          <p:cNvPr id="12" name="">
+            <a:extLst xmlns:a="http://schemas.openxmlformats.org/drawingml/2006/main">
+              <a:ext uri="{FF2B5EF4-FFF2-40B4-BE49-F238E27FC236}">
+                <a16:creationId xmlns:a16="http://schemas.microsoft.com/office/drawing/2014/main" id="{B437067D-C9E3-4B8A-8F10-10C5D7153DBE}"/>
+              </a:ext>
+            </a:extLst>
+          </p:cNvPr>
+          <p:cNvSpPr>
+            <a:spLocks xmlns:a="http://schemas.openxmlformats.org/drawingml/2006/main" noGrp="1"/>
+          </p:cNvSpPr>
+          <p:nvPr/>
+        </p:nvSpPr>
+        <p:spPr>
+          <a:xfrm xmlns:a="http://schemas.openxmlformats.org/drawingml/2006/main">
+            <a:off x="4448175" y="2600325"/>
+            <a:ext cx="323850" cy="171450"/>
+          </a:xfrm>
+          <a:prstGeom xmlns:a="http://schemas.openxmlformats.org/drawingml/2006/main" prst="rect">
+            <a:avLst/>
+          </a:prstGeom>
+          <a:noFill xmlns:a="http://schemas.openxmlformats.org/drawingml/2006/main"/>
+          <a:ln xmlns:a="http://schemas.openxmlformats.org/drawingml/2006/main" w="0">
+            <a:noFill/>
+            <a:prstDash val="solid"/>
+          </a:ln>
+        </p:spPr>
+        <p:txBody>
+          <a:bodyPr xmlns:a="http://schemas.openxmlformats.org/drawingml/2006/main"/>
+          <a:lstStyle xmlns:a="http://schemas.openxmlformats.org/drawingml/2006/main"/>
+          <a:p xmlns:a="http://schemas.openxmlformats.org/drawingml/2006/main">
+            <a:pPr algn="ctr">
+              <a:defRPr sz="1275" b="1">
+                <a:solidFill>
+                  <a:srgbClr val="FFFFFF"/>
+                </a:solidFill>
+              </a:defRPr>
+            </a:pPr>
+            <a:r>
+              <a:rPr sz="1275" b="1">
+                <a:solidFill>
+                  <a:srgbClr val="FFFFFF"/>
+                </a:solidFill>
+              </a:rPr>
+              <a:t>2</a:t>
+            </a:r>
+          </a:p>
+        </p:txBody>
+      </p:sp>
+      <p:sp>
+        <p:nvSpPr>
+          <p:cNvPr id="13" name="">
+            <a:extLst xmlns:a="http://schemas.openxmlformats.org/drawingml/2006/main">
+              <a:ext uri="{FF2B5EF4-FFF2-40B4-BE49-F238E27FC236}">
+                <a16:creationId xmlns:a16="http://schemas.microsoft.com/office/drawing/2014/main" id="{EFDDF5B9-F72D-4AA6-8301-B9A35B481DD7}"/>
+              </a:ext>
+            </a:extLst>
+          </p:cNvPr>
+          <p:cNvSpPr>
+            <a:spLocks xmlns:a="http://schemas.openxmlformats.org/drawingml/2006/main" noGrp="1"/>
+          </p:cNvSpPr>
+          <p:nvPr/>
+        </p:nvSpPr>
+        <p:spPr>
+          <a:xfrm xmlns:a="http://schemas.openxmlformats.org/drawingml/2006/main">
+            <a:off x="4924425" y="2438400"/>
+            <a:ext cx="2505075" cy="228600"/>
+          </a:xfrm>
+          <a:prstGeom xmlns:a="http://schemas.openxmlformats.org/drawingml/2006/main" prst="rect">
+            <a:avLst/>
+          </a:prstGeom>
+          <a:noFill xmlns:a="http://schemas.openxmlformats.org/drawingml/2006/main"/>
+          <a:ln xmlns:a="http://schemas.openxmlformats.org/drawingml/2006/main" w="0">
+            <a:noFill/>
+            <a:prstDash val="solid"/>
+          </a:ln>
+        </p:spPr>
+        <p:txBody>
+          <a:bodyPr xmlns:a="http://schemas.openxmlformats.org/drawingml/2006/main"/>
+          <a:lstStyle xmlns:a="http://schemas.openxmlformats.org/drawingml/2006/main"/>
+          <a:p xmlns:a="http://schemas.openxmlformats.org/drawingml/2006/main">
+            <a:pPr algn="l">
+              <a:defRPr sz="1350" b="1">
+                <a:solidFill>
+                  <a:srgbClr val="DC2626"/>
+                </a:solidFill>
+              </a:defRPr>
+            </a:pPr>
+            <a:r>
+              <a:rPr sz="1350" b="1">
+                <a:solidFill>
+                  <a:srgbClr val="DC2626"/>
+                </a:solidFill>
+              </a:rPr>
+              <a:t>Set autonomy and risk</a:t>
+            </a:r>
+          </a:p>
+        </p:txBody>
+      </p:sp>
+      <p:sp>
+        <p:nvSpPr>
+          <p:cNvPr id="14" name="">
+            <a:extLst xmlns:a="http://schemas.openxmlformats.org/drawingml/2006/main">
+              <a:ext uri="{FF2B5EF4-FFF2-40B4-BE49-F238E27FC236}">
+                <a16:creationId xmlns:a16="http://schemas.microsoft.com/office/drawing/2014/main" id="{56B458C1-7C35-4D33-A9F0-BBD0BD0A7148}"/>
+              </a:ext>
+            </a:extLst>
+          </p:cNvPr>
+          <p:cNvSpPr>
+            <a:spLocks xmlns:a="http://schemas.openxmlformats.org/drawingml/2006/main" noGrp="1"/>
+          </p:cNvSpPr>
+          <p:nvPr/>
+        </p:nvSpPr>
+        <p:spPr>
+          <a:xfrm xmlns:a="http://schemas.openxmlformats.org/drawingml/2006/main">
+            <a:off x="4924425" y="2714625"/>
+            <a:ext cx="2505075" cy="400050"/>
+          </a:xfrm>
+          <a:prstGeom xmlns:a="http://schemas.openxmlformats.org/drawingml/2006/main" prst="rect">
+            <a:avLst/>
+          </a:prstGeom>
+          <a:noFill xmlns:a="http://schemas.openxmlformats.org/drawingml/2006/main"/>
+          <a:ln xmlns:a="http://schemas.openxmlformats.org/drawingml/2006/main" w="0">
+            <a:noFill/>
+            <a:prstDash val="solid"/>
+          </a:ln>
+        </p:spPr>
+        <p:txBody>
+          <a:bodyPr xmlns:a="http://schemas.openxmlformats.org/drawingml/2006/main"/>
+          <a:lstStyle xmlns:a="http://schemas.openxmlformats.org/drawingml/2006/main"/>
+          <a:p xmlns:a="http://schemas.openxmlformats.org/drawingml/2006/main">
+            <a:pPr algn="l">
+              <a:defRPr sz="1125" b="0">
+                <a:solidFill>
+                  <a:srgbClr val="4B5563"/>
+                </a:solidFill>
+              </a:defRPr>
+            </a:pPr>
+            <a:r>
+              <a:rPr sz="1125" b="0">
+                <a:solidFill>
+                  <a:srgbClr val="4B5563"/>
+                </a:solidFill>
+              </a:rPr>
+              <a:t>Criticality, budget, latency, permissions, and stop conditions.</a:t>
+            </a:r>
+          </a:p>
+        </p:txBody>
+      </p:sp>
+      <p:sp>
+        <p:nvSpPr>
+          <p:cNvPr id="15" name="">
+            <a:extLst xmlns:a="http://schemas.openxmlformats.org/drawingml/2006/main">
+              <a:ext uri="{FF2B5EF4-FFF2-40B4-BE49-F238E27FC236}">
+                <a16:creationId xmlns:a16="http://schemas.microsoft.com/office/drawing/2014/main" id="{D3E782C8-023C-4653-A070-B1FD12B78310}"/>
+              </a:ext>
+            </a:extLst>
+          </p:cNvPr>
+          <p:cNvSpPr>
+            <a:spLocks xmlns:a="http://schemas.openxmlformats.org/drawingml/2006/main" noGrp="1"/>
+          </p:cNvSpPr>
+          <p:nvPr/>
+        </p:nvSpPr>
+        <p:spPr>
+          <a:xfrm xmlns:a="http://schemas.openxmlformats.org/drawingml/2006/main">
+            <a:off x="7905750" y="2286000"/>
+            <a:ext cx="3286125" cy="914400"/>
+          </a:xfrm>
+          <a:prstGeom xmlns:a="http://schemas.openxmlformats.org/drawingml/2006/main" prst="rect">
+            <a:avLst/>
+          </a:prstGeom>
+          <a:solidFill xmlns:a="http://schemas.openxmlformats.org/drawingml/2006/main">
+            <a:srgbClr val="FFFFFF"/>
+          </a:solidFill>
+          <a:ln xmlns:a="http://schemas.openxmlformats.org/drawingml/2006/main" w="9525">
+            <a:solidFill>
+              <a:srgbClr val="CBD5E1"/>
+            </a:solidFill>
+            <a:prstDash val="solid"/>
+          </a:ln>
+        </p:spPr>
+      </p:sp>
+      <p:sp>
+        <p:nvSpPr>
+          <p:cNvPr id="16" name="">
+            <a:extLst xmlns:a="http://schemas.openxmlformats.org/drawingml/2006/main">
+              <a:ext uri="{FF2B5EF4-FFF2-40B4-BE49-F238E27FC236}">
+                <a16:creationId xmlns:a16="http://schemas.microsoft.com/office/drawing/2014/main" id="{61C030BF-5E1F-43DA-A46B-ED69A1DC514D}"/>
+              </a:ext>
+            </a:extLst>
+          </p:cNvPr>
+          <p:cNvSpPr>
+            <a:spLocks xmlns:a="http://schemas.openxmlformats.org/drawingml/2006/main" noGrp="1"/>
+          </p:cNvSpPr>
+          <p:nvPr/>
+        </p:nvSpPr>
+        <p:spPr>
+          <a:xfrm xmlns:a="http://schemas.openxmlformats.org/drawingml/2006/main">
+            <a:off x="8058150" y="2543175"/>
+            <a:ext cx="323850" cy="323850"/>
+          </a:xfrm>
+          <a:prstGeom xmlns:a="http://schemas.openxmlformats.org/drawingml/2006/main" prst="rect">
+            <a:avLst/>
+          </a:prstGeom>
+          <a:solidFill xmlns:a="http://schemas.openxmlformats.org/drawingml/2006/main">
+            <a:srgbClr val="0891B2"/>
+          </a:solidFill>
+          <a:ln xmlns:a="http://schemas.openxmlformats.org/drawingml/2006/main" w="9525">
+            <a:solidFill>
+              <a:srgbClr val="0891B2"/>
+            </a:solidFill>
+            <a:prstDash val="solid"/>
+          </a:ln>
+        </p:spPr>
+      </p:sp>
+      <p:sp>
+        <p:nvSpPr>
+          <p:cNvPr id="17" name="">
+            <a:extLst xmlns:a="http://schemas.openxmlformats.org/drawingml/2006/main">
+              <a:ext uri="{FF2B5EF4-FFF2-40B4-BE49-F238E27FC236}">
+                <a16:creationId xmlns:a16="http://schemas.microsoft.com/office/drawing/2014/main" id="{C14FC45A-AB83-4F6F-BCF4-83F967F53592}"/>
+              </a:ext>
+            </a:extLst>
+          </p:cNvPr>
+          <p:cNvSpPr>
+            <a:spLocks xmlns:a="http://schemas.openxmlformats.org/drawingml/2006/main" noGrp="1"/>
+          </p:cNvSpPr>
+          <p:nvPr/>
+        </p:nvSpPr>
+        <p:spPr>
+          <a:xfrm xmlns:a="http://schemas.openxmlformats.org/drawingml/2006/main">
+            <a:off x="8058150" y="2600325"/>
+            <a:ext cx="323850" cy="171450"/>
+          </a:xfrm>
+          <a:prstGeom xmlns:a="http://schemas.openxmlformats.org/drawingml/2006/main" prst="rect">
+            <a:avLst/>
+          </a:prstGeom>
+          <a:noFill xmlns:a="http://schemas.openxmlformats.org/drawingml/2006/main"/>
+          <a:ln xmlns:a="http://schemas.openxmlformats.org/drawingml/2006/main" w="0">
+            <a:noFill/>
+            <a:prstDash val="solid"/>
+          </a:ln>
+        </p:spPr>
+        <p:txBody>
+          <a:bodyPr xmlns:a="http://schemas.openxmlformats.org/drawingml/2006/main"/>
+          <a:lstStyle xmlns:a="http://schemas.openxmlformats.org/drawingml/2006/main"/>
+          <a:p xmlns:a="http://schemas.openxmlformats.org/drawingml/2006/main">
+            <a:pPr algn="ctr">
+              <a:defRPr sz="1275" b="1">
+                <a:solidFill>
+                  <a:srgbClr val="FFFFFF"/>
+                </a:solidFill>
+              </a:defRPr>
+            </a:pPr>
+            <a:r>
+              <a:rPr sz="1275" b="1">
+                <a:solidFill>
+                  <a:srgbClr val="FFFFFF"/>
+                </a:solidFill>
+              </a:rPr>
+              <a:t>3</a:t>
+            </a:r>
+          </a:p>
+        </p:txBody>
+      </p:sp>
+      <p:sp>
+        <p:nvSpPr>
+          <p:cNvPr id="18" name="">
+            <a:extLst xmlns:a="http://schemas.openxmlformats.org/drawingml/2006/main">
+              <a:ext uri="{FF2B5EF4-FFF2-40B4-BE49-F238E27FC236}">
+                <a16:creationId xmlns:a16="http://schemas.microsoft.com/office/drawing/2014/main" id="{6C99D0DF-8581-4F3C-B449-44ECF3D6782F}"/>
+              </a:ext>
+            </a:extLst>
+          </p:cNvPr>
+          <p:cNvSpPr>
+            <a:spLocks xmlns:a="http://schemas.openxmlformats.org/drawingml/2006/main" noGrp="1"/>
+          </p:cNvSpPr>
+          <p:nvPr/>
+        </p:nvSpPr>
+        <p:spPr>
+          <a:xfrm xmlns:a="http://schemas.openxmlformats.org/drawingml/2006/main">
+            <a:off x="8534400" y="2438400"/>
+            <a:ext cx="2505075" cy="228600"/>
+          </a:xfrm>
+          <a:prstGeom xmlns:a="http://schemas.openxmlformats.org/drawingml/2006/main" prst="rect">
+            <a:avLst/>
+          </a:prstGeom>
+          <a:noFill xmlns:a="http://schemas.openxmlformats.org/drawingml/2006/main"/>
+          <a:ln xmlns:a="http://schemas.openxmlformats.org/drawingml/2006/main" w="0">
+            <a:noFill/>
+            <a:prstDash val="solid"/>
+          </a:ln>
+        </p:spPr>
+        <p:txBody>
+          <a:bodyPr xmlns:a="http://schemas.openxmlformats.org/drawingml/2006/main"/>
+          <a:lstStyle xmlns:a="http://schemas.openxmlformats.org/drawingml/2006/main"/>
+          <a:p xmlns:a="http://schemas.openxmlformats.org/drawingml/2006/main">
+            <a:pPr algn="l">
+              <a:defRPr sz="1350" b="1">
+                <a:solidFill>
+                  <a:srgbClr val="0891B2"/>
+                </a:solidFill>
+              </a:defRPr>
+            </a:pPr>
+            <a:r>
+              <a:rPr sz="1350" b="1">
+                <a:solidFill>
+                  <a:srgbClr val="0891B2"/>
+                </a:solidFill>
+              </a:rPr>
+              <a:t>Choose the pattern</a:t>
+            </a:r>
+          </a:p>
+        </p:txBody>
+      </p:sp>
+      <p:sp>
+        <p:nvSpPr>
+          <p:cNvPr id="19" name="">
+            <a:extLst xmlns:a="http://schemas.openxmlformats.org/drawingml/2006/main">
+              <a:ext uri="{FF2B5EF4-FFF2-40B4-BE49-F238E27FC236}">
+                <a16:creationId xmlns:a16="http://schemas.microsoft.com/office/drawing/2014/main" id="{84E28F20-DAA4-400D-A6CA-93012DB899E6}"/>
+              </a:ext>
+            </a:extLst>
+          </p:cNvPr>
+          <p:cNvSpPr>
+            <a:spLocks xmlns:a="http://schemas.openxmlformats.org/drawingml/2006/main" noGrp="1"/>
+          </p:cNvSpPr>
+          <p:nvPr/>
+        </p:nvSpPr>
+        <p:spPr>
+          <a:xfrm xmlns:a="http://schemas.openxmlformats.org/drawingml/2006/main">
+            <a:off x="8534400" y="2714625"/>
+            <a:ext cx="2505075" cy="400050"/>
+          </a:xfrm>
+          <a:prstGeom xmlns:a="http://schemas.openxmlformats.org/drawingml/2006/main" prst="rect">
+            <a:avLst/>
+          </a:prstGeom>
+          <a:noFill xmlns:a="http://schemas.openxmlformats.org/drawingml/2006/main"/>
+          <a:ln xmlns:a="http://schemas.openxmlformats.org/drawingml/2006/main" w="0">
+            <a:noFill/>
+            <a:prstDash val="solid"/>
+          </a:ln>
+        </p:spPr>
+        <p:txBody>
+          <a:bodyPr xmlns:a="http://schemas.openxmlformats.org/drawingml/2006/main"/>
+          <a:lstStyle xmlns:a="http://schemas.openxmlformats.org/drawingml/2006/main"/>
+          <a:p xmlns:a="http://schemas.openxmlformats.org/drawingml/2006/main">
+            <a:pPr algn="l">
+              <a:defRPr sz="1125" b="0">
+                <a:solidFill>
+                  <a:srgbClr val="4B5563"/>
+                </a:solidFill>
+              </a:defRPr>
+            </a:pPr>
+            <a:r>
+              <a:rPr sz="1125" b="0">
+                <a:solidFill>
+                  <a:srgbClr val="4B5563"/>
+                </a:solidFill>
+              </a:rPr>
+              <a:t>Augmented LLM first; graph or swarm only when needed.</a:t>
+            </a:r>
+          </a:p>
+        </p:txBody>
+      </p:sp>
+      <p:sp>
+        <p:nvSpPr>
+          <p:cNvPr id="20" name="">
+            <a:extLst xmlns:a="http://schemas.openxmlformats.org/drawingml/2006/main">
+              <a:ext uri="{FF2B5EF4-FFF2-40B4-BE49-F238E27FC236}">
+                <a16:creationId xmlns:a16="http://schemas.microsoft.com/office/drawing/2014/main" id="{CC4B6148-21EE-42F4-B554-958EC5A3E9B6}"/>
+              </a:ext>
+            </a:extLst>
+          </p:cNvPr>
+          <p:cNvSpPr>
+            <a:spLocks xmlns:a="http://schemas.openxmlformats.org/drawingml/2006/main" noGrp="1"/>
+          </p:cNvSpPr>
+          <p:nvPr/>
+        </p:nvSpPr>
+        <p:spPr>
+          <a:xfrm xmlns:a="http://schemas.openxmlformats.org/drawingml/2006/main">
+            <a:off x="685800" y="3352800"/>
+            <a:ext cx="3286125" cy="914400"/>
+          </a:xfrm>
+          <a:prstGeom xmlns:a="http://schemas.openxmlformats.org/drawingml/2006/main" prst="rect">
+            <a:avLst/>
+          </a:prstGeom>
+          <a:solidFill xmlns:a="http://schemas.openxmlformats.org/drawingml/2006/main">
+            <a:srgbClr val="FFFFFF"/>
+          </a:solidFill>
+          <a:ln xmlns:a="http://schemas.openxmlformats.org/drawingml/2006/main" w="9525">
+            <a:solidFill>
+              <a:srgbClr val="CBD5E1"/>
+            </a:solidFill>
+            <a:prstDash val="solid"/>
+          </a:ln>
+        </p:spPr>
+      </p:sp>
+      <p:sp>
+        <p:nvSpPr>
+          <p:cNvPr id="21" name="">
+            <a:extLst xmlns:a="http://schemas.openxmlformats.org/drawingml/2006/main">
+              <a:ext uri="{FF2B5EF4-FFF2-40B4-BE49-F238E27FC236}">
+                <a16:creationId xmlns:a16="http://schemas.microsoft.com/office/drawing/2014/main" id="{B44F0AAE-366E-4607-A06C-2967750EFFD1}"/>
+              </a:ext>
+            </a:extLst>
+          </p:cNvPr>
+          <p:cNvSpPr>
+            <a:spLocks xmlns:a="http://schemas.openxmlformats.org/drawingml/2006/main" noGrp="1"/>
+          </p:cNvSpPr>
+          <p:nvPr/>
+        </p:nvSpPr>
+        <p:spPr>
+          <a:xfrm xmlns:a="http://schemas.openxmlformats.org/drawingml/2006/main">
+            <a:off x="838200" y="3609975"/>
+            <a:ext cx="323850" cy="323850"/>
+          </a:xfrm>
+          <a:prstGeom xmlns:a="http://schemas.openxmlformats.org/drawingml/2006/main" prst="rect">
+            <a:avLst/>
+          </a:prstGeom>
+          <a:solidFill xmlns:a="http://schemas.openxmlformats.org/drawingml/2006/main">
+            <a:srgbClr val="D97706"/>
+          </a:solidFill>
+          <a:ln xmlns:a="http://schemas.openxmlformats.org/drawingml/2006/main" w="9525">
+            <a:solidFill>
+              <a:srgbClr val="D97706"/>
+            </a:solidFill>
+            <a:prstDash val="solid"/>
+          </a:ln>
+        </p:spPr>
+      </p:sp>
+      <p:sp>
+        <p:nvSpPr>
+          <p:cNvPr id="22" name="">
+            <a:extLst xmlns:a="http://schemas.openxmlformats.org/drawingml/2006/main">
+              <a:ext uri="{FF2B5EF4-FFF2-40B4-BE49-F238E27FC236}">
+                <a16:creationId xmlns:a16="http://schemas.microsoft.com/office/drawing/2014/main" id="{28B40F68-48FC-43EE-BB82-F4FE9BF08841}"/>
+              </a:ext>
+            </a:extLst>
+          </p:cNvPr>
+          <p:cNvSpPr>
+            <a:spLocks xmlns:a="http://schemas.openxmlformats.org/drawingml/2006/main" noGrp="1"/>
+          </p:cNvSpPr>
+          <p:nvPr/>
+        </p:nvSpPr>
+        <p:spPr>
+          <a:xfrm xmlns:a="http://schemas.openxmlformats.org/drawingml/2006/main">
+            <a:off x="838200" y="3667125"/>
+            <a:ext cx="323850" cy="171450"/>
+          </a:xfrm>
+          <a:prstGeom xmlns:a="http://schemas.openxmlformats.org/drawingml/2006/main" prst="rect">
+            <a:avLst/>
+          </a:prstGeom>
+          <a:noFill xmlns:a="http://schemas.openxmlformats.org/drawingml/2006/main"/>
+          <a:ln xmlns:a="http://schemas.openxmlformats.org/drawingml/2006/main" w="0">
+            <a:noFill/>
+            <a:prstDash val="solid"/>
+          </a:ln>
+        </p:spPr>
+        <p:txBody>
+          <a:bodyPr xmlns:a="http://schemas.openxmlformats.org/drawingml/2006/main"/>
+          <a:lstStyle xmlns:a="http://schemas.openxmlformats.org/drawingml/2006/main"/>
+          <a:p xmlns:a="http://schemas.openxmlformats.org/drawingml/2006/main">
+            <a:pPr algn="ctr">
+              <a:defRPr sz="1275" b="1">
+                <a:solidFill>
+                  <a:srgbClr val="FFFFFF"/>
+                </a:solidFill>
+              </a:defRPr>
+            </a:pPr>
+            <a:r>
+              <a:rPr sz="1275" b="1">
+                <a:solidFill>
+                  <a:srgbClr val="FFFFFF"/>
+                </a:solidFill>
+              </a:rPr>
+              <a:t>4</a:t>
+            </a:r>
+          </a:p>
+        </p:txBody>
+      </p:sp>
+      <p:sp>
+        <p:nvSpPr>
+          <p:cNvPr id="23" name="">
+            <a:extLst xmlns:a="http://schemas.openxmlformats.org/drawingml/2006/main">
+              <a:ext uri="{FF2B5EF4-FFF2-40B4-BE49-F238E27FC236}">
+                <a16:creationId xmlns:a16="http://schemas.microsoft.com/office/drawing/2014/main" id="{E8063533-08D6-40EA-B41B-66CB444B9D4F}"/>
+              </a:ext>
+            </a:extLst>
+          </p:cNvPr>
+          <p:cNvSpPr>
+            <a:spLocks xmlns:a="http://schemas.openxmlformats.org/drawingml/2006/main" noGrp="1"/>
+          </p:cNvSpPr>
+          <p:nvPr/>
+        </p:nvSpPr>
+        <p:spPr>
+          <a:xfrm xmlns:a="http://schemas.openxmlformats.org/drawingml/2006/main">
+            <a:off x="1314450" y="3505200"/>
+            <a:ext cx="2505075" cy="228600"/>
+          </a:xfrm>
+          <a:prstGeom xmlns:a="http://schemas.openxmlformats.org/drawingml/2006/main" prst="rect">
+            <a:avLst/>
+          </a:prstGeom>
+          <a:noFill xmlns:a="http://schemas.openxmlformats.org/drawingml/2006/main"/>
+          <a:ln xmlns:a="http://schemas.openxmlformats.org/drawingml/2006/main" w="0">
+            <a:noFill/>
+            <a:prstDash val="solid"/>
+          </a:ln>
+        </p:spPr>
+        <p:txBody>
+          <a:bodyPr xmlns:a="http://schemas.openxmlformats.org/drawingml/2006/main"/>
+          <a:lstStyle xmlns:a="http://schemas.openxmlformats.org/drawingml/2006/main"/>
+          <a:p xmlns:a="http://schemas.openxmlformats.org/drawingml/2006/main">
+            <a:pPr algn="l">
+              <a:defRPr sz="1350" b="1">
+                <a:solidFill>
+                  <a:srgbClr val="D97706"/>
+                </a:solidFill>
+              </a:defRPr>
+            </a:pPr>
+            <a:r>
+              <a:rPr sz="1350" b="1">
+                <a:solidFill>
+                  <a:srgbClr val="D97706"/>
+                </a:solidFill>
+              </a:rPr>
+              <a:t>Mark critical stages</a:t>
+            </a:r>
+          </a:p>
+        </p:txBody>
+      </p:sp>
+      <p:sp>
+        <p:nvSpPr>
+          <p:cNvPr id="24" name="">
+            <a:extLst xmlns:a="http://schemas.openxmlformats.org/drawingml/2006/main">
+              <a:ext uri="{FF2B5EF4-FFF2-40B4-BE49-F238E27FC236}">
+                <a16:creationId xmlns:a16="http://schemas.microsoft.com/office/drawing/2014/main" id="{A3448C30-8F59-4313-A273-8A1BA7429937}"/>
+              </a:ext>
+            </a:extLst>
+          </p:cNvPr>
+          <p:cNvSpPr>
+            <a:spLocks xmlns:a="http://schemas.openxmlformats.org/drawingml/2006/main" noGrp="1"/>
+          </p:cNvSpPr>
+          <p:nvPr/>
+        </p:nvSpPr>
+        <p:spPr>
+          <a:xfrm xmlns:a="http://schemas.openxmlformats.org/drawingml/2006/main">
+            <a:off x="1314450" y="3781425"/>
+            <a:ext cx="2505075" cy="400050"/>
+          </a:xfrm>
+          <a:prstGeom xmlns:a="http://schemas.openxmlformats.org/drawingml/2006/main" prst="rect">
+            <a:avLst/>
+          </a:prstGeom>
+          <a:noFill xmlns:a="http://schemas.openxmlformats.org/drawingml/2006/main"/>
+          <a:ln xmlns:a="http://schemas.openxmlformats.org/drawingml/2006/main" w="0">
+            <a:noFill/>
+            <a:prstDash val="solid"/>
+          </a:ln>
+        </p:spPr>
+        <p:txBody>
+          <a:bodyPr xmlns:a="http://schemas.openxmlformats.org/drawingml/2006/main"/>
+          <a:lstStyle xmlns:a="http://schemas.openxmlformats.org/drawingml/2006/main"/>
+          <a:p xmlns:a="http://schemas.openxmlformats.org/drawingml/2006/main">
+            <a:pPr algn="l">
+              <a:defRPr sz="1125" b="0">
+                <a:solidFill>
+                  <a:srgbClr val="4B5563"/>
+                </a:solidFill>
+              </a:defRPr>
+            </a:pPr>
+            <a:r>
+              <a:rPr sz="1125" b="0">
+                <a:solidFill>
+                  <a:srgbClr val="4B5563"/>
+                </a:solidFill>
+              </a:rPr>
+              <a:t>Decisions, writes, external actions, and irreversible steps.</a:t>
+            </a:r>
+          </a:p>
+        </p:txBody>
+      </p:sp>
+      <p:sp>
+        <p:nvSpPr>
+          <p:cNvPr id="25" name="">
+            <a:extLst xmlns:a="http://schemas.openxmlformats.org/drawingml/2006/main">
+              <a:ext uri="{FF2B5EF4-FFF2-40B4-BE49-F238E27FC236}">
+                <a16:creationId xmlns:a16="http://schemas.microsoft.com/office/drawing/2014/main" id="{99644943-95EB-43DE-800C-9100CB69BCBD}"/>
+              </a:ext>
+            </a:extLst>
+          </p:cNvPr>
+          <p:cNvSpPr>
+            <a:spLocks xmlns:a="http://schemas.openxmlformats.org/drawingml/2006/main" noGrp="1"/>
+          </p:cNvSpPr>
+          <p:nvPr/>
+        </p:nvSpPr>
+        <p:spPr>
+          <a:xfrm xmlns:a="http://schemas.openxmlformats.org/drawingml/2006/main">
+            <a:off x="4295775" y="3352800"/>
+            <a:ext cx="3286125" cy="914400"/>
+          </a:xfrm>
+          <a:prstGeom xmlns:a="http://schemas.openxmlformats.org/drawingml/2006/main" prst="rect">
+            <a:avLst/>
+          </a:prstGeom>
+          <a:solidFill xmlns:a="http://schemas.openxmlformats.org/drawingml/2006/main">
+            <a:srgbClr val="FFFFFF"/>
+          </a:solidFill>
+          <a:ln xmlns:a="http://schemas.openxmlformats.org/drawingml/2006/main" w="9525">
+            <a:solidFill>
+              <a:srgbClr val="CBD5E1"/>
+            </a:solidFill>
+            <a:prstDash val="solid"/>
+          </a:ln>
+        </p:spPr>
+      </p:sp>
+      <p:sp>
+        <p:nvSpPr>
+          <p:cNvPr id="26" name="">
+            <a:extLst xmlns:a="http://schemas.openxmlformats.org/drawingml/2006/main">
+              <a:ext uri="{FF2B5EF4-FFF2-40B4-BE49-F238E27FC236}">
+                <a16:creationId xmlns:a16="http://schemas.microsoft.com/office/drawing/2014/main" id="{125E3CF1-F43D-42DB-A871-FB442DC7D5C9}"/>
+              </a:ext>
+            </a:extLst>
+          </p:cNvPr>
+          <p:cNvSpPr>
+            <a:spLocks xmlns:a="http://schemas.openxmlformats.org/drawingml/2006/main" noGrp="1"/>
+          </p:cNvSpPr>
+          <p:nvPr/>
+        </p:nvSpPr>
+        <p:spPr>
+          <a:xfrm xmlns:a="http://schemas.openxmlformats.org/drawingml/2006/main">
+            <a:off x="4448175" y="3609975"/>
+            <a:ext cx="323850" cy="323850"/>
+          </a:xfrm>
+          <a:prstGeom xmlns:a="http://schemas.openxmlformats.org/drawingml/2006/main" prst="rect">
+            <a:avLst/>
+          </a:prstGeom>
+          <a:solidFill xmlns:a="http://schemas.openxmlformats.org/drawingml/2006/main">
+            <a:srgbClr val="059669"/>
+          </a:solidFill>
+          <a:ln xmlns:a="http://schemas.openxmlformats.org/drawingml/2006/main" w="9525">
+            <a:solidFill>
+              <a:srgbClr val="059669"/>
+            </a:solidFill>
+            <a:prstDash val="solid"/>
+          </a:ln>
+        </p:spPr>
+      </p:sp>
+      <p:sp>
+        <p:nvSpPr>
+          <p:cNvPr id="27" name="">
+            <a:extLst xmlns:a="http://schemas.openxmlformats.org/drawingml/2006/main">
+              <a:ext uri="{FF2B5EF4-FFF2-40B4-BE49-F238E27FC236}">
+                <a16:creationId xmlns:a16="http://schemas.microsoft.com/office/drawing/2014/main" id="{69091EED-4083-4002-B864-38B929D077F9}"/>
+              </a:ext>
+            </a:extLst>
+          </p:cNvPr>
+          <p:cNvSpPr>
+            <a:spLocks xmlns:a="http://schemas.openxmlformats.org/drawingml/2006/main" noGrp="1"/>
+          </p:cNvSpPr>
+          <p:nvPr/>
+        </p:nvSpPr>
+        <p:spPr>
+          <a:xfrm xmlns:a="http://schemas.openxmlformats.org/drawingml/2006/main">
+            <a:off x="4448175" y="3667125"/>
+            <a:ext cx="323850" cy="171450"/>
+          </a:xfrm>
+          <a:prstGeom xmlns:a="http://schemas.openxmlformats.org/drawingml/2006/main" prst="rect">
+            <a:avLst/>
+          </a:prstGeom>
+          <a:noFill xmlns:a="http://schemas.openxmlformats.org/drawingml/2006/main"/>
+          <a:ln xmlns:a="http://schemas.openxmlformats.org/drawingml/2006/main" w="0">
+            <a:noFill/>
+            <a:prstDash val="solid"/>
+          </a:ln>
+        </p:spPr>
+        <p:txBody>
+          <a:bodyPr xmlns:a="http://schemas.openxmlformats.org/drawingml/2006/main"/>
+          <a:lstStyle xmlns:a="http://schemas.openxmlformats.org/drawingml/2006/main"/>
+          <a:p xmlns:a="http://schemas.openxmlformats.org/drawingml/2006/main">
+            <a:pPr algn="ctr">
+              <a:defRPr sz="1275" b="1">
+                <a:solidFill>
+                  <a:srgbClr val="FFFFFF"/>
+                </a:solidFill>
+              </a:defRPr>
+            </a:pPr>
+            <a:r>
+              <a:rPr sz="1275" b="1">
+                <a:solidFill>
+                  <a:srgbClr val="FFFFFF"/>
+                </a:solidFill>
+              </a:rPr>
+              <a:t>5</a:t>
+            </a:r>
+          </a:p>
+        </p:txBody>
+      </p:sp>
+      <p:sp>
+        <p:nvSpPr>
+          <p:cNvPr id="28" name="">
+            <a:extLst xmlns:a="http://schemas.openxmlformats.org/drawingml/2006/main">
+              <a:ext uri="{FF2B5EF4-FFF2-40B4-BE49-F238E27FC236}">
+                <a16:creationId xmlns:a16="http://schemas.microsoft.com/office/drawing/2014/main" id="{AD96E4E3-43E6-45F4-BD2F-29DC88A51D0A}"/>
+              </a:ext>
+            </a:extLst>
+          </p:cNvPr>
+          <p:cNvSpPr>
+            <a:spLocks xmlns:a="http://schemas.openxmlformats.org/drawingml/2006/main" noGrp="1"/>
+          </p:cNvSpPr>
+          <p:nvPr/>
+        </p:nvSpPr>
+        <p:spPr>
+          <a:xfrm xmlns:a="http://schemas.openxmlformats.org/drawingml/2006/main">
+            <a:off x="4924425" y="3505200"/>
+            <a:ext cx="2505075" cy="228600"/>
+          </a:xfrm>
+          <a:prstGeom xmlns:a="http://schemas.openxmlformats.org/drawingml/2006/main" prst="rect">
+            <a:avLst/>
+          </a:prstGeom>
+          <a:noFill xmlns:a="http://schemas.openxmlformats.org/drawingml/2006/main"/>
+          <a:ln xmlns:a="http://schemas.openxmlformats.org/drawingml/2006/main" w="0">
+            <a:noFill/>
+            <a:prstDash val="solid"/>
+          </a:ln>
+        </p:spPr>
+        <p:txBody>
+          <a:bodyPr xmlns:a="http://schemas.openxmlformats.org/drawingml/2006/main"/>
+          <a:lstStyle xmlns:a="http://schemas.openxmlformats.org/drawingml/2006/main"/>
+          <a:p xmlns:a="http://schemas.openxmlformats.org/drawingml/2006/main">
+            <a:pPr algn="l">
+              <a:defRPr sz="1350" b="1">
+                <a:solidFill>
+                  <a:srgbClr val="059669"/>
+                </a:solidFill>
+              </a:defRPr>
+            </a:pPr>
+            <a:r>
+              <a:rPr sz="1350" b="1">
+                <a:solidFill>
+                  <a:srgbClr val="059669"/>
+                </a:solidFill>
+              </a:rPr>
+              <a:t>Install guardrails</a:t>
+            </a:r>
+          </a:p>
+        </p:txBody>
+      </p:sp>
+      <p:sp>
+        <p:nvSpPr>
+          <p:cNvPr id="29" name="">
+            <a:extLst xmlns:a="http://schemas.openxmlformats.org/drawingml/2006/main">
+              <a:ext uri="{FF2B5EF4-FFF2-40B4-BE49-F238E27FC236}">
+                <a16:creationId xmlns:a16="http://schemas.microsoft.com/office/drawing/2014/main" id="{A3BD3C77-EAB3-4EC4-B58D-8B0397FBB330}"/>
+              </a:ext>
+            </a:extLst>
+          </p:cNvPr>
+          <p:cNvSpPr>
+            <a:spLocks xmlns:a="http://schemas.openxmlformats.org/drawingml/2006/main" noGrp="1"/>
+          </p:cNvSpPr>
+          <p:nvPr/>
+        </p:nvSpPr>
+        <p:spPr>
+          <a:xfrm xmlns:a="http://schemas.openxmlformats.org/drawingml/2006/main">
+            <a:off x="4924425" y="3781425"/>
+            <a:ext cx="2505075" cy="400050"/>
+          </a:xfrm>
+          <a:prstGeom xmlns:a="http://schemas.openxmlformats.org/drawingml/2006/main" prst="rect">
+            <a:avLst/>
+          </a:prstGeom>
+          <a:noFill xmlns:a="http://schemas.openxmlformats.org/drawingml/2006/main"/>
+          <a:ln xmlns:a="http://schemas.openxmlformats.org/drawingml/2006/main" w="0">
+            <a:noFill/>
+            <a:prstDash val="solid"/>
+          </a:ln>
+        </p:spPr>
+        <p:txBody>
+          <a:bodyPr xmlns:a="http://schemas.openxmlformats.org/drawingml/2006/main"/>
+          <a:lstStyle xmlns:a="http://schemas.openxmlformats.org/drawingml/2006/main"/>
+          <a:p xmlns:a="http://schemas.openxmlformats.org/drawingml/2006/main">
+            <a:pPr algn="l">
+              <a:defRPr sz="1125" b="0">
+                <a:solidFill>
+                  <a:srgbClr val="4B5563"/>
+                </a:solidFill>
+              </a:defRPr>
+            </a:pPr>
+            <a:r>
+              <a:rPr sz="1125" b="0">
+                <a:solidFill>
+                  <a:srgbClr val="4B5563"/>
+                </a:solidFill>
+              </a:rPr>
+              <a:t>Steering, hooks, policy checks, and HITL for high-risk steps.</a:t>
+            </a:r>
+          </a:p>
+        </p:txBody>
+      </p:sp>
+      <p:sp>
+        <p:nvSpPr>
+          <p:cNvPr id="30" name="">
+            <a:extLst xmlns:a="http://schemas.openxmlformats.org/drawingml/2006/main">
+              <a:ext uri="{FF2B5EF4-FFF2-40B4-BE49-F238E27FC236}">
+                <a16:creationId xmlns:a16="http://schemas.microsoft.com/office/drawing/2014/main" id="{5C5FD469-07FB-4B63-B345-31F4287ED188}"/>
+              </a:ext>
+            </a:extLst>
+          </p:cNvPr>
+          <p:cNvSpPr>
+            <a:spLocks xmlns:a="http://schemas.openxmlformats.org/drawingml/2006/main" noGrp="1"/>
+          </p:cNvSpPr>
+          <p:nvPr/>
+        </p:nvSpPr>
+        <p:spPr>
+          <a:xfrm xmlns:a="http://schemas.openxmlformats.org/drawingml/2006/main">
+            <a:off x="7905750" y="3352800"/>
+            <a:ext cx="3286125" cy="914400"/>
+          </a:xfrm>
+          <a:prstGeom xmlns:a="http://schemas.openxmlformats.org/drawingml/2006/main" prst="rect">
+            <a:avLst/>
+          </a:prstGeom>
+          <a:solidFill xmlns:a="http://schemas.openxmlformats.org/drawingml/2006/main">
+            <a:srgbClr val="FFFFFF"/>
+          </a:solidFill>
+          <a:ln xmlns:a="http://schemas.openxmlformats.org/drawingml/2006/main" w="9525">
+            <a:solidFill>
+              <a:srgbClr val="CBD5E1"/>
+            </a:solidFill>
+            <a:prstDash val="solid"/>
+          </a:ln>
+        </p:spPr>
+      </p:sp>
+      <p:sp>
+        <p:nvSpPr>
+          <p:cNvPr id="31" name="">
+            <a:extLst xmlns:a="http://schemas.openxmlformats.org/drawingml/2006/main">
+              <a:ext uri="{FF2B5EF4-FFF2-40B4-BE49-F238E27FC236}">
+                <a16:creationId xmlns:a16="http://schemas.microsoft.com/office/drawing/2014/main" id="{F14F48C4-CFE2-4AB4-BCAE-8F4EEC8810B0}"/>
+              </a:ext>
+            </a:extLst>
+          </p:cNvPr>
+          <p:cNvSpPr>
+            <a:spLocks xmlns:a="http://schemas.openxmlformats.org/drawingml/2006/main" noGrp="1"/>
+          </p:cNvSpPr>
+          <p:nvPr/>
+        </p:nvSpPr>
+        <p:spPr>
+          <a:xfrm xmlns:a="http://schemas.openxmlformats.org/drawingml/2006/main">
+            <a:off x="8058150" y="3609975"/>
+            <a:ext cx="323850" cy="323850"/>
+          </a:xfrm>
+          <a:prstGeom xmlns:a="http://schemas.openxmlformats.org/drawingml/2006/main" prst="rect">
+            <a:avLst/>
+          </a:prstGeom>
+          <a:solidFill xmlns:a="http://schemas.openxmlformats.org/drawingml/2006/main">
+            <a:srgbClr val="2563EB"/>
+          </a:solidFill>
+          <a:ln xmlns:a="http://schemas.openxmlformats.org/drawingml/2006/main" w="9525">
+            <a:solidFill>
+              <a:srgbClr val="2563EB"/>
+            </a:solidFill>
+            <a:prstDash val="solid"/>
+          </a:ln>
+        </p:spPr>
+      </p:sp>
+      <p:sp>
+        <p:nvSpPr>
+          <p:cNvPr id="32" name="">
+            <a:extLst xmlns:a="http://schemas.openxmlformats.org/drawingml/2006/main">
+              <a:ext uri="{FF2B5EF4-FFF2-40B4-BE49-F238E27FC236}">
+                <a16:creationId xmlns:a16="http://schemas.microsoft.com/office/drawing/2014/main" id="{0AA50D6D-A8F7-4435-8CFB-B4DEAEBB2C87}"/>
+              </a:ext>
+            </a:extLst>
+          </p:cNvPr>
+          <p:cNvSpPr>
+            <a:spLocks xmlns:a="http://schemas.openxmlformats.org/drawingml/2006/main" noGrp="1"/>
+          </p:cNvSpPr>
+          <p:nvPr/>
+        </p:nvSpPr>
+        <p:spPr>
+          <a:xfrm xmlns:a="http://schemas.openxmlformats.org/drawingml/2006/main">
+            <a:off x="8058150" y="3667125"/>
+            <a:ext cx="323850" cy="171450"/>
+          </a:xfrm>
+          <a:prstGeom xmlns:a="http://schemas.openxmlformats.org/drawingml/2006/main" prst="rect">
+            <a:avLst/>
+          </a:prstGeom>
+          <a:noFill xmlns:a="http://schemas.openxmlformats.org/drawingml/2006/main"/>
+          <a:ln xmlns:a="http://schemas.openxmlformats.org/drawingml/2006/main" w="0">
+            <a:noFill/>
+            <a:prstDash val="solid"/>
+          </a:ln>
+        </p:spPr>
+        <p:txBody>
+          <a:bodyPr xmlns:a="http://schemas.openxmlformats.org/drawingml/2006/main"/>
+          <a:lstStyle xmlns:a="http://schemas.openxmlformats.org/drawingml/2006/main"/>
+          <a:p xmlns:a="http://schemas.openxmlformats.org/drawingml/2006/main">
+            <a:pPr algn="ctr">
+              <a:defRPr sz="1275" b="1">
+                <a:solidFill>
+                  <a:srgbClr val="FFFFFF"/>
+                </a:solidFill>
+              </a:defRPr>
+            </a:pPr>
+            <a:r>
+              <a:rPr sz="1275" b="1">
+                <a:solidFill>
+                  <a:srgbClr val="FFFFFF"/>
+                </a:solidFill>
+              </a:rPr>
+              <a:t>6</a:t>
+            </a:r>
+          </a:p>
+        </p:txBody>
+      </p:sp>
+      <p:sp>
+        <p:nvSpPr>
+          <p:cNvPr id="33" name="">
+            <a:extLst xmlns:a="http://schemas.openxmlformats.org/drawingml/2006/main">
+              <a:ext uri="{FF2B5EF4-FFF2-40B4-BE49-F238E27FC236}">
+                <a16:creationId xmlns:a16="http://schemas.microsoft.com/office/drawing/2014/main" id="{D36C4969-9AB9-4B83-84D7-1BC6DCAFFD71}"/>
+              </a:ext>
+            </a:extLst>
+          </p:cNvPr>
+          <p:cNvSpPr>
+            <a:spLocks xmlns:a="http://schemas.openxmlformats.org/drawingml/2006/main" noGrp="1"/>
+          </p:cNvSpPr>
+          <p:nvPr/>
+        </p:nvSpPr>
+        <p:spPr>
+          <a:xfrm xmlns:a="http://schemas.openxmlformats.org/drawingml/2006/main">
+            <a:off x="8534400" y="3505200"/>
+            <a:ext cx="2505075" cy="228600"/>
+          </a:xfrm>
+          <a:prstGeom xmlns:a="http://schemas.openxmlformats.org/drawingml/2006/main" prst="rect">
+            <a:avLst/>
+          </a:prstGeom>
+          <a:noFill xmlns:a="http://schemas.openxmlformats.org/drawingml/2006/main"/>
+          <a:ln xmlns:a="http://schemas.openxmlformats.org/drawingml/2006/main" w="0">
+            <a:noFill/>
+            <a:prstDash val="solid"/>
+          </a:ln>
+        </p:spPr>
+        <p:txBody>
+          <a:bodyPr xmlns:a="http://schemas.openxmlformats.org/drawingml/2006/main"/>
+          <a:lstStyle xmlns:a="http://schemas.openxmlformats.org/drawingml/2006/main"/>
+          <a:p xmlns:a="http://schemas.openxmlformats.org/drawingml/2006/main">
+            <a:pPr algn="l">
+              <a:defRPr sz="1350" b="1">
+                <a:solidFill>
+                  <a:srgbClr val="2563EB"/>
+                </a:solidFill>
+              </a:defRPr>
+            </a:pPr>
+            <a:r>
+              <a:rPr sz="1350" b="1">
+                <a:solidFill>
+                  <a:srgbClr val="2563EB"/>
+                </a:solidFill>
+              </a:rPr>
+              <a:t>Control context and tools</a:t>
+            </a:r>
+          </a:p>
+        </p:txBody>
+      </p:sp>
+      <p:sp>
+        <p:nvSpPr>
+          <p:cNvPr id="34" name="">
+            <a:extLst xmlns:a="http://schemas.openxmlformats.org/drawingml/2006/main">
+              <a:ext uri="{FF2B5EF4-FFF2-40B4-BE49-F238E27FC236}">
+                <a16:creationId xmlns:a16="http://schemas.microsoft.com/office/drawing/2014/main" id="{717896D7-FD0D-48F6-8493-F7904D5F2DF2}"/>
+              </a:ext>
+            </a:extLst>
+          </p:cNvPr>
+          <p:cNvSpPr>
+            <a:spLocks xmlns:a="http://schemas.openxmlformats.org/drawingml/2006/main" noGrp="1"/>
+          </p:cNvSpPr>
+          <p:nvPr/>
+        </p:nvSpPr>
+        <p:spPr>
+          <a:xfrm xmlns:a="http://schemas.openxmlformats.org/drawingml/2006/main">
+            <a:off x="8534400" y="3781425"/>
+            <a:ext cx="2505075" cy="400050"/>
+          </a:xfrm>
+          <a:prstGeom xmlns:a="http://schemas.openxmlformats.org/drawingml/2006/main" prst="rect">
+            <a:avLst/>
+          </a:prstGeom>
+          <a:noFill xmlns:a="http://schemas.openxmlformats.org/drawingml/2006/main"/>
+          <a:ln xmlns:a="http://schemas.openxmlformats.org/drawingml/2006/main" w="0">
+            <a:noFill/>
+            <a:prstDash val="solid"/>
+          </a:ln>
+        </p:spPr>
+        <p:txBody>
+          <a:bodyPr xmlns:a="http://schemas.openxmlformats.org/drawingml/2006/main"/>
+          <a:lstStyle xmlns:a="http://schemas.openxmlformats.org/drawingml/2006/main"/>
+          <a:p xmlns:a="http://schemas.openxmlformats.org/drawingml/2006/main">
+            <a:pPr algn="l">
+              <a:defRPr sz="1125" b="0">
+                <a:solidFill>
+                  <a:srgbClr val="4B5563"/>
+                </a:solidFill>
+              </a:defRPr>
+            </a:pPr>
+            <a:r>
+              <a:rPr sz="1125" b="0">
+                <a:solidFill>
+                  <a:srgbClr val="4B5563"/>
+                </a:solidFill>
+              </a:rPr>
+              <a:t>Tool filters, skills, retrieval, and progressive disclosure.</a:t>
+            </a:r>
+          </a:p>
+        </p:txBody>
+      </p:sp>
+      <p:sp>
+        <p:nvSpPr>
+          <p:cNvPr id="35" name="">
+            <a:extLst xmlns:a="http://schemas.openxmlformats.org/drawingml/2006/main">
+              <a:ext uri="{FF2B5EF4-FFF2-40B4-BE49-F238E27FC236}">
+                <a16:creationId xmlns:a16="http://schemas.microsoft.com/office/drawing/2014/main" id="{9B4DD677-18CB-4997-9300-9732F36EBB4E}"/>
+              </a:ext>
+            </a:extLst>
+          </p:cNvPr>
+          <p:cNvSpPr>
+            <a:spLocks xmlns:a="http://schemas.openxmlformats.org/drawingml/2006/main" noGrp="1"/>
+          </p:cNvSpPr>
+          <p:nvPr/>
+        </p:nvSpPr>
+        <p:spPr>
+          <a:xfrm xmlns:a="http://schemas.openxmlformats.org/drawingml/2006/main">
+            <a:off x="685800" y="4419600"/>
+            <a:ext cx="3286125" cy="914400"/>
+          </a:xfrm>
+          <a:prstGeom xmlns:a="http://schemas.openxmlformats.org/drawingml/2006/main" prst="rect">
+            <a:avLst/>
+          </a:prstGeom>
+          <a:solidFill xmlns:a="http://schemas.openxmlformats.org/drawingml/2006/main">
+            <a:srgbClr val="FFFFFF"/>
+          </a:solidFill>
+          <a:ln xmlns:a="http://schemas.openxmlformats.org/drawingml/2006/main" w="9525">
+            <a:solidFill>
+              <a:srgbClr val="CBD5E1"/>
+            </a:solidFill>
+            <a:prstDash val="solid"/>
+          </a:ln>
+        </p:spPr>
+      </p:sp>
+      <p:sp>
+        <p:nvSpPr>
+          <p:cNvPr id="36" name="">
+            <a:extLst xmlns:a="http://schemas.openxmlformats.org/drawingml/2006/main">
+              <a:ext uri="{FF2B5EF4-FFF2-40B4-BE49-F238E27FC236}">
+                <a16:creationId xmlns:a16="http://schemas.microsoft.com/office/drawing/2014/main" id="{D54001CC-8A79-4916-8DAE-B93C4E2C6672}"/>
+              </a:ext>
+            </a:extLst>
+          </p:cNvPr>
+          <p:cNvSpPr>
+            <a:spLocks xmlns:a="http://schemas.openxmlformats.org/drawingml/2006/main" noGrp="1"/>
+          </p:cNvSpPr>
+          <p:nvPr/>
+        </p:nvSpPr>
+        <p:spPr>
+          <a:xfrm xmlns:a="http://schemas.openxmlformats.org/drawingml/2006/main">
+            <a:off x="838200" y="4676775"/>
+            <a:ext cx="323850" cy="323850"/>
+          </a:xfrm>
+          <a:prstGeom xmlns:a="http://schemas.openxmlformats.org/drawingml/2006/main" prst="rect">
+            <a:avLst/>
+          </a:prstGeom>
+          <a:solidFill xmlns:a="http://schemas.openxmlformats.org/drawingml/2006/main">
+            <a:srgbClr val="0891B2"/>
+          </a:solidFill>
+          <a:ln xmlns:a="http://schemas.openxmlformats.org/drawingml/2006/main" w="9525">
+            <a:solidFill>
+              <a:srgbClr val="0891B2"/>
+            </a:solidFill>
+            <a:prstDash val="solid"/>
+          </a:ln>
+        </p:spPr>
+      </p:sp>
+      <p:sp>
+        <p:nvSpPr>
+          <p:cNvPr id="37" name="">
+            <a:extLst xmlns:a="http://schemas.openxmlformats.org/drawingml/2006/main">
+              <a:ext uri="{FF2B5EF4-FFF2-40B4-BE49-F238E27FC236}">
+                <a16:creationId xmlns:a16="http://schemas.microsoft.com/office/drawing/2014/main" id="{96308364-9CFE-415E-9435-F72ED7F305A1}"/>
+              </a:ext>
+            </a:extLst>
+          </p:cNvPr>
+          <p:cNvSpPr>
+            <a:spLocks xmlns:a="http://schemas.openxmlformats.org/drawingml/2006/main" noGrp="1"/>
+          </p:cNvSpPr>
+          <p:nvPr/>
+        </p:nvSpPr>
+        <p:spPr>
+          <a:xfrm xmlns:a="http://schemas.openxmlformats.org/drawingml/2006/main">
+            <a:off x="838200" y="4733925"/>
+            <a:ext cx="323850" cy="171450"/>
+          </a:xfrm>
+          <a:prstGeom xmlns:a="http://schemas.openxmlformats.org/drawingml/2006/main" prst="rect">
+            <a:avLst/>
+          </a:prstGeom>
+          <a:noFill xmlns:a="http://schemas.openxmlformats.org/drawingml/2006/main"/>
+          <a:ln xmlns:a="http://schemas.openxmlformats.org/drawingml/2006/main" w="0">
+            <a:noFill/>
+            <a:prstDash val="solid"/>
+          </a:ln>
+        </p:spPr>
+        <p:txBody>
+          <a:bodyPr xmlns:a="http://schemas.openxmlformats.org/drawingml/2006/main"/>
+          <a:lstStyle xmlns:a="http://schemas.openxmlformats.org/drawingml/2006/main"/>
+          <a:p xmlns:a="http://schemas.openxmlformats.org/drawingml/2006/main">
+            <a:pPr algn="ctr">
+              <a:defRPr sz="1275" b="1">
+                <a:solidFill>
+                  <a:srgbClr val="FFFFFF"/>
+                </a:solidFill>
+              </a:defRPr>
+            </a:pPr>
+            <a:r>
+              <a:rPr sz="1275" b="1">
+                <a:solidFill>
+                  <a:srgbClr val="FFFFFF"/>
+                </a:solidFill>
+              </a:rPr>
+              <a:t>7</a:t>
+            </a:r>
+          </a:p>
+        </p:txBody>
+      </p:sp>
+      <p:sp>
+        <p:nvSpPr>
+          <p:cNvPr id="38" name="">
+            <a:extLst xmlns:a="http://schemas.openxmlformats.org/drawingml/2006/main">
+              <a:ext uri="{FF2B5EF4-FFF2-40B4-BE49-F238E27FC236}">
+                <a16:creationId xmlns:a16="http://schemas.microsoft.com/office/drawing/2014/main" id="{9834576E-5A92-4F66-945D-A782A998B2F9}"/>
+              </a:ext>
+            </a:extLst>
+          </p:cNvPr>
+          <p:cNvSpPr>
+            <a:spLocks xmlns:a="http://schemas.openxmlformats.org/drawingml/2006/main" noGrp="1"/>
+          </p:cNvSpPr>
+          <p:nvPr/>
+        </p:nvSpPr>
+        <p:spPr>
+          <a:xfrm xmlns:a="http://schemas.openxmlformats.org/drawingml/2006/main">
+            <a:off x="1314450" y="4572000"/>
+            <a:ext cx="2505075" cy="228600"/>
+          </a:xfrm>
+          <a:prstGeom xmlns:a="http://schemas.openxmlformats.org/drawingml/2006/main" prst="rect">
+            <a:avLst/>
+          </a:prstGeom>
+          <a:noFill xmlns:a="http://schemas.openxmlformats.org/drawingml/2006/main"/>
+          <a:ln xmlns:a="http://schemas.openxmlformats.org/drawingml/2006/main" w="0">
+            <a:noFill/>
+            <a:prstDash val="solid"/>
+          </a:ln>
+        </p:spPr>
+        <p:txBody>
+          <a:bodyPr xmlns:a="http://schemas.openxmlformats.org/drawingml/2006/main"/>
+          <a:lstStyle xmlns:a="http://schemas.openxmlformats.org/drawingml/2006/main"/>
+          <a:p xmlns:a="http://schemas.openxmlformats.org/drawingml/2006/main">
+            <a:pPr algn="l">
+              <a:defRPr sz="1350" b="1">
+                <a:solidFill>
+                  <a:srgbClr val="0891B2"/>
+                </a:solidFill>
+              </a:defRPr>
+            </a:pPr>
+            <a:r>
+              <a:rPr sz="1350" b="1">
+                <a:solidFill>
+                  <a:srgbClr val="0891B2"/>
+                </a:solidFill>
+              </a:rPr>
+              <a:t>Evaluate every stage</a:t>
+            </a:r>
+          </a:p>
+        </p:txBody>
+      </p:sp>
+      <p:sp>
+        <p:nvSpPr>
+          <p:cNvPr id="39" name="">
+            <a:extLst xmlns:a="http://schemas.openxmlformats.org/drawingml/2006/main">
+              <a:ext uri="{FF2B5EF4-FFF2-40B4-BE49-F238E27FC236}">
+                <a16:creationId xmlns:a16="http://schemas.microsoft.com/office/drawing/2014/main" id="{91AB0072-43D3-480C-9608-5DA17E252BCA}"/>
+              </a:ext>
+            </a:extLst>
+          </p:cNvPr>
+          <p:cNvSpPr>
+            <a:spLocks xmlns:a="http://schemas.openxmlformats.org/drawingml/2006/main" noGrp="1"/>
+          </p:cNvSpPr>
+          <p:nvPr/>
+        </p:nvSpPr>
+        <p:spPr>
+          <a:xfrm xmlns:a="http://schemas.openxmlformats.org/drawingml/2006/main">
+            <a:off x="1314450" y="4848225"/>
+            <a:ext cx="2505075" cy="400050"/>
+          </a:xfrm>
+          <a:prstGeom xmlns:a="http://schemas.openxmlformats.org/drawingml/2006/main" prst="rect">
+            <a:avLst/>
+          </a:prstGeom>
+          <a:noFill xmlns:a="http://schemas.openxmlformats.org/drawingml/2006/main"/>
+          <a:ln xmlns:a="http://schemas.openxmlformats.org/drawingml/2006/main" w="0">
+            <a:noFill/>
+            <a:prstDash val="solid"/>
+          </a:ln>
+        </p:spPr>
+        <p:txBody>
+          <a:bodyPr xmlns:a="http://schemas.openxmlformats.org/drawingml/2006/main"/>
+          <a:lstStyle xmlns:a="http://schemas.openxmlformats.org/drawingml/2006/main"/>
+          <a:p xmlns:a="http://schemas.openxmlformats.org/drawingml/2006/main">
+            <a:pPr algn="l">
+              <a:defRPr sz="1125" b="0">
+                <a:solidFill>
+                  <a:srgbClr val="4B5563"/>
+                </a:solidFill>
+              </a:defRPr>
+            </a:pPr>
+            <a:r>
+              <a:rPr sz="1125" b="0">
+                <a:solidFill>
+                  <a:srgbClr val="4B5563"/>
+                </a:solidFill>
+              </a:rPr>
+              <a:t>Deterministic and LLM evals in CI/CD regression suites.</a:t>
+            </a:r>
+          </a:p>
+        </p:txBody>
+      </p:sp>
+      <p:sp>
+        <p:nvSpPr>
+          <p:cNvPr id="40" name="">
+            <a:extLst xmlns:a="http://schemas.openxmlformats.org/drawingml/2006/main">
+              <a:ext uri="{FF2B5EF4-FFF2-40B4-BE49-F238E27FC236}">
+                <a16:creationId xmlns:a16="http://schemas.microsoft.com/office/drawing/2014/main" id="{769F24F8-185B-45AA-9F6C-92871D4E7B5F}"/>
+              </a:ext>
+            </a:extLst>
+          </p:cNvPr>
+          <p:cNvSpPr>
+            <a:spLocks xmlns:a="http://schemas.openxmlformats.org/drawingml/2006/main" noGrp="1"/>
+          </p:cNvSpPr>
+          <p:nvPr/>
+        </p:nvSpPr>
+        <p:spPr>
+          <a:xfrm xmlns:a="http://schemas.openxmlformats.org/drawingml/2006/main">
+            <a:off x="4295775" y="4419600"/>
+            <a:ext cx="3286125" cy="914400"/>
+          </a:xfrm>
+          <a:prstGeom xmlns:a="http://schemas.openxmlformats.org/drawingml/2006/main" prst="rect">
+            <a:avLst/>
+          </a:prstGeom>
+          <a:solidFill xmlns:a="http://schemas.openxmlformats.org/drawingml/2006/main">
+            <a:srgbClr val="FFFFFF"/>
+          </a:solidFill>
+          <a:ln xmlns:a="http://schemas.openxmlformats.org/drawingml/2006/main" w="9525">
+            <a:solidFill>
+              <a:srgbClr val="CBD5E1"/>
+            </a:solidFill>
+            <a:prstDash val="solid"/>
+          </a:ln>
+        </p:spPr>
+      </p:sp>
+      <p:sp>
+        <p:nvSpPr>
+          <p:cNvPr id="41" name="">
+            <a:extLst xmlns:a="http://schemas.openxmlformats.org/drawingml/2006/main">
+              <a:ext uri="{FF2B5EF4-FFF2-40B4-BE49-F238E27FC236}">
+                <a16:creationId xmlns:a16="http://schemas.microsoft.com/office/drawing/2014/main" id="{B8A5A6D7-93FD-41DD-8B50-048410872679}"/>
+              </a:ext>
+            </a:extLst>
+          </p:cNvPr>
+          <p:cNvSpPr>
+            <a:spLocks xmlns:a="http://schemas.openxmlformats.org/drawingml/2006/main" noGrp="1"/>
+          </p:cNvSpPr>
+          <p:nvPr/>
+        </p:nvSpPr>
+        <p:spPr>
+          <a:xfrm xmlns:a="http://schemas.openxmlformats.org/drawingml/2006/main">
+            <a:off x="4448175" y="4676775"/>
+            <a:ext cx="323850" cy="323850"/>
+          </a:xfrm>
+          <a:prstGeom xmlns:a="http://schemas.openxmlformats.org/drawingml/2006/main" prst="rect">
+            <a:avLst/>
+          </a:prstGeom>
+          <a:solidFill xmlns:a="http://schemas.openxmlformats.org/drawingml/2006/main">
+            <a:srgbClr val="059669"/>
+          </a:solidFill>
+          <a:ln xmlns:a="http://schemas.openxmlformats.org/drawingml/2006/main" w="9525">
+            <a:solidFill>
+              <a:srgbClr val="059669"/>
+            </a:solidFill>
+            <a:prstDash val="solid"/>
+          </a:ln>
+        </p:spPr>
+      </p:sp>
+      <p:sp>
+        <p:nvSpPr>
+          <p:cNvPr id="42" name="">
+            <a:extLst xmlns:a="http://schemas.openxmlformats.org/drawingml/2006/main">
+              <a:ext uri="{FF2B5EF4-FFF2-40B4-BE49-F238E27FC236}">
+                <a16:creationId xmlns:a16="http://schemas.microsoft.com/office/drawing/2014/main" id="{404C645A-40B9-4438-89BE-81F76575C68A}"/>
+              </a:ext>
+            </a:extLst>
+          </p:cNvPr>
+          <p:cNvSpPr>
+            <a:spLocks xmlns:a="http://schemas.openxmlformats.org/drawingml/2006/main" noGrp="1"/>
+          </p:cNvSpPr>
+          <p:nvPr/>
+        </p:nvSpPr>
+        <p:spPr>
+          <a:xfrm xmlns:a="http://schemas.openxmlformats.org/drawingml/2006/main">
+            <a:off x="4448175" y="4733925"/>
+            <a:ext cx="323850" cy="171450"/>
+          </a:xfrm>
+          <a:prstGeom xmlns:a="http://schemas.openxmlformats.org/drawingml/2006/main" prst="rect">
+            <a:avLst/>
+          </a:prstGeom>
+          <a:noFill xmlns:a="http://schemas.openxmlformats.org/drawingml/2006/main"/>
+          <a:ln xmlns:a="http://schemas.openxmlformats.org/drawingml/2006/main" w="0">
+            <a:noFill/>
+            <a:prstDash val="solid"/>
+          </a:ln>
+        </p:spPr>
+        <p:txBody>
+          <a:bodyPr xmlns:a="http://schemas.openxmlformats.org/drawingml/2006/main"/>
+          <a:lstStyle xmlns:a="http://schemas.openxmlformats.org/drawingml/2006/main"/>
+          <a:p xmlns:a="http://schemas.openxmlformats.org/drawingml/2006/main">
+            <a:pPr algn="ctr">
+              <a:defRPr sz="1275" b="1">
+                <a:solidFill>
+                  <a:srgbClr val="FFFFFF"/>
+                </a:solidFill>
+              </a:defRPr>
+            </a:pPr>
+            <a:r>
+              <a:rPr sz="1275" b="1">
+                <a:solidFill>
+                  <a:srgbClr val="FFFFFF"/>
+                </a:solidFill>
+              </a:rPr>
+              <a:t>8</a:t>
+            </a:r>
+          </a:p>
+        </p:txBody>
+      </p:sp>
+      <p:sp>
+        <p:nvSpPr>
+          <p:cNvPr id="43" name="">
+            <a:extLst xmlns:a="http://schemas.openxmlformats.org/drawingml/2006/main">
+              <a:ext uri="{FF2B5EF4-FFF2-40B4-BE49-F238E27FC236}">
+                <a16:creationId xmlns:a16="http://schemas.microsoft.com/office/drawing/2014/main" id="{DF456FB4-1973-4593-9B76-74D1B5705115}"/>
+              </a:ext>
+            </a:extLst>
+          </p:cNvPr>
+          <p:cNvSpPr>
+            <a:spLocks xmlns:a="http://schemas.openxmlformats.org/drawingml/2006/main" noGrp="1"/>
+          </p:cNvSpPr>
+          <p:nvPr/>
+        </p:nvSpPr>
+        <p:spPr>
+          <a:xfrm xmlns:a="http://schemas.openxmlformats.org/drawingml/2006/main">
+            <a:off x="4924425" y="4572000"/>
+            <a:ext cx="2505075" cy="228600"/>
+          </a:xfrm>
+          <a:prstGeom xmlns:a="http://schemas.openxmlformats.org/drawingml/2006/main" prst="rect">
+            <a:avLst/>
+          </a:prstGeom>
+          <a:noFill xmlns:a="http://schemas.openxmlformats.org/drawingml/2006/main"/>
+          <a:ln xmlns:a="http://schemas.openxmlformats.org/drawingml/2006/main" w="0">
+            <a:noFill/>
+            <a:prstDash val="solid"/>
+          </a:ln>
+        </p:spPr>
+        <p:txBody>
+          <a:bodyPr xmlns:a="http://schemas.openxmlformats.org/drawingml/2006/main"/>
+          <a:lstStyle xmlns:a="http://schemas.openxmlformats.org/drawingml/2006/main"/>
+          <a:p xmlns:a="http://schemas.openxmlformats.org/drawingml/2006/main">
+            <a:pPr algn="l">
+              <a:defRPr sz="1350" b="1">
+                <a:solidFill>
+                  <a:srgbClr val="059669"/>
+                </a:solidFill>
+              </a:defRPr>
+            </a:pPr>
+            <a:r>
+              <a:rPr sz="1350" b="1">
+                <a:solidFill>
+                  <a:srgbClr val="059669"/>
+                </a:solidFill>
+              </a:rPr>
+              <a:t>Define done</a:t>
+            </a:r>
+          </a:p>
+        </p:txBody>
+      </p:sp>
+      <p:sp>
+        <p:nvSpPr>
+          <p:cNvPr id="44" name="">
+            <a:extLst xmlns:a="http://schemas.openxmlformats.org/drawingml/2006/main">
+              <a:ext uri="{FF2B5EF4-FFF2-40B4-BE49-F238E27FC236}">
+                <a16:creationId xmlns:a16="http://schemas.microsoft.com/office/drawing/2014/main" id="{6FFAFE47-A1DD-4418-B326-3FF720197611}"/>
+              </a:ext>
+            </a:extLst>
+          </p:cNvPr>
+          <p:cNvSpPr>
+            <a:spLocks xmlns:a="http://schemas.openxmlformats.org/drawingml/2006/main" noGrp="1"/>
+          </p:cNvSpPr>
+          <p:nvPr/>
+        </p:nvSpPr>
+        <p:spPr>
+          <a:xfrm xmlns:a="http://schemas.openxmlformats.org/drawingml/2006/main">
+            <a:off x="4924425" y="4848225"/>
+            <a:ext cx="2505075" cy="400050"/>
+          </a:xfrm>
+          <a:prstGeom xmlns:a="http://schemas.openxmlformats.org/drawingml/2006/main" prst="rect">
+            <a:avLst/>
+          </a:prstGeom>
+          <a:noFill xmlns:a="http://schemas.openxmlformats.org/drawingml/2006/main"/>
+          <a:ln xmlns:a="http://schemas.openxmlformats.org/drawingml/2006/main" w="0">
+            <a:noFill/>
+            <a:prstDash val="solid"/>
+          </a:ln>
+        </p:spPr>
+        <p:txBody>
+          <a:bodyPr xmlns:a="http://schemas.openxmlformats.org/drawingml/2006/main"/>
+          <a:lstStyle xmlns:a="http://schemas.openxmlformats.org/drawingml/2006/main"/>
+          <a:p xmlns:a="http://schemas.openxmlformats.org/drawingml/2006/main">
+            <a:pPr algn="l">
+              <a:defRPr sz="1125" b="0">
+                <a:solidFill>
+                  <a:srgbClr val="4B5563"/>
+                </a:solidFill>
+              </a:defRPr>
+            </a:pPr>
+            <a:r>
+              <a:rPr sz="1125" b="0">
+                <a:solidFill>
+                  <a:srgbClr val="4B5563"/>
+                </a:solidFill>
+              </a:rPr>
+              <a:t>Goal loops, schemas, acceptance criteria, and attempt budgets.</a:t>
+            </a:r>
+          </a:p>
+        </p:txBody>
+      </p:sp>
+      <p:sp>
+        <p:nvSpPr>
+          <p:cNvPr id="45" name="">
+            <a:extLst xmlns:a="http://schemas.openxmlformats.org/drawingml/2006/main">
+              <a:ext uri="{FF2B5EF4-FFF2-40B4-BE49-F238E27FC236}">
+                <a16:creationId xmlns:a16="http://schemas.microsoft.com/office/drawing/2014/main" id="{AAF5F084-9E08-4626-BF03-580B0EA496C3}"/>
+              </a:ext>
+            </a:extLst>
+          </p:cNvPr>
+          <p:cNvSpPr>
+            <a:spLocks xmlns:a="http://schemas.openxmlformats.org/drawingml/2006/main" noGrp="1"/>
+          </p:cNvSpPr>
+          <p:nvPr/>
+        </p:nvSpPr>
+        <p:spPr>
+          <a:xfrm xmlns:a="http://schemas.openxmlformats.org/drawingml/2006/main">
+            <a:off x="7905750" y="4419600"/>
+            <a:ext cx="3286125" cy="914400"/>
+          </a:xfrm>
+          <a:prstGeom xmlns:a="http://schemas.openxmlformats.org/drawingml/2006/main" prst="rect">
+            <a:avLst/>
+          </a:prstGeom>
+          <a:solidFill xmlns:a="http://schemas.openxmlformats.org/drawingml/2006/main">
+            <a:srgbClr val="FFFFFF"/>
+          </a:solidFill>
+          <a:ln xmlns:a="http://schemas.openxmlformats.org/drawingml/2006/main" w="9525">
+            <a:solidFill>
+              <a:srgbClr val="CBD5E1"/>
+            </a:solidFill>
+            <a:prstDash val="solid"/>
+          </a:ln>
+        </p:spPr>
+      </p:sp>
+      <p:sp>
+        <p:nvSpPr>
+          <p:cNvPr id="46" name="">
+            <a:extLst xmlns:a="http://schemas.openxmlformats.org/drawingml/2006/main">
+              <a:ext uri="{FF2B5EF4-FFF2-40B4-BE49-F238E27FC236}">
+                <a16:creationId xmlns:a16="http://schemas.microsoft.com/office/drawing/2014/main" id="{1161E5EB-1126-490B-953B-AFBD02B893C9}"/>
+              </a:ext>
+            </a:extLst>
+          </p:cNvPr>
+          <p:cNvSpPr>
+            <a:spLocks xmlns:a="http://schemas.openxmlformats.org/drawingml/2006/main" noGrp="1"/>
+          </p:cNvSpPr>
+          <p:nvPr/>
+        </p:nvSpPr>
+        <p:spPr>
+          <a:xfrm xmlns:a="http://schemas.openxmlformats.org/drawingml/2006/main">
+            <a:off x="8058150" y="4676775"/>
+            <a:ext cx="323850" cy="323850"/>
+          </a:xfrm>
+          <a:prstGeom xmlns:a="http://schemas.openxmlformats.org/drawingml/2006/main" prst="rect">
+            <a:avLst/>
+          </a:prstGeom>
+          <a:solidFill xmlns:a="http://schemas.openxmlformats.org/drawingml/2006/main">
+            <a:srgbClr val="D97706"/>
+          </a:solidFill>
+          <a:ln xmlns:a="http://schemas.openxmlformats.org/drawingml/2006/main" w="9525">
+            <a:solidFill>
+              <a:srgbClr val="D97706"/>
+            </a:solidFill>
+            <a:prstDash val="solid"/>
+          </a:ln>
+        </p:spPr>
+      </p:sp>
+      <p:sp>
+        <p:nvSpPr>
+          <p:cNvPr id="47" name="">
+            <a:extLst xmlns:a="http://schemas.openxmlformats.org/drawingml/2006/main">
+              <a:ext uri="{FF2B5EF4-FFF2-40B4-BE49-F238E27FC236}">
+                <a16:creationId xmlns:a16="http://schemas.microsoft.com/office/drawing/2014/main" id="{45F66129-4CBF-4F8C-A1D6-F37BACAC416B}"/>
+              </a:ext>
+            </a:extLst>
+          </p:cNvPr>
+          <p:cNvSpPr>
+            <a:spLocks xmlns:a="http://schemas.openxmlformats.org/drawingml/2006/main" noGrp="1"/>
+          </p:cNvSpPr>
+          <p:nvPr/>
+        </p:nvSpPr>
+        <p:spPr>
+          <a:xfrm xmlns:a="http://schemas.openxmlformats.org/drawingml/2006/main">
+            <a:off x="8058150" y="4733925"/>
+            <a:ext cx="323850" cy="171450"/>
+          </a:xfrm>
+          <a:prstGeom xmlns:a="http://schemas.openxmlformats.org/drawingml/2006/main" prst="rect">
+            <a:avLst/>
+          </a:prstGeom>
+          <a:noFill xmlns:a="http://schemas.openxmlformats.org/drawingml/2006/main"/>
+          <a:ln xmlns:a="http://schemas.openxmlformats.org/drawingml/2006/main" w="0">
+            <a:noFill/>
+            <a:prstDash val="solid"/>
+          </a:ln>
+        </p:spPr>
+        <p:txBody>
+          <a:bodyPr xmlns:a="http://schemas.openxmlformats.org/drawingml/2006/main"/>
+          <a:lstStyle xmlns:a="http://schemas.openxmlformats.org/drawingml/2006/main"/>
+          <a:p xmlns:a="http://schemas.openxmlformats.org/drawingml/2006/main">
+            <a:pPr algn="ctr">
+              <a:defRPr sz="1275" b="1">
+                <a:solidFill>
+                  <a:srgbClr val="FFFFFF"/>
+                </a:solidFill>
+              </a:defRPr>
+            </a:pPr>
+            <a:r>
+              <a:rPr sz="1275" b="1">
+                <a:solidFill>
+                  <a:srgbClr val="FFFFFF"/>
+                </a:solidFill>
+              </a:rPr>
+              <a:t>9</a:t>
+            </a:r>
+          </a:p>
+        </p:txBody>
+      </p:sp>
+      <p:sp>
+        <p:nvSpPr>
+          <p:cNvPr id="48" name="">
+            <a:extLst xmlns:a="http://schemas.openxmlformats.org/drawingml/2006/main">
+              <a:ext uri="{FF2B5EF4-FFF2-40B4-BE49-F238E27FC236}">
+                <a16:creationId xmlns:a16="http://schemas.microsoft.com/office/drawing/2014/main" id="{9B3CD872-B785-40FB-9838-A6F9D0780854}"/>
+              </a:ext>
+            </a:extLst>
+          </p:cNvPr>
+          <p:cNvSpPr>
+            <a:spLocks xmlns:a="http://schemas.openxmlformats.org/drawingml/2006/main" noGrp="1"/>
+          </p:cNvSpPr>
+          <p:nvPr/>
+        </p:nvSpPr>
+        <p:spPr>
+          <a:xfrm xmlns:a="http://schemas.openxmlformats.org/drawingml/2006/main">
+            <a:off x="8534400" y="4572000"/>
+            <a:ext cx="2505075" cy="228600"/>
+          </a:xfrm>
+          <a:prstGeom xmlns:a="http://schemas.openxmlformats.org/drawingml/2006/main" prst="rect">
+            <a:avLst/>
+          </a:prstGeom>
+          <a:noFill xmlns:a="http://schemas.openxmlformats.org/drawingml/2006/main"/>
+          <a:ln xmlns:a="http://schemas.openxmlformats.org/drawingml/2006/main" w="0">
+            <a:noFill/>
+            <a:prstDash val="solid"/>
+          </a:ln>
+        </p:spPr>
+        <p:txBody>
+          <a:bodyPr xmlns:a="http://schemas.openxmlformats.org/drawingml/2006/main"/>
+          <a:lstStyle xmlns:a="http://schemas.openxmlformats.org/drawingml/2006/main"/>
+          <a:p xmlns:a="http://schemas.openxmlformats.org/drawingml/2006/main">
+            <a:pPr algn="l">
+              <a:defRPr sz="1350" b="1">
+                <a:solidFill>
+                  <a:srgbClr val="D97706"/>
+                </a:solidFill>
+              </a:defRPr>
+            </a:pPr>
+            <a:r>
+              <a:rPr sz="1350" b="1">
+                <a:solidFill>
+                  <a:srgbClr val="D97706"/>
+                </a:solidFill>
+              </a:rPr>
+              <a:t>Observe and improve</a:t>
+            </a:r>
+          </a:p>
+        </p:txBody>
+      </p:sp>
+      <p:sp>
+        <p:nvSpPr>
+          <p:cNvPr id="49" name="">
+            <a:extLst xmlns:a="http://schemas.openxmlformats.org/drawingml/2006/main">
+              <a:ext uri="{FF2B5EF4-FFF2-40B4-BE49-F238E27FC236}">
+                <a16:creationId xmlns:a16="http://schemas.microsoft.com/office/drawing/2014/main" id="{12556DAD-6171-40C3-B2AA-3CEC32FB9619}"/>
+              </a:ext>
+            </a:extLst>
+          </p:cNvPr>
+          <p:cNvSpPr>
+            <a:spLocks xmlns:a="http://schemas.openxmlformats.org/drawingml/2006/main" noGrp="1"/>
+          </p:cNvSpPr>
+          <p:nvPr/>
+        </p:nvSpPr>
+        <p:spPr>
+          <a:xfrm xmlns:a="http://schemas.openxmlformats.org/drawingml/2006/main">
+            <a:off x="8534400" y="4848225"/>
+            <a:ext cx="2505075" cy="400050"/>
+          </a:xfrm>
+          <a:prstGeom xmlns:a="http://schemas.openxmlformats.org/drawingml/2006/main" prst="rect">
+            <a:avLst/>
+          </a:prstGeom>
+          <a:noFill xmlns:a="http://schemas.openxmlformats.org/drawingml/2006/main"/>
+          <a:ln xmlns:a="http://schemas.openxmlformats.org/drawingml/2006/main" w="0">
+            <a:noFill/>
+            <a:prstDash val="solid"/>
+          </a:ln>
+        </p:spPr>
+        <p:txBody>
+          <a:bodyPr xmlns:a="http://schemas.openxmlformats.org/drawingml/2006/main"/>
+          <a:lstStyle xmlns:a="http://schemas.openxmlformats.org/drawingml/2006/main"/>
+          <a:p xmlns:a="http://schemas.openxmlformats.org/drawingml/2006/main">
+            <a:pPr algn="l">
+              <a:defRPr sz="1125" b="0">
+                <a:solidFill>
+                  <a:srgbClr val="4B5563"/>
+                </a:solidFill>
+              </a:defRPr>
+            </a:pPr>
+            <a:r>
+              <a:rPr sz="1125" b="0">
+                <a:solidFill>
+                  <a:srgbClr val="4B5563"/>
+                </a:solidFill>
+              </a:rPr>
+              <a:t>Traces, decisions, tool calls, misses, and rejected attempts.</a:t>
+            </a:r>
+          </a:p>
+        </p:txBody>
+      </p:sp>
+      <p:sp>
+        <p:nvSpPr>
+          <p:cNvPr id="50" name="">
+            <a:extLst xmlns:a="http://schemas.openxmlformats.org/drawingml/2006/main">
+              <a:ext uri="{FF2B5EF4-FFF2-40B4-BE49-F238E27FC236}">
+                <a16:creationId xmlns:a16="http://schemas.microsoft.com/office/drawing/2014/main" id="{5357D9D8-B968-416C-9AB6-40CA3D09DD4A}"/>
+              </a:ext>
+            </a:extLst>
+          </p:cNvPr>
+          <p:cNvSpPr>
+            <a:spLocks xmlns:a="http://schemas.openxmlformats.org/drawingml/2006/main" noGrp="1"/>
+          </p:cNvSpPr>
+          <p:nvPr/>
+        </p:nvSpPr>
+        <p:spPr>
+          <a:xfrm xmlns:a="http://schemas.openxmlformats.org/drawingml/2006/main">
+            <a:off x="1123950" y="6096000"/>
+            <a:ext cx="9944100" cy="361950"/>
+          </a:xfrm>
+          <a:prstGeom xmlns:a="http://schemas.openxmlformats.org/drawingml/2006/main" prst="rect">
+            <a:avLst/>
+          </a:prstGeom>
+          <a:solidFill xmlns:a="http://schemas.openxmlformats.org/drawingml/2006/main">
+            <a:srgbClr val="EFF6FF"/>
+          </a:solidFill>
+          <a:ln xmlns:a="http://schemas.openxmlformats.org/drawingml/2006/main" w="9525">
+            <a:solidFill>
+              <a:srgbClr val="BFDBFE"/>
+            </a:solidFill>
+            <a:prstDash val="solid"/>
+          </a:ln>
+        </p:spPr>
+      </p:sp>
+      <p:sp>
+        <p:nvSpPr>
+          <p:cNvPr id="51" name="">
+            <a:extLst xmlns:a="http://schemas.openxmlformats.org/drawingml/2006/main">
+              <a:ext uri="{FF2B5EF4-FFF2-40B4-BE49-F238E27FC236}">
+                <a16:creationId xmlns:a16="http://schemas.microsoft.com/office/drawing/2014/main" id="{26CB9757-340A-450A-B8E5-51670A3912AF}"/>
+              </a:ext>
+            </a:extLst>
+          </p:cNvPr>
+          <p:cNvSpPr>
+            <a:spLocks xmlns:a="http://schemas.openxmlformats.org/drawingml/2006/main" noGrp="1"/>
+          </p:cNvSpPr>
+          <p:nvPr/>
+        </p:nvSpPr>
+        <p:spPr>
+          <a:xfrm xmlns:a="http://schemas.openxmlformats.org/drawingml/2006/main">
+            <a:off x="1428750" y="6191250"/>
+            <a:ext cx="9334500" cy="190500"/>
+          </a:xfrm>
+          <a:prstGeom xmlns:a="http://schemas.openxmlformats.org/drawingml/2006/main" prst="rect">
+            <a:avLst/>
+          </a:prstGeom>
+          <a:noFill xmlns:a="http://schemas.openxmlformats.org/drawingml/2006/main"/>
+          <a:ln xmlns:a="http://schemas.openxmlformats.org/drawingml/2006/main" w="0">
+            <a:noFill/>
+            <a:prstDash val="solid"/>
+          </a:ln>
+        </p:spPr>
+        <p:txBody>
+          <a:bodyPr xmlns:a="http://schemas.openxmlformats.org/drawingml/2006/main"/>
+          <a:lstStyle xmlns:a="http://schemas.openxmlformats.org/drawingml/2006/main"/>
+          <a:p xmlns:a="http://schemas.openxmlformats.org/drawingml/2006/main">
+            <a:pPr algn="ctr">
+              <a:defRPr sz="1350" b="1">
+                <a:solidFill>
+                  <a:srgbClr val="2563EB"/>
+                </a:solidFill>
+              </a:defRPr>
+            </a:pPr>
+            <a:r>
+              <a:rPr sz="1350" b="1">
+                <a:solidFill>
+                  <a:srgbClr val="2563EB"/>
+                </a:solidFill>
+              </a:rPr>
+              <a:t>Principle: autonomy is earned by adding evidence, boundaries, evaluation, recovery, and human escalation.</a:t>
+            </a:r>
+          </a:p>
+        </p:txBody>
+      </p:sp>
+    </p:spTree>
+    <p:extLst>
+      <p:ext uri="{BB962C8B-B14F-4D97-AF65-F5344CB8AC3E}">
+        <p14:creationId xmlns:p14="http://schemas.microsoft.com/office/powerpoint/2010/main" val="795475722"/>
+      </p:ext>
+    </p:extLst>
+  </p:cSld>
+</p:sld>
+</file>
+
+<file path=ppt/slides/slide12.xml><?xml version="1.0" encoding="utf-8"?>
+<p:sld xmlns:p="http://schemas.openxmlformats.org/presentationml/2006/main">
+  <p:cSld>
+    <p:bg>
+      <p:bgPr>
+        <a:solidFill xmlns:a="http://schemas.openxmlformats.org/drawingml/2006/main">
+          <a:srgbClr val="FFFFFF"/>
+        </a:solidFill>
+      </p:bgPr>
+    </p:bg>
+    <p:spTree>
+      <p:nvGrpSpPr>
+        <p:cNvPr id="1" name=""/>
+        <p:cNvGrpSpPr/>
+        <p:nvPr/>
+      </p:nvGrpSpPr>
+      <p:grpSpPr>
+        <a:xfrm xmlns:a="http://schemas.openxmlformats.org/drawingml/2006/main"/>
+      </p:grpSpPr>
+      <p:sp>
+        <p:nvSpPr>
+          <p:cNvPr id="16" name="">
+            <a:extLst xmlns:a="http://schemas.openxmlformats.org/drawingml/2006/main">
+              <a:ext uri="{FF2B5EF4-FFF2-40B4-BE49-F238E27FC236}">
+                <a16:creationId xmlns:a16="http://schemas.microsoft.com/office/drawing/2014/main" id="{64B6A23A-0764-4156-A386-02028A6FA49F}"/>
+              </a:ext>
+            </a:extLst>
+          </p:cNvPr>
+          <p:cNvSpPr>
+            <a:spLocks xmlns:a="http://schemas.openxmlformats.org/drawingml/2006/main" noGrp="1"/>
+          </p:cNvSpPr>
+          <p:nvPr/>
+        </p:nvSpPr>
+        <p:spPr>
+          <a:xfrm xmlns:a="http://schemas.openxmlformats.org/drawingml/2006/main">
+            <a:off x="609600" y="361950"/>
+            <a:ext cx="3238500" cy="228600"/>
+          </a:xfrm>
+          <a:prstGeom xmlns:a="http://schemas.openxmlformats.org/drawingml/2006/main" prst="rect">
+            <a:avLst/>
+          </a:prstGeom>
+          <a:noFill xmlns:a="http://schemas.openxmlformats.org/drawingml/2006/main"/>
+          <a:ln xmlns:a="http://schemas.openxmlformats.org/drawingml/2006/main" w="0">
+            <a:noFill/>
+            <a:prstDash val="solid"/>
+          </a:ln>
+        </p:spPr>
+        <p:txBody>
+          <a:bodyPr xmlns:a="http://schemas.openxmlformats.org/drawingml/2006/main"/>
+          <a:lstStyle xmlns:a="http://schemas.openxmlformats.org/drawingml/2006/main"/>
+          <a:p xmlns:a="http://schemas.openxmlformats.org/drawingml/2006/main">
+            <a:pPr algn="l">
+              <a:buNone/>
+              <a:defRPr sz="975" b="1">
+                <a:solidFill>
+                  <a:srgbClr val="2563EB"/>
+                </a:solidFill>
+              </a:defRPr>
+            </a:pPr>
+            <a:r>
+              <a:rPr sz="975" b="1">
+                <a:solidFill>
+                  <a:srgbClr val="2563EB"/>
+                </a:solidFill>
+              </a:rPr>
+              <a:t>APPENDIX</a:t>
+            </a:r>
+          </a:p>
+        </p:txBody>
+      </p:sp>
+      <p:sp>
+        <p:nvSpPr>
+          <p:cNvPr id="2" name="">
+            <a:extLst xmlns:a="http://schemas.openxmlformats.org/drawingml/2006/main">
+              <a:ext uri="{FF2B5EF4-FFF2-40B4-BE49-F238E27FC236}">
+                <a16:creationId xmlns:a16="http://schemas.microsoft.com/office/drawing/2014/main" id="{CEC93461-B644-4A51-989C-53BC07347260}"/>
+              </a:ext>
+            </a:extLst>
+          </p:cNvPr>
+          <p:cNvSpPr>
+            <a:spLocks xmlns:a="http://schemas.openxmlformats.org/drawingml/2006/main" noGrp="1"/>
+          </p:cNvSpPr>
+          <p:nvPr/>
+        </p:nvSpPr>
+        <p:spPr>
+          <a:xfrm xmlns:a="http://schemas.openxmlformats.org/drawingml/2006/main">
+            <a:off x="609600" y="723900"/>
+            <a:ext cx="9715500" cy="552450"/>
+          </a:xfrm>
+          <a:prstGeom xmlns:a="http://schemas.openxmlformats.org/drawingml/2006/main" prst="rect">
+            <a:avLst/>
+          </a:prstGeom>
+          <a:noFill xmlns:a="http://schemas.openxmlformats.org/drawingml/2006/main"/>
+          <a:ln xmlns:a="http://schemas.openxmlformats.org/drawingml/2006/main" w="0">
+            <a:noFill/>
+            <a:prstDash val="solid"/>
+          </a:ln>
+        </p:spPr>
+        <p:txBody>
+          <a:bodyPr xmlns:a="http://schemas.openxmlformats.org/drawingml/2006/main"/>
+          <a:lstStyle xmlns:a="http://schemas.openxmlformats.org/drawingml/2006/main"/>
+          <a:p xmlns:a="http://schemas.openxmlformats.org/drawingml/2006/main">
+            <a:pPr algn="l">
+              <a:buNone/>
+              <a:defRPr sz="2925" b="1">
+                <a:solidFill>
+                  <a:srgbClr val="0B0F19"/>
+                </a:solidFill>
+              </a:defRPr>
+            </a:pPr>
+            <a:r>
+              <a:rPr sz="2925" b="1">
+                <a:solidFill>
+                  <a:srgbClr val="0B0F19"/>
+                </a:solidFill>
+              </a:rPr>
+              <a:t>Appendix: harness, loop, and workflow are different lenses</a:t>
+            </a:r>
+          </a:p>
+        </p:txBody>
+      </p:sp>
+      <p:sp>
+        <p:nvSpPr>
+          <p:cNvPr id="3" name="">
+            <a:extLst xmlns:a="http://schemas.openxmlformats.org/drawingml/2006/main">
+              <a:ext uri="{FF2B5EF4-FFF2-40B4-BE49-F238E27FC236}">
+                <a16:creationId xmlns:a16="http://schemas.microsoft.com/office/drawing/2014/main" id="{B36B401A-A908-4235-8A92-06DC0C3FE5B3}"/>
+              </a:ext>
+            </a:extLst>
+          </p:cNvPr>
+          <p:cNvSpPr>
+            <a:spLocks xmlns:a="http://schemas.openxmlformats.org/drawingml/2006/main" noGrp="1"/>
+          </p:cNvSpPr>
+          <p:nvPr/>
+        </p:nvSpPr>
+        <p:spPr>
+          <a:xfrm xmlns:a="http://schemas.openxmlformats.org/drawingml/2006/main">
+            <a:off x="609600" y="1409700"/>
+            <a:ext cx="10972800" cy="9525"/>
+          </a:xfrm>
+          <a:prstGeom xmlns:a="http://schemas.openxmlformats.org/drawingml/2006/main" prst="rect">
+            <a:avLst/>
+          </a:prstGeom>
+          <a:solidFill xmlns:a="http://schemas.openxmlformats.org/drawingml/2006/main">
+            <a:srgbClr val="CBD5E1"/>
+          </a:solidFill>
+          <a:ln xmlns:a="http://schemas.openxmlformats.org/drawingml/2006/main" w="9525">
+            <a:solidFill>
+              <a:srgbClr val="CBD5E1"/>
+            </a:solidFill>
+            <a:prstDash val="solid"/>
+          </a:ln>
+        </p:spPr>
+      </p:sp>
+      <p:sp>
+        <p:nvSpPr>
+          <p:cNvPr id="4" name="">
+            <a:extLst xmlns:a="http://schemas.openxmlformats.org/drawingml/2006/main">
+              <a:ext uri="{FF2B5EF4-FFF2-40B4-BE49-F238E27FC236}">
                 <a16:creationId xmlns:a16="http://schemas.microsoft.com/office/drawing/2014/main" id="{6562AB74-0BA0-46F4-BBE6-C22EC326C1E4}"/>
               </a:ext>
             </a:extLst>
@@ -3586,6 +5944,7 @@
           <a:lstStyle xmlns:a="http://schemas.openxmlformats.org/drawingml/2006/main"/>
           <a:p xmlns:a="http://schemas.openxmlformats.org/drawingml/2006/main">
             <a:pPr algn="l">
+              <a:buNone/>
               <a:defRPr sz="1725" b="1">
                 <a:solidFill>
                   <a:srgbClr val="2563EB"/>
@@ -3636,6 +5995,7 @@
           <a:lstStyle xmlns:a="http://schemas.openxmlformats.org/drawingml/2006/main"/>
           <a:p xmlns:a="http://schemas.openxmlformats.org/drawingml/2006/main">
             <a:pPr algn="l">
+              <a:buNone/>
               <a:defRPr sz="1575" b="1">
                 <a:solidFill>
                   <a:srgbClr val="0B0F19"/>
@@ -3686,6 +6046,7 @@
           <a:lstStyle xmlns:a="http://schemas.openxmlformats.org/drawingml/2006/main"/>
           <a:p xmlns:a="http://schemas.openxmlformats.org/drawingml/2006/main">
             <a:pPr algn="l">
+              <a:buNone/>
               <a:defRPr sz="1425" b="0">
                 <a:solidFill>
                   <a:srgbClr val="4B5563"/>
@@ -3769,6 +6130,7 @@
           <a:lstStyle xmlns:a="http://schemas.openxmlformats.org/drawingml/2006/main"/>
           <a:p xmlns:a="http://schemas.openxmlformats.org/drawingml/2006/main">
             <a:pPr algn="l">
+              <a:buNone/>
               <a:defRPr sz="1725" b="1">
                 <a:solidFill>
                   <a:srgbClr val="0B0F19"/>
@@ -3819,6 +6181,7 @@
           <a:lstStyle xmlns:a="http://schemas.openxmlformats.org/drawingml/2006/main"/>
           <a:p xmlns:a="http://schemas.openxmlformats.org/drawingml/2006/main">
             <a:pPr algn="l">
+              <a:buNone/>
               <a:defRPr sz="1575" b="1">
                 <a:solidFill>
                   <a:srgbClr val="0B0F19"/>
@@ -3869,6 +6232,7 @@
           <a:lstStyle xmlns:a="http://schemas.openxmlformats.org/drawingml/2006/main"/>
           <a:p xmlns:a="http://schemas.openxmlformats.org/drawingml/2006/main">
             <a:pPr algn="l">
+              <a:buNone/>
               <a:defRPr sz="1425" b="0">
                 <a:solidFill>
                   <a:srgbClr val="4B5563"/>
@@ -3952,6 +6316,7 @@
           <a:lstStyle xmlns:a="http://schemas.openxmlformats.org/drawingml/2006/main"/>
           <a:p xmlns:a="http://schemas.openxmlformats.org/drawingml/2006/main">
             <a:pPr algn="l">
+              <a:buNone/>
               <a:defRPr sz="1725" b="1">
                 <a:solidFill>
                   <a:srgbClr val="0B0F19"/>
@@ -4002,6 +6367,7 @@
           <a:lstStyle xmlns:a="http://schemas.openxmlformats.org/drawingml/2006/main"/>
           <a:p xmlns:a="http://schemas.openxmlformats.org/drawingml/2006/main">
             <a:pPr algn="l">
+              <a:buNone/>
               <a:defRPr sz="1575" b="1">
                 <a:solidFill>
                   <a:srgbClr val="0B0F19"/>
@@ -4052,6 +6418,7 @@
           <a:lstStyle xmlns:a="http://schemas.openxmlformats.org/drawingml/2006/main"/>
           <a:p xmlns:a="http://schemas.openxmlformats.org/drawingml/2006/main">
             <a:pPr algn="l">
+              <a:buNone/>
               <a:defRPr sz="1425" b="0">
                 <a:solidFill>
                   <a:srgbClr val="4B5563"/>
@@ -4131,6 +6498,7 @@
           <a:lstStyle xmlns:a="http://schemas.openxmlformats.org/drawingml/2006/main"/>
           <a:p xmlns:a="http://schemas.openxmlformats.org/drawingml/2006/main">
             <a:pPr algn="l">
+              <a:buNone/>
               <a:defRPr sz="975" b="1">
                 <a:solidFill>
                   <a:srgbClr val="2563EB"/>
@@ -4181,6 +6549,7 @@
           <a:lstStyle xmlns:a="http://schemas.openxmlformats.org/drawingml/2006/main"/>
           <a:p xmlns:a="http://schemas.openxmlformats.org/drawingml/2006/main">
             <a:pPr algn="l">
+              <a:buNone/>
               <a:defRPr sz="2925" b="1">
                 <a:solidFill>
                   <a:srgbClr val="0B0F19"/>
@@ -4297,6 +6666,7 @@
           <a:lstStyle xmlns:a="http://schemas.openxmlformats.org/drawingml/2006/main"/>
           <a:p xmlns:a="http://schemas.openxmlformats.org/drawingml/2006/main">
             <a:pPr algn="l">
+              <a:buNone/>
               <a:defRPr sz="1950" b="1">
                 <a:solidFill>
                   <a:srgbClr val="2563EB"/>
@@ -4347,6 +6717,7 @@
           <a:lstStyle xmlns:a="http://schemas.openxmlformats.org/drawingml/2006/main"/>
           <a:p xmlns:a="http://schemas.openxmlformats.org/drawingml/2006/main">
             <a:pPr algn="ctr">
+              <a:buNone/>
               <a:defRPr sz="1650" b="0">
                 <a:solidFill>
                   <a:srgbClr val="0B0F19"/>
@@ -4430,6 +6801,7 @@
           <a:lstStyle xmlns:a="http://schemas.openxmlformats.org/drawingml/2006/main"/>
           <a:p xmlns:a="http://schemas.openxmlformats.org/drawingml/2006/main">
             <a:pPr algn="l">
+              <a:buNone/>
               <a:defRPr sz="2100" b="1">
                 <a:solidFill>
                   <a:srgbClr val="2563EB"/>
@@ -4513,6 +6885,7 @@
           <a:lstStyle xmlns:a="http://schemas.openxmlformats.org/drawingml/2006/main"/>
           <a:p xmlns:a="http://schemas.openxmlformats.org/drawingml/2006/main">
             <a:pPr algn="ctr">
+              <a:buNone/>
               <a:defRPr sz="1275" b="1">
                 <a:solidFill>
                   <a:srgbClr val="0B0F19"/>
@@ -4596,6 +6969,7 @@
           <a:lstStyle xmlns:a="http://schemas.openxmlformats.org/drawingml/2006/main"/>
           <a:p xmlns:a="http://schemas.openxmlformats.org/drawingml/2006/main">
             <a:pPr algn="ctr">
+              <a:buNone/>
               <a:defRPr sz="1275" b="1">
                 <a:solidFill>
                   <a:srgbClr val="0B0F19"/>
@@ -4679,6 +7053,7 @@
           <a:lstStyle xmlns:a="http://schemas.openxmlformats.org/drawingml/2006/main"/>
           <a:p xmlns:a="http://schemas.openxmlformats.org/drawingml/2006/main">
             <a:pPr algn="ctr">
+              <a:buNone/>
               <a:defRPr sz="1275" b="1">
                 <a:solidFill>
                   <a:srgbClr val="0B0F19"/>
@@ -4762,6 +7137,7 @@
           <a:lstStyle xmlns:a="http://schemas.openxmlformats.org/drawingml/2006/main"/>
           <a:p xmlns:a="http://schemas.openxmlformats.org/drawingml/2006/main">
             <a:pPr algn="ctr">
+              <a:buNone/>
               <a:defRPr sz="1275" b="1">
                 <a:solidFill>
                   <a:srgbClr val="0B0F19"/>
@@ -4845,6 +7221,7 @@
           <a:lstStyle xmlns:a="http://schemas.openxmlformats.org/drawingml/2006/main"/>
           <a:p xmlns:a="http://schemas.openxmlformats.org/drawingml/2006/main">
             <a:pPr algn="ctr">
+              <a:buNone/>
               <a:defRPr sz="1275" b="1">
                 <a:solidFill>
                   <a:srgbClr val="0B0F19"/>
@@ -4928,6 +7305,7 @@
           <a:lstStyle xmlns:a="http://schemas.openxmlformats.org/drawingml/2006/main"/>
           <a:p xmlns:a="http://schemas.openxmlformats.org/drawingml/2006/main">
             <a:pPr algn="ctr">
+              <a:buNone/>
               <a:defRPr sz="1275" b="1">
                 <a:solidFill>
                   <a:srgbClr val="0B0F19"/>
@@ -5011,6 +7389,7 @@
           <a:lstStyle xmlns:a="http://schemas.openxmlformats.org/drawingml/2006/main"/>
           <a:p xmlns:a="http://schemas.openxmlformats.org/drawingml/2006/main">
             <a:pPr algn="ctr">
+              <a:buNone/>
               <a:defRPr sz="1275" b="1">
                 <a:solidFill>
                   <a:srgbClr val="0B0F19"/>
@@ -5094,6 +7473,7 @@
           <a:lstStyle xmlns:a="http://schemas.openxmlformats.org/drawingml/2006/main"/>
           <a:p xmlns:a="http://schemas.openxmlformats.org/drawingml/2006/main">
             <a:pPr algn="ctr">
+              <a:buNone/>
               <a:defRPr sz="1275" b="1">
                 <a:solidFill>
                   <a:srgbClr val="0B0F19"/>
@@ -5208,6 +7588,7 @@
           <a:lstStyle xmlns:a="http://schemas.openxmlformats.org/drawingml/2006/main"/>
           <a:p xmlns:a="http://schemas.openxmlformats.org/drawingml/2006/main">
             <a:pPr algn="ctr">
+              <a:buNone/>
               <a:defRPr sz="2100" b="1">
                 <a:solidFill>
                   <a:srgbClr val="059669"/>
@@ -5287,6 +7668,7 @@
           <a:lstStyle xmlns:a="http://schemas.openxmlformats.org/drawingml/2006/main"/>
           <a:p xmlns:a="http://schemas.openxmlformats.org/drawingml/2006/main">
             <a:pPr algn="l">
+              <a:buNone/>
               <a:defRPr sz="975" b="1">
                 <a:solidFill>
                   <a:srgbClr val="2563EB"/>
@@ -5337,6 +7719,7 @@
           <a:lstStyle xmlns:a="http://schemas.openxmlformats.org/drawingml/2006/main"/>
           <a:p xmlns:a="http://schemas.openxmlformats.org/drawingml/2006/main">
             <a:pPr algn="l">
+              <a:buNone/>
               <a:defRPr sz="2925" b="1">
                 <a:solidFill>
                   <a:srgbClr val="0B0F19"/>
@@ -5453,6 +7836,7 @@
           <a:lstStyle xmlns:a="http://schemas.openxmlformats.org/drawingml/2006/main"/>
           <a:p xmlns:a="http://schemas.openxmlformats.org/drawingml/2006/main">
             <a:pPr algn="l">
+              <a:buNone/>
               <a:defRPr sz="1500" b="1">
                 <a:solidFill>
                   <a:srgbClr val="FFFFFF"/>
@@ -5503,6 +7887,7 @@
           <a:lstStyle xmlns:a="http://schemas.openxmlformats.org/drawingml/2006/main"/>
           <a:p xmlns:a="http://schemas.openxmlformats.org/drawingml/2006/main">
             <a:pPr algn="l">
+              <a:buNone/>
               <a:defRPr sz="1500" b="1">
                 <a:solidFill>
                   <a:srgbClr val="FFFFFF"/>
@@ -5553,6 +7938,7 @@
           <a:lstStyle xmlns:a="http://schemas.openxmlformats.org/drawingml/2006/main"/>
           <a:p xmlns:a="http://schemas.openxmlformats.org/drawingml/2006/main">
             <a:pPr algn="l">
+              <a:buNone/>
               <a:defRPr sz="1500" b="1">
                 <a:solidFill>
                   <a:srgbClr val="FFFFFF"/>
@@ -5636,6 +8022,7 @@
           <a:lstStyle xmlns:a="http://schemas.openxmlformats.org/drawingml/2006/main"/>
           <a:p xmlns:a="http://schemas.openxmlformats.org/drawingml/2006/main">
             <a:pPr algn="l">
+              <a:buNone/>
               <a:defRPr sz="1425" b="1">
                 <a:solidFill>
                   <a:srgbClr val="0B0F19"/>
@@ -5686,6 +8073,7 @@
           <a:lstStyle xmlns:a="http://schemas.openxmlformats.org/drawingml/2006/main"/>
           <a:p xmlns:a="http://schemas.openxmlformats.org/drawingml/2006/main">
             <a:pPr algn="l">
+              <a:buNone/>
               <a:defRPr sz="1425" b="1">
                 <a:solidFill>
                   <a:srgbClr val="2563EB"/>
@@ -5736,6 +8124,7 @@
           <a:lstStyle xmlns:a="http://schemas.openxmlformats.org/drawingml/2006/main"/>
           <a:p xmlns:a="http://schemas.openxmlformats.org/drawingml/2006/main">
             <a:pPr algn="l">
+              <a:buNone/>
               <a:defRPr sz="1350" b="0">
                 <a:solidFill>
                   <a:srgbClr val="4B5563"/>
@@ -5819,6 +8208,7 @@
           <a:lstStyle xmlns:a="http://schemas.openxmlformats.org/drawingml/2006/main"/>
           <a:p xmlns:a="http://schemas.openxmlformats.org/drawingml/2006/main">
             <a:pPr algn="l">
+              <a:buNone/>
               <a:defRPr sz="1425" b="1">
                 <a:solidFill>
                   <a:srgbClr val="0B0F19"/>
@@ -5869,6 +8259,7 @@
           <a:lstStyle xmlns:a="http://schemas.openxmlformats.org/drawingml/2006/main"/>
           <a:p xmlns:a="http://schemas.openxmlformats.org/drawingml/2006/main">
             <a:pPr algn="l">
+              <a:buNone/>
               <a:defRPr sz="1425" b="1">
                 <a:solidFill>
                   <a:srgbClr val="2563EB"/>
@@ -5919,6 +8310,7 @@
           <a:lstStyle xmlns:a="http://schemas.openxmlformats.org/drawingml/2006/main"/>
           <a:p xmlns:a="http://schemas.openxmlformats.org/drawingml/2006/main">
             <a:pPr algn="l">
+              <a:buNone/>
               <a:defRPr sz="1350" b="0">
                 <a:solidFill>
                   <a:srgbClr val="4B5563"/>
@@ -6002,6 +8394,7 @@
           <a:lstStyle xmlns:a="http://schemas.openxmlformats.org/drawingml/2006/main"/>
           <a:p xmlns:a="http://schemas.openxmlformats.org/drawingml/2006/main">
             <a:pPr algn="l">
+              <a:buNone/>
               <a:defRPr sz="1425" b="1">
                 <a:solidFill>
                   <a:srgbClr val="0B0F19"/>
@@ -6052,6 +8445,7 @@
           <a:lstStyle xmlns:a="http://schemas.openxmlformats.org/drawingml/2006/main"/>
           <a:p xmlns:a="http://schemas.openxmlformats.org/drawingml/2006/main">
             <a:pPr algn="l">
+              <a:buNone/>
               <a:defRPr sz="1425" b="1">
                 <a:solidFill>
                   <a:srgbClr val="2563EB"/>
@@ -6102,6 +8496,7 @@
           <a:lstStyle xmlns:a="http://schemas.openxmlformats.org/drawingml/2006/main"/>
           <a:p xmlns:a="http://schemas.openxmlformats.org/drawingml/2006/main">
             <a:pPr algn="l">
+              <a:buNone/>
               <a:defRPr sz="1350" b="0">
                 <a:solidFill>
                   <a:srgbClr val="4B5563"/>
@@ -6185,6 +8580,7 @@
           <a:lstStyle xmlns:a="http://schemas.openxmlformats.org/drawingml/2006/main"/>
           <a:p xmlns:a="http://schemas.openxmlformats.org/drawingml/2006/main">
             <a:pPr algn="l">
+              <a:buNone/>
               <a:defRPr sz="1425" b="1">
                 <a:solidFill>
                   <a:srgbClr val="0B0F19"/>
@@ -6235,6 +8631,7 @@
           <a:lstStyle xmlns:a="http://schemas.openxmlformats.org/drawingml/2006/main"/>
           <a:p xmlns:a="http://schemas.openxmlformats.org/drawingml/2006/main">
             <a:pPr algn="l">
+              <a:buNone/>
               <a:defRPr sz="1425" b="1">
                 <a:solidFill>
                   <a:srgbClr val="2563EB"/>
@@ -6285,6 +8682,7 @@
           <a:lstStyle xmlns:a="http://schemas.openxmlformats.org/drawingml/2006/main"/>
           <a:p xmlns:a="http://schemas.openxmlformats.org/drawingml/2006/main">
             <a:pPr algn="l">
+              <a:buNone/>
               <a:defRPr sz="1350" b="0">
                 <a:solidFill>
                   <a:srgbClr val="4B5563"/>
@@ -6368,6 +8766,7 @@
           <a:lstStyle xmlns:a="http://schemas.openxmlformats.org/drawingml/2006/main"/>
           <a:p xmlns:a="http://schemas.openxmlformats.org/drawingml/2006/main">
             <a:pPr algn="l">
+              <a:buNone/>
               <a:defRPr sz="1425" b="1">
                 <a:solidFill>
                   <a:srgbClr val="0B0F19"/>
@@ -6418,6 +8817,7 @@
           <a:lstStyle xmlns:a="http://schemas.openxmlformats.org/drawingml/2006/main"/>
           <a:p xmlns:a="http://schemas.openxmlformats.org/drawingml/2006/main">
             <a:pPr algn="l">
+              <a:buNone/>
               <a:defRPr sz="1425" b="1">
                 <a:solidFill>
                   <a:srgbClr val="2563EB"/>
@@ -6468,6 +8868,7 @@
           <a:lstStyle xmlns:a="http://schemas.openxmlformats.org/drawingml/2006/main"/>
           <a:p xmlns:a="http://schemas.openxmlformats.org/drawingml/2006/main">
             <a:pPr algn="l">
+              <a:buNone/>
               <a:defRPr sz="1350" b="0">
                 <a:solidFill>
                   <a:srgbClr val="4B5563"/>
@@ -6551,6 +8952,7 @@
           <a:lstStyle xmlns:a="http://schemas.openxmlformats.org/drawingml/2006/main"/>
           <a:p xmlns:a="http://schemas.openxmlformats.org/drawingml/2006/main">
             <a:pPr algn="l">
+              <a:buNone/>
               <a:defRPr sz="1425" b="1">
                 <a:solidFill>
                   <a:srgbClr val="0B0F19"/>
@@ -6601,6 +9003,7 @@
           <a:lstStyle xmlns:a="http://schemas.openxmlformats.org/drawingml/2006/main"/>
           <a:p xmlns:a="http://schemas.openxmlformats.org/drawingml/2006/main">
             <a:pPr algn="l">
+              <a:buNone/>
               <a:defRPr sz="1425" b="1">
                 <a:solidFill>
                   <a:srgbClr val="2563EB"/>
@@ -6651,6 +9054,7 @@
           <a:lstStyle xmlns:a="http://schemas.openxmlformats.org/drawingml/2006/main"/>
           <a:p xmlns:a="http://schemas.openxmlformats.org/drawingml/2006/main">
             <a:pPr algn="l">
+              <a:buNone/>
               <a:defRPr sz="1350" b="0">
                 <a:solidFill>
                   <a:srgbClr val="4B5563"/>
@@ -6730,6 +9134,7 @@
           <a:lstStyle xmlns:a="http://schemas.openxmlformats.org/drawingml/2006/main"/>
           <a:p xmlns:a="http://schemas.openxmlformats.org/drawingml/2006/main">
             <a:pPr algn="l">
+              <a:buNone/>
               <a:defRPr sz="975" b="1">
                 <a:solidFill>
                   <a:srgbClr val="2563EB"/>
@@ -6780,6 +9185,7 @@
           <a:lstStyle xmlns:a="http://schemas.openxmlformats.org/drawingml/2006/main"/>
           <a:p xmlns:a="http://schemas.openxmlformats.org/drawingml/2006/main">
             <a:pPr algn="l">
+              <a:buNone/>
               <a:defRPr sz="2925" b="1">
                 <a:solidFill>
                   <a:srgbClr val="0B0F19"/>
@@ -6896,6 +9302,7 @@
           <a:lstStyle xmlns:a="http://schemas.openxmlformats.org/drawingml/2006/main"/>
           <a:p xmlns:a="http://schemas.openxmlformats.org/drawingml/2006/main">
             <a:pPr algn="l">
+              <a:buNone/>
               <a:defRPr sz="1350" b="1">
                 <a:solidFill>
                   <a:srgbClr val="2563EB"/>
@@ -6946,6 +9353,7 @@
           <a:lstStyle xmlns:a="http://schemas.openxmlformats.org/drawingml/2006/main"/>
           <a:p xmlns:a="http://schemas.openxmlformats.org/drawingml/2006/main">
             <a:pPr algn="l">
+              <a:buNone/>
               <a:defRPr sz="1500" b="0">
                 <a:solidFill>
                   <a:srgbClr val="0B0F19"/>
@@ -7029,6 +9437,7 @@
           <a:lstStyle xmlns:a="http://schemas.openxmlformats.org/drawingml/2006/main"/>
           <a:p xmlns:a="http://schemas.openxmlformats.org/drawingml/2006/main">
             <a:pPr algn="l">
+              <a:buNone/>
               <a:defRPr sz="1350" b="1">
                 <a:solidFill>
                   <a:srgbClr val="0891B2"/>
@@ -7079,6 +9488,7 @@
           <a:lstStyle xmlns:a="http://schemas.openxmlformats.org/drawingml/2006/main"/>
           <a:p xmlns:a="http://schemas.openxmlformats.org/drawingml/2006/main">
             <a:pPr algn="l">
+              <a:buNone/>
               <a:defRPr sz="1500" b="0">
                 <a:solidFill>
                   <a:srgbClr val="0B0F19"/>
@@ -7162,6 +9572,7 @@
           <a:lstStyle xmlns:a="http://schemas.openxmlformats.org/drawingml/2006/main"/>
           <a:p xmlns:a="http://schemas.openxmlformats.org/drawingml/2006/main">
             <a:pPr algn="l">
+              <a:buNone/>
               <a:defRPr sz="1350" b="1">
                 <a:solidFill>
                   <a:srgbClr val="059669"/>
@@ -7212,6 +9623,7 @@
           <a:lstStyle xmlns:a="http://schemas.openxmlformats.org/drawingml/2006/main"/>
           <a:p xmlns:a="http://schemas.openxmlformats.org/drawingml/2006/main">
             <a:pPr algn="l">
+              <a:buNone/>
               <a:defRPr sz="1500" b="0">
                 <a:solidFill>
                   <a:srgbClr val="0B0F19"/>
@@ -7324,6 +9736,7 @@
           <a:lstStyle xmlns:a="http://schemas.openxmlformats.org/drawingml/2006/main"/>
           <a:p xmlns:a="http://schemas.openxmlformats.org/drawingml/2006/main">
             <a:pPr algn="l">
+              <a:buNone/>
               <a:defRPr sz="2025" b="1">
                 <a:solidFill>
                   <a:srgbClr val="0B0F19"/>
@@ -7407,6 +9820,7 @@
           <a:lstStyle xmlns:a="http://schemas.openxmlformats.org/drawingml/2006/main"/>
           <a:p xmlns:a="http://schemas.openxmlformats.org/drawingml/2006/main">
             <a:pPr algn="l">
+              <a:buNone/>
               <a:defRPr sz="1575" b="0">
                 <a:solidFill>
                   <a:srgbClr val="0B0F19"/>
@@ -7490,6 +9904,7 @@
           <a:lstStyle xmlns:a="http://schemas.openxmlformats.org/drawingml/2006/main"/>
           <a:p xmlns:a="http://schemas.openxmlformats.org/drawingml/2006/main">
             <a:pPr algn="l">
+              <a:buNone/>
               <a:defRPr sz="1575" b="0">
                 <a:solidFill>
                   <a:srgbClr val="0B0F19"/>
@@ -7569,6 +9984,7 @@
           <a:lstStyle xmlns:a="http://schemas.openxmlformats.org/drawingml/2006/main"/>
           <a:p xmlns:a="http://schemas.openxmlformats.org/drawingml/2006/main">
             <a:pPr algn="l">
+              <a:buNone/>
               <a:defRPr sz="975" b="1">
                 <a:solidFill>
                   <a:srgbClr val="2563EB"/>
@@ -7619,6 +10035,7 @@
           <a:lstStyle xmlns:a="http://schemas.openxmlformats.org/drawingml/2006/main"/>
           <a:p xmlns:a="http://schemas.openxmlformats.org/drawingml/2006/main">
             <a:pPr algn="l">
+              <a:buNone/>
               <a:defRPr sz="2925" b="1">
                 <a:solidFill>
                   <a:srgbClr val="0B0F19"/>
@@ -7735,6 +10152,7 @@
           <a:lstStyle xmlns:a="http://schemas.openxmlformats.org/drawingml/2006/main"/>
           <a:p xmlns:a="http://schemas.openxmlformats.org/drawingml/2006/main">
             <a:pPr algn="ctr">
+              <a:buNone/>
               <a:defRPr sz="1575" b="1">
                 <a:solidFill>
                   <a:srgbClr val="0B0F19"/>
@@ -7785,6 +10203,7 @@
           <a:lstStyle xmlns:a="http://schemas.openxmlformats.org/drawingml/2006/main"/>
           <a:p xmlns:a="http://schemas.openxmlformats.org/drawingml/2006/main">
             <a:pPr algn="ctr">
+              <a:buNone/>
               <a:defRPr sz="3000" b="1">
                 <a:solidFill>
                   <a:srgbClr val="2563EB"/>
@@ -7835,6 +10254,7 @@
           <a:lstStyle xmlns:a="http://schemas.openxmlformats.org/drawingml/2006/main"/>
           <a:p xmlns:a="http://schemas.openxmlformats.org/drawingml/2006/main">
             <a:pPr algn="ctr">
+              <a:buNone/>
               <a:defRPr sz="1200" b="0">
                 <a:solidFill>
                   <a:srgbClr val="4B5563"/>
@@ -7918,6 +10338,7 @@
           <a:lstStyle xmlns:a="http://schemas.openxmlformats.org/drawingml/2006/main"/>
           <a:p xmlns:a="http://schemas.openxmlformats.org/drawingml/2006/main">
             <a:pPr algn="ctr">
+              <a:buNone/>
               <a:defRPr sz="1575" b="1">
                 <a:solidFill>
                   <a:srgbClr val="0B0F19"/>
@@ -7968,6 +10389,7 @@
           <a:lstStyle xmlns:a="http://schemas.openxmlformats.org/drawingml/2006/main"/>
           <a:p xmlns:a="http://schemas.openxmlformats.org/drawingml/2006/main">
             <a:pPr algn="ctr">
+              <a:buNone/>
               <a:defRPr sz="3000" b="1">
                 <a:solidFill>
                   <a:srgbClr val="2563EB"/>
@@ -8018,6 +10440,7 @@
           <a:lstStyle xmlns:a="http://schemas.openxmlformats.org/drawingml/2006/main"/>
           <a:p xmlns:a="http://schemas.openxmlformats.org/drawingml/2006/main">
             <a:pPr algn="ctr">
+              <a:buNone/>
               <a:defRPr sz="1200" b="0">
                 <a:solidFill>
                   <a:srgbClr val="4B5563"/>
@@ -8101,6 +10524,7 @@
           <a:lstStyle xmlns:a="http://schemas.openxmlformats.org/drawingml/2006/main"/>
           <a:p xmlns:a="http://schemas.openxmlformats.org/drawingml/2006/main">
             <a:pPr algn="ctr">
+              <a:buNone/>
               <a:defRPr sz="1575" b="1">
                 <a:solidFill>
                   <a:srgbClr val="0B0F19"/>
@@ -8151,6 +10575,7 @@
           <a:lstStyle xmlns:a="http://schemas.openxmlformats.org/drawingml/2006/main"/>
           <a:p xmlns:a="http://schemas.openxmlformats.org/drawingml/2006/main">
             <a:pPr algn="ctr">
+              <a:buNone/>
               <a:defRPr sz="3000" b="1">
                 <a:solidFill>
                   <a:srgbClr val="2563EB"/>
@@ -8201,6 +10626,7 @@
           <a:lstStyle xmlns:a="http://schemas.openxmlformats.org/drawingml/2006/main"/>
           <a:p xmlns:a="http://schemas.openxmlformats.org/drawingml/2006/main">
             <a:pPr algn="ctr">
+              <a:buNone/>
               <a:defRPr sz="1200" b="0">
                 <a:solidFill>
                   <a:srgbClr val="4B5563"/>
@@ -8284,6 +10710,7 @@
           <a:lstStyle xmlns:a="http://schemas.openxmlformats.org/drawingml/2006/main"/>
           <a:p xmlns:a="http://schemas.openxmlformats.org/drawingml/2006/main">
             <a:pPr algn="ctr">
+              <a:buNone/>
               <a:defRPr sz="1575" b="1">
                 <a:solidFill>
                   <a:srgbClr val="0B0F19"/>
@@ -8334,6 +10761,7 @@
           <a:lstStyle xmlns:a="http://schemas.openxmlformats.org/drawingml/2006/main"/>
           <a:p xmlns:a="http://schemas.openxmlformats.org/drawingml/2006/main">
             <a:pPr algn="ctr">
+              <a:buNone/>
               <a:defRPr sz="3000" b="1">
                 <a:solidFill>
                   <a:srgbClr val="2563EB"/>
@@ -8384,6 +10812,7 @@
           <a:lstStyle xmlns:a="http://schemas.openxmlformats.org/drawingml/2006/main"/>
           <a:p xmlns:a="http://schemas.openxmlformats.org/drawingml/2006/main">
             <a:pPr algn="ctr">
+              <a:buNone/>
               <a:defRPr sz="1200" b="0">
                 <a:solidFill>
                   <a:srgbClr val="4B5563"/>
@@ -8467,6 +10896,7 @@
           <a:lstStyle xmlns:a="http://schemas.openxmlformats.org/drawingml/2006/main"/>
           <a:p xmlns:a="http://schemas.openxmlformats.org/drawingml/2006/main">
             <a:pPr algn="ctr">
+              <a:buNone/>
               <a:defRPr sz="1575" b="1">
                 <a:solidFill>
                   <a:srgbClr val="0B0F19"/>
@@ -8517,6 +10947,7 @@
           <a:lstStyle xmlns:a="http://schemas.openxmlformats.org/drawingml/2006/main"/>
           <a:p xmlns:a="http://schemas.openxmlformats.org/drawingml/2006/main">
             <a:pPr algn="ctr">
+              <a:buNone/>
               <a:defRPr sz="3000" b="1">
                 <a:solidFill>
                   <a:srgbClr val="2563EB"/>
@@ -8567,6 +10998,7 @@
           <a:lstStyle xmlns:a="http://schemas.openxmlformats.org/drawingml/2006/main"/>
           <a:p xmlns:a="http://schemas.openxmlformats.org/drawingml/2006/main">
             <a:pPr algn="ctr">
+              <a:buNone/>
               <a:defRPr sz="1200" b="0">
                 <a:solidFill>
                   <a:srgbClr val="4B5563"/>
@@ -8650,6 +11082,7 @@
           <a:lstStyle xmlns:a="http://schemas.openxmlformats.org/drawingml/2006/main"/>
           <a:p xmlns:a="http://schemas.openxmlformats.org/drawingml/2006/main">
             <a:pPr algn="ctr">
+              <a:buNone/>
               <a:defRPr sz="1875" b="1">
                 <a:solidFill>
                   <a:srgbClr val="2563EB"/>
@@ -8729,6 +11162,7 @@
           <a:lstStyle xmlns:a="http://schemas.openxmlformats.org/drawingml/2006/main"/>
           <a:p xmlns:a="http://schemas.openxmlformats.org/drawingml/2006/main">
             <a:pPr algn="l">
+              <a:buNone/>
               <a:defRPr sz="975" b="1">
                 <a:solidFill>
                   <a:srgbClr val="2563EB"/>
@@ -8779,6 +11213,7 @@
           <a:lstStyle xmlns:a="http://schemas.openxmlformats.org/drawingml/2006/main"/>
           <a:p xmlns:a="http://schemas.openxmlformats.org/drawingml/2006/main">
             <a:pPr algn="l">
+              <a:buNone/>
               <a:defRPr sz="2925" b="1">
                 <a:solidFill>
                   <a:srgbClr val="0B0F19"/>
@@ -8895,6 +11330,7 @@
           <a:lstStyle xmlns:a="http://schemas.openxmlformats.org/drawingml/2006/main"/>
           <a:p xmlns:a="http://schemas.openxmlformats.org/drawingml/2006/main">
             <a:pPr algn="ctr">
+              <a:buNone/>
               <a:defRPr sz="1425" b="1">
                 <a:solidFill>
                   <a:srgbClr val="0B0F19"/>
@@ -9009,6 +11445,7 @@
           <a:lstStyle xmlns:a="http://schemas.openxmlformats.org/drawingml/2006/main"/>
           <a:p xmlns:a="http://schemas.openxmlformats.org/drawingml/2006/main">
             <a:pPr algn="ctr">
+              <a:buNone/>
               <a:defRPr sz="1425" b="1">
                 <a:solidFill>
                   <a:srgbClr val="0B0F19"/>
@@ -9123,6 +11560,7 @@
           <a:lstStyle xmlns:a="http://schemas.openxmlformats.org/drawingml/2006/main"/>
           <a:p xmlns:a="http://schemas.openxmlformats.org/drawingml/2006/main">
             <a:pPr algn="ctr">
+              <a:buNone/>
               <a:defRPr sz="1425" b="1">
                 <a:solidFill>
                   <a:srgbClr val="0B0F19"/>
@@ -9237,6 +11675,7 @@
           <a:lstStyle xmlns:a="http://schemas.openxmlformats.org/drawingml/2006/main"/>
           <a:p xmlns:a="http://schemas.openxmlformats.org/drawingml/2006/main">
             <a:pPr algn="ctr">
+              <a:buNone/>
               <a:defRPr sz="1425" b="1">
                 <a:solidFill>
                   <a:srgbClr val="0B0F19"/>
@@ -9351,6 +11790,7 @@
           <a:lstStyle xmlns:a="http://schemas.openxmlformats.org/drawingml/2006/main"/>
           <a:p xmlns:a="http://schemas.openxmlformats.org/drawingml/2006/main">
             <a:pPr algn="ctr">
+              <a:buNone/>
               <a:defRPr sz="1425" b="1">
                 <a:solidFill>
                   <a:srgbClr val="0B0F19"/>
@@ -9465,6 +11905,7 @@
           <a:lstStyle xmlns:a="http://schemas.openxmlformats.org/drawingml/2006/main"/>
           <a:p xmlns:a="http://schemas.openxmlformats.org/drawingml/2006/main">
             <a:pPr algn="ctr">
+              <a:buNone/>
               <a:defRPr sz="1425" b="1">
                 <a:solidFill>
                   <a:srgbClr val="059669"/>
@@ -9515,6 +11956,7 @@
           <a:lstStyle xmlns:a="http://schemas.openxmlformats.org/drawingml/2006/main"/>
           <a:p xmlns:a="http://schemas.openxmlformats.org/drawingml/2006/main">
             <a:pPr algn="l">
+              <a:buNone/>
               <a:defRPr sz="2100" b="1">
                 <a:solidFill>
                   <a:srgbClr val="0B0F19"/>
@@ -9598,6 +12040,7 @@
           <a:lstStyle xmlns:a="http://schemas.openxmlformats.org/drawingml/2006/main"/>
           <a:p xmlns:a="http://schemas.openxmlformats.org/drawingml/2006/main">
             <a:pPr algn="l">
+              <a:buNone/>
               <a:defRPr sz="1575" b="0">
                 <a:solidFill>
                   <a:srgbClr val="0B0F19"/>
@@ -9681,6 +12124,7 @@
           <a:lstStyle xmlns:a="http://schemas.openxmlformats.org/drawingml/2006/main"/>
           <a:p xmlns:a="http://schemas.openxmlformats.org/drawingml/2006/main">
             <a:pPr algn="l">
+              <a:buNone/>
               <a:defRPr sz="1575" b="0">
                 <a:solidFill>
                   <a:srgbClr val="0B0F19"/>
@@ -9760,6 +12204,7 @@
           <a:lstStyle xmlns:a="http://schemas.openxmlformats.org/drawingml/2006/main"/>
           <a:p xmlns:a="http://schemas.openxmlformats.org/drawingml/2006/main">
             <a:pPr algn="l">
+              <a:buNone/>
               <a:defRPr sz="975" b="1">
                 <a:solidFill>
                   <a:srgbClr val="2563EB"/>
@@ -9810,6 +12255,7 @@
           <a:lstStyle xmlns:a="http://schemas.openxmlformats.org/drawingml/2006/main"/>
           <a:p xmlns:a="http://schemas.openxmlformats.org/drawingml/2006/main">
             <a:pPr algn="l">
+              <a:buNone/>
               <a:defRPr sz="2925" b="1">
                 <a:solidFill>
                   <a:srgbClr val="0B0F19"/>
@@ -9926,6 +12372,7 @@
           <a:lstStyle xmlns:a="http://schemas.openxmlformats.org/drawingml/2006/main"/>
           <a:p xmlns:a="http://schemas.openxmlformats.org/drawingml/2006/main">
             <a:pPr algn="l">
+              <a:buNone/>
               <a:defRPr sz="1350" b="1">
                 <a:solidFill>
                   <a:srgbClr val="2563EB"/>
@@ -9976,6 +12423,7 @@
           <a:lstStyle xmlns:a="http://schemas.openxmlformats.org/drawingml/2006/main"/>
           <a:p xmlns:a="http://schemas.openxmlformats.org/drawingml/2006/main">
             <a:pPr algn="l">
+              <a:buNone/>
               <a:defRPr sz="1500" b="0">
                 <a:solidFill>
                   <a:srgbClr val="0B0F19"/>
@@ -10059,6 +12507,7 @@
           <a:lstStyle xmlns:a="http://schemas.openxmlformats.org/drawingml/2006/main"/>
           <a:p xmlns:a="http://schemas.openxmlformats.org/drawingml/2006/main">
             <a:pPr algn="l">
+              <a:buNone/>
               <a:defRPr sz="1350" b="1">
                 <a:solidFill>
                   <a:srgbClr val="0891B2"/>
@@ -10109,6 +12558,7 @@
           <a:lstStyle xmlns:a="http://schemas.openxmlformats.org/drawingml/2006/main"/>
           <a:p xmlns:a="http://schemas.openxmlformats.org/drawingml/2006/main">
             <a:pPr algn="l">
+              <a:buNone/>
               <a:defRPr sz="1500" b="0">
                 <a:solidFill>
                   <a:srgbClr val="0B0F19"/>
@@ -10192,6 +12642,7 @@
           <a:lstStyle xmlns:a="http://schemas.openxmlformats.org/drawingml/2006/main"/>
           <a:p xmlns:a="http://schemas.openxmlformats.org/drawingml/2006/main">
             <a:pPr algn="l">
+              <a:buNone/>
               <a:defRPr sz="1350" b="1">
                 <a:solidFill>
                   <a:srgbClr val="D97706"/>
@@ -10242,6 +12693,7 @@
           <a:lstStyle xmlns:a="http://schemas.openxmlformats.org/drawingml/2006/main"/>
           <a:p xmlns:a="http://schemas.openxmlformats.org/drawingml/2006/main">
             <a:pPr algn="l">
+              <a:buNone/>
               <a:defRPr sz="1500" b="0">
                 <a:solidFill>
                   <a:srgbClr val="0B0F19"/>
@@ -10325,6 +12777,7 @@
           <a:lstStyle xmlns:a="http://schemas.openxmlformats.org/drawingml/2006/main"/>
           <a:p xmlns:a="http://schemas.openxmlformats.org/drawingml/2006/main">
             <a:pPr algn="l">
+              <a:buNone/>
               <a:defRPr sz="1350" b="1">
                 <a:solidFill>
                   <a:srgbClr val="059669"/>
@@ -10375,6 +12828,7 @@
           <a:lstStyle xmlns:a="http://schemas.openxmlformats.org/drawingml/2006/main"/>
           <a:p xmlns:a="http://schemas.openxmlformats.org/drawingml/2006/main">
             <a:pPr algn="l">
+              <a:buNone/>
               <a:defRPr sz="1500" b="0">
                 <a:solidFill>
                   <a:srgbClr val="0B0F19"/>
@@ -10425,6 +12879,7 @@
           <a:lstStyle xmlns:a="http://schemas.openxmlformats.org/drawingml/2006/main"/>
           <a:p xmlns:a="http://schemas.openxmlformats.org/drawingml/2006/main">
             <a:pPr algn="l">
+              <a:buNone/>
               <a:defRPr sz="2100" b="1">
                 <a:solidFill>
                   <a:srgbClr val="0B0F19"/>
@@ -10508,6 +12963,7 @@
           <a:lstStyle xmlns:a="http://schemas.openxmlformats.org/drawingml/2006/main"/>
           <a:p xmlns:a="http://schemas.openxmlformats.org/drawingml/2006/main">
             <a:pPr algn="l">
+              <a:buNone/>
               <a:defRPr sz="1575" b="0">
                 <a:solidFill>
                   <a:srgbClr val="0B0F19"/>
@@ -10591,6 +13047,7 @@
           <a:lstStyle xmlns:a="http://schemas.openxmlformats.org/drawingml/2006/main"/>
           <a:p xmlns:a="http://schemas.openxmlformats.org/drawingml/2006/main">
             <a:pPr algn="l">
+              <a:buNone/>
               <a:defRPr sz="1575" b="0">
                 <a:solidFill>
                   <a:srgbClr val="0B0F19"/>
@@ -10670,6 +13127,7 @@
           <a:lstStyle xmlns:a="http://schemas.openxmlformats.org/drawingml/2006/main"/>
           <a:p xmlns:a="http://schemas.openxmlformats.org/drawingml/2006/main">
             <a:pPr algn="l">
+              <a:buNone/>
               <a:defRPr sz="975" b="1">
                 <a:solidFill>
                   <a:srgbClr val="2563EB"/>
@@ -10720,6 +13178,7 @@
           <a:lstStyle xmlns:a="http://schemas.openxmlformats.org/drawingml/2006/main"/>
           <a:p xmlns:a="http://schemas.openxmlformats.org/drawingml/2006/main">
             <a:pPr algn="l">
+              <a:buNone/>
               <a:defRPr sz="2925" b="1">
                 <a:solidFill>
                   <a:srgbClr val="0B0F19"/>
@@ -10836,6 +13295,7 @@
           <a:lstStyle xmlns:a="http://schemas.openxmlformats.org/drawingml/2006/main"/>
           <a:p xmlns:a="http://schemas.openxmlformats.org/drawingml/2006/main">
             <a:pPr algn="ctr">
+              <a:buNone/>
               <a:defRPr sz="1800" b="1">
                 <a:solidFill>
                   <a:srgbClr val="0B0F19"/>
@@ -10950,6 +13410,7 @@
           <a:lstStyle xmlns:a="http://schemas.openxmlformats.org/drawingml/2006/main"/>
           <a:p xmlns:a="http://schemas.openxmlformats.org/drawingml/2006/main">
             <a:pPr algn="ctr">
+              <a:buNone/>
               <a:defRPr sz="1800" b="1">
                 <a:solidFill>
                   <a:srgbClr val="DC2626"/>
@@ -11000,6 +13461,7 @@
           <a:lstStyle xmlns:a="http://schemas.openxmlformats.org/drawingml/2006/main"/>
           <a:p xmlns:a="http://schemas.openxmlformats.org/drawingml/2006/main">
             <a:pPr algn="ctr">
+              <a:buNone/>
               <a:defRPr sz="1425" b="0">
                 <a:solidFill>
                   <a:srgbClr val="0B0F19"/>
@@ -11017,6 +13479,7 @@
           </a:p>
           <a:p xmlns:a="http://schemas.openxmlformats.org/drawingml/2006/main">
             <a:pPr algn="ctr">
+              <a:buNone/>
               <a:defRPr sz="1425" b="0">
                 <a:solidFill>
                   <a:srgbClr val="0B0F19"/>
@@ -11034,6 +13497,7 @@
           </a:p>
           <a:p xmlns:a="http://schemas.openxmlformats.org/drawingml/2006/main">
             <a:pPr algn="ctr">
+              <a:buNone/>
               <a:defRPr sz="1425" b="0">
                 <a:solidFill>
                   <a:srgbClr val="0B0F19"/>
@@ -11148,6 +13612,7 @@
           <a:lstStyle xmlns:a="http://schemas.openxmlformats.org/drawingml/2006/main"/>
           <a:p xmlns:a="http://schemas.openxmlformats.org/drawingml/2006/main">
             <a:pPr algn="ctr">
+              <a:buNone/>
               <a:defRPr sz="1800" b="1">
                 <a:solidFill>
                   <a:srgbClr val="059669"/>
@@ -11231,6 +13696,7 @@
           <a:lstStyle xmlns:a="http://schemas.openxmlformats.org/drawingml/2006/main"/>
           <a:p xmlns:a="http://schemas.openxmlformats.org/drawingml/2006/main">
             <a:pPr algn="l">
+              <a:buNone/>
               <a:defRPr sz="1575" b="0">
                 <a:solidFill>
                   <a:srgbClr val="0B0F19"/>
@@ -11314,6 +13780,7 @@
           <a:lstStyle xmlns:a="http://schemas.openxmlformats.org/drawingml/2006/main"/>
           <a:p xmlns:a="http://schemas.openxmlformats.org/drawingml/2006/main">
             <a:pPr algn="l">
+              <a:buNone/>
               <a:defRPr sz="1575" b="0">
                 <a:solidFill>
                   <a:srgbClr val="0B0F19"/>
@@ -11393,6 +13860,7 @@
           <a:lstStyle xmlns:a="http://schemas.openxmlformats.org/drawingml/2006/main"/>
           <a:p xmlns:a="http://schemas.openxmlformats.org/drawingml/2006/main">
             <a:pPr algn="l">
+              <a:buNone/>
               <a:defRPr sz="975" b="1">
                 <a:solidFill>
                   <a:srgbClr val="2563EB"/>
@@ -11443,6 +13911,7 @@
           <a:lstStyle xmlns:a="http://schemas.openxmlformats.org/drawingml/2006/main"/>
           <a:p xmlns:a="http://schemas.openxmlformats.org/drawingml/2006/main">
             <a:pPr algn="l">
+              <a:buNone/>
               <a:defRPr sz="2925" b="1">
                 <a:solidFill>
                   <a:srgbClr val="0B0F19"/>
@@ -11559,6 +14028,7 @@
           <a:lstStyle xmlns:a="http://schemas.openxmlformats.org/drawingml/2006/main"/>
           <a:p xmlns:a="http://schemas.openxmlformats.org/drawingml/2006/main">
             <a:pPr algn="l">
+              <a:buNone/>
               <a:defRPr sz="1650" b="1">
                 <a:solidFill>
                   <a:srgbClr val="DC2626"/>
@@ -11609,6 +14079,7 @@
           <a:lstStyle xmlns:a="http://schemas.openxmlformats.org/drawingml/2006/main"/>
           <a:p xmlns:a="http://schemas.openxmlformats.org/drawingml/2006/main">
             <a:pPr algn="l">
+              <a:buNone/>
               <a:defRPr sz="1500" b="1">
                 <a:solidFill>
                   <a:srgbClr val="0B0F19"/>
@@ -11659,6 +14130,7 @@
           <a:lstStyle xmlns:a="http://schemas.openxmlformats.org/drawingml/2006/main"/>
           <a:p xmlns:a="http://schemas.openxmlformats.org/drawingml/2006/main">
             <a:pPr algn="l">
+              <a:buNone/>
               <a:defRPr sz="1350" b="0">
                 <a:solidFill>
                   <a:srgbClr val="4B5563"/>
@@ -11742,6 +14214,7 @@
           <a:lstStyle xmlns:a="http://schemas.openxmlformats.org/drawingml/2006/main"/>
           <a:p xmlns:a="http://schemas.openxmlformats.org/drawingml/2006/main">
             <a:pPr algn="l">
+              <a:buNone/>
               <a:defRPr sz="1650" b="1">
                 <a:solidFill>
                   <a:srgbClr val="DC2626"/>
@@ -11792,6 +14265,7 @@
           <a:lstStyle xmlns:a="http://schemas.openxmlformats.org/drawingml/2006/main"/>
           <a:p xmlns:a="http://schemas.openxmlformats.org/drawingml/2006/main">
             <a:pPr algn="l">
+              <a:buNone/>
               <a:defRPr sz="1500" b="1">
                 <a:solidFill>
                   <a:srgbClr val="0B0F19"/>
@@ -11842,6 +14316,7 @@
           <a:lstStyle xmlns:a="http://schemas.openxmlformats.org/drawingml/2006/main"/>
           <a:p xmlns:a="http://schemas.openxmlformats.org/drawingml/2006/main">
             <a:pPr algn="l">
+              <a:buNone/>
               <a:defRPr sz="1350" b="0">
                 <a:solidFill>
                   <a:srgbClr val="4B5563"/>
@@ -11925,6 +14400,7 @@
           <a:lstStyle xmlns:a="http://schemas.openxmlformats.org/drawingml/2006/main"/>
           <a:p xmlns:a="http://schemas.openxmlformats.org/drawingml/2006/main">
             <a:pPr algn="l">
+              <a:buNone/>
               <a:defRPr sz="1650" b="1">
                 <a:solidFill>
                   <a:srgbClr val="2563EB"/>
@@ -11975,6 +14451,7 @@
           <a:lstStyle xmlns:a="http://schemas.openxmlformats.org/drawingml/2006/main"/>
           <a:p xmlns:a="http://schemas.openxmlformats.org/drawingml/2006/main">
             <a:pPr algn="l">
+              <a:buNone/>
               <a:defRPr sz="1500" b="1">
                 <a:solidFill>
                   <a:srgbClr val="0B0F19"/>
@@ -12025,6 +14502,7 @@
           <a:lstStyle xmlns:a="http://schemas.openxmlformats.org/drawingml/2006/main"/>
           <a:p xmlns:a="http://schemas.openxmlformats.org/drawingml/2006/main">
             <a:pPr algn="l">
+              <a:buNone/>
               <a:defRPr sz="1350" b="0">
                 <a:solidFill>
                   <a:srgbClr val="4B5563"/>
@@ -12108,6 +14586,7 @@
           <a:lstStyle xmlns:a="http://schemas.openxmlformats.org/drawingml/2006/main"/>
           <a:p xmlns:a="http://schemas.openxmlformats.org/drawingml/2006/main">
             <a:pPr algn="l">
+              <a:buNone/>
               <a:defRPr sz="1650" b="1">
                 <a:solidFill>
                   <a:srgbClr val="059669"/>
@@ -12158,6 +14637,7 @@
           <a:lstStyle xmlns:a="http://schemas.openxmlformats.org/drawingml/2006/main"/>
           <a:p xmlns:a="http://schemas.openxmlformats.org/drawingml/2006/main">
             <a:pPr algn="l">
+              <a:buNone/>
               <a:defRPr sz="1500" b="1">
                 <a:solidFill>
                   <a:srgbClr val="0B0F19"/>
@@ -12208,6 +14688,7 @@
           <a:lstStyle xmlns:a="http://schemas.openxmlformats.org/drawingml/2006/main"/>
           <a:p xmlns:a="http://schemas.openxmlformats.org/drawingml/2006/main">
             <a:pPr algn="l">
+              <a:buNone/>
               <a:defRPr sz="1350" b="0">
                 <a:solidFill>
                   <a:srgbClr val="4B5563"/>
@@ -12291,6 +14772,7 @@
           <a:lstStyle xmlns:a="http://schemas.openxmlformats.org/drawingml/2006/main"/>
           <a:p xmlns:a="http://schemas.openxmlformats.org/drawingml/2006/main">
             <a:pPr algn="l">
+              <a:buNone/>
               <a:defRPr sz="1650" b="1">
                 <a:solidFill>
                   <a:srgbClr val="059669"/>
@@ -12341,6 +14823,7 @@
           <a:lstStyle xmlns:a="http://schemas.openxmlformats.org/drawingml/2006/main"/>
           <a:p xmlns:a="http://schemas.openxmlformats.org/drawingml/2006/main">
             <a:pPr algn="l">
+              <a:buNone/>
               <a:defRPr sz="1500" b="1">
                 <a:solidFill>
                   <a:srgbClr val="0B0F19"/>
@@ -12391,6 +14874,7 @@
           <a:lstStyle xmlns:a="http://schemas.openxmlformats.org/drawingml/2006/main"/>
           <a:p xmlns:a="http://schemas.openxmlformats.org/drawingml/2006/main">
             <a:pPr algn="l">
+              <a:buNone/>
               <a:defRPr sz="1350" b="0">
                 <a:solidFill>
                   <a:srgbClr val="4B5563"/>
@@ -12441,6 +14925,7 @@
           <a:lstStyle xmlns:a="http://schemas.openxmlformats.org/drawingml/2006/main"/>
           <a:p xmlns:a="http://schemas.openxmlformats.org/drawingml/2006/main">
             <a:pPr algn="l">
+              <a:buNone/>
               <a:defRPr sz="1725" b="1">
                 <a:solidFill>
                   <a:srgbClr val="2563EB"/>

</xml_diff>

<commit_message>
Add memory policy to production harness checklist
</commit_message>
<xml_diff>
--- a/presentations/harness-engineering-principles-demo.pptx
+++ b/presentations/harness-engineering-principles-demo.pptx
@@ -2,24 +2,24 @@
 <file path=ppt/presentation.xml><?xml version="1.0" encoding="utf-8"?>
 <p:presentation xmlns:p="http://schemas.openxmlformats.org/presentationml/2006/main">
   <p:sldMasterIdLst>
-    <p:sldMasterId xmlns:r="http://schemas.openxmlformats.org/officeDocument/2006/relationships" id="2147483648" r:id="R84b1d69a374348c7"/>
+    <p:sldMasterId xmlns:r="http://schemas.openxmlformats.org/officeDocument/2006/relationships" id="2147483648" r:id="R5ec0d80ebbe048ce"/>
   </p:sldMasterIdLst>
   <p:notesMasterIdLst>
-    <p:notesMasterId xmlns:r="http://schemas.openxmlformats.org/officeDocument/2006/relationships" r:id="R95747480da5f4136"/>
+    <p:notesMasterId xmlns:r="http://schemas.openxmlformats.org/officeDocument/2006/relationships" r:id="Rb08a92d8785541ad"/>
   </p:notesMasterIdLst>
   <p:sldIdLst>
-    <p:sldId xmlns:r="http://schemas.openxmlformats.org/officeDocument/2006/relationships" id="256" r:id="Rcd4e3944d9ef475a"/>
-    <p:sldId xmlns:r="http://schemas.openxmlformats.org/officeDocument/2006/relationships" id="257" r:id="R612a234503f14f3f"/>
-    <p:sldId xmlns:r="http://schemas.openxmlformats.org/officeDocument/2006/relationships" id="258" r:id="Rfb2d4dd329b94b66"/>
-    <p:sldId xmlns:r="http://schemas.openxmlformats.org/officeDocument/2006/relationships" id="259" r:id="Rc7c9dbac6c5c4d2a"/>
-    <p:sldId xmlns:r="http://schemas.openxmlformats.org/officeDocument/2006/relationships" id="260" r:id="R89dec0b03ef34104"/>
-    <p:sldId xmlns:r="http://schemas.openxmlformats.org/officeDocument/2006/relationships" id="261" r:id="R12fa739939454536"/>
-    <p:sldId xmlns:r="http://schemas.openxmlformats.org/officeDocument/2006/relationships" id="262" r:id="R19acd7defdae425a"/>
-    <p:sldId xmlns:r="http://schemas.openxmlformats.org/officeDocument/2006/relationships" id="263" r:id="Rafb8b2c490fe4868"/>
-    <p:sldId xmlns:r="http://schemas.openxmlformats.org/officeDocument/2006/relationships" id="264" r:id="Rfc999b86680d4adb"/>
-    <p:sldId xmlns:r="http://schemas.openxmlformats.org/officeDocument/2006/relationships" id="265" r:id="Red2115ba255d4b96"/>
-    <p:sldId xmlns:r="http://schemas.openxmlformats.org/officeDocument/2006/relationships" id="266" r:id="R6d9de5c0e2a24399"/>
-    <p:sldId xmlns:r="http://schemas.openxmlformats.org/officeDocument/2006/relationships" id="267" r:id="Ra7782c26ca914996"/>
+    <p:sldId xmlns:r="http://schemas.openxmlformats.org/officeDocument/2006/relationships" id="256" r:id="R255745a229644485"/>
+    <p:sldId xmlns:r="http://schemas.openxmlformats.org/officeDocument/2006/relationships" id="257" r:id="R247148b62d7149cd"/>
+    <p:sldId xmlns:r="http://schemas.openxmlformats.org/officeDocument/2006/relationships" id="258" r:id="R08d3e30a5f9e4082"/>
+    <p:sldId xmlns:r="http://schemas.openxmlformats.org/officeDocument/2006/relationships" id="259" r:id="Ra462a251996c4ec2"/>
+    <p:sldId xmlns:r="http://schemas.openxmlformats.org/officeDocument/2006/relationships" id="260" r:id="R094e05244a4e4475"/>
+    <p:sldId xmlns:r="http://schemas.openxmlformats.org/officeDocument/2006/relationships" id="261" r:id="R184705da06fe4009"/>
+    <p:sldId xmlns:r="http://schemas.openxmlformats.org/officeDocument/2006/relationships" id="262" r:id="Rf1085d2b969b400c"/>
+    <p:sldId xmlns:r="http://schemas.openxmlformats.org/officeDocument/2006/relationships" id="263" r:id="R9b84f7e0901443bb"/>
+    <p:sldId xmlns:r="http://schemas.openxmlformats.org/officeDocument/2006/relationships" id="264" r:id="R1356a33ac8374824"/>
+    <p:sldId xmlns:r="http://schemas.openxmlformats.org/officeDocument/2006/relationships" id="265" r:id="Rc0d63264c5184df1"/>
+    <p:sldId xmlns:r="http://schemas.openxmlformats.org/officeDocument/2006/relationships" id="266" r:id="Rc60830892c0746dd"/>
+    <p:sldId xmlns:r="http://schemas.openxmlformats.org/officeDocument/2006/relationships" id="267" r:id="Rf0bddf7fb1ba4644"/>
   </p:sldIdLst>
   <p:sldSz cx="12192000" cy="6858000"/>
   <p:notesSz cx="6858000" cy="9144000"/>
@@ -623,27 +623,27 @@
           </a:p>
           <a:p xmlns:a="http://schemas.openxmlformats.org/drawingml/2006/main">
             <a:r>
-              <a:t>OpenAI, A practical guide to building agents: recommends defining tools/instructions/orchestration, using evals before optimizing model cost/latency, applying layered guardrails, and planning human intervention for failure thresholds and high-risk actions. https://openai.com/business/guides-and-resources/a-practical-guide-to-building-ai-agents/</a:t>
-            </a:r>
-          </a:p>
-          <a:p xmlns:a="http://schemas.openxmlformats.org/drawingml/2006/main">
-            <a:r>
-              <a:t>OpenAI Agents SDK guardrails docs: input, output, and tool guardrails can run at workflow boundaries and around function-tool invocation. https://openai.github.io/openai-agents-js/guides/guardrails/</a:t>
-            </a:r>
-          </a:p>
-          <a:p xmlns:a="http://schemas.openxmlformats.org/drawingml/2006/main">
-            <a:r>
-              <a:t>Anthropic, Building effective agents: start with the simplest solution, use augmented LLM/workflow/agent patterns, and apply evaluator-optimizer or orchestrator-worker patterns when justified by complexity. https://www.anthropic.com/engineering/building-effective-agents</a:t>
+              <a:t>Claude Cookbook, Context engineering: memory, compaction, and tool clearing, Mar 20 2026: compaction summarizes a long context window, tool-result clearing drops bulky re-fetchable tool outputs, and memory persists structured notes across sessions. https://platform.claude.com/cookbook/tool-use-context-engineering-context-engineering-tools</a:t>
+            </a:r>
+          </a:p>
+          <a:p xmlns:a="http://schemas.openxmlformats.org/drawingml/2006/main">
+            <a:r>
+              <a:t>Microsoft Agent Framework, Chat History Storage Patterns, Apr 24 2026: conversation history storage affects UX, compliance, architecture, cost, privacy, portability, and whether history is service-managed or client-managed. Client-managed history needs explicit truncation, sliding window, summarization, and tool-call collapse. https://devblogs.microsoft.com/agent-framework/chat-history-storage-patterns-in-microsoft-agent-framework/</a:t>
+            </a:r>
+          </a:p>
+          <a:p xmlns:a="http://schemas.openxmlformats.org/drawingml/2006/main">
+            <a:r>
+              <a:t>OpenAI Agents SDK Sessions docs: sessions provide persistent memory by fetching prior conversation items, persisting new outputs, and supporting custom storage backends; Responses compaction can shrink stored history. https://openai.github.io/openai-agents-js/guides/sessions/</a:t>
+            </a:r>
+          </a:p>
+          <a:p xmlns:a="http://schemas.openxmlformats.org/drawingml/2006/main">
+            <a:r>
+              <a:t>Anthropic, Building effective agents: start with the simplest agentic pattern and move to workflows/agents only when needed. https://www.anthropic.com/engineering/building-effective-agents</a:t>
             </a:r>
           </a:p>
           <a:p xmlns:a="http://schemas.openxmlformats.org/drawingml/2006/main">
             <a:r>
               <a:t>Fowler, Harness engineering: combines feedforward guides, feedback sensors, steering loops, timing/keep-quality-left, and the role of the human. https://martinfowler.com/articles/harness-engineering.html</a:t>
-            </a:r>
-          </a:p>
-          <a:p xmlns:a="http://schemas.openxmlformats.org/drawingml/2006/main">
-            <a:r>
-              <a:t>OpenAI, Harness engineering: repository/system knowledge should be legible, versioned, enforceable, and continuously improved; agents need boundaries, verification, observability, and garbage collection. https://openai.com/index/harness-engineering/</a:t>
             </a:r>
           </a:p>
         </p:txBody>
@@ -1466,7 +1466,7 @@
   </p:cSld>
   <p:clrMap bg1="lt1" tx1="dk1" bg2="lt2" tx2="dk2" accent1="accent1" accent2="accent2" accent3="accent3" accent4="accent4" accent5="accent5" accent6="accent6" hlink="hlink" folHlink="folHlink"/>
   <p:sldLayoutIdLst>
-    <p:sldLayoutId xmlns:r="http://schemas.openxmlformats.org/officeDocument/2006/relationships" id="2147483649" r:id="R4b19912fa6384ee1"/>
+    <p:sldLayoutId xmlns:r="http://schemas.openxmlformats.org/officeDocument/2006/relationships" id="2147483649" r:id="R6ab3aa20c1834dbd"/>
   </p:sldLayoutIdLst>
   <p:txStyles>
     <p:titleStyle>
@@ -3537,6 +3537,7 @@
           <a:lstStyle xmlns:a="http://schemas.openxmlformats.org/drawingml/2006/main"/>
           <a:p xmlns:a="http://schemas.openxmlformats.org/drawingml/2006/main">
             <a:pPr algn="l">
+              <a:buNone/>
               <a:defRPr sz="975" b="1">
                 <a:solidFill>
                   <a:srgbClr val="2563EB"/>
@@ -3587,6 +3588,7 @@
           <a:lstStyle xmlns:a="http://schemas.openxmlformats.org/drawingml/2006/main"/>
           <a:p xmlns:a="http://schemas.openxmlformats.org/drawingml/2006/main">
             <a:pPr algn="l">
+              <a:buNone/>
               <a:defRPr sz="2925" b="1">
                 <a:solidFill>
                   <a:srgbClr val="0B0F19"/>
@@ -3670,6 +3672,7 @@
           <a:lstStyle xmlns:a="http://schemas.openxmlformats.org/drawingml/2006/main"/>
           <a:p xmlns:a="http://schemas.openxmlformats.org/drawingml/2006/main">
             <a:pPr algn="l">
+              <a:buNone/>
               <a:defRPr sz="1575" b="0">
                 <a:solidFill>
                   <a:srgbClr val="4B5563"/>
@@ -3786,6 +3789,7 @@
           <a:lstStyle xmlns:a="http://schemas.openxmlformats.org/drawingml/2006/main"/>
           <a:p xmlns:a="http://schemas.openxmlformats.org/drawingml/2006/main">
             <a:pPr algn="ctr">
+              <a:buNone/>
               <a:defRPr sz="1275" b="1">
                 <a:solidFill>
                   <a:srgbClr val="FFFFFF"/>
@@ -3836,6 +3840,7 @@
           <a:lstStyle xmlns:a="http://schemas.openxmlformats.org/drawingml/2006/main"/>
           <a:p xmlns:a="http://schemas.openxmlformats.org/drawingml/2006/main">
             <a:pPr algn="l">
+              <a:buNone/>
               <a:defRPr sz="1350" b="1">
                 <a:solidFill>
                   <a:srgbClr val="2563EB"/>
@@ -3886,6 +3891,7 @@
           <a:lstStyle xmlns:a="http://schemas.openxmlformats.org/drawingml/2006/main"/>
           <a:p xmlns:a="http://schemas.openxmlformats.org/drawingml/2006/main">
             <a:pPr algn="l">
+              <a:buNone/>
               <a:defRPr sz="1125" b="0">
                 <a:solidFill>
                   <a:srgbClr val="4B5563"/>
@@ -4002,6 +4008,7 @@
           <a:lstStyle xmlns:a="http://schemas.openxmlformats.org/drawingml/2006/main"/>
           <a:p xmlns:a="http://schemas.openxmlformats.org/drawingml/2006/main">
             <a:pPr algn="ctr">
+              <a:buNone/>
               <a:defRPr sz="1275" b="1">
                 <a:solidFill>
                   <a:srgbClr val="FFFFFF"/>
@@ -4052,6 +4059,7 @@
           <a:lstStyle xmlns:a="http://schemas.openxmlformats.org/drawingml/2006/main"/>
           <a:p xmlns:a="http://schemas.openxmlformats.org/drawingml/2006/main">
             <a:pPr algn="l">
+              <a:buNone/>
               <a:defRPr sz="1350" b="1">
                 <a:solidFill>
                   <a:srgbClr val="DC2626"/>
@@ -4102,6 +4110,7 @@
           <a:lstStyle xmlns:a="http://schemas.openxmlformats.org/drawingml/2006/main"/>
           <a:p xmlns:a="http://schemas.openxmlformats.org/drawingml/2006/main">
             <a:pPr algn="l">
+              <a:buNone/>
               <a:defRPr sz="1125" b="0">
                 <a:solidFill>
                   <a:srgbClr val="4B5563"/>
@@ -4218,6 +4227,7 @@
           <a:lstStyle xmlns:a="http://schemas.openxmlformats.org/drawingml/2006/main"/>
           <a:p xmlns:a="http://schemas.openxmlformats.org/drawingml/2006/main">
             <a:pPr algn="ctr">
+              <a:buNone/>
               <a:defRPr sz="1275" b="1">
                 <a:solidFill>
                   <a:srgbClr val="FFFFFF"/>
@@ -4268,6 +4278,7 @@
           <a:lstStyle xmlns:a="http://schemas.openxmlformats.org/drawingml/2006/main"/>
           <a:p xmlns:a="http://schemas.openxmlformats.org/drawingml/2006/main">
             <a:pPr algn="l">
+              <a:buNone/>
               <a:defRPr sz="1350" b="1">
                 <a:solidFill>
                   <a:srgbClr val="0891B2"/>
@@ -4318,6 +4329,7 @@
           <a:lstStyle xmlns:a="http://schemas.openxmlformats.org/drawingml/2006/main"/>
           <a:p xmlns:a="http://schemas.openxmlformats.org/drawingml/2006/main">
             <a:pPr algn="l">
+              <a:buNone/>
               <a:defRPr sz="1125" b="0">
                 <a:solidFill>
                   <a:srgbClr val="4B5563"/>
@@ -4434,6 +4446,7 @@
           <a:lstStyle xmlns:a="http://schemas.openxmlformats.org/drawingml/2006/main"/>
           <a:p xmlns:a="http://schemas.openxmlformats.org/drawingml/2006/main">
             <a:pPr algn="ctr">
+              <a:buNone/>
               <a:defRPr sz="1275" b="1">
                 <a:solidFill>
                   <a:srgbClr val="FFFFFF"/>
@@ -4484,6 +4497,7 @@
           <a:lstStyle xmlns:a="http://schemas.openxmlformats.org/drawingml/2006/main"/>
           <a:p xmlns:a="http://schemas.openxmlformats.org/drawingml/2006/main">
             <a:pPr algn="l">
+              <a:buNone/>
               <a:defRPr sz="1350" b="1">
                 <a:solidFill>
                   <a:srgbClr val="D97706"/>
@@ -4534,6 +4548,7 @@
           <a:lstStyle xmlns:a="http://schemas.openxmlformats.org/drawingml/2006/main"/>
           <a:p xmlns:a="http://schemas.openxmlformats.org/drawingml/2006/main">
             <a:pPr algn="l">
+              <a:buNone/>
               <a:defRPr sz="1125" b="0">
                 <a:solidFill>
                   <a:srgbClr val="4B5563"/>
@@ -4650,6 +4665,7 @@
           <a:lstStyle xmlns:a="http://schemas.openxmlformats.org/drawingml/2006/main"/>
           <a:p xmlns:a="http://schemas.openxmlformats.org/drawingml/2006/main">
             <a:pPr algn="ctr">
+              <a:buNone/>
               <a:defRPr sz="1275" b="1">
                 <a:solidFill>
                   <a:srgbClr val="FFFFFF"/>
@@ -4700,6 +4716,7 @@
           <a:lstStyle xmlns:a="http://schemas.openxmlformats.org/drawingml/2006/main"/>
           <a:p xmlns:a="http://schemas.openxmlformats.org/drawingml/2006/main">
             <a:pPr algn="l">
+              <a:buNone/>
               <a:defRPr sz="1350" b="1">
                 <a:solidFill>
                   <a:srgbClr val="059669"/>
@@ -4750,6 +4767,7 @@
           <a:lstStyle xmlns:a="http://schemas.openxmlformats.org/drawingml/2006/main"/>
           <a:p xmlns:a="http://schemas.openxmlformats.org/drawingml/2006/main">
             <a:pPr algn="l">
+              <a:buNone/>
               <a:defRPr sz="1125" b="0">
                 <a:solidFill>
                   <a:srgbClr val="4B5563"/>
@@ -4866,6 +4884,7 @@
           <a:lstStyle xmlns:a="http://schemas.openxmlformats.org/drawingml/2006/main"/>
           <a:p xmlns:a="http://schemas.openxmlformats.org/drawingml/2006/main">
             <a:pPr algn="ctr">
+              <a:buNone/>
               <a:defRPr sz="1275" b="1">
                 <a:solidFill>
                   <a:srgbClr val="FFFFFF"/>
@@ -4916,6 +4935,7 @@
           <a:lstStyle xmlns:a="http://schemas.openxmlformats.org/drawingml/2006/main"/>
           <a:p xmlns:a="http://schemas.openxmlformats.org/drawingml/2006/main">
             <a:pPr algn="l">
+              <a:buNone/>
               <a:defRPr sz="1350" b="1">
                 <a:solidFill>
                   <a:srgbClr val="2563EB"/>
@@ -4966,6 +4986,7 @@
           <a:lstStyle xmlns:a="http://schemas.openxmlformats.org/drawingml/2006/main"/>
           <a:p xmlns:a="http://schemas.openxmlformats.org/drawingml/2006/main">
             <a:pPr algn="l">
+              <a:buNone/>
               <a:defRPr sz="1125" b="0">
                 <a:solidFill>
                   <a:srgbClr val="4B5563"/>
@@ -5082,6 +5103,7 @@
           <a:lstStyle xmlns:a="http://schemas.openxmlformats.org/drawingml/2006/main"/>
           <a:p xmlns:a="http://schemas.openxmlformats.org/drawingml/2006/main">
             <a:pPr algn="ctr">
+              <a:buNone/>
               <a:defRPr sz="1275" b="1">
                 <a:solidFill>
                   <a:srgbClr val="FFFFFF"/>
@@ -5132,6 +5154,7 @@
           <a:lstStyle xmlns:a="http://schemas.openxmlformats.org/drawingml/2006/main"/>
           <a:p xmlns:a="http://schemas.openxmlformats.org/drawingml/2006/main">
             <a:pPr algn="l">
+              <a:buNone/>
               <a:defRPr sz="1350" b="1">
                 <a:solidFill>
                   <a:srgbClr val="0891B2"/>
@@ -5182,6 +5205,7 @@
           <a:lstStyle xmlns:a="http://schemas.openxmlformats.org/drawingml/2006/main"/>
           <a:p xmlns:a="http://schemas.openxmlformats.org/drawingml/2006/main">
             <a:pPr algn="l">
+              <a:buNone/>
               <a:defRPr sz="1125" b="0">
                 <a:solidFill>
                   <a:srgbClr val="4B5563"/>
@@ -5298,6 +5322,7 @@
           <a:lstStyle xmlns:a="http://schemas.openxmlformats.org/drawingml/2006/main"/>
           <a:p xmlns:a="http://schemas.openxmlformats.org/drawingml/2006/main">
             <a:pPr algn="ctr">
+              <a:buNone/>
               <a:defRPr sz="1275" b="1">
                 <a:solidFill>
                   <a:srgbClr val="FFFFFF"/>
@@ -5348,6 +5373,7 @@
           <a:lstStyle xmlns:a="http://schemas.openxmlformats.org/drawingml/2006/main"/>
           <a:p xmlns:a="http://schemas.openxmlformats.org/drawingml/2006/main">
             <a:pPr algn="l">
+              <a:buNone/>
               <a:defRPr sz="1350" b="1">
                 <a:solidFill>
                   <a:srgbClr val="059669"/>
@@ -5398,6 +5424,7 @@
           <a:lstStyle xmlns:a="http://schemas.openxmlformats.org/drawingml/2006/main"/>
           <a:p xmlns:a="http://schemas.openxmlformats.org/drawingml/2006/main">
             <a:pPr algn="l">
+              <a:buNone/>
               <a:defRPr sz="1125" b="0">
                 <a:solidFill>
                   <a:srgbClr val="4B5563"/>
@@ -5514,6 +5541,7 @@
           <a:lstStyle xmlns:a="http://schemas.openxmlformats.org/drawingml/2006/main"/>
           <a:p xmlns:a="http://schemas.openxmlformats.org/drawingml/2006/main">
             <a:pPr algn="ctr">
+              <a:buNone/>
               <a:defRPr sz="1275" b="1">
                 <a:solidFill>
                   <a:srgbClr val="FFFFFF"/>
@@ -5564,6 +5592,7 @@
           <a:lstStyle xmlns:a="http://schemas.openxmlformats.org/drawingml/2006/main"/>
           <a:p xmlns:a="http://schemas.openxmlformats.org/drawingml/2006/main">
             <a:pPr algn="l">
+              <a:buNone/>
               <a:defRPr sz="1350" b="1">
                 <a:solidFill>
                   <a:srgbClr val="D97706"/>
@@ -5614,6 +5643,7 @@
           <a:lstStyle xmlns:a="http://schemas.openxmlformats.org/drawingml/2006/main"/>
           <a:p xmlns:a="http://schemas.openxmlformats.org/drawingml/2006/main">
             <a:pPr algn="l">
+              <a:buNone/>
               <a:defRPr sz="1125" b="0">
                 <a:solidFill>
                   <a:srgbClr val="4B5563"/>
@@ -5697,6 +5727,7 @@
           <a:lstStyle xmlns:a="http://schemas.openxmlformats.org/drawingml/2006/main"/>
           <a:p xmlns:a="http://schemas.openxmlformats.org/drawingml/2006/main">
             <a:pPr algn="ctr">
+              <a:buNone/>
               <a:defRPr sz="1350" b="1">
                 <a:solidFill>
                   <a:srgbClr val="2563EB"/>
@@ -5710,6 +5741,2565 @@
                 </a:solidFill>
               </a:rPr>
               <a:t>Principle: autonomy is earned by adding evidence, boundaries, evaluation, recovery, and human escalation.</a:t>
+            </a:r>
+          </a:p>
+        </p:txBody>
+      </p:sp>
+      <p:sp>
+        <p:nvSpPr>
+          <p:cNvPr id="53" name="">
+            <a:extLst xmlns:a="http://schemas.openxmlformats.org/drawingml/2006/main">
+              <a:ext uri="{FF2B5EF4-FFF2-40B4-BE49-F238E27FC236}">
+                <a16:creationId xmlns:a16="http://schemas.microsoft.com/office/drawing/2014/main" id="{D9022453-0941-48CA-BCBE-5F2C4F825F43}"/>
+              </a:ext>
+            </a:extLst>
+          </p:cNvPr>
+          <p:cNvSpPr>
+            <a:spLocks xmlns:a="http://schemas.openxmlformats.org/drawingml/2006/main" noGrp="1"/>
+          </p:cNvSpPr>
+          <p:nvPr/>
+        </p:nvSpPr>
+        <p:spPr>
+          <a:xfrm xmlns:a="http://schemas.openxmlformats.org/drawingml/2006/main">
+            <a:off x="0" y="0"/>
+            <a:ext cx="12192000" cy="6858000"/>
+          </a:xfrm>
+          <a:prstGeom xmlns:a="http://schemas.openxmlformats.org/drawingml/2006/main" prst="rect">
+            <a:avLst/>
+          </a:prstGeom>
+          <a:solidFill xmlns:a="http://schemas.openxmlformats.org/drawingml/2006/main">
+            <a:srgbClr val="FFFFFF"/>
+          </a:solidFill>
+          <a:ln xmlns:a="http://schemas.openxmlformats.org/drawingml/2006/main" w="9525">
+            <a:solidFill>
+              <a:srgbClr val="FFFFFF"/>
+            </a:solidFill>
+            <a:prstDash val="solid"/>
+          </a:ln>
+        </p:spPr>
+      </p:sp>
+      <p:sp>
+        <p:nvSpPr>
+          <p:cNvPr id="54" name="">
+            <a:extLst xmlns:a="http://schemas.openxmlformats.org/drawingml/2006/main">
+              <a:ext uri="{FF2B5EF4-FFF2-40B4-BE49-F238E27FC236}">
+                <a16:creationId xmlns:a16="http://schemas.microsoft.com/office/drawing/2014/main" id="{EF07F312-8E04-4595-9DC0-5F13209A606B}"/>
+              </a:ext>
+            </a:extLst>
+          </p:cNvPr>
+          <p:cNvSpPr>
+            <a:spLocks xmlns:a="http://schemas.openxmlformats.org/drawingml/2006/main" noGrp="1"/>
+          </p:cNvSpPr>
+          <p:nvPr/>
+        </p:nvSpPr>
+        <p:spPr>
+          <a:xfrm xmlns:a="http://schemas.openxmlformats.org/drawingml/2006/main">
+            <a:off x="609600" y="361950"/>
+            <a:ext cx="3238500" cy="228600"/>
+          </a:xfrm>
+          <a:prstGeom xmlns:a="http://schemas.openxmlformats.org/drawingml/2006/main" prst="rect">
+            <a:avLst/>
+          </a:prstGeom>
+          <a:noFill xmlns:a="http://schemas.openxmlformats.org/drawingml/2006/main"/>
+          <a:ln xmlns:a="http://schemas.openxmlformats.org/drawingml/2006/main" w="0">
+            <a:noFill/>
+            <a:prstDash val="solid"/>
+          </a:ln>
+        </p:spPr>
+        <p:txBody>
+          <a:bodyPr xmlns:a="http://schemas.openxmlformats.org/drawingml/2006/main"/>
+          <a:lstStyle xmlns:a="http://schemas.openxmlformats.org/drawingml/2006/main"/>
+          <a:p xmlns:a="http://schemas.openxmlformats.org/drawingml/2006/main">
+            <a:pPr algn="l">
+              <a:defRPr sz="975" b="1">
+                <a:solidFill>
+                  <a:srgbClr val="2563EB"/>
+                </a:solidFill>
+              </a:defRPr>
+            </a:pPr>
+            <a:r>
+              <a:rPr sz="975" b="1">
+                <a:solidFill>
+                  <a:srgbClr val="2563EB"/>
+                </a:solidFill>
+              </a:rPr>
+              <a:t>PRODUCTION PLAYBOOK</a:t>
+            </a:r>
+          </a:p>
+        </p:txBody>
+      </p:sp>
+      <p:sp>
+        <p:nvSpPr>
+          <p:cNvPr id="55" name="">
+            <a:extLst xmlns:a="http://schemas.openxmlformats.org/drawingml/2006/main">
+              <a:ext uri="{FF2B5EF4-FFF2-40B4-BE49-F238E27FC236}">
+                <a16:creationId xmlns:a16="http://schemas.microsoft.com/office/drawing/2014/main" id="{61324E7E-F5DE-4823-84FF-D8DA91276255}"/>
+              </a:ext>
+            </a:extLst>
+          </p:cNvPr>
+          <p:cNvSpPr>
+            <a:spLocks xmlns:a="http://schemas.openxmlformats.org/drawingml/2006/main" noGrp="1"/>
+          </p:cNvSpPr>
+          <p:nvPr/>
+        </p:nvSpPr>
+        <p:spPr>
+          <a:xfrm xmlns:a="http://schemas.openxmlformats.org/drawingml/2006/main">
+            <a:off x="609600" y="723900"/>
+            <a:ext cx="10001250" cy="552450"/>
+          </a:xfrm>
+          <a:prstGeom xmlns:a="http://schemas.openxmlformats.org/drawingml/2006/main" prst="rect">
+            <a:avLst/>
+          </a:prstGeom>
+          <a:noFill xmlns:a="http://schemas.openxmlformats.org/drawingml/2006/main"/>
+          <a:ln xmlns:a="http://schemas.openxmlformats.org/drawingml/2006/main" w="0">
+            <a:noFill/>
+            <a:prstDash val="solid"/>
+          </a:ln>
+        </p:spPr>
+        <p:txBody>
+          <a:bodyPr xmlns:a="http://schemas.openxmlformats.org/drawingml/2006/main"/>
+          <a:lstStyle xmlns:a="http://schemas.openxmlformats.org/drawingml/2006/main"/>
+          <a:p xmlns:a="http://schemas.openxmlformats.org/drawingml/2006/main">
+            <a:pPr algn="l">
+              <a:defRPr sz="2925" b="1">
+                <a:solidFill>
+                  <a:srgbClr val="0B0F19"/>
+                </a:solidFill>
+              </a:defRPr>
+            </a:pPr>
+            <a:r>
+              <a:rPr sz="2925" b="1">
+                <a:solidFill>
+                  <a:srgbClr val="0B0F19"/>
+                </a:solidFill>
+              </a:rPr>
+              <a:t>Production harness build checklist</a:t>
+            </a:r>
+          </a:p>
+        </p:txBody>
+      </p:sp>
+      <p:sp>
+        <p:nvSpPr>
+          <p:cNvPr id="56" name="">
+            <a:extLst xmlns:a="http://schemas.openxmlformats.org/drawingml/2006/main">
+              <a:ext uri="{FF2B5EF4-FFF2-40B4-BE49-F238E27FC236}">
+                <a16:creationId xmlns:a16="http://schemas.microsoft.com/office/drawing/2014/main" id="{E80DD5FA-915A-4EB5-86CF-4B7CBC895F8F}"/>
+              </a:ext>
+            </a:extLst>
+          </p:cNvPr>
+          <p:cNvSpPr>
+            <a:spLocks xmlns:a="http://schemas.openxmlformats.org/drawingml/2006/main" noGrp="1"/>
+          </p:cNvSpPr>
+          <p:nvPr/>
+        </p:nvSpPr>
+        <p:spPr>
+          <a:xfrm xmlns:a="http://schemas.openxmlformats.org/drawingml/2006/main">
+            <a:off x="609600" y="1409700"/>
+            <a:ext cx="10972800" cy="9525"/>
+          </a:xfrm>
+          <a:prstGeom xmlns:a="http://schemas.openxmlformats.org/drawingml/2006/main" prst="rect">
+            <a:avLst/>
+          </a:prstGeom>
+          <a:solidFill xmlns:a="http://schemas.openxmlformats.org/drawingml/2006/main">
+            <a:srgbClr val="CBD5E1"/>
+          </a:solidFill>
+          <a:ln xmlns:a="http://schemas.openxmlformats.org/drawingml/2006/main" w="9525">
+            <a:solidFill>
+              <a:srgbClr val="CBD5E1"/>
+            </a:solidFill>
+            <a:prstDash val="solid"/>
+          </a:ln>
+        </p:spPr>
+      </p:sp>
+      <p:sp>
+        <p:nvSpPr>
+          <p:cNvPr id="57" name="">
+            <a:extLst xmlns:a="http://schemas.openxmlformats.org/drawingml/2006/main">
+              <a:ext uri="{FF2B5EF4-FFF2-40B4-BE49-F238E27FC236}">
+                <a16:creationId xmlns:a16="http://schemas.microsoft.com/office/drawing/2014/main" id="{956F0F1D-C5A1-4B9F-95D7-F6CAC5066F3B}"/>
+              </a:ext>
+            </a:extLst>
+          </p:cNvPr>
+          <p:cNvSpPr>
+            <a:spLocks xmlns:a="http://schemas.openxmlformats.org/drawingml/2006/main" noGrp="1"/>
+          </p:cNvSpPr>
+          <p:nvPr/>
+        </p:nvSpPr>
+        <p:spPr>
+          <a:xfrm xmlns:a="http://schemas.openxmlformats.org/drawingml/2006/main">
+            <a:off x="685800" y="1600200"/>
+            <a:ext cx="10382250" cy="361950"/>
+          </a:xfrm>
+          <a:prstGeom xmlns:a="http://schemas.openxmlformats.org/drawingml/2006/main" prst="rect">
+            <a:avLst/>
+          </a:prstGeom>
+          <a:noFill xmlns:a="http://schemas.openxmlformats.org/drawingml/2006/main"/>
+          <a:ln xmlns:a="http://schemas.openxmlformats.org/drawingml/2006/main" w="0">
+            <a:noFill/>
+            <a:prstDash val="solid"/>
+          </a:ln>
+        </p:spPr>
+        <p:txBody>
+          <a:bodyPr xmlns:a="http://schemas.openxmlformats.org/drawingml/2006/main"/>
+          <a:lstStyle xmlns:a="http://schemas.openxmlformats.org/drawingml/2006/main"/>
+          <a:p xmlns:a="http://schemas.openxmlformats.org/drawingml/2006/main">
+            <a:pPr algn="l">
+              <a:defRPr sz="1575" b="0">
+                <a:solidFill>
+                  <a:srgbClr val="4B5563"/>
+                </a:solidFill>
+              </a:defRPr>
+            </a:pPr>
+            <a:r>
+              <a:rPr sz="1575" b="0">
+                <a:solidFill>
+                  <a:srgbClr val="4B5563"/>
+                </a:solidFill>
+              </a:rPr>
+              <a:t>Design the work, bound autonomy, decide memory/session policy, then add controls that make behavior measurable and recoverable.</a:t>
+            </a:r>
+          </a:p>
+        </p:txBody>
+      </p:sp>
+      <p:sp>
+        <p:nvSpPr>
+          <p:cNvPr id="58" name="">
+            <a:extLst xmlns:a="http://schemas.openxmlformats.org/drawingml/2006/main">
+              <a:ext uri="{FF2B5EF4-FFF2-40B4-BE49-F238E27FC236}">
+                <a16:creationId xmlns:a16="http://schemas.microsoft.com/office/drawing/2014/main" id="{8F31555C-D854-42C3-AA75-DB803295F193}"/>
+              </a:ext>
+            </a:extLst>
+          </p:cNvPr>
+          <p:cNvSpPr>
+            <a:spLocks xmlns:a="http://schemas.openxmlformats.org/drawingml/2006/main" noGrp="1"/>
+          </p:cNvSpPr>
+          <p:nvPr/>
+        </p:nvSpPr>
+        <p:spPr>
+          <a:xfrm xmlns:a="http://schemas.openxmlformats.org/drawingml/2006/main">
+            <a:off x="857250" y="2190750"/>
+            <a:ext cx="4095750" cy="247650"/>
+          </a:xfrm>
+          <a:prstGeom xmlns:a="http://schemas.openxmlformats.org/drawingml/2006/main" prst="rect">
+            <a:avLst/>
+          </a:prstGeom>
+          <a:noFill xmlns:a="http://schemas.openxmlformats.org/drawingml/2006/main"/>
+          <a:ln xmlns:a="http://schemas.openxmlformats.org/drawingml/2006/main" w="0">
+            <a:noFill/>
+            <a:prstDash val="solid"/>
+          </a:ln>
+        </p:spPr>
+        <p:txBody>
+          <a:bodyPr xmlns:a="http://schemas.openxmlformats.org/drawingml/2006/main"/>
+          <a:lstStyle xmlns:a="http://schemas.openxmlformats.org/drawingml/2006/main"/>
+          <a:p xmlns:a="http://schemas.openxmlformats.org/drawingml/2006/main">
+            <a:pPr algn="l">
+              <a:defRPr sz="1725" b="1">
+                <a:solidFill>
+                  <a:srgbClr val="0B0F19"/>
+                </a:solidFill>
+              </a:defRPr>
+            </a:pPr>
+            <a:r>
+              <a:rPr sz="1725" b="1">
+                <a:solidFill>
+                  <a:srgbClr val="0B0F19"/>
+                </a:solidFill>
+              </a:rPr>
+              <a:t>Design the agentic system</a:t>
+            </a:r>
+          </a:p>
+        </p:txBody>
+      </p:sp>
+      <p:sp>
+        <p:nvSpPr>
+          <p:cNvPr id="59" name="">
+            <a:extLst xmlns:a="http://schemas.openxmlformats.org/drawingml/2006/main">
+              <a:ext uri="{FF2B5EF4-FFF2-40B4-BE49-F238E27FC236}">
+                <a16:creationId xmlns:a16="http://schemas.microsoft.com/office/drawing/2014/main" id="{F4DAA8B6-51B4-4F97-BDE2-2F7AB6992A70}"/>
+              </a:ext>
+            </a:extLst>
+          </p:cNvPr>
+          <p:cNvSpPr>
+            <a:spLocks xmlns:a="http://schemas.openxmlformats.org/drawingml/2006/main" noGrp="1"/>
+          </p:cNvSpPr>
+          <p:nvPr/>
+        </p:nvSpPr>
+        <p:spPr>
+          <a:xfrm xmlns:a="http://schemas.openxmlformats.org/drawingml/2006/main">
+            <a:off x="6429375" y="2190750"/>
+            <a:ext cx="4095750" cy="247650"/>
+          </a:xfrm>
+          <a:prstGeom xmlns:a="http://schemas.openxmlformats.org/drawingml/2006/main" prst="rect">
+            <a:avLst/>
+          </a:prstGeom>
+          <a:noFill xmlns:a="http://schemas.openxmlformats.org/drawingml/2006/main"/>
+          <a:ln xmlns:a="http://schemas.openxmlformats.org/drawingml/2006/main" w="0">
+            <a:noFill/>
+            <a:prstDash val="solid"/>
+          </a:ln>
+        </p:spPr>
+        <p:txBody>
+          <a:bodyPr xmlns:a="http://schemas.openxmlformats.org/drawingml/2006/main"/>
+          <a:lstStyle xmlns:a="http://schemas.openxmlformats.org/drawingml/2006/main"/>
+          <a:p xmlns:a="http://schemas.openxmlformats.org/drawingml/2006/main">
+            <a:pPr algn="l">
+              <a:defRPr sz="1725" b="1">
+                <a:solidFill>
+                  <a:srgbClr val="0B0F19"/>
+                </a:solidFill>
+              </a:defRPr>
+            </a:pPr>
+            <a:r>
+              <a:rPr sz="1725" b="1">
+                <a:solidFill>
+                  <a:srgbClr val="0B0F19"/>
+                </a:solidFill>
+              </a:rPr>
+              <a:t>Manage context and memory</a:t>
+            </a:r>
+          </a:p>
+        </p:txBody>
+      </p:sp>
+      <p:sp>
+        <p:nvSpPr>
+          <p:cNvPr id="60" name="">
+            <a:extLst xmlns:a="http://schemas.openxmlformats.org/drawingml/2006/main">
+              <a:ext uri="{FF2B5EF4-FFF2-40B4-BE49-F238E27FC236}">
+                <a16:creationId xmlns:a16="http://schemas.microsoft.com/office/drawing/2014/main" id="{F1AF1F64-EA5E-478E-9210-26BFF6149A45}"/>
+              </a:ext>
+            </a:extLst>
+          </p:cNvPr>
+          <p:cNvSpPr>
+            <a:spLocks xmlns:a="http://schemas.openxmlformats.org/drawingml/2006/main" noGrp="1"/>
+          </p:cNvSpPr>
+          <p:nvPr/>
+        </p:nvSpPr>
+        <p:spPr>
+          <a:xfrm xmlns:a="http://schemas.openxmlformats.org/drawingml/2006/main">
+            <a:off x="838200" y="2571750"/>
+            <a:ext cx="4762500" cy="800100"/>
+          </a:xfrm>
+          <a:prstGeom xmlns:a="http://schemas.openxmlformats.org/drawingml/2006/main" prst="rect">
+            <a:avLst/>
+          </a:prstGeom>
+          <a:solidFill xmlns:a="http://schemas.openxmlformats.org/drawingml/2006/main">
+            <a:srgbClr val="FFFFFF"/>
+          </a:solidFill>
+          <a:ln xmlns:a="http://schemas.openxmlformats.org/drawingml/2006/main" w="9525">
+            <a:solidFill>
+              <a:srgbClr val="CBD5E1"/>
+            </a:solidFill>
+            <a:prstDash val="solid"/>
+          </a:ln>
+        </p:spPr>
+      </p:sp>
+      <p:sp>
+        <p:nvSpPr>
+          <p:cNvPr id="61" name="">
+            <a:extLst xmlns:a="http://schemas.openxmlformats.org/drawingml/2006/main">
+              <a:ext uri="{FF2B5EF4-FFF2-40B4-BE49-F238E27FC236}">
+                <a16:creationId xmlns:a16="http://schemas.microsoft.com/office/drawing/2014/main" id="{58E5CCD7-74FB-4248-840C-56B480613C44}"/>
+              </a:ext>
+            </a:extLst>
+          </p:cNvPr>
+          <p:cNvSpPr>
+            <a:spLocks xmlns:a="http://schemas.openxmlformats.org/drawingml/2006/main" noGrp="1"/>
+          </p:cNvSpPr>
+          <p:nvPr/>
+        </p:nvSpPr>
+        <p:spPr>
+          <a:xfrm xmlns:a="http://schemas.openxmlformats.org/drawingml/2006/main">
+            <a:off x="971550" y="2809875"/>
+            <a:ext cx="381000" cy="304800"/>
+          </a:xfrm>
+          <a:prstGeom xmlns:a="http://schemas.openxmlformats.org/drawingml/2006/main" prst="rect">
+            <a:avLst/>
+          </a:prstGeom>
+          <a:solidFill xmlns:a="http://schemas.openxmlformats.org/drawingml/2006/main">
+            <a:srgbClr val="2563EB"/>
+          </a:solidFill>
+          <a:ln xmlns:a="http://schemas.openxmlformats.org/drawingml/2006/main" w="9525">
+            <a:solidFill>
+              <a:srgbClr val="2563EB"/>
+            </a:solidFill>
+            <a:prstDash val="solid"/>
+          </a:ln>
+        </p:spPr>
+      </p:sp>
+      <p:sp>
+        <p:nvSpPr>
+          <p:cNvPr id="62" name="">
+            <a:extLst xmlns:a="http://schemas.openxmlformats.org/drawingml/2006/main">
+              <a:ext uri="{FF2B5EF4-FFF2-40B4-BE49-F238E27FC236}">
+                <a16:creationId xmlns:a16="http://schemas.microsoft.com/office/drawing/2014/main" id="{D30B27ED-177C-4838-9D77-9496BEA7A84C}"/>
+              </a:ext>
+            </a:extLst>
+          </p:cNvPr>
+          <p:cNvSpPr>
+            <a:spLocks xmlns:a="http://schemas.openxmlformats.org/drawingml/2006/main" noGrp="1"/>
+          </p:cNvSpPr>
+          <p:nvPr/>
+        </p:nvSpPr>
+        <p:spPr>
+          <a:xfrm xmlns:a="http://schemas.openxmlformats.org/drawingml/2006/main">
+            <a:off x="971550" y="2857500"/>
+            <a:ext cx="381000" cy="171450"/>
+          </a:xfrm>
+          <a:prstGeom xmlns:a="http://schemas.openxmlformats.org/drawingml/2006/main" prst="rect">
+            <a:avLst/>
+          </a:prstGeom>
+          <a:noFill xmlns:a="http://schemas.openxmlformats.org/drawingml/2006/main"/>
+          <a:ln xmlns:a="http://schemas.openxmlformats.org/drawingml/2006/main" w="0">
+            <a:noFill/>
+            <a:prstDash val="solid"/>
+          </a:ln>
+        </p:spPr>
+        <p:txBody>
+          <a:bodyPr xmlns:a="http://schemas.openxmlformats.org/drawingml/2006/main"/>
+          <a:lstStyle xmlns:a="http://schemas.openxmlformats.org/drawingml/2006/main"/>
+          <a:p xmlns:a="http://schemas.openxmlformats.org/drawingml/2006/main">
+            <a:pPr algn="ctr">
+              <a:defRPr sz="1125" b="1">
+                <a:solidFill>
+                  <a:srgbClr val="FFFFFF"/>
+                </a:solidFill>
+              </a:defRPr>
+            </a:pPr>
+            <a:r>
+              <a:rPr sz="1125" b="1">
+                <a:solidFill>
+                  <a:srgbClr val="FFFFFF"/>
+                </a:solidFill>
+              </a:rPr>
+              <a:t>1</a:t>
+            </a:r>
+          </a:p>
+        </p:txBody>
+      </p:sp>
+      <p:sp>
+        <p:nvSpPr>
+          <p:cNvPr id="63" name="">
+            <a:extLst xmlns:a="http://schemas.openxmlformats.org/drawingml/2006/main">
+              <a:ext uri="{FF2B5EF4-FFF2-40B4-BE49-F238E27FC236}">
+                <a16:creationId xmlns:a16="http://schemas.microsoft.com/office/drawing/2014/main" id="{5FC1EE21-64DD-4039-957A-80A094718F8F}"/>
+              </a:ext>
+            </a:extLst>
+          </p:cNvPr>
+          <p:cNvSpPr>
+            <a:spLocks xmlns:a="http://schemas.openxmlformats.org/drawingml/2006/main" noGrp="1"/>
+          </p:cNvSpPr>
+          <p:nvPr/>
+        </p:nvSpPr>
+        <p:spPr>
+          <a:xfrm xmlns:a="http://schemas.openxmlformats.org/drawingml/2006/main">
+            <a:off x="1504950" y="2705100"/>
+            <a:ext cx="3962400" cy="209550"/>
+          </a:xfrm>
+          <a:prstGeom xmlns:a="http://schemas.openxmlformats.org/drawingml/2006/main" prst="rect">
+            <a:avLst/>
+          </a:prstGeom>
+          <a:noFill xmlns:a="http://schemas.openxmlformats.org/drawingml/2006/main"/>
+          <a:ln xmlns:a="http://schemas.openxmlformats.org/drawingml/2006/main" w="0">
+            <a:noFill/>
+            <a:prstDash val="solid"/>
+          </a:ln>
+        </p:spPr>
+        <p:txBody>
+          <a:bodyPr xmlns:a="http://schemas.openxmlformats.org/drawingml/2006/main"/>
+          <a:lstStyle xmlns:a="http://schemas.openxmlformats.org/drawingml/2006/main"/>
+          <a:p xmlns:a="http://schemas.openxmlformats.org/drawingml/2006/main">
+            <a:pPr algn="l">
+              <a:defRPr sz="1275" b="1">
+                <a:solidFill>
+                  <a:srgbClr val="2563EB"/>
+                </a:solidFill>
+              </a:defRPr>
+            </a:pPr>
+            <a:r>
+              <a:rPr sz="1275" b="1">
+                <a:solidFill>
+                  <a:srgbClr val="2563EB"/>
+                </a:solidFill>
+              </a:rPr>
+              <a:t>Decompose the work</a:t>
+            </a:r>
+          </a:p>
+        </p:txBody>
+      </p:sp>
+      <p:sp>
+        <p:nvSpPr>
+          <p:cNvPr id="64" name="">
+            <a:extLst xmlns:a="http://schemas.openxmlformats.org/drawingml/2006/main">
+              <a:ext uri="{FF2B5EF4-FFF2-40B4-BE49-F238E27FC236}">
+                <a16:creationId xmlns:a16="http://schemas.microsoft.com/office/drawing/2014/main" id="{B34CA817-56D3-4457-B6BE-96C39DBA4EE4}"/>
+              </a:ext>
+            </a:extLst>
+          </p:cNvPr>
+          <p:cNvSpPr>
+            <a:spLocks xmlns:a="http://schemas.openxmlformats.org/drawingml/2006/main" noGrp="1"/>
+          </p:cNvSpPr>
+          <p:nvPr/>
+        </p:nvSpPr>
+        <p:spPr>
+          <a:xfrm xmlns:a="http://schemas.openxmlformats.org/drawingml/2006/main">
+            <a:off x="1504950" y="2952750"/>
+            <a:ext cx="3962400" cy="342900"/>
+          </a:xfrm>
+          <a:prstGeom xmlns:a="http://schemas.openxmlformats.org/drawingml/2006/main" prst="rect">
+            <a:avLst/>
+          </a:prstGeom>
+          <a:noFill xmlns:a="http://schemas.openxmlformats.org/drawingml/2006/main"/>
+          <a:ln xmlns:a="http://schemas.openxmlformats.org/drawingml/2006/main" w="0">
+            <a:noFill/>
+            <a:prstDash val="solid"/>
+          </a:ln>
+        </p:spPr>
+        <p:txBody>
+          <a:bodyPr xmlns:a="http://schemas.openxmlformats.org/drawingml/2006/main"/>
+          <a:lstStyle xmlns:a="http://schemas.openxmlformats.org/drawingml/2006/main"/>
+          <a:p xmlns:a="http://schemas.openxmlformats.org/drawingml/2006/main">
+            <a:pPr algn="l">
+              <a:defRPr sz="1050" b="0">
+                <a:solidFill>
+                  <a:srgbClr val="4B5563"/>
+                </a:solidFill>
+              </a:defRPr>
+            </a:pPr>
+            <a:r>
+              <a:rPr sz="1050" b="0">
+                <a:solidFill>
+                  <a:srgbClr val="4B5563"/>
+                </a:solidFill>
+              </a:rPr>
+              <a:t>Stages, inputs, outputs, owners, and handoffs.</a:t>
+            </a:r>
+          </a:p>
+        </p:txBody>
+      </p:sp>
+      <p:sp>
+        <p:nvSpPr>
+          <p:cNvPr id="65" name="">
+            <a:extLst xmlns:a="http://schemas.openxmlformats.org/drawingml/2006/main">
+              <a:ext uri="{FF2B5EF4-FFF2-40B4-BE49-F238E27FC236}">
+                <a16:creationId xmlns:a16="http://schemas.microsoft.com/office/drawing/2014/main" id="{A1F37129-A967-4A3C-B770-B6210B206987}"/>
+              </a:ext>
+            </a:extLst>
+          </p:cNvPr>
+          <p:cNvSpPr>
+            <a:spLocks xmlns:a="http://schemas.openxmlformats.org/drawingml/2006/main" noGrp="1"/>
+          </p:cNvSpPr>
+          <p:nvPr/>
+        </p:nvSpPr>
+        <p:spPr>
+          <a:xfrm xmlns:a="http://schemas.openxmlformats.org/drawingml/2006/main">
+            <a:off x="838200" y="3295650"/>
+            <a:ext cx="4762500" cy="800100"/>
+          </a:xfrm>
+          <a:prstGeom xmlns:a="http://schemas.openxmlformats.org/drawingml/2006/main" prst="rect">
+            <a:avLst/>
+          </a:prstGeom>
+          <a:solidFill xmlns:a="http://schemas.openxmlformats.org/drawingml/2006/main">
+            <a:srgbClr val="FFFFFF"/>
+          </a:solidFill>
+          <a:ln xmlns:a="http://schemas.openxmlformats.org/drawingml/2006/main" w="9525">
+            <a:solidFill>
+              <a:srgbClr val="CBD5E1"/>
+            </a:solidFill>
+            <a:prstDash val="solid"/>
+          </a:ln>
+        </p:spPr>
+      </p:sp>
+      <p:sp>
+        <p:nvSpPr>
+          <p:cNvPr id="66" name="">
+            <a:extLst xmlns:a="http://schemas.openxmlformats.org/drawingml/2006/main">
+              <a:ext uri="{FF2B5EF4-FFF2-40B4-BE49-F238E27FC236}">
+                <a16:creationId xmlns:a16="http://schemas.microsoft.com/office/drawing/2014/main" id="{206AE7E6-4139-4A85-8292-C80C6C121FCA}"/>
+              </a:ext>
+            </a:extLst>
+          </p:cNvPr>
+          <p:cNvSpPr>
+            <a:spLocks xmlns:a="http://schemas.openxmlformats.org/drawingml/2006/main" noGrp="1"/>
+          </p:cNvSpPr>
+          <p:nvPr/>
+        </p:nvSpPr>
+        <p:spPr>
+          <a:xfrm xmlns:a="http://schemas.openxmlformats.org/drawingml/2006/main">
+            <a:off x="971550" y="3533775"/>
+            <a:ext cx="381000" cy="304800"/>
+          </a:xfrm>
+          <a:prstGeom xmlns:a="http://schemas.openxmlformats.org/drawingml/2006/main" prst="rect">
+            <a:avLst/>
+          </a:prstGeom>
+          <a:solidFill xmlns:a="http://schemas.openxmlformats.org/drawingml/2006/main">
+            <a:srgbClr val="DC2626"/>
+          </a:solidFill>
+          <a:ln xmlns:a="http://schemas.openxmlformats.org/drawingml/2006/main" w="9525">
+            <a:solidFill>
+              <a:srgbClr val="DC2626"/>
+            </a:solidFill>
+            <a:prstDash val="solid"/>
+          </a:ln>
+        </p:spPr>
+      </p:sp>
+      <p:sp>
+        <p:nvSpPr>
+          <p:cNvPr id="67" name="">
+            <a:extLst xmlns:a="http://schemas.openxmlformats.org/drawingml/2006/main">
+              <a:ext uri="{FF2B5EF4-FFF2-40B4-BE49-F238E27FC236}">
+                <a16:creationId xmlns:a16="http://schemas.microsoft.com/office/drawing/2014/main" id="{1751AA76-7A02-493F-8A1F-E3BC416AFA03}"/>
+              </a:ext>
+            </a:extLst>
+          </p:cNvPr>
+          <p:cNvSpPr>
+            <a:spLocks xmlns:a="http://schemas.openxmlformats.org/drawingml/2006/main" noGrp="1"/>
+          </p:cNvSpPr>
+          <p:nvPr/>
+        </p:nvSpPr>
+        <p:spPr>
+          <a:xfrm xmlns:a="http://schemas.openxmlformats.org/drawingml/2006/main">
+            <a:off x="971550" y="3581400"/>
+            <a:ext cx="381000" cy="171450"/>
+          </a:xfrm>
+          <a:prstGeom xmlns:a="http://schemas.openxmlformats.org/drawingml/2006/main" prst="rect">
+            <a:avLst/>
+          </a:prstGeom>
+          <a:noFill xmlns:a="http://schemas.openxmlformats.org/drawingml/2006/main"/>
+          <a:ln xmlns:a="http://schemas.openxmlformats.org/drawingml/2006/main" w="0">
+            <a:noFill/>
+            <a:prstDash val="solid"/>
+          </a:ln>
+        </p:spPr>
+        <p:txBody>
+          <a:bodyPr xmlns:a="http://schemas.openxmlformats.org/drawingml/2006/main"/>
+          <a:lstStyle xmlns:a="http://schemas.openxmlformats.org/drawingml/2006/main"/>
+          <a:p xmlns:a="http://schemas.openxmlformats.org/drawingml/2006/main">
+            <a:pPr algn="ctr">
+              <a:defRPr sz="1125" b="1">
+                <a:solidFill>
+                  <a:srgbClr val="FFFFFF"/>
+                </a:solidFill>
+              </a:defRPr>
+            </a:pPr>
+            <a:r>
+              <a:rPr sz="1125" b="1">
+                <a:solidFill>
+                  <a:srgbClr val="FFFFFF"/>
+                </a:solidFill>
+              </a:rPr>
+              <a:t>2</a:t>
+            </a:r>
+          </a:p>
+        </p:txBody>
+      </p:sp>
+      <p:sp>
+        <p:nvSpPr>
+          <p:cNvPr id="68" name="">
+            <a:extLst xmlns:a="http://schemas.openxmlformats.org/drawingml/2006/main">
+              <a:ext uri="{FF2B5EF4-FFF2-40B4-BE49-F238E27FC236}">
+                <a16:creationId xmlns:a16="http://schemas.microsoft.com/office/drawing/2014/main" id="{3E1C1A40-4DE0-4DE1-95AA-DE8C038A69BF}"/>
+              </a:ext>
+            </a:extLst>
+          </p:cNvPr>
+          <p:cNvSpPr>
+            <a:spLocks xmlns:a="http://schemas.openxmlformats.org/drawingml/2006/main" noGrp="1"/>
+          </p:cNvSpPr>
+          <p:nvPr/>
+        </p:nvSpPr>
+        <p:spPr>
+          <a:xfrm xmlns:a="http://schemas.openxmlformats.org/drawingml/2006/main">
+            <a:off x="1504950" y="3429000"/>
+            <a:ext cx="3962400" cy="209550"/>
+          </a:xfrm>
+          <a:prstGeom xmlns:a="http://schemas.openxmlformats.org/drawingml/2006/main" prst="rect">
+            <a:avLst/>
+          </a:prstGeom>
+          <a:noFill xmlns:a="http://schemas.openxmlformats.org/drawingml/2006/main"/>
+          <a:ln xmlns:a="http://schemas.openxmlformats.org/drawingml/2006/main" w="0">
+            <a:noFill/>
+            <a:prstDash val="solid"/>
+          </a:ln>
+        </p:spPr>
+        <p:txBody>
+          <a:bodyPr xmlns:a="http://schemas.openxmlformats.org/drawingml/2006/main"/>
+          <a:lstStyle xmlns:a="http://schemas.openxmlformats.org/drawingml/2006/main"/>
+          <a:p xmlns:a="http://schemas.openxmlformats.org/drawingml/2006/main">
+            <a:pPr algn="l">
+              <a:defRPr sz="1275" b="1">
+                <a:solidFill>
+                  <a:srgbClr val="DC2626"/>
+                </a:solidFill>
+              </a:defRPr>
+            </a:pPr>
+            <a:r>
+              <a:rPr sz="1275" b="1">
+                <a:solidFill>
+                  <a:srgbClr val="DC2626"/>
+                </a:solidFill>
+              </a:rPr>
+              <a:t>Set autonomy and risk</a:t>
+            </a:r>
+          </a:p>
+        </p:txBody>
+      </p:sp>
+      <p:sp>
+        <p:nvSpPr>
+          <p:cNvPr id="69" name="">
+            <a:extLst xmlns:a="http://schemas.openxmlformats.org/drawingml/2006/main">
+              <a:ext uri="{FF2B5EF4-FFF2-40B4-BE49-F238E27FC236}">
+                <a16:creationId xmlns:a16="http://schemas.microsoft.com/office/drawing/2014/main" id="{2892E9CE-E9E2-41AB-8BCA-94D1FE1D685C}"/>
+              </a:ext>
+            </a:extLst>
+          </p:cNvPr>
+          <p:cNvSpPr>
+            <a:spLocks xmlns:a="http://schemas.openxmlformats.org/drawingml/2006/main" noGrp="1"/>
+          </p:cNvSpPr>
+          <p:nvPr/>
+        </p:nvSpPr>
+        <p:spPr>
+          <a:xfrm xmlns:a="http://schemas.openxmlformats.org/drawingml/2006/main">
+            <a:off x="1504950" y="3676650"/>
+            <a:ext cx="3962400" cy="342900"/>
+          </a:xfrm>
+          <a:prstGeom xmlns:a="http://schemas.openxmlformats.org/drawingml/2006/main" prst="rect">
+            <a:avLst/>
+          </a:prstGeom>
+          <a:noFill xmlns:a="http://schemas.openxmlformats.org/drawingml/2006/main"/>
+          <a:ln xmlns:a="http://schemas.openxmlformats.org/drawingml/2006/main" w="0">
+            <a:noFill/>
+            <a:prstDash val="solid"/>
+          </a:ln>
+        </p:spPr>
+        <p:txBody>
+          <a:bodyPr xmlns:a="http://schemas.openxmlformats.org/drawingml/2006/main"/>
+          <a:lstStyle xmlns:a="http://schemas.openxmlformats.org/drawingml/2006/main"/>
+          <a:p xmlns:a="http://schemas.openxmlformats.org/drawingml/2006/main">
+            <a:pPr algn="l">
+              <a:defRPr sz="1050" b="0">
+                <a:solidFill>
+                  <a:srgbClr val="4B5563"/>
+                </a:solidFill>
+              </a:defRPr>
+            </a:pPr>
+            <a:r>
+              <a:rPr sz="1050" b="0">
+                <a:solidFill>
+                  <a:srgbClr val="4B5563"/>
+                </a:solidFill>
+              </a:rPr>
+              <a:t>Criticality, budget, latency, permissions, and stop conditions.</a:t>
+            </a:r>
+          </a:p>
+        </p:txBody>
+      </p:sp>
+      <p:sp>
+        <p:nvSpPr>
+          <p:cNvPr id="70" name="">
+            <a:extLst xmlns:a="http://schemas.openxmlformats.org/drawingml/2006/main">
+              <a:ext uri="{FF2B5EF4-FFF2-40B4-BE49-F238E27FC236}">
+                <a16:creationId xmlns:a16="http://schemas.microsoft.com/office/drawing/2014/main" id="{39AFA902-2EAB-41AA-A9F1-3D56A42C458E}"/>
+              </a:ext>
+            </a:extLst>
+          </p:cNvPr>
+          <p:cNvSpPr>
+            <a:spLocks xmlns:a="http://schemas.openxmlformats.org/drawingml/2006/main" noGrp="1"/>
+          </p:cNvSpPr>
+          <p:nvPr/>
+        </p:nvSpPr>
+        <p:spPr>
+          <a:xfrm xmlns:a="http://schemas.openxmlformats.org/drawingml/2006/main">
+            <a:off x="838200" y="4019550"/>
+            <a:ext cx="4762500" cy="800100"/>
+          </a:xfrm>
+          <a:prstGeom xmlns:a="http://schemas.openxmlformats.org/drawingml/2006/main" prst="rect">
+            <a:avLst/>
+          </a:prstGeom>
+          <a:solidFill xmlns:a="http://schemas.openxmlformats.org/drawingml/2006/main">
+            <a:srgbClr val="FFFFFF"/>
+          </a:solidFill>
+          <a:ln xmlns:a="http://schemas.openxmlformats.org/drawingml/2006/main" w="9525">
+            <a:solidFill>
+              <a:srgbClr val="CBD5E1"/>
+            </a:solidFill>
+            <a:prstDash val="solid"/>
+          </a:ln>
+        </p:spPr>
+      </p:sp>
+      <p:sp>
+        <p:nvSpPr>
+          <p:cNvPr id="71" name="">
+            <a:extLst xmlns:a="http://schemas.openxmlformats.org/drawingml/2006/main">
+              <a:ext uri="{FF2B5EF4-FFF2-40B4-BE49-F238E27FC236}">
+                <a16:creationId xmlns:a16="http://schemas.microsoft.com/office/drawing/2014/main" id="{686FC190-98DC-4BD7-9438-3B659EB9C075}"/>
+              </a:ext>
+            </a:extLst>
+          </p:cNvPr>
+          <p:cNvSpPr>
+            <a:spLocks xmlns:a="http://schemas.openxmlformats.org/drawingml/2006/main" noGrp="1"/>
+          </p:cNvSpPr>
+          <p:nvPr/>
+        </p:nvSpPr>
+        <p:spPr>
+          <a:xfrm xmlns:a="http://schemas.openxmlformats.org/drawingml/2006/main">
+            <a:off x="971550" y="4257675"/>
+            <a:ext cx="381000" cy="304800"/>
+          </a:xfrm>
+          <a:prstGeom xmlns:a="http://schemas.openxmlformats.org/drawingml/2006/main" prst="rect">
+            <a:avLst/>
+          </a:prstGeom>
+          <a:solidFill xmlns:a="http://schemas.openxmlformats.org/drawingml/2006/main">
+            <a:srgbClr val="0891B2"/>
+          </a:solidFill>
+          <a:ln xmlns:a="http://schemas.openxmlformats.org/drawingml/2006/main" w="9525">
+            <a:solidFill>
+              <a:srgbClr val="0891B2"/>
+            </a:solidFill>
+            <a:prstDash val="solid"/>
+          </a:ln>
+        </p:spPr>
+      </p:sp>
+      <p:sp>
+        <p:nvSpPr>
+          <p:cNvPr id="72" name="">
+            <a:extLst xmlns:a="http://schemas.openxmlformats.org/drawingml/2006/main">
+              <a:ext uri="{FF2B5EF4-FFF2-40B4-BE49-F238E27FC236}">
+                <a16:creationId xmlns:a16="http://schemas.microsoft.com/office/drawing/2014/main" id="{6906E3C6-0722-49D4-B330-902A2C6C98E5}"/>
+              </a:ext>
+            </a:extLst>
+          </p:cNvPr>
+          <p:cNvSpPr>
+            <a:spLocks xmlns:a="http://schemas.openxmlformats.org/drawingml/2006/main" noGrp="1"/>
+          </p:cNvSpPr>
+          <p:nvPr/>
+        </p:nvSpPr>
+        <p:spPr>
+          <a:xfrm xmlns:a="http://schemas.openxmlformats.org/drawingml/2006/main">
+            <a:off x="971550" y="4305300"/>
+            <a:ext cx="381000" cy="171450"/>
+          </a:xfrm>
+          <a:prstGeom xmlns:a="http://schemas.openxmlformats.org/drawingml/2006/main" prst="rect">
+            <a:avLst/>
+          </a:prstGeom>
+          <a:noFill xmlns:a="http://schemas.openxmlformats.org/drawingml/2006/main"/>
+          <a:ln xmlns:a="http://schemas.openxmlformats.org/drawingml/2006/main" w="0">
+            <a:noFill/>
+            <a:prstDash val="solid"/>
+          </a:ln>
+        </p:spPr>
+        <p:txBody>
+          <a:bodyPr xmlns:a="http://schemas.openxmlformats.org/drawingml/2006/main"/>
+          <a:lstStyle xmlns:a="http://schemas.openxmlformats.org/drawingml/2006/main"/>
+          <a:p xmlns:a="http://schemas.openxmlformats.org/drawingml/2006/main">
+            <a:pPr algn="ctr">
+              <a:defRPr sz="1125" b="1">
+                <a:solidFill>
+                  <a:srgbClr val="FFFFFF"/>
+                </a:solidFill>
+              </a:defRPr>
+            </a:pPr>
+            <a:r>
+              <a:rPr sz="1125" b="1">
+                <a:solidFill>
+                  <a:srgbClr val="FFFFFF"/>
+                </a:solidFill>
+              </a:rPr>
+              <a:t>3</a:t>
+            </a:r>
+          </a:p>
+        </p:txBody>
+      </p:sp>
+      <p:sp>
+        <p:nvSpPr>
+          <p:cNvPr id="73" name="">
+            <a:extLst xmlns:a="http://schemas.openxmlformats.org/drawingml/2006/main">
+              <a:ext uri="{FF2B5EF4-FFF2-40B4-BE49-F238E27FC236}">
+                <a16:creationId xmlns:a16="http://schemas.microsoft.com/office/drawing/2014/main" id="{4018D392-E6EE-45EB-ADCE-284840457847}"/>
+              </a:ext>
+            </a:extLst>
+          </p:cNvPr>
+          <p:cNvSpPr>
+            <a:spLocks xmlns:a="http://schemas.openxmlformats.org/drawingml/2006/main" noGrp="1"/>
+          </p:cNvSpPr>
+          <p:nvPr/>
+        </p:nvSpPr>
+        <p:spPr>
+          <a:xfrm xmlns:a="http://schemas.openxmlformats.org/drawingml/2006/main">
+            <a:off x="1504950" y="4152900"/>
+            <a:ext cx="3962400" cy="209550"/>
+          </a:xfrm>
+          <a:prstGeom xmlns:a="http://schemas.openxmlformats.org/drawingml/2006/main" prst="rect">
+            <a:avLst/>
+          </a:prstGeom>
+          <a:noFill xmlns:a="http://schemas.openxmlformats.org/drawingml/2006/main"/>
+          <a:ln xmlns:a="http://schemas.openxmlformats.org/drawingml/2006/main" w="0">
+            <a:noFill/>
+            <a:prstDash val="solid"/>
+          </a:ln>
+        </p:spPr>
+        <p:txBody>
+          <a:bodyPr xmlns:a="http://schemas.openxmlformats.org/drawingml/2006/main"/>
+          <a:lstStyle xmlns:a="http://schemas.openxmlformats.org/drawingml/2006/main"/>
+          <a:p xmlns:a="http://schemas.openxmlformats.org/drawingml/2006/main">
+            <a:pPr algn="l">
+              <a:defRPr sz="1275" b="1">
+                <a:solidFill>
+                  <a:srgbClr val="0891B2"/>
+                </a:solidFill>
+              </a:defRPr>
+            </a:pPr>
+            <a:r>
+              <a:rPr sz="1275" b="1">
+                <a:solidFill>
+                  <a:srgbClr val="0891B2"/>
+                </a:solidFill>
+              </a:rPr>
+              <a:t>Choose the pattern</a:t>
+            </a:r>
+          </a:p>
+        </p:txBody>
+      </p:sp>
+      <p:sp>
+        <p:nvSpPr>
+          <p:cNvPr id="74" name="">
+            <a:extLst xmlns:a="http://schemas.openxmlformats.org/drawingml/2006/main">
+              <a:ext uri="{FF2B5EF4-FFF2-40B4-BE49-F238E27FC236}">
+                <a16:creationId xmlns:a16="http://schemas.microsoft.com/office/drawing/2014/main" id="{55A79A59-B9AD-48D2-A9C9-EE167E5AFD76}"/>
+              </a:ext>
+            </a:extLst>
+          </p:cNvPr>
+          <p:cNvSpPr>
+            <a:spLocks xmlns:a="http://schemas.openxmlformats.org/drawingml/2006/main" noGrp="1"/>
+          </p:cNvSpPr>
+          <p:nvPr/>
+        </p:nvSpPr>
+        <p:spPr>
+          <a:xfrm xmlns:a="http://schemas.openxmlformats.org/drawingml/2006/main">
+            <a:off x="1504950" y="4400550"/>
+            <a:ext cx="3962400" cy="342900"/>
+          </a:xfrm>
+          <a:prstGeom xmlns:a="http://schemas.openxmlformats.org/drawingml/2006/main" prst="rect">
+            <a:avLst/>
+          </a:prstGeom>
+          <a:noFill xmlns:a="http://schemas.openxmlformats.org/drawingml/2006/main"/>
+          <a:ln xmlns:a="http://schemas.openxmlformats.org/drawingml/2006/main" w="0">
+            <a:noFill/>
+            <a:prstDash val="solid"/>
+          </a:ln>
+        </p:spPr>
+        <p:txBody>
+          <a:bodyPr xmlns:a="http://schemas.openxmlformats.org/drawingml/2006/main"/>
+          <a:lstStyle xmlns:a="http://schemas.openxmlformats.org/drawingml/2006/main"/>
+          <a:p xmlns:a="http://schemas.openxmlformats.org/drawingml/2006/main">
+            <a:pPr algn="l">
+              <a:defRPr sz="1050" b="0">
+                <a:solidFill>
+                  <a:srgbClr val="4B5563"/>
+                </a:solidFill>
+              </a:defRPr>
+            </a:pPr>
+            <a:r>
+              <a:rPr sz="1050" b="0">
+                <a:solidFill>
+                  <a:srgbClr val="4B5563"/>
+                </a:solidFill>
+              </a:rPr>
+              <a:t>Augmented LLM first; graph or swarm only when needed.</a:t>
+            </a:r>
+          </a:p>
+        </p:txBody>
+      </p:sp>
+      <p:sp>
+        <p:nvSpPr>
+          <p:cNvPr id="75" name="">
+            <a:extLst xmlns:a="http://schemas.openxmlformats.org/drawingml/2006/main">
+              <a:ext uri="{FF2B5EF4-FFF2-40B4-BE49-F238E27FC236}">
+                <a16:creationId xmlns:a16="http://schemas.microsoft.com/office/drawing/2014/main" id="{8B0CB75E-B4B7-4B45-93C8-4CFA90C21566}"/>
+              </a:ext>
+            </a:extLst>
+          </p:cNvPr>
+          <p:cNvSpPr>
+            <a:spLocks xmlns:a="http://schemas.openxmlformats.org/drawingml/2006/main" noGrp="1"/>
+          </p:cNvSpPr>
+          <p:nvPr/>
+        </p:nvSpPr>
+        <p:spPr>
+          <a:xfrm xmlns:a="http://schemas.openxmlformats.org/drawingml/2006/main">
+            <a:off x="838200" y="4743450"/>
+            <a:ext cx="4762500" cy="800100"/>
+          </a:xfrm>
+          <a:prstGeom xmlns:a="http://schemas.openxmlformats.org/drawingml/2006/main" prst="rect">
+            <a:avLst/>
+          </a:prstGeom>
+          <a:solidFill xmlns:a="http://schemas.openxmlformats.org/drawingml/2006/main">
+            <a:srgbClr val="FFFFFF"/>
+          </a:solidFill>
+          <a:ln xmlns:a="http://schemas.openxmlformats.org/drawingml/2006/main" w="9525">
+            <a:solidFill>
+              <a:srgbClr val="CBD5E1"/>
+            </a:solidFill>
+            <a:prstDash val="solid"/>
+          </a:ln>
+        </p:spPr>
+      </p:sp>
+      <p:sp>
+        <p:nvSpPr>
+          <p:cNvPr id="76" name="">
+            <a:extLst xmlns:a="http://schemas.openxmlformats.org/drawingml/2006/main">
+              <a:ext uri="{FF2B5EF4-FFF2-40B4-BE49-F238E27FC236}">
+                <a16:creationId xmlns:a16="http://schemas.microsoft.com/office/drawing/2014/main" id="{DC54694E-97BC-42E7-9AA2-D25C607027D1}"/>
+              </a:ext>
+            </a:extLst>
+          </p:cNvPr>
+          <p:cNvSpPr>
+            <a:spLocks xmlns:a="http://schemas.openxmlformats.org/drawingml/2006/main" noGrp="1"/>
+          </p:cNvSpPr>
+          <p:nvPr/>
+        </p:nvSpPr>
+        <p:spPr>
+          <a:xfrm xmlns:a="http://schemas.openxmlformats.org/drawingml/2006/main">
+            <a:off x="971550" y="4981575"/>
+            <a:ext cx="381000" cy="304800"/>
+          </a:xfrm>
+          <a:prstGeom xmlns:a="http://schemas.openxmlformats.org/drawingml/2006/main" prst="rect">
+            <a:avLst/>
+          </a:prstGeom>
+          <a:solidFill xmlns:a="http://schemas.openxmlformats.org/drawingml/2006/main">
+            <a:srgbClr val="D97706"/>
+          </a:solidFill>
+          <a:ln xmlns:a="http://schemas.openxmlformats.org/drawingml/2006/main" w="9525">
+            <a:solidFill>
+              <a:srgbClr val="D97706"/>
+            </a:solidFill>
+            <a:prstDash val="solid"/>
+          </a:ln>
+        </p:spPr>
+      </p:sp>
+      <p:sp>
+        <p:nvSpPr>
+          <p:cNvPr id="77" name="">
+            <a:extLst xmlns:a="http://schemas.openxmlformats.org/drawingml/2006/main">
+              <a:ext uri="{FF2B5EF4-FFF2-40B4-BE49-F238E27FC236}">
+                <a16:creationId xmlns:a16="http://schemas.microsoft.com/office/drawing/2014/main" id="{5A234338-0BE0-4A4F-8FA2-8B53028D3C7C}"/>
+              </a:ext>
+            </a:extLst>
+          </p:cNvPr>
+          <p:cNvSpPr>
+            <a:spLocks xmlns:a="http://schemas.openxmlformats.org/drawingml/2006/main" noGrp="1"/>
+          </p:cNvSpPr>
+          <p:nvPr/>
+        </p:nvSpPr>
+        <p:spPr>
+          <a:xfrm xmlns:a="http://schemas.openxmlformats.org/drawingml/2006/main">
+            <a:off x="971550" y="5029200"/>
+            <a:ext cx="381000" cy="171450"/>
+          </a:xfrm>
+          <a:prstGeom xmlns:a="http://schemas.openxmlformats.org/drawingml/2006/main" prst="rect">
+            <a:avLst/>
+          </a:prstGeom>
+          <a:noFill xmlns:a="http://schemas.openxmlformats.org/drawingml/2006/main"/>
+          <a:ln xmlns:a="http://schemas.openxmlformats.org/drawingml/2006/main" w="0">
+            <a:noFill/>
+            <a:prstDash val="solid"/>
+          </a:ln>
+        </p:spPr>
+        <p:txBody>
+          <a:bodyPr xmlns:a="http://schemas.openxmlformats.org/drawingml/2006/main"/>
+          <a:lstStyle xmlns:a="http://schemas.openxmlformats.org/drawingml/2006/main"/>
+          <a:p xmlns:a="http://schemas.openxmlformats.org/drawingml/2006/main">
+            <a:pPr algn="ctr">
+              <a:defRPr sz="1125" b="1">
+                <a:solidFill>
+                  <a:srgbClr val="FFFFFF"/>
+                </a:solidFill>
+              </a:defRPr>
+            </a:pPr>
+            <a:r>
+              <a:rPr sz="1125" b="1">
+                <a:solidFill>
+                  <a:srgbClr val="FFFFFF"/>
+                </a:solidFill>
+              </a:rPr>
+              <a:t>4</a:t>
+            </a:r>
+          </a:p>
+        </p:txBody>
+      </p:sp>
+      <p:sp>
+        <p:nvSpPr>
+          <p:cNvPr id="78" name="">
+            <a:extLst xmlns:a="http://schemas.openxmlformats.org/drawingml/2006/main">
+              <a:ext uri="{FF2B5EF4-FFF2-40B4-BE49-F238E27FC236}">
+                <a16:creationId xmlns:a16="http://schemas.microsoft.com/office/drawing/2014/main" id="{FD3F6607-FEAA-4F11-BD4A-644F8CBD8D49}"/>
+              </a:ext>
+            </a:extLst>
+          </p:cNvPr>
+          <p:cNvSpPr>
+            <a:spLocks xmlns:a="http://schemas.openxmlformats.org/drawingml/2006/main" noGrp="1"/>
+          </p:cNvSpPr>
+          <p:nvPr/>
+        </p:nvSpPr>
+        <p:spPr>
+          <a:xfrm xmlns:a="http://schemas.openxmlformats.org/drawingml/2006/main">
+            <a:off x="1504950" y="4876800"/>
+            <a:ext cx="3962400" cy="209550"/>
+          </a:xfrm>
+          <a:prstGeom xmlns:a="http://schemas.openxmlformats.org/drawingml/2006/main" prst="rect">
+            <a:avLst/>
+          </a:prstGeom>
+          <a:noFill xmlns:a="http://schemas.openxmlformats.org/drawingml/2006/main"/>
+          <a:ln xmlns:a="http://schemas.openxmlformats.org/drawingml/2006/main" w="0">
+            <a:noFill/>
+            <a:prstDash val="solid"/>
+          </a:ln>
+        </p:spPr>
+        <p:txBody>
+          <a:bodyPr xmlns:a="http://schemas.openxmlformats.org/drawingml/2006/main"/>
+          <a:lstStyle xmlns:a="http://schemas.openxmlformats.org/drawingml/2006/main"/>
+          <a:p xmlns:a="http://schemas.openxmlformats.org/drawingml/2006/main">
+            <a:pPr algn="l">
+              <a:defRPr sz="1275" b="1">
+                <a:solidFill>
+                  <a:srgbClr val="D97706"/>
+                </a:solidFill>
+              </a:defRPr>
+            </a:pPr>
+            <a:r>
+              <a:rPr sz="1275" b="1">
+                <a:solidFill>
+                  <a:srgbClr val="D97706"/>
+                </a:solidFill>
+              </a:rPr>
+              <a:t>Mark critical stages</a:t>
+            </a:r>
+          </a:p>
+        </p:txBody>
+      </p:sp>
+      <p:sp>
+        <p:nvSpPr>
+          <p:cNvPr id="79" name="">
+            <a:extLst xmlns:a="http://schemas.openxmlformats.org/drawingml/2006/main">
+              <a:ext uri="{FF2B5EF4-FFF2-40B4-BE49-F238E27FC236}">
+                <a16:creationId xmlns:a16="http://schemas.microsoft.com/office/drawing/2014/main" id="{0F38277A-E6C7-431B-B0C5-721E83D1A69D}"/>
+              </a:ext>
+            </a:extLst>
+          </p:cNvPr>
+          <p:cNvSpPr>
+            <a:spLocks xmlns:a="http://schemas.openxmlformats.org/drawingml/2006/main" noGrp="1"/>
+          </p:cNvSpPr>
+          <p:nvPr/>
+        </p:nvSpPr>
+        <p:spPr>
+          <a:xfrm xmlns:a="http://schemas.openxmlformats.org/drawingml/2006/main">
+            <a:off x="1504950" y="5124450"/>
+            <a:ext cx="3962400" cy="342900"/>
+          </a:xfrm>
+          <a:prstGeom xmlns:a="http://schemas.openxmlformats.org/drawingml/2006/main" prst="rect">
+            <a:avLst/>
+          </a:prstGeom>
+          <a:noFill xmlns:a="http://schemas.openxmlformats.org/drawingml/2006/main"/>
+          <a:ln xmlns:a="http://schemas.openxmlformats.org/drawingml/2006/main" w="0">
+            <a:noFill/>
+            <a:prstDash val="solid"/>
+          </a:ln>
+        </p:spPr>
+        <p:txBody>
+          <a:bodyPr xmlns:a="http://schemas.openxmlformats.org/drawingml/2006/main"/>
+          <a:lstStyle xmlns:a="http://schemas.openxmlformats.org/drawingml/2006/main"/>
+          <a:p xmlns:a="http://schemas.openxmlformats.org/drawingml/2006/main">
+            <a:pPr algn="l">
+              <a:defRPr sz="1050" b="0">
+                <a:solidFill>
+                  <a:srgbClr val="4B5563"/>
+                </a:solidFill>
+              </a:defRPr>
+            </a:pPr>
+            <a:r>
+              <a:rPr sz="1050" b="0">
+                <a:solidFill>
+                  <a:srgbClr val="4B5563"/>
+                </a:solidFill>
+              </a:rPr>
+              <a:t>Decisions, writes, external actions, and irreversible steps.</a:t>
+            </a:r>
+          </a:p>
+        </p:txBody>
+      </p:sp>
+      <p:sp>
+        <p:nvSpPr>
+          <p:cNvPr id="80" name="">
+            <a:extLst xmlns:a="http://schemas.openxmlformats.org/drawingml/2006/main">
+              <a:ext uri="{FF2B5EF4-FFF2-40B4-BE49-F238E27FC236}">
+                <a16:creationId xmlns:a16="http://schemas.microsoft.com/office/drawing/2014/main" id="{ACFE27B7-29FC-410E-A8DB-E6A17FC4EC6F}"/>
+              </a:ext>
+            </a:extLst>
+          </p:cNvPr>
+          <p:cNvSpPr>
+            <a:spLocks xmlns:a="http://schemas.openxmlformats.org/drawingml/2006/main" noGrp="1"/>
+          </p:cNvSpPr>
+          <p:nvPr/>
+        </p:nvSpPr>
+        <p:spPr>
+          <a:xfrm xmlns:a="http://schemas.openxmlformats.org/drawingml/2006/main">
+            <a:off x="838200" y="5467350"/>
+            <a:ext cx="4762500" cy="800100"/>
+          </a:xfrm>
+          <a:prstGeom xmlns:a="http://schemas.openxmlformats.org/drawingml/2006/main" prst="rect">
+            <a:avLst/>
+          </a:prstGeom>
+          <a:solidFill xmlns:a="http://schemas.openxmlformats.org/drawingml/2006/main">
+            <a:srgbClr val="FFFFFF"/>
+          </a:solidFill>
+          <a:ln xmlns:a="http://schemas.openxmlformats.org/drawingml/2006/main" w="9525">
+            <a:solidFill>
+              <a:srgbClr val="CBD5E1"/>
+            </a:solidFill>
+            <a:prstDash val="solid"/>
+          </a:ln>
+        </p:spPr>
+      </p:sp>
+      <p:sp>
+        <p:nvSpPr>
+          <p:cNvPr id="81" name="">
+            <a:extLst xmlns:a="http://schemas.openxmlformats.org/drawingml/2006/main">
+              <a:ext uri="{FF2B5EF4-FFF2-40B4-BE49-F238E27FC236}">
+                <a16:creationId xmlns:a16="http://schemas.microsoft.com/office/drawing/2014/main" id="{CADDC9CD-F7BF-4FD7-8E14-40ABDC784240}"/>
+              </a:ext>
+            </a:extLst>
+          </p:cNvPr>
+          <p:cNvSpPr>
+            <a:spLocks xmlns:a="http://schemas.openxmlformats.org/drawingml/2006/main" noGrp="1"/>
+          </p:cNvSpPr>
+          <p:nvPr/>
+        </p:nvSpPr>
+        <p:spPr>
+          <a:xfrm xmlns:a="http://schemas.openxmlformats.org/drawingml/2006/main">
+            <a:off x="971550" y="5705475"/>
+            <a:ext cx="381000" cy="304800"/>
+          </a:xfrm>
+          <a:prstGeom xmlns:a="http://schemas.openxmlformats.org/drawingml/2006/main" prst="rect">
+            <a:avLst/>
+          </a:prstGeom>
+          <a:solidFill xmlns:a="http://schemas.openxmlformats.org/drawingml/2006/main">
+            <a:srgbClr val="059669"/>
+          </a:solidFill>
+          <a:ln xmlns:a="http://schemas.openxmlformats.org/drawingml/2006/main" w="9525">
+            <a:solidFill>
+              <a:srgbClr val="059669"/>
+            </a:solidFill>
+            <a:prstDash val="solid"/>
+          </a:ln>
+        </p:spPr>
+      </p:sp>
+      <p:sp>
+        <p:nvSpPr>
+          <p:cNvPr id="82" name="">
+            <a:extLst xmlns:a="http://schemas.openxmlformats.org/drawingml/2006/main">
+              <a:ext uri="{FF2B5EF4-FFF2-40B4-BE49-F238E27FC236}">
+                <a16:creationId xmlns:a16="http://schemas.microsoft.com/office/drawing/2014/main" id="{42741CCC-1C56-47C6-AF43-300E3E4C1F7F}"/>
+              </a:ext>
+            </a:extLst>
+          </p:cNvPr>
+          <p:cNvSpPr>
+            <a:spLocks xmlns:a="http://schemas.openxmlformats.org/drawingml/2006/main" noGrp="1"/>
+          </p:cNvSpPr>
+          <p:nvPr/>
+        </p:nvSpPr>
+        <p:spPr>
+          <a:xfrm xmlns:a="http://schemas.openxmlformats.org/drawingml/2006/main">
+            <a:off x="971550" y="5753100"/>
+            <a:ext cx="381000" cy="171450"/>
+          </a:xfrm>
+          <a:prstGeom xmlns:a="http://schemas.openxmlformats.org/drawingml/2006/main" prst="rect">
+            <a:avLst/>
+          </a:prstGeom>
+          <a:noFill xmlns:a="http://schemas.openxmlformats.org/drawingml/2006/main"/>
+          <a:ln xmlns:a="http://schemas.openxmlformats.org/drawingml/2006/main" w="0">
+            <a:noFill/>
+            <a:prstDash val="solid"/>
+          </a:ln>
+        </p:spPr>
+        <p:txBody>
+          <a:bodyPr xmlns:a="http://schemas.openxmlformats.org/drawingml/2006/main"/>
+          <a:lstStyle xmlns:a="http://schemas.openxmlformats.org/drawingml/2006/main"/>
+          <a:p xmlns:a="http://schemas.openxmlformats.org/drawingml/2006/main">
+            <a:pPr algn="ctr">
+              <a:defRPr sz="1125" b="1">
+                <a:solidFill>
+                  <a:srgbClr val="FFFFFF"/>
+                </a:solidFill>
+              </a:defRPr>
+            </a:pPr>
+            <a:r>
+              <a:rPr sz="1125" b="1">
+                <a:solidFill>
+                  <a:srgbClr val="FFFFFF"/>
+                </a:solidFill>
+              </a:rPr>
+              <a:t>5</a:t>
+            </a:r>
+          </a:p>
+        </p:txBody>
+      </p:sp>
+      <p:sp>
+        <p:nvSpPr>
+          <p:cNvPr id="83" name="">
+            <a:extLst xmlns:a="http://schemas.openxmlformats.org/drawingml/2006/main">
+              <a:ext uri="{FF2B5EF4-FFF2-40B4-BE49-F238E27FC236}">
+                <a16:creationId xmlns:a16="http://schemas.microsoft.com/office/drawing/2014/main" id="{39BD8BA2-AE4B-478D-8BB8-3B0583F61C4C}"/>
+              </a:ext>
+            </a:extLst>
+          </p:cNvPr>
+          <p:cNvSpPr>
+            <a:spLocks xmlns:a="http://schemas.openxmlformats.org/drawingml/2006/main" noGrp="1"/>
+          </p:cNvSpPr>
+          <p:nvPr/>
+        </p:nvSpPr>
+        <p:spPr>
+          <a:xfrm xmlns:a="http://schemas.openxmlformats.org/drawingml/2006/main">
+            <a:off x="1504950" y="5600700"/>
+            <a:ext cx="3962400" cy="209550"/>
+          </a:xfrm>
+          <a:prstGeom xmlns:a="http://schemas.openxmlformats.org/drawingml/2006/main" prst="rect">
+            <a:avLst/>
+          </a:prstGeom>
+          <a:noFill xmlns:a="http://schemas.openxmlformats.org/drawingml/2006/main"/>
+          <a:ln xmlns:a="http://schemas.openxmlformats.org/drawingml/2006/main" w="0">
+            <a:noFill/>
+            <a:prstDash val="solid"/>
+          </a:ln>
+        </p:spPr>
+        <p:txBody>
+          <a:bodyPr xmlns:a="http://schemas.openxmlformats.org/drawingml/2006/main"/>
+          <a:lstStyle xmlns:a="http://schemas.openxmlformats.org/drawingml/2006/main"/>
+          <a:p xmlns:a="http://schemas.openxmlformats.org/drawingml/2006/main">
+            <a:pPr algn="l">
+              <a:defRPr sz="1275" b="1">
+                <a:solidFill>
+                  <a:srgbClr val="059669"/>
+                </a:solidFill>
+              </a:defRPr>
+            </a:pPr>
+            <a:r>
+              <a:rPr sz="1275" b="1">
+                <a:solidFill>
+                  <a:srgbClr val="059669"/>
+                </a:solidFill>
+              </a:rPr>
+              <a:t>Install guardrails</a:t>
+            </a:r>
+          </a:p>
+        </p:txBody>
+      </p:sp>
+      <p:sp>
+        <p:nvSpPr>
+          <p:cNvPr id="84" name="">
+            <a:extLst xmlns:a="http://schemas.openxmlformats.org/drawingml/2006/main">
+              <a:ext uri="{FF2B5EF4-FFF2-40B4-BE49-F238E27FC236}">
+                <a16:creationId xmlns:a16="http://schemas.microsoft.com/office/drawing/2014/main" id="{1EABA12E-3187-4171-9CCC-062CA42F09EB}"/>
+              </a:ext>
+            </a:extLst>
+          </p:cNvPr>
+          <p:cNvSpPr>
+            <a:spLocks xmlns:a="http://schemas.openxmlformats.org/drawingml/2006/main" noGrp="1"/>
+          </p:cNvSpPr>
+          <p:nvPr/>
+        </p:nvSpPr>
+        <p:spPr>
+          <a:xfrm xmlns:a="http://schemas.openxmlformats.org/drawingml/2006/main">
+            <a:off x="1504950" y="5848350"/>
+            <a:ext cx="3962400" cy="342900"/>
+          </a:xfrm>
+          <a:prstGeom xmlns:a="http://schemas.openxmlformats.org/drawingml/2006/main" prst="rect">
+            <a:avLst/>
+          </a:prstGeom>
+          <a:noFill xmlns:a="http://schemas.openxmlformats.org/drawingml/2006/main"/>
+          <a:ln xmlns:a="http://schemas.openxmlformats.org/drawingml/2006/main" w="0">
+            <a:noFill/>
+            <a:prstDash val="solid"/>
+          </a:ln>
+        </p:spPr>
+        <p:txBody>
+          <a:bodyPr xmlns:a="http://schemas.openxmlformats.org/drawingml/2006/main"/>
+          <a:lstStyle xmlns:a="http://schemas.openxmlformats.org/drawingml/2006/main"/>
+          <a:p xmlns:a="http://schemas.openxmlformats.org/drawingml/2006/main">
+            <a:pPr algn="l">
+              <a:defRPr sz="1050" b="0">
+                <a:solidFill>
+                  <a:srgbClr val="4B5563"/>
+                </a:solidFill>
+              </a:defRPr>
+            </a:pPr>
+            <a:r>
+              <a:rPr sz="1050" b="0">
+                <a:solidFill>
+                  <a:srgbClr val="4B5563"/>
+                </a:solidFill>
+              </a:rPr>
+              <a:t>Steering, hooks, policy checks, and HITL for high-risk steps.</a:t>
+            </a:r>
+          </a:p>
+        </p:txBody>
+      </p:sp>
+      <p:sp>
+        <p:nvSpPr>
+          <p:cNvPr id="85" name="">
+            <a:extLst xmlns:a="http://schemas.openxmlformats.org/drawingml/2006/main">
+              <a:ext uri="{FF2B5EF4-FFF2-40B4-BE49-F238E27FC236}">
+                <a16:creationId xmlns:a16="http://schemas.microsoft.com/office/drawing/2014/main" id="{5A8CA9A5-AD28-4118-8D20-2A3960551D98}"/>
+              </a:ext>
+            </a:extLst>
+          </p:cNvPr>
+          <p:cNvSpPr>
+            <a:spLocks xmlns:a="http://schemas.openxmlformats.org/drawingml/2006/main" noGrp="1"/>
+          </p:cNvSpPr>
+          <p:nvPr/>
+        </p:nvSpPr>
+        <p:spPr>
+          <a:xfrm xmlns:a="http://schemas.openxmlformats.org/drawingml/2006/main">
+            <a:off x="6400800" y="2571750"/>
+            <a:ext cx="4953000" cy="800100"/>
+          </a:xfrm>
+          <a:prstGeom xmlns:a="http://schemas.openxmlformats.org/drawingml/2006/main" prst="rect">
+            <a:avLst/>
+          </a:prstGeom>
+          <a:solidFill xmlns:a="http://schemas.openxmlformats.org/drawingml/2006/main">
+            <a:srgbClr val="FFFFFF"/>
+          </a:solidFill>
+          <a:ln xmlns:a="http://schemas.openxmlformats.org/drawingml/2006/main" w="9525">
+            <a:solidFill>
+              <a:srgbClr val="CBD5E1"/>
+            </a:solidFill>
+            <a:prstDash val="solid"/>
+          </a:ln>
+        </p:spPr>
+      </p:sp>
+      <p:sp>
+        <p:nvSpPr>
+          <p:cNvPr id="86" name="">
+            <a:extLst xmlns:a="http://schemas.openxmlformats.org/drawingml/2006/main">
+              <a:ext uri="{FF2B5EF4-FFF2-40B4-BE49-F238E27FC236}">
+                <a16:creationId xmlns:a16="http://schemas.microsoft.com/office/drawing/2014/main" id="{EAE33B59-A67C-44E9-ABFB-3752BB3AEF5D}"/>
+              </a:ext>
+            </a:extLst>
+          </p:cNvPr>
+          <p:cNvSpPr>
+            <a:spLocks xmlns:a="http://schemas.openxmlformats.org/drawingml/2006/main" noGrp="1"/>
+          </p:cNvSpPr>
+          <p:nvPr/>
+        </p:nvSpPr>
+        <p:spPr>
+          <a:xfrm xmlns:a="http://schemas.openxmlformats.org/drawingml/2006/main">
+            <a:off x="6534150" y="2809875"/>
+            <a:ext cx="381000" cy="304800"/>
+          </a:xfrm>
+          <a:prstGeom xmlns:a="http://schemas.openxmlformats.org/drawingml/2006/main" prst="rect">
+            <a:avLst/>
+          </a:prstGeom>
+          <a:solidFill xmlns:a="http://schemas.openxmlformats.org/drawingml/2006/main">
+            <a:srgbClr val="2563EB"/>
+          </a:solidFill>
+          <a:ln xmlns:a="http://schemas.openxmlformats.org/drawingml/2006/main" w="9525">
+            <a:solidFill>
+              <a:srgbClr val="2563EB"/>
+            </a:solidFill>
+            <a:prstDash val="solid"/>
+          </a:ln>
+        </p:spPr>
+      </p:sp>
+      <p:sp>
+        <p:nvSpPr>
+          <p:cNvPr id="87" name="">
+            <a:extLst xmlns:a="http://schemas.openxmlformats.org/drawingml/2006/main">
+              <a:ext uri="{FF2B5EF4-FFF2-40B4-BE49-F238E27FC236}">
+                <a16:creationId xmlns:a16="http://schemas.microsoft.com/office/drawing/2014/main" id="{9980A4DA-87CF-44C6-8638-ECA9B2BCBE7D}"/>
+              </a:ext>
+            </a:extLst>
+          </p:cNvPr>
+          <p:cNvSpPr>
+            <a:spLocks xmlns:a="http://schemas.openxmlformats.org/drawingml/2006/main" noGrp="1"/>
+          </p:cNvSpPr>
+          <p:nvPr/>
+        </p:nvSpPr>
+        <p:spPr>
+          <a:xfrm xmlns:a="http://schemas.openxmlformats.org/drawingml/2006/main">
+            <a:off x="6534150" y="2857500"/>
+            <a:ext cx="381000" cy="171450"/>
+          </a:xfrm>
+          <a:prstGeom xmlns:a="http://schemas.openxmlformats.org/drawingml/2006/main" prst="rect">
+            <a:avLst/>
+          </a:prstGeom>
+          <a:noFill xmlns:a="http://schemas.openxmlformats.org/drawingml/2006/main"/>
+          <a:ln xmlns:a="http://schemas.openxmlformats.org/drawingml/2006/main" w="0">
+            <a:noFill/>
+            <a:prstDash val="solid"/>
+          </a:ln>
+        </p:spPr>
+        <p:txBody>
+          <a:bodyPr xmlns:a="http://schemas.openxmlformats.org/drawingml/2006/main"/>
+          <a:lstStyle xmlns:a="http://schemas.openxmlformats.org/drawingml/2006/main"/>
+          <a:p xmlns:a="http://schemas.openxmlformats.org/drawingml/2006/main">
+            <a:pPr algn="ctr">
+              <a:defRPr sz="1125" b="1">
+                <a:solidFill>
+                  <a:srgbClr val="FFFFFF"/>
+                </a:solidFill>
+              </a:defRPr>
+            </a:pPr>
+            <a:r>
+              <a:rPr sz="1125" b="1">
+                <a:solidFill>
+                  <a:srgbClr val="FFFFFF"/>
+                </a:solidFill>
+              </a:rPr>
+              <a:t>6</a:t>
+            </a:r>
+          </a:p>
+        </p:txBody>
+      </p:sp>
+      <p:sp>
+        <p:nvSpPr>
+          <p:cNvPr id="88" name="">
+            <a:extLst xmlns:a="http://schemas.openxmlformats.org/drawingml/2006/main">
+              <a:ext uri="{FF2B5EF4-FFF2-40B4-BE49-F238E27FC236}">
+                <a16:creationId xmlns:a16="http://schemas.microsoft.com/office/drawing/2014/main" id="{68ED16A8-12CC-4422-838C-D233E49DE461}"/>
+              </a:ext>
+            </a:extLst>
+          </p:cNvPr>
+          <p:cNvSpPr>
+            <a:spLocks xmlns:a="http://schemas.openxmlformats.org/drawingml/2006/main" noGrp="1"/>
+          </p:cNvSpPr>
+          <p:nvPr/>
+        </p:nvSpPr>
+        <p:spPr>
+          <a:xfrm xmlns:a="http://schemas.openxmlformats.org/drawingml/2006/main">
+            <a:off x="7067550" y="2705100"/>
+            <a:ext cx="4152900" cy="209550"/>
+          </a:xfrm>
+          <a:prstGeom xmlns:a="http://schemas.openxmlformats.org/drawingml/2006/main" prst="rect">
+            <a:avLst/>
+          </a:prstGeom>
+          <a:noFill xmlns:a="http://schemas.openxmlformats.org/drawingml/2006/main"/>
+          <a:ln xmlns:a="http://schemas.openxmlformats.org/drawingml/2006/main" w="0">
+            <a:noFill/>
+            <a:prstDash val="solid"/>
+          </a:ln>
+        </p:spPr>
+        <p:txBody>
+          <a:bodyPr xmlns:a="http://schemas.openxmlformats.org/drawingml/2006/main"/>
+          <a:lstStyle xmlns:a="http://schemas.openxmlformats.org/drawingml/2006/main"/>
+          <a:p xmlns:a="http://schemas.openxmlformats.org/drawingml/2006/main">
+            <a:pPr algn="l">
+              <a:defRPr sz="1275" b="1">
+                <a:solidFill>
+                  <a:srgbClr val="2563EB"/>
+                </a:solidFill>
+              </a:defRPr>
+            </a:pPr>
+            <a:r>
+              <a:rPr sz="1275" b="1">
+                <a:solidFill>
+                  <a:srgbClr val="2563EB"/>
+                </a:solidFill>
+              </a:rPr>
+              <a:t>Decide session scope</a:t>
+            </a:r>
+          </a:p>
+        </p:txBody>
+      </p:sp>
+      <p:sp>
+        <p:nvSpPr>
+          <p:cNvPr id="89" name="">
+            <a:extLst xmlns:a="http://schemas.openxmlformats.org/drawingml/2006/main">
+              <a:ext uri="{FF2B5EF4-FFF2-40B4-BE49-F238E27FC236}">
+                <a16:creationId xmlns:a16="http://schemas.microsoft.com/office/drawing/2014/main" id="{27A3C457-7AEF-43A3-A35F-7DEB31104101}"/>
+              </a:ext>
+            </a:extLst>
+          </p:cNvPr>
+          <p:cNvSpPr>
+            <a:spLocks xmlns:a="http://schemas.openxmlformats.org/drawingml/2006/main" noGrp="1"/>
+          </p:cNvSpPr>
+          <p:nvPr/>
+        </p:nvSpPr>
+        <p:spPr>
+          <a:xfrm xmlns:a="http://schemas.openxmlformats.org/drawingml/2006/main">
+            <a:off x="7067550" y="2952750"/>
+            <a:ext cx="4152900" cy="342900"/>
+          </a:xfrm>
+          <a:prstGeom xmlns:a="http://schemas.openxmlformats.org/drawingml/2006/main" prst="rect">
+            <a:avLst/>
+          </a:prstGeom>
+          <a:noFill xmlns:a="http://schemas.openxmlformats.org/drawingml/2006/main"/>
+          <a:ln xmlns:a="http://schemas.openxmlformats.org/drawingml/2006/main" w="0">
+            <a:noFill/>
+            <a:prstDash val="solid"/>
+          </a:ln>
+        </p:spPr>
+        <p:txBody>
+          <a:bodyPr xmlns:a="http://schemas.openxmlformats.org/drawingml/2006/main"/>
+          <a:lstStyle xmlns:a="http://schemas.openxmlformats.org/drawingml/2006/main"/>
+          <a:p xmlns:a="http://schemas.openxmlformats.org/drawingml/2006/main">
+            <a:pPr algn="l">
+              <a:defRPr sz="1050" b="0">
+                <a:solidFill>
+                  <a:srgbClr val="4B5563"/>
+                </a:solidFill>
+              </a:defRPr>
+            </a:pPr>
+            <a:r>
+              <a:rPr sz="1050" b="0">
+                <a:solidFill>
+                  <a:srgbClr val="4B5563"/>
+                </a:solidFill>
+              </a:rPr>
+              <a:t>In-session scratchpad vs durable across-session state.</a:t>
+            </a:r>
+          </a:p>
+        </p:txBody>
+      </p:sp>
+      <p:sp>
+        <p:nvSpPr>
+          <p:cNvPr id="90" name="">
+            <a:extLst xmlns:a="http://schemas.openxmlformats.org/drawingml/2006/main">
+              <a:ext uri="{FF2B5EF4-FFF2-40B4-BE49-F238E27FC236}">
+                <a16:creationId xmlns:a16="http://schemas.microsoft.com/office/drawing/2014/main" id="{B5CCB383-15C7-4866-9228-841A25135FAE}"/>
+              </a:ext>
+            </a:extLst>
+          </p:cNvPr>
+          <p:cNvSpPr>
+            <a:spLocks xmlns:a="http://schemas.openxmlformats.org/drawingml/2006/main" noGrp="1"/>
+          </p:cNvSpPr>
+          <p:nvPr/>
+        </p:nvSpPr>
+        <p:spPr>
+          <a:xfrm xmlns:a="http://schemas.openxmlformats.org/drawingml/2006/main">
+            <a:off x="6400800" y="3295650"/>
+            <a:ext cx="4953000" cy="800100"/>
+          </a:xfrm>
+          <a:prstGeom xmlns:a="http://schemas.openxmlformats.org/drawingml/2006/main" prst="rect">
+            <a:avLst/>
+          </a:prstGeom>
+          <a:solidFill xmlns:a="http://schemas.openxmlformats.org/drawingml/2006/main">
+            <a:srgbClr val="FFFFFF"/>
+          </a:solidFill>
+          <a:ln xmlns:a="http://schemas.openxmlformats.org/drawingml/2006/main" w="9525">
+            <a:solidFill>
+              <a:srgbClr val="CBD5E1"/>
+            </a:solidFill>
+            <a:prstDash val="solid"/>
+          </a:ln>
+        </p:spPr>
+      </p:sp>
+      <p:sp>
+        <p:nvSpPr>
+          <p:cNvPr id="91" name="">
+            <a:extLst xmlns:a="http://schemas.openxmlformats.org/drawingml/2006/main">
+              <a:ext uri="{FF2B5EF4-FFF2-40B4-BE49-F238E27FC236}">
+                <a16:creationId xmlns:a16="http://schemas.microsoft.com/office/drawing/2014/main" id="{CB829D1A-8DDE-425C-A954-5BB769D04FF6}"/>
+              </a:ext>
+            </a:extLst>
+          </p:cNvPr>
+          <p:cNvSpPr>
+            <a:spLocks xmlns:a="http://schemas.openxmlformats.org/drawingml/2006/main" noGrp="1"/>
+          </p:cNvSpPr>
+          <p:nvPr/>
+        </p:nvSpPr>
+        <p:spPr>
+          <a:xfrm xmlns:a="http://schemas.openxmlformats.org/drawingml/2006/main">
+            <a:off x="6534150" y="3533775"/>
+            <a:ext cx="381000" cy="304800"/>
+          </a:xfrm>
+          <a:prstGeom xmlns:a="http://schemas.openxmlformats.org/drawingml/2006/main" prst="rect">
+            <a:avLst/>
+          </a:prstGeom>
+          <a:solidFill xmlns:a="http://schemas.openxmlformats.org/drawingml/2006/main">
+            <a:srgbClr val="0891B2"/>
+          </a:solidFill>
+          <a:ln xmlns:a="http://schemas.openxmlformats.org/drawingml/2006/main" w="9525">
+            <a:solidFill>
+              <a:srgbClr val="0891B2"/>
+            </a:solidFill>
+            <a:prstDash val="solid"/>
+          </a:ln>
+        </p:spPr>
+      </p:sp>
+      <p:sp>
+        <p:nvSpPr>
+          <p:cNvPr id="92" name="">
+            <a:extLst xmlns:a="http://schemas.openxmlformats.org/drawingml/2006/main">
+              <a:ext uri="{FF2B5EF4-FFF2-40B4-BE49-F238E27FC236}">
+                <a16:creationId xmlns:a16="http://schemas.microsoft.com/office/drawing/2014/main" id="{F7B82DAF-4A65-4A8D-B7FC-48B1A17BB763}"/>
+              </a:ext>
+            </a:extLst>
+          </p:cNvPr>
+          <p:cNvSpPr>
+            <a:spLocks xmlns:a="http://schemas.openxmlformats.org/drawingml/2006/main" noGrp="1"/>
+          </p:cNvSpPr>
+          <p:nvPr/>
+        </p:nvSpPr>
+        <p:spPr>
+          <a:xfrm xmlns:a="http://schemas.openxmlformats.org/drawingml/2006/main">
+            <a:off x="6534150" y="3581400"/>
+            <a:ext cx="381000" cy="171450"/>
+          </a:xfrm>
+          <a:prstGeom xmlns:a="http://schemas.openxmlformats.org/drawingml/2006/main" prst="rect">
+            <a:avLst/>
+          </a:prstGeom>
+          <a:noFill xmlns:a="http://schemas.openxmlformats.org/drawingml/2006/main"/>
+          <a:ln xmlns:a="http://schemas.openxmlformats.org/drawingml/2006/main" w="0">
+            <a:noFill/>
+            <a:prstDash val="solid"/>
+          </a:ln>
+        </p:spPr>
+        <p:txBody>
+          <a:bodyPr xmlns:a="http://schemas.openxmlformats.org/drawingml/2006/main"/>
+          <a:lstStyle xmlns:a="http://schemas.openxmlformats.org/drawingml/2006/main"/>
+          <a:p xmlns:a="http://schemas.openxmlformats.org/drawingml/2006/main">
+            <a:pPr algn="ctr">
+              <a:defRPr sz="1125" b="1">
+                <a:solidFill>
+                  <a:srgbClr val="FFFFFF"/>
+                </a:solidFill>
+              </a:defRPr>
+            </a:pPr>
+            <a:r>
+              <a:rPr sz="1125" b="1">
+                <a:solidFill>
+                  <a:srgbClr val="FFFFFF"/>
+                </a:solidFill>
+              </a:rPr>
+              <a:t>7</a:t>
+            </a:r>
+          </a:p>
+        </p:txBody>
+      </p:sp>
+      <p:sp>
+        <p:nvSpPr>
+          <p:cNvPr id="93" name="">
+            <a:extLst xmlns:a="http://schemas.openxmlformats.org/drawingml/2006/main">
+              <a:ext uri="{FF2B5EF4-FFF2-40B4-BE49-F238E27FC236}">
+                <a16:creationId xmlns:a16="http://schemas.microsoft.com/office/drawing/2014/main" id="{9D27183F-45AC-4FC9-BA17-F7ADE1801D21}"/>
+              </a:ext>
+            </a:extLst>
+          </p:cNvPr>
+          <p:cNvSpPr>
+            <a:spLocks xmlns:a="http://schemas.openxmlformats.org/drawingml/2006/main" noGrp="1"/>
+          </p:cNvSpPr>
+          <p:nvPr/>
+        </p:nvSpPr>
+        <p:spPr>
+          <a:xfrm xmlns:a="http://schemas.openxmlformats.org/drawingml/2006/main">
+            <a:off x="7067550" y="3429000"/>
+            <a:ext cx="4152900" cy="209550"/>
+          </a:xfrm>
+          <a:prstGeom xmlns:a="http://schemas.openxmlformats.org/drawingml/2006/main" prst="rect">
+            <a:avLst/>
+          </a:prstGeom>
+          <a:noFill xmlns:a="http://schemas.openxmlformats.org/drawingml/2006/main"/>
+          <a:ln xmlns:a="http://schemas.openxmlformats.org/drawingml/2006/main" w="0">
+            <a:noFill/>
+            <a:prstDash val="solid"/>
+          </a:ln>
+        </p:spPr>
+        <p:txBody>
+          <a:bodyPr xmlns:a="http://schemas.openxmlformats.org/drawingml/2006/main"/>
+          <a:lstStyle xmlns:a="http://schemas.openxmlformats.org/drawingml/2006/main"/>
+          <a:p xmlns:a="http://schemas.openxmlformats.org/drawingml/2006/main">
+            <a:pPr algn="l">
+              <a:defRPr sz="1275" b="1">
+                <a:solidFill>
+                  <a:srgbClr val="0891B2"/>
+                </a:solidFill>
+              </a:defRPr>
+            </a:pPr>
+            <a:r>
+              <a:rPr sz="1275" b="1">
+                <a:solidFill>
+                  <a:srgbClr val="0891B2"/>
+                </a:solidFill>
+              </a:rPr>
+              <a:t>Choose history ownership</a:t>
+            </a:r>
+          </a:p>
+        </p:txBody>
+      </p:sp>
+      <p:sp>
+        <p:nvSpPr>
+          <p:cNvPr id="94" name="">
+            <a:extLst xmlns:a="http://schemas.openxmlformats.org/drawingml/2006/main">
+              <a:ext uri="{FF2B5EF4-FFF2-40B4-BE49-F238E27FC236}">
+                <a16:creationId xmlns:a16="http://schemas.microsoft.com/office/drawing/2014/main" id="{5AD32C17-5D43-4BD9-A637-3AECD38F8B80}"/>
+              </a:ext>
+            </a:extLst>
+          </p:cNvPr>
+          <p:cNvSpPr>
+            <a:spLocks xmlns:a="http://schemas.openxmlformats.org/drawingml/2006/main" noGrp="1"/>
+          </p:cNvSpPr>
+          <p:nvPr/>
+        </p:nvSpPr>
+        <p:spPr>
+          <a:xfrm xmlns:a="http://schemas.openxmlformats.org/drawingml/2006/main">
+            <a:off x="7067550" y="3676650"/>
+            <a:ext cx="4152900" cy="342900"/>
+          </a:xfrm>
+          <a:prstGeom xmlns:a="http://schemas.openxmlformats.org/drawingml/2006/main" prst="rect">
+            <a:avLst/>
+          </a:prstGeom>
+          <a:noFill xmlns:a="http://schemas.openxmlformats.org/drawingml/2006/main"/>
+          <a:ln xmlns:a="http://schemas.openxmlformats.org/drawingml/2006/main" w="0">
+            <a:noFill/>
+            <a:prstDash val="solid"/>
+          </a:ln>
+        </p:spPr>
+        <p:txBody>
+          <a:bodyPr xmlns:a="http://schemas.openxmlformats.org/drawingml/2006/main"/>
+          <a:lstStyle xmlns:a="http://schemas.openxmlformats.org/drawingml/2006/main"/>
+          <a:p xmlns:a="http://schemas.openxmlformats.org/drawingml/2006/main">
+            <a:pPr algn="l">
+              <a:defRPr sz="1050" b="0">
+                <a:solidFill>
+                  <a:srgbClr val="4B5563"/>
+                </a:solidFill>
+              </a:defRPr>
+            </a:pPr>
+            <a:r>
+              <a:rPr sz="1050" b="0">
+                <a:solidFill>
+                  <a:srgbClr val="4B5563"/>
+                </a:solidFill>
+              </a:rPr>
+              <a:t>Service-managed, client-managed, or hybrid audit store.</a:t>
+            </a:r>
+          </a:p>
+        </p:txBody>
+      </p:sp>
+      <p:sp>
+        <p:nvSpPr>
+          <p:cNvPr id="95" name="">
+            <a:extLst xmlns:a="http://schemas.openxmlformats.org/drawingml/2006/main">
+              <a:ext uri="{FF2B5EF4-FFF2-40B4-BE49-F238E27FC236}">
+                <a16:creationId xmlns:a16="http://schemas.microsoft.com/office/drawing/2014/main" id="{810018A7-97F2-4468-8AE5-BDDCAAE6B5ED}"/>
+              </a:ext>
+            </a:extLst>
+          </p:cNvPr>
+          <p:cNvSpPr>
+            <a:spLocks xmlns:a="http://schemas.openxmlformats.org/drawingml/2006/main" noGrp="1"/>
+          </p:cNvSpPr>
+          <p:nvPr/>
+        </p:nvSpPr>
+        <p:spPr>
+          <a:xfrm xmlns:a="http://schemas.openxmlformats.org/drawingml/2006/main">
+            <a:off x="6400800" y="4019550"/>
+            <a:ext cx="4953000" cy="800100"/>
+          </a:xfrm>
+          <a:prstGeom xmlns:a="http://schemas.openxmlformats.org/drawingml/2006/main" prst="rect">
+            <a:avLst/>
+          </a:prstGeom>
+          <a:solidFill xmlns:a="http://schemas.openxmlformats.org/drawingml/2006/main">
+            <a:srgbClr val="FFFFFF"/>
+          </a:solidFill>
+          <a:ln xmlns:a="http://schemas.openxmlformats.org/drawingml/2006/main" w="9525">
+            <a:solidFill>
+              <a:srgbClr val="CBD5E1"/>
+            </a:solidFill>
+            <a:prstDash val="solid"/>
+          </a:ln>
+        </p:spPr>
+      </p:sp>
+      <p:sp>
+        <p:nvSpPr>
+          <p:cNvPr id="96" name="">
+            <a:extLst xmlns:a="http://schemas.openxmlformats.org/drawingml/2006/main">
+              <a:ext uri="{FF2B5EF4-FFF2-40B4-BE49-F238E27FC236}">
+                <a16:creationId xmlns:a16="http://schemas.microsoft.com/office/drawing/2014/main" id="{18F803CD-248E-478D-937E-BBDF32366602}"/>
+              </a:ext>
+            </a:extLst>
+          </p:cNvPr>
+          <p:cNvSpPr>
+            <a:spLocks xmlns:a="http://schemas.openxmlformats.org/drawingml/2006/main" noGrp="1"/>
+          </p:cNvSpPr>
+          <p:nvPr/>
+        </p:nvSpPr>
+        <p:spPr>
+          <a:xfrm xmlns:a="http://schemas.openxmlformats.org/drawingml/2006/main">
+            <a:off x="6534150" y="4257675"/>
+            <a:ext cx="381000" cy="304800"/>
+          </a:xfrm>
+          <a:prstGeom xmlns:a="http://schemas.openxmlformats.org/drawingml/2006/main" prst="rect">
+            <a:avLst/>
+          </a:prstGeom>
+          <a:solidFill xmlns:a="http://schemas.openxmlformats.org/drawingml/2006/main">
+            <a:srgbClr val="059669"/>
+          </a:solidFill>
+          <a:ln xmlns:a="http://schemas.openxmlformats.org/drawingml/2006/main" w="9525">
+            <a:solidFill>
+              <a:srgbClr val="059669"/>
+            </a:solidFill>
+            <a:prstDash val="solid"/>
+          </a:ln>
+        </p:spPr>
+      </p:sp>
+      <p:sp>
+        <p:nvSpPr>
+          <p:cNvPr id="97" name="">
+            <a:extLst xmlns:a="http://schemas.openxmlformats.org/drawingml/2006/main">
+              <a:ext uri="{FF2B5EF4-FFF2-40B4-BE49-F238E27FC236}">
+                <a16:creationId xmlns:a16="http://schemas.microsoft.com/office/drawing/2014/main" id="{1471B04F-678F-4800-A97C-2F399290DCA4}"/>
+              </a:ext>
+            </a:extLst>
+          </p:cNvPr>
+          <p:cNvSpPr>
+            <a:spLocks xmlns:a="http://schemas.openxmlformats.org/drawingml/2006/main" noGrp="1"/>
+          </p:cNvSpPr>
+          <p:nvPr/>
+        </p:nvSpPr>
+        <p:spPr>
+          <a:xfrm xmlns:a="http://schemas.openxmlformats.org/drawingml/2006/main">
+            <a:off x="6534150" y="4305300"/>
+            <a:ext cx="381000" cy="171450"/>
+          </a:xfrm>
+          <a:prstGeom xmlns:a="http://schemas.openxmlformats.org/drawingml/2006/main" prst="rect">
+            <a:avLst/>
+          </a:prstGeom>
+          <a:noFill xmlns:a="http://schemas.openxmlformats.org/drawingml/2006/main"/>
+          <a:ln xmlns:a="http://schemas.openxmlformats.org/drawingml/2006/main" w="0">
+            <a:noFill/>
+            <a:prstDash val="solid"/>
+          </a:ln>
+        </p:spPr>
+        <p:txBody>
+          <a:bodyPr xmlns:a="http://schemas.openxmlformats.org/drawingml/2006/main"/>
+          <a:lstStyle xmlns:a="http://schemas.openxmlformats.org/drawingml/2006/main"/>
+          <a:p xmlns:a="http://schemas.openxmlformats.org/drawingml/2006/main">
+            <a:pPr algn="ctr">
+              <a:defRPr sz="1125" b="1">
+                <a:solidFill>
+                  <a:srgbClr val="FFFFFF"/>
+                </a:solidFill>
+              </a:defRPr>
+            </a:pPr>
+            <a:r>
+              <a:rPr sz="1125" b="1">
+                <a:solidFill>
+                  <a:srgbClr val="FFFFFF"/>
+                </a:solidFill>
+              </a:rPr>
+              <a:t>8</a:t>
+            </a:r>
+          </a:p>
+        </p:txBody>
+      </p:sp>
+      <p:sp>
+        <p:nvSpPr>
+          <p:cNvPr id="98" name="">
+            <a:extLst xmlns:a="http://schemas.openxmlformats.org/drawingml/2006/main">
+              <a:ext uri="{FF2B5EF4-FFF2-40B4-BE49-F238E27FC236}">
+                <a16:creationId xmlns:a16="http://schemas.microsoft.com/office/drawing/2014/main" id="{069BBB84-F175-4CBE-A018-F5E0BFEB335C}"/>
+              </a:ext>
+            </a:extLst>
+          </p:cNvPr>
+          <p:cNvSpPr>
+            <a:spLocks xmlns:a="http://schemas.openxmlformats.org/drawingml/2006/main" noGrp="1"/>
+          </p:cNvSpPr>
+          <p:nvPr/>
+        </p:nvSpPr>
+        <p:spPr>
+          <a:xfrm xmlns:a="http://schemas.openxmlformats.org/drawingml/2006/main">
+            <a:off x="7067550" y="4152900"/>
+            <a:ext cx="4152900" cy="209550"/>
+          </a:xfrm>
+          <a:prstGeom xmlns:a="http://schemas.openxmlformats.org/drawingml/2006/main" prst="rect">
+            <a:avLst/>
+          </a:prstGeom>
+          <a:noFill xmlns:a="http://schemas.openxmlformats.org/drawingml/2006/main"/>
+          <a:ln xmlns:a="http://schemas.openxmlformats.org/drawingml/2006/main" w="0">
+            <a:noFill/>
+            <a:prstDash val="solid"/>
+          </a:ln>
+        </p:spPr>
+        <p:txBody>
+          <a:bodyPr xmlns:a="http://schemas.openxmlformats.org/drawingml/2006/main"/>
+          <a:lstStyle xmlns:a="http://schemas.openxmlformats.org/drawingml/2006/main"/>
+          <a:p xmlns:a="http://schemas.openxmlformats.org/drawingml/2006/main">
+            <a:pPr algn="l">
+              <a:defRPr sz="1275" b="1">
+                <a:solidFill>
+                  <a:srgbClr val="059669"/>
+                </a:solidFill>
+              </a:defRPr>
+            </a:pPr>
+            <a:r>
+              <a:rPr sz="1275" b="1">
+                <a:solidFill>
+                  <a:srgbClr val="059669"/>
+                </a:solidFill>
+              </a:rPr>
+              <a:t>Persist useful memory</a:t>
+            </a:r>
+          </a:p>
+        </p:txBody>
+      </p:sp>
+      <p:sp>
+        <p:nvSpPr>
+          <p:cNvPr id="99" name="">
+            <a:extLst xmlns:a="http://schemas.openxmlformats.org/drawingml/2006/main">
+              <a:ext uri="{FF2B5EF4-FFF2-40B4-BE49-F238E27FC236}">
+                <a16:creationId xmlns:a16="http://schemas.microsoft.com/office/drawing/2014/main" id="{2CFE8B82-86AE-42EE-8734-188B2B736C6A}"/>
+              </a:ext>
+            </a:extLst>
+          </p:cNvPr>
+          <p:cNvSpPr>
+            <a:spLocks xmlns:a="http://schemas.openxmlformats.org/drawingml/2006/main" noGrp="1"/>
+          </p:cNvSpPr>
+          <p:nvPr/>
+        </p:nvSpPr>
+        <p:spPr>
+          <a:xfrm xmlns:a="http://schemas.openxmlformats.org/drawingml/2006/main">
+            <a:off x="7067550" y="4400550"/>
+            <a:ext cx="4152900" cy="342900"/>
+          </a:xfrm>
+          <a:prstGeom xmlns:a="http://schemas.openxmlformats.org/drawingml/2006/main" prst="rect">
+            <a:avLst/>
+          </a:prstGeom>
+          <a:noFill xmlns:a="http://schemas.openxmlformats.org/drawingml/2006/main"/>
+          <a:ln xmlns:a="http://schemas.openxmlformats.org/drawingml/2006/main" w="0">
+            <a:noFill/>
+            <a:prstDash val="solid"/>
+          </a:ln>
+        </p:spPr>
+        <p:txBody>
+          <a:bodyPr xmlns:a="http://schemas.openxmlformats.org/drawingml/2006/main"/>
+          <a:lstStyle xmlns:a="http://schemas.openxmlformats.org/drawingml/2006/main"/>
+          <a:p xmlns:a="http://schemas.openxmlformats.org/drawingml/2006/main">
+            <a:pPr algn="l">
+              <a:defRPr sz="1050" b="0">
+                <a:solidFill>
+                  <a:srgbClr val="4B5563"/>
+                </a:solidFill>
+              </a:defRPr>
+            </a:pPr>
+            <a:r>
+              <a:rPr sz="1050" b="0">
+                <a:solidFill>
+                  <a:srgbClr val="4B5563"/>
+                </a:solidFill>
+              </a:rPr>
+              <a:t>Save facts, decisions, preferences, and lessons with provenance.</a:t>
+            </a:r>
+          </a:p>
+        </p:txBody>
+      </p:sp>
+      <p:sp>
+        <p:nvSpPr>
+          <p:cNvPr id="100" name="">
+            <a:extLst xmlns:a="http://schemas.openxmlformats.org/drawingml/2006/main">
+              <a:ext uri="{FF2B5EF4-FFF2-40B4-BE49-F238E27FC236}">
+                <a16:creationId xmlns:a16="http://schemas.microsoft.com/office/drawing/2014/main" id="{62945549-245C-4C3B-A802-51605DA7E9CC}"/>
+              </a:ext>
+            </a:extLst>
+          </p:cNvPr>
+          <p:cNvSpPr>
+            <a:spLocks xmlns:a="http://schemas.openxmlformats.org/drawingml/2006/main" noGrp="1"/>
+          </p:cNvSpPr>
+          <p:nvPr/>
+        </p:nvSpPr>
+        <p:spPr>
+          <a:xfrm xmlns:a="http://schemas.openxmlformats.org/drawingml/2006/main">
+            <a:off x="6400800" y="4743450"/>
+            <a:ext cx="4953000" cy="800100"/>
+          </a:xfrm>
+          <a:prstGeom xmlns:a="http://schemas.openxmlformats.org/drawingml/2006/main" prst="rect">
+            <a:avLst/>
+          </a:prstGeom>
+          <a:solidFill xmlns:a="http://schemas.openxmlformats.org/drawingml/2006/main">
+            <a:srgbClr val="FFFFFF"/>
+          </a:solidFill>
+          <a:ln xmlns:a="http://schemas.openxmlformats.org/drawingml/2006/main" w="9525">
+            <a:solidFill>
+              <a:srgbClr val="CBD5E1"/>
+            </a:solidFill>
+            <a:prstDash val="solid"/>
+          </a:ln>
+        </p:spPr>
+      </p:sp>
+      <p:sp>
+        <p:nvSpPr>
+          <p:cNvPr id="101" name="">
+            <a:extLst xmlns:a="http://schemas.openxmlformats.org/drawingml/2006/main">
+              <a:ext uri="{FF2B5EF4-FFF2-40B4-BE49-F238E27FC236}">
+                <a16:creationId xmlns:a16="http://schemas.microsoft.com/office/drawing/2014/main" id="{7DDDD938-20FE-4274-8794-770CE6B5818C}"/>
+              </a:ext>
+            </a:extLst>
+          </p:cNvPr>
+          <p:cNvSpPr>
+            <a:spLocks xmlns:a="http://schemas.openxmlformats.org/drawingml/2006/main" noGrp="1"/>
+          </p:cNvSpPr>
+          <p:nvPr/>
+        </p:nvSpPr>
+        <p:spPr>
+          <a:xfrm xmlns:a="http://schemas.openxmlformats.org/drawingml/2006/main">
+            <a:off x="6534150" y="4981575"/>
+            <a:ext cx="381000" cy="304800"/>
+          </a:xfrm>
+          <a:prstGeom xmlns:a="http://schemas.openxmlformats.org/drawingml/2006/main" prst="rect">
+            <a:avLst/>
+          </a:prstGeom>
+          <a:solidFill xmlns:a="http://schemas.openxmlformats.org/drawingml/2006/main">
+            <a:srgbClr val="D97706"/>
+          </a:solidFill>
+          <a:ln xmlns:a="http://schemas.openxmlformats.org/drawingml/2006/main" w="9525">
+            <a:solidFill>
+              <a:srgbClr val="D97706"/>
+            </a:solidFill>
+            <a:prstDash val="solid"/>
+          </a:ln>
+        </p:spPr>
+      </p:sp>
+      <p:sp>
+        <p:nvSpPr>
+          <p:cNvPr id="102" name="">
+            <a:extLst xmlns:a="http://schemas.openxmlformats.org/drawingml/2006/main">
+              <a:ext uri="{FF2B5EF4-FFF2-40B4-BE49-F238E27FC236}">
+                <a16:creationId xmlns:a16="http://schemas.microsoft.com/office/drawing/2014/main" id="{0C53C498-E2DF-4BCF-A9D7-E5EDC303B288}"/>
+              </a:ext>
+            </a:extLst>
+          </p:cNvPr>
+          <p:cNvSpPr>
+            <a:spLocks xmlns:a="http://schemas.openxmlformats.org/drawingml/2006/main" noGrp="1"/>
+          </p:cNvSpPr>
+          <p:nvPr/>
+        </p:nvSpPr>
+        <p:spPr>
+          <a:xfrm xmlns:a="http://schemas.openxmlformats.org/drawingml/2006/main">
+            <a:off x="6534150" y="5029200"/>
+            <a:ext cx="381000" cy="171450"/>
+          </a:xfrm>
+          <a:prstGeom xmlns:a="http://schemas.openxmlformats.org/drawingml/2006/main" prst="rect">
+            <a:avLst/>
+          </a:prstGeom>
+          <a:noFill xmlns:a="http://schemas.openxmlformats.org/drawingml/2006/main"/>
+          <a:ln xmlns:a="http://schemas.openxmlformats.org/drawingml/2006/main" w="0">
+            <a:noFill/>
+            <a:prstDash val="solid"/>
+          </a:ln>
+        </p:spPr>
+        <p:txBody>
+          <a:bodyPr xmlns:a="http://schemas.openxmlformats.org/drawingml/2006/main"/>
+          <a:lstStyle xmlns:a="http://schemas.openxmlformats.org/drawingml/2006/main"/>
+          <a:p xmlns:a="http://schemas.openxmlformats.org/drawingml/2006/main">
+            <a:pPr algn="ctr">
+              <a:defRPr sz="1125" b="1">
+                <a:solidFill>
+                  <a:srgbClr val="FFFFFF"/>
+                </a:solidFill>
+              </a:defRPr>
+            </a:pPr>
+            <a:r>
+              <a:rPr sz="1125" b="1">
+                <a:solidFill>
+                  <a:srgbClr val="FFFFFF"/>
+                </a:solidFill>
+              </a:rPr>
+              <a:t>9</a:t>
+            </a:r>
+          </a:p>
+        </p:txBody>
+      </p:sp>
+      <p:sp>
+        <p:nvSpPr>
+          <p:cNvPr id="103" name="">
+            <a:extLst xmlns:a="http://schemas.openxmlformats.org/drawingml/2006/main">
+              <a:ext uri="{FF2B5EF4-FFF2-40B4-BE49-F238E27FC236}">
+                <a16:creationId xmlns:a16="http://schemas.microsoft.com/office/drawing/2014/main" id="{1B36F185-54A1-47DE-9D94-3826564D3C2F}"/>
+              </a:ext>
+            </a:extLst>
+          </p:cNvPr>
+          <p:cNvSpPr>
+            <a:spLocks xmlns:a="http://schemas.openxmlformats.org/drawingml/2006/main" noGrp="1"/>
+          </p:cNvSpPr>
+          <p:nvPr/>
+        </p:nvSpPr>
+        <p:spPr>
+          <a:xfrm xmlns:a="http://schemas.openxmlformats.org/drawingml/2006/main">
+            <a:off x="7067550" y="4876800"/>
+            <a:ext cx="4152900" cy="209550"/>
+          </a:xfrm>
+          <a:prstGeom xmlns:a="http://schemas.openxmlformats.org/drawingml/2006/main" prst="rect">
+            <a:avLst/>
+          </a:prstGeom>
+          <a:noFill xmlns:a="http://schemas.openxmlformats.org/drawingml/2006/main"/>
+          <a:ln xmlns:a="http://schemas.openxmlformats.org/drawingml/2006/main" w="0">
+            <a:noFill/>
+            <a:prstDash val="solid"/>
+          </a:ln>
+        </p:spPr>
+        <p:txBody>
+          <a:bodyPr xmlns:a="http://schemas.openxmlformats.org/drawingml/2006/main"/>
+          <a:lstStyle xmlns:a="http://schemas.openxmlformats.org/drawingml/2006/main"/>
+          <a:p xmlns:a="http://schemas.openxmlformats.org/drawingml/2006/main">
+            <a:pPr algn="l">
+              <a:defRPr sz="1275" b="1">
+                <a:solidFill>
+                  <a:srgbClr val="D97706"/>
+                </a:solidFill>
+              </a:defRPr>
+            </a:pPr>
+            <a:r>
+              <a:rPr sz="1275" b="1">
+                <a:solidFill>
+                  <a:srgbClr val="D97706"/>
+                </a:solidFill>
+              </a:rPr>
+              <a:t>Compact and offload</a:t>
+            </a:r>
+          </a:p>
+        </p:txBody>
+      </p:sp>
+      <p:sp>
+        <p:nvSpPr>
+          <p:cNvPr id="104" name="">
+            <a:extLst xmlns:a="http://schemas.openxmlformats.org/drawingml/2006/main">
+              <a:ext uri="{FF2B5EF4-FFF2-40B4-BE49-F238E27FC236}">
+                <a16:creationId xmlns:a16="http://schemas.microsoft.com/office/drawing/2014/main" id="{1A9B1808-FE7F-459B-B2B3-2EC381FFB3E4}"/>
+              </a:ext>
+            </a:extLst>
+          </p:cNvPr>
+          <p:cNvSpPr>
+            <a:spLocks xmlns:a="http://schemas.openxmlformats.org/drawingml/2006/main" noGrp="1"/>
+          </p:cNvSpPr>
+          <p:nvPr/>
+        </p:nvSpPr>
+        <p:spPr>
+          <a:xfrm xmlns:a="http://schemas.openxmlformats.org/drawingml/2006/main">
+            <a:off x="7067550" y="5124450"/>
+            <a:ext cx="4152900" cy="342900"/>
+          </a:xfrm>
+          <a:prstGeom xmlns:a="http://schemas.openxmlformats.org/drawingml/2006/main" prst="rect">
+            <a:avLst/>
+          </a:prstGeom>
+          <a:noFill xmlns:a="http://schemas.openxmlformats.org/drawingml/2006/main"/>
+          <a:ln xmlns:a="http://schemas.openxmlformats.org/drawingml/2006/main" w="0">
+            <a:noFill/>
+            <a:prstDash val="solid"/>
+          </a:ln>
+        </p:spPr>
+        <p:txBody>
+          <a:bodyPr xmlns:a="http://schemas.openxmlformats.org/drawingml/2006/main"/>
+          <a:lstStyle xmlns:a="http://schemas.openxmlformats.org/drawingml/2006/main"/>
+          <a:p xmlns:a="http://schemas.openxmlformats.org/drawingml/2006/main">
+            <a:pPr algn="l">
+              <a:defRPr sz="1050" b="0">
+                <a:solidFill>
+                  <a:srgbClr val="4B5563"/>
+                </a:solidFill>
+              </a:defRPr>
+            </a:pPr>
+            <a:r>
+              <a:rPr sz="1050" b="0">
+                <a:solidFill>
+                  <a:srgbClr val="4B5563"/>
+                </a:solidFill>
+              </a:rPr>
+              <a:t>Summarize old turns; clear/re-fetch bulky tool results.</a:t>
+            </a:r>
+          </a:p>
+        </p:txBody>
+      </p:sp>
+      <p:sp>
+        <p:nvSpPr>
+          <p:cNvPr id="105" name="">
+            <a:extLst xmlns:a="http://schemas.openxmlformats.org/drawingml/2006/main">
+              <a:ext uri="{FF2B5EF4-FFF2-40B4-BE49-F238E27FC236}">
+                <a16:creationId xmlns:a16="http://schemas.microsoft.com/office/drawing/2014/main" id="{306053FF-0BD2-4956-B64C-9E413C7C1C7B}"/>
+              </a:ext>
+            </a:extLst>
+          </p:cNvPr>
+          <p:cNvSpPr>
+            <a:spLocks xmlns:a="http://schemas.openxmlformats.org/drawingml/2006/main" noGrp="1"/>
+          </p:cNvSpPr>
+          <p:nvPr/>
+        </p:nvSpPr>
+        <p:spPr>
+          <a:xfrm xmlns:a="http://schemas.openxmlformats.org/drawingml/2006/main">
+            <a:off x="6400800" y="5467350"/>
+            <a:ext cx="4953000" cy="800100"/>
+          </a:xfrm>
+          <a:prstGeom xmlns:a="http://schemas.openxmlformats.org/drawingml/2006/main" prst="rect">
+            <a:avLst/>
+          </a:prstGeom>
+          <a:solidFill xmlns:a="http://schemas.openxmlformats.org/drawingml/2006/main">
+            <a:srgbClr val="FFFFFF"/>
+          </a:solidFill>
+          <a:ln xmlns:a="http://schemas.openxmlformats.org/drawingml/2006/main" w="9525">
+            <a:solidFill>
+              <a:srgbClr val="CBD5E1"/>
+            </a:solidFill>
+            <a:prstDash val="solid"/>
+          </a:ln>
+        </p:spPr>
+      </p:sp>
+      <p:sp>
+        <p:nvSpPr>
+          <p:cNvPr id="106" name="">
+            <a:extLst xmlns:a="http://schemas.openxmlformats.org/drawingml/2006/main">
+              <a:ext uri="{FF2B5EF4-FFF2-40B4-BE49-F238E27FC236}">
+                <a16:creationId xmlns:a16="http://schemas.microsoft.com/office/drawing/2014/main" id="{3176D209-7522-44DA-B062-DCFB4B46820D}"/>
+              </a:ext>
+            </a:extLst>
+          </p:cNvPr>
+          <p:cNvSpPr>
+            <a:spLocks xmlns:a="http://schemas.openxmlformats.org/drawingml/2006/main" noGrp="1"/>
+          </p:cNvSpPr>
+          <p:nvPr/>
+        </p:nvSpPr>
+        <p:spPr>
+          <a:xfrm xmlns:a="http://schemas.openxmlformats.org/drawingml/2006/main">
+            <a:off x="6534150" y="5705475"/>
+            <a:ext cx="381000" cy="304800"/>
+          </a:xfrm>
+          <a:prstGeom xmlns:a="http://schemas.openxmlformats.org/drawingml/2006/main" prst="rect">
+            <a:avLst/>
+          </a:prstGeom>
+          <a:solidFill xmlns:a="http://schemas.openxmlformats.org/drawingml/2006/main">
+            <a:srgbClr val="DC2626"/>
+          </a:solidFill>
+          <a:ln xmlns:a="http://schemas.openxmlformats.org/drawingml/2006/main" w="9525">
+            <a:solidFill>
+              <a:srgbClr val="DC2626"/>
+            </a:solidFill>
+            <a:prstDash val="solid"/>
+          </a:ln>
+        </p:spPr>
+      </p:sp>
+      <p:sp>
+        <p:nvSpPr>
+          <p:cNvPr id="107" name="">
+            <a:extLst xmlns:a="http://schemas.openxmlformats.org/drawingml/2006/main">
+              <a:ext uri="{FF2B5EF4-FFF2-40B4-BE49-F238E27FC236}">
+                <a16:creationId xmlns:a16="http://schemas.microsoft.com/office/drawing/2014/main" id="{2D872EA0-6A7F-4C67-9629-7AF97DE4CBE8}"/>
+              </a:ext>
+            </a:extLst>
+          </p:cNvPr>
+          <p:cNvSpPr>
+            <a:spLocks xmlns:a="http://schemas.openxmlformats.org/drawingml/2006/main" noGrp="1"/>
+          </p:cNvSpPr>
+          <p:nvPr/>
+        </p:nvSpPr>
+        <p:spPr>
+          <a:xfrm xmlns:a="http://schemas.openxmlformats.org/drawingml/2006/main">
+            <a:off x="6534150" y="5753100"/>
+            <a:ext cx="381000" cy="171450"/>
+          </a:xfrm>
+          <a:prstGeom xmlns:a="http://schemas.openxmlformats.org/drawingml/2006/main" prst="rect">
+            <a:avLst/>
+          </a:prstGeom>
+          <a:noFill xmlns:a="http://schemas.openxmlformats.org/drawingml/2006/main"/>
+          <a:ln xmlns:a="http://schemas.openxmlformats.org/drawingml/2006/main" w="0">
+            <a:noFill/>
+            <a:prstDash val="solid"/>
+          </a:ln>
+        </p:spPr>
+        <p:txBody>
+          <a:bodyPr xmlns:a="http://schemas.openxmlformats.org/drawingml/2006/main"/>
+          <a:lstStyle xmlns:a="http://schemas.openxmlformats.org/drawingml/2006/main"/>
+          <a:p xmlns:a="http://schemas.openxmlformats.org/drawingml/2006/main">
+            <a:pPr algn="ctr">
+              <a:defRPr sz="1125" b="1">
+                <a:solidFill>
+                  <a:srgbClr val="FFFFFF"/>
+                </a:solidFill>
+              </a:defRPr>
+            </a:pPr>
+            <a:r>
+              <a:rPr sz="1125" b="1">
+                <a:solidFill>
+                  <a:srgbClr val="FFFFFF"/>
+                </a:solidFill>
+              </a:rPr>
+              <a:t>10</a:t>
+            </a:r>
+          </a:p>
+        </p:txBody>
+      </p:sp>
+      <p:sp>
+        <p:nvSpPr>
+          <p:cNvPr id="108" name="">
+            <a:extLst xmlns:a="http://schemas.openxmlformats.org/drawingml/2006/main">
+              <a:ext uri="{FF2B5EF4-FFF2-40B4-BE49-F238E27FC236}">
+                <a16:creationId xmlns:a16="http://schemas.microsoft.com/office/drawing/2014/main" id="{0799A9E7-FF5E-4438-9052-CC146B971CA8}"/>
+              </a:ext>
+            </a:extLst>
+          </p:cNvPr>
+          <p:cNvSpPr>
+            <a:spLocks xmlns:a="http://schemas.openxmlformats.org/drawingml/2006/main" noGrp="1"/>
+          </p:cNvSpPr>
+          <p:nvPr/>
+        </p:nvSpPr>
+        <p:spPr>
+          <a:xfrm xmlns:a="http://schemas.openxmlformats.org/drawingml/2006/main">
+            <a:off x="7067550" y="5600700"/>
+            <a:ext cx="4152900" cy="209550"/>
+          </a:xfrm>
+          <a:prstGeom xmlns:a="http://schemas.openxmlformats.org/drawingml/2006/main" prst="rect">
+            <a:avLst/>
+          </a:prstGeom>
+          <a:noFill xmlns:a="http://schemas.openxmlformats.org/drawingml/2006/main"/>
+          <a:ln xmlns:a="http://schemas.openxmlformats.org/drawingml/2006/main" w="0">
+            <a:noFill/>
+            <a:prstDash val="solid"/>
+          </a:ln>
+        </p:spPr>
+        <p:txBody>
+          <a:bodyPr xmlns:a="http://schemas.openxmlformats.org/drawingml/2006/main"/>
+          <a:lstStyle xmlns:a="http://schemas.openxmlformats.org/drawingml/2006/main"/>
+          <a:p xmlns:a="http://schemas.openxmlformats.org/drawingml/2006/main">
+            <a:pPr algn="l">
+              <a:defRPr sz="1275" b="1">
+                <a:solidFill>
+                  <a:srgbClr val="DC2626"/>
+                </a:solidFill>
+              </a:defRPr>
+            </a:pPr>
+            <a:r>
+              <a:rPr sz="1275" b="1">
+                <a:solidFill>
+                  <a:srgbClr val="DC2626"/>
+                </a:solidFill>
+              </a:rPr>
+              <a:t>Evaluate and observe</a:t>
+            </a:r>
+          </a:p>
+        </p:txBody>
+      </p:sp>
+      <p:sp>
+        <p:nvSpPr>
+          <p:cNvPr id="109" name="">
+            <a:extLst xmlns:a="http://schemas.openxmlformats.org/drawingml/2006/main">
+              <a:ext uri="{FF2B5EF4-FFF2-40B4-BE49-F238E27FC236}">
+                <a16:creationId xmlns:a16="http://schemas.microsoft.com/office/drawing/2014/main" id="{262BCE88-E555-4BC2-9692-7BF476D03392}"/>
+              </a:ext>
+            </a:extLst>
+          </p:cNvPr>
+          <p:cNvSpPr>
+            <a:spLocks xmlns:a="http://schemas.openxmlformats.org/drawingml/2006/main" noGrp="1"/>
+          </p:cNvSpPr>
+          <p:nvPr/>
+        </p:nvSpPr>
+        <p:spPr>
+          <a:xfrm xmlns:a="http://schemas.openxmlformats.org/drawingml/2006/main">
+            <a:off x="7067550" y="5848350"/>
+            <a:ext cx="4152900" cy="342900"/>
+          </a:xfrm>
+          <a:prstGeom xmlns:a="http://schemas.openxmlformats.org/drawingml/2006/main" prst="rect">
+            <a:avLst/>
+          </a:prstGeom>
+          <a:noFill xmlns:a="http://schemas.openxmlformats.org/drawingml/2006/main"/>
+          <a:ln xmlns:a="http://schemas.openxmlformats.org/drawingml/2006/main" w="0">
+            <a:noFill/>
+            <a:prstDash val="solid"/>
+          </a:ln>
+        </p:spPr>
+        <p:txBody>
+          <a:bodyPr xmlns:a="http://schemas.openxmlformats.org/drawingml/2006/main"/>
+          <a:lstStyle xmlns:a="http://schemas.openxmlformats.org/drawingml/2006/main"/>
+          <a:p xmlns:a="http://schemas.openxmlformats.org/drawingml/2006/main">
+            <a:pPr algn="l">
+              <a:defRPr sz="1050" b="0">
+                <a:solidFill>
+                  <a:srgbClr val="4B5563"/>
+                </a:solidFill>
+              </a:defRPr>
+            </a:pPr>
+            <a:r>
+              <a:rPr sz="1050" b="0">
+                <a:solidFill>
+                  <a:srgbClr val="4B5563"/>
+                </a:solidFill>
+              </a:rPr>
+              <a:t>Goal loops, CI/CD evals, traces, misses, and rejected attempts.</a:t>
+            </a:r>
+          </a:p>
+        </p:txBody>
+      </p:sp>
+      <p:sp>
+        <p:nvSpPr>
+          <p:cNvPr id="110" name="">
+            <a:extLst xmlns:a="http://schemas.openxmlformats.org/drawingml/2006/main">
+              <a:ext uri="{FF2B5EF4-FFF2-40B4-BE49-F238E27FC236}">
+                <a16:creationId xmlns:a16="http://schemas.microsoft.com/office/drawing/2014/main" id="{5B8F9E98-43F2-4645-A0B8-B91B21375A4D}"/>
+              </a:ext>
+            </a:extLst>
+          </p:cNvPr>
+          <p:cNvSpPr>
+            <a:spLocks xmlns:a="http://schemas.openxmlformats.org/drawingml/2006/main" noGrp="1"/>
+          </p:cNvSpPr>
+          <p:nvPr/>
+        </p:nvSpPr>
+        <p:spPr>
+          <a:xfrm xmlns:a="http://schemas.openxmlformats.org/drawingml/2006/main">
+            <a:off x="1219200" y="6248400"/>
+            <a:ext cx="9753600" cy="342900"/>
+          </a:xfrm>
+          <a:prstGeom xmlns:a="http://schemas.openxmlformats.org/drawingml/2006/main" prst="rect">
+            <a:avLst/>
+          </a:prstGeom>
+          <a:solidFill xmlns:a="http://schemas.openxmlformats.org/drawingml/2006/main">
+            <a:srgbClr val="EFF6FF"/>
+          </a:solidFill>
+          <a:ln xmlns:a="http://schemas.openxmlformats.org/drawingml/2006/main" w="9525">
+            <a:solidFill>
+              <a:srgbClr val="BFDBFE"/>
+            </a:solidFill>
+            <a:prstDash val="solid"/>
+          </a:ln>
+        </p:spPr>
+      </p:sp>
+      <p:sp>
+        <p:nvSpPr>
+          <p:cNvPr id="111" name="">
+            <a:extLst xmlns:a="http://schemas.openxmlformats.org/drawingml/2006/main">
+              <a:ext uri="{FF2B5EF4-FFF2-40B4-BE49-F238E27FC236}">
+                <a16:creationId xmlns:a16="http://schemas.microsoft.com/office/drawing/2014/main" id="{82595DBC-E930-454A-A95C-0DA70C2ED97F}"/>
+              </a:ext>
+            </a:extLst>
+          </p:cNvPr>
+          <p:cNvSpPr>
+            <a:spLocks xmlns:a="http://schemas.openxmlformats.org/drawingml/2006/main" noGrp="1"/>
+          </p:cNvSpPr>
+          <p:nvPr/>
+        </p:nvSpPr>
+        <p:spPr>
+          <a:xfrm xmlns:a="http://schemas.openxmlformats.org/drawingml/2006/main">
+            <a:off x="1466850" y="6334125"/>
+            <a:ext cx="9239250" cy="171450"/>
+          </a:xfrm>
+          <a:prstGeom xmlns:a="http://schemas.openxmlformats.org/drawingml/2006/main" prst="rect">
+            <a:avLst/>
+          </a:prstGeom>
+          <a:noFill xmlns:a="http://schemas.openxmlformats.org/drawingml/2006/main"/>
+          <a:ln xmlns:a="http://schemas.openxmlformats.org/drawingml/2006/main" w="0">
+            <a:noFill/>
+            <a:prstDash val="solid"/>
+          </a:ln>
+        </p:spPr>
+        <p:txBody>
+          <a:bodyPr xmlns:a="http://schemas.openxmlformats.org/drawingml/2006/main"/>
+          <a:lstStyle xmlns:a="http://schemas.openxmlformats.org/drawingml/2006/main"/>
+          <a:p xmlns:a="http://schemas.openxmlformats.org/drawingml/2006/main">
+            <a:pPr algn="ctr">
+              <a:defRPr sz="1275" b="1">
+                <a:solidFill>
+                  <a:srgbClr val="2563EB"/>
+                </a:solidFill>
+              </a:defRPr>
+            </a:pPr>
+            <a:r>
+              <a:rPr sz="1275" b="1">
+                <a:solidFill>
+                  <a:srgbClr val="2563EB"/>
+                </a:solidFill>
+              </a:rPr>
+              <a:t>Principle: preserve the right state, retrieve it deliberately, and keep active context lean.</a:t>
             </a:r>
           </a:p>
         </p:txBody>

</xml_diff>